<commit_message>
feat(slides): construct and verify Slides 4, 5, and 6 with open editorial typography
</commit_message>
<xml_diff>
--- a/write_up/Project Final Defense Slides_FINAL.pptx
+++ b/write_up/Project Final Defense Slides_FINAL.pptx
@@ -13,6 +13,7 @@
     <p:sldId id="555" r:id="rId4"/>
     <p:sldId id="558" r:id="rId5"/>
     <p:sldId id="561" r:id="rId6"/>
+    <p:sldId id="562" r:id="rId13"/>
   </p:sldIdLst>
   <p:sldSz cx="12192000" cy="6858000"/>
   <p:notesSz cx="6858000" cy="9144000"/>
@@ -1716,8 +1717,8 @@
         </p:nvSpPr>
         <p:spPr>
           <a:xfrm>
-            <a:off x="5989320" y="457200"/>
-            <a:ext cx="5760720" cy="5943600"/>
+            <a:off x="5921654" y="0"/>
+            <a:ext cx="6270040" cy="6858000"/>
           </a:xfrm>
           <a:prstGeom prst="rect">
             <a:avLst/>
@@ -1743,21 +1744,21 @@
           </a:fontRef>
         </p:style>
         <p:txBody>
-          <a:bodyPr rtlCol="0" anchor="ctr" wrap="square" lIns="228600" rIns="228600" tIns="137160" bIns="137160"/>
+          <a:bodyPr rtlCol="0" anchor="ctr" wrap="square" lIns="365760" rIns="365760" tIns="320040" bIns="320040"/>
           <a:lstStyle/>
           <a:p>
             <a:pPr algn="ctr">
               <a:lnSpc>
-                <a:spcPct val="110000"/>
+                <a:spcPct val="115000"/>
               </a:lnSpc>
               <a:spcAft>
                 <a:spcPts val="100"/>
               </a:spcAft>
-              <a:defRPr sz="1200" b="1" i="0">
-                <a:solidFill>
-                  <a:srgbClr val="002060"/>
-                </a:solidFill>
-                <a:latin typeface="Gill Sans MT"/>
+              <a:defRPr sz="1400" b="1" i="0">
+                <a:solidFill>
+                  <a:srgbClr val="FDB813"/>
+                </a:solidFill>
+                <a:latin typeface="Calisto MT"/>
               </a:defRPr>
             </a:pPr>
             <a:r>
@@ -1772,132 +1773,132 @@
             </a:endParaRPr>
           </a:p>
           <a:p>
-            <a:pPr>
-              <a:lnSpc>
-                <a:spcPct val="110000"/>
+            <a:pPr algn="ctr">
+              <a:lnSpc>
+                <a:spcPct val="115000"/>
+              </a:lnSpc>
+              <a:spcAft>
+                <a:spcPts val="1400"/>
+              </a:spcAft>
+              <a:defRPr sz="1300" b="1" i="0">
+                <a:solidFill>
+                  <a:srgbClr val="E2E8F0"/>
+                </a:solidFill>
+                <a:latin typeface="Calisto MT"/>
+              </a:defRPr>
+            </a:pPr>
+            <a:r>
+              <a:t>DEPARTMENT OF COMPUTER ENGINEERING</a:t>
+            </a:r>
+          </a:p>
+          <a:p>
+            <a:pPr algn="ctr">
+              <a:lnSpc>
+                <a:spcPct val="115000"/>
               </a:lnSpc>
               <a:spcAft>
                 <a:spcPts val="1200"/>
               </a:spcAft>
+              <a:defRPr sz="1800" b="1" i="0">
+                <a:solidFill>
+                  <a:srgbClr val="FFFFFF"/>
+                </a:solidFill>
+                <a:latin typeface="Calisto MT"/>
+              </a:defRPr>
+            </a:pPr>
+            <a:r>
+              <a:t>DEVELOPMENT AND IMPLEMENTATION OF A ROBOTIC APPLICATION FOR HUMAN INTENTION RECOGNITION USING MOTION AND HAND GESTURE</a:t>
+            </a:r>
+          </a:p>
+          <a:p>
+            <a:pPr algn="ctr">
+              <a:lnSpc>
+                <a:spcPct val="115000"/>
+              </a:lnSpc>
+              <a:spcAft>
+                <a:spcPts val="1800"/>
+              </a:spcAft>
+              <a:defRPr sz="1200" b="0" i="1">
+                <a:solidFill>
+                  <a:srgbClr val="E2E8F0"/>
+                </a:solidFill>
+                <a:latin typeface="Calisto MT"/>
+              </a:defRPr>
+            </a:pPr>
+            <a:r>
+              <a:t>A Final Project Report Submitted in Partial Fulfillment of the Requirements for the Degree of Bachelor of Science in Computer Engineering</a:t>
+            </a:r>
+          </a:p>
+          <a:p>
+            <a:pPr algn="ctr">
+              <a:lnSpc>
+                <a:spcPct val="115000"/>
+              </a:lnSpc>
+              <a:spcAft>
+                <a:spcPts val="200"/>
+              </a:spcAft>
               <a:defRPr sz="1200" b="1" i="0">
                 <a:solidFill>
-                  <a:srgbClr val="002060"/>
-                </a:solidFill>
-                <a:latin typeface="Gill Sans MT"/>
-              </a:defRPr>
-            </a:pPr>
-            <a:r>
-              <a:t>DEPARTMENT OF COMPUTER ENGINEERING</a:t>
-            </a:r>
-          </a:p>
-          <a:p>
-            <a:pPr>
+                  <a:srgbClr val="FDB813"/>
+                </a:solidFill>
+                <a:latin typeface="Calisto MT"/>
+              </a:defRPr>
+            </a:pPr>
+            <a:r>
+              <a:t>PRESENTATION BY:</a:t>
+            </a:r>
+          </a:p>
+          <a:p>
+            <a:pPr algn="ctr">
               <a:lnSpc>
                 <a:spcPct val="115000"/>
               </a:lnSpc>
               <a:spcAft>
-                <a:spcPts val="1000"/>
-              </a:spcAft>
-              <a:defRPr sz="1450" b="1" i="0">
-                <a:solidFill>
-                  <a:srgbClr val="0F172A"/>
-                </a:solidFill>
-                <a:latin typeface="Gill Sans MT"/>
-              </a:defRPr>
-            </a:pPr>
-            <a:r>
-              <a:t>DEVELOPMENT AND IMPLEMENTATION OF A ROBOTIC APPLICATION FOR HUMAN INTENTION RECOGNITION USING MOTION AND HAND GESTURE</a:t>
-            </a:r>
-          </a:p>
-          <a:p>
-            <a:pPr>
+                <a:spcPts val="200"/>
+              </a:spcAft>
+              <a:defRPr sz="1350" b="1" i="0">
+                <a:solidFill>
+                  <a:srgbClr val="FFFFFF"/>
+                </a:solidFill>
+                <a:latin typeface="Calisto MT"/>
+              </a:defRPr>
+            </a:pPr>
+            <a:r>
+              <a:t>ELEANA OSEI OWUSU — 4121230024</a:t>
+            </a:r>
+          </a:p>
+          <a:p>
+            <a:pPr algn="ctr">
               <a:lnSpc>
                 <a:spcPct val="115000"/>
               </a:lnSpc>
               <a:spcAft>
                 <a:spcPts val="1600"/>
               </a:spcAft>
-              <a:defRPr sz="1050" b="0" i="1">
-                <a:solidFill>
-                  <a:srgbClr val="475569"/>
-                </a:solidFill>
-                <a:latin typeface="Gill Sans MT"/>
-              </a:defRPr>
-            </a:pPr>
-            <a:r>
-              <a:t>A Final Project Report Submitted in Partial Fulfillment of the Requirements for the Degree of Bachelor of Science in Computer Engineering</a:t>
-            </a:r>
-          </a:p>
-          <a:p>
-            <a:pPr>
-              <a:lnSpc>
-                <a:spcPct val="110000"/>
+              <a:defRPr sz="1350" b="1" i="0">
+                <a:solidFill>
+                  <a:srgbClr val="FFFFFF"/>
+                </a:solidFill>
+                <a:latin typeface="Calisto MT"/>
+              </a:defRPr>
+            </a:pPr>
+            <a:r>
+              <a:t>JOEL NII ADJETEY AHULU — 4121230020</a:t>
+            </a:r>
+          </a:p>
+          <a:p>
+            <a:pPr algn="ctr">
+              <a:lnSpc>
+                <a:spcPct val="115000"/>
               </a:lnSpc>
               <a:spcAft>
                 <a:spcPts val="200"/>
               </a:spcAft>
-              <a:defRPr sz="1050" b="1" i="0">
-                <a:solidFill>
-                  <a:srgbClr val="002060"/>
-                </a:solidFill>
-                <a:latin typeface="Gill Sans MT"/>
-              </a:defRPr>
-            </a:pPr>
-            <a:r>
-              <a:t>PRESENTED BY:</a:t>
-            </a:r>
-          </a:p>
-          <a:p>
-            <a:pPr>
-              <a:lnSpc>
-                <a:spcPct val="110000"/>
-              </a:lnSpc>
-              <a:spcAft>
-                <a:spcPts val="100"/>
-              </a:spcAft>
-              <a:defRPr sz="1100" b="1" i="0">
-                <a:solidFill>
-                  <a:srgbClr val="0F172A"/>
-                </a:solidFill>
-                <a:latin typeface="Gill Sans MT"/>
-              </a:defRPr>
-            </a:pPr>
-            <a:r>
-              <a:t>ELEANA OSEI OWUSU  (Index: 4121230024)</a:t>
-            </a:r>
-          </a:p>
-          <a:p>
-            <a:pPr>
-              <a:lnSpc>
-                <a:spcPct val="110000"/>
-              </a:lnSpc>
-              <a:spcAft>
-                <a:spcPts val="1400"/>
-              </a:spcAft>
-              <a:defRPr sz="1100" b="1" i="0">
-                <a:solidFill>
-                  <a:srgbClr val="0F172A"/>
-                </a:solidFill>
-                <a:latin typeface="Gill Sans MT"/>
-              </a:defRPr>
-            </a:pPr>
-            <a:r>
-              <a:t>JOEL NII ADJETEY AHULU  (Index: 4121230020)</a:t>
-            </a:r>
-          </a:p>
-          <a:p>
-            <a:pPr>
-              <a:lnSpc>
-                <a:spcPct val="110000"/>
-              </a:lnSpc>
-              <a:spcAft>
-                <a:spcPts val="200"/>
-              </a:spcAft>
-              <a:defRPr sz="1100" b="1" i="0">
-                <a:solidFill>
-                  <a:srgbClr val="002060"/>
-                </a:solidFill>
-                <a:latin typeface="Gill Sans MT"/>
+              <a:defRPr sz="1300" b="1" i="0">
+                <a:solidFill>
+                  <a:srgbClr val="FDB813"/>
+                </a:solidFill>
+                <a:latin typeface="Calisto MT"/>
               </a:defRPr>
             </a:pPr>
             <a:r>
@@ -1905,18 +1906,18 @@
             </a:r>
           </a:p>
           <a:p>
-            <a:pPr>
-              <a:lnSpc>
-                <a:spcPct val="110000"/>
-              </a:lnSpc>
-              <a:spcAft>
-                <a:spcPts val="0"/>
-              </a:spcAft>
-              <a:defRPr sz="1000" b="0" i="0">
-                <a:solidFill>
-                  <a:srgbClr val="64748B"/>
-                </a:solidFill>
-                <a:latin typeface="Gill Sans MT"/>
+            <a:pPr algn="ctr">
+              <a:lnSpc>
+                <a:spcPct val="115000"/>
+              </a:lnSpc>
+              <a:spcAft>
+                <a:spcPts val="0"/>
+              </a:spcAft>
+              <a:defRPr sz="1150" b="0" i="0">
+                <a:solidFill>
+                  <a:srgbClr val="E2E8F0"/>
+                </a:solidFill>
+                <a:latin typeface="Calisto MT"/>
               </a:defRPr>
             </a:pPr>
             <a:r>
@@ -1959,51 +1960,6 @@
               </a:buClr>
               <a:buSzPts val="1100"/>
             </a:pPr>
-            <a:br>
-              <a:rPr lang="en-US" sz="2000" b="1" dirty="0">
-                <a:solidFill>
-                  <a:srgbClr val="000000"/>
-                </a:solidFill>
-                <a:latin typeface="Arial" panose="020B0604020202020204" pitchFamily="34" charset="0"/>
-                <a:ea typeface="Times New Roman" panose="02020603050405020304"/>
-                <a:cs typeface="Arial" panose="020B0604020202020204" pitchFamily="34" charset="0"/>
-                <a:sym typeface="Times New Roman" panose="02020603050405020304"/>
-              </a:rPr>
-            </a:br>
-            <a:br>
-              <a:rPr lang="en-US" sz="2000" b="1" dirty="0">
-                <a:solidFill>
-                  <a:srgbClr val="000000"/>
-                </a:solidFill>
-                <a:latin typeface="Arial" panose="020B0604020202020204" pitchFamily="34" charset="0"/>
-                <a:ea typeface="Times New Roman" panose="02020603050405020304"/>
-                <a:cs typeface="Arial" panose="020B0604020202020204" pitchFamily="34" charset="0"/>
-                <a:sym typeface="Times New Roman" panose="02020603050405020304"/>
-              </a:rPr>
-            </a:br>
-            <a:br>
-              <a:rPr lang="en-US" sz="2000" b="1" dirty="0">
-                <a:solidFill>
-                  <a:srgbClr val="000000"/>
-                </a:solidFill>
-                <a:latin typeface="Arial" panose="020B0604020202020204" pitchFamily="34" charset="0"/>
-                <a:ea typeface="Times New Roman" panose="02020603050405020304"/>
-                <a:cs typeface="Arial" panose="020B0604020202020204" pitchFamily="34" charset="0"/>
-                <a:sym typeface="Times New Roman" panose="02020603050405020304"/>
-              </a:rPr>
-            </a:br>
-            <a:r>
-              <a:rPr lang="en-US" sz="2000" b="1" dirty="0">
-                <a:solidFill>
-                  <a:srgbClr val="000000"/>
-                </a:solidFill>
-                <a:latin typeface="Arial" panose="020B0604020202020204" pitchFamily="34" charset="0"/>
-                <a:ea typeface="Times New Roman" panose="02020603050405020304"/>
-                <a:cs typeface="Arial" panose="020B0604020202020204" pitchFamily="34" charset="0"/>
-                <a:sym typeface="Times New Roman" panose="02020603050405020304"/>
-              </a:rPr>
-              <a:t>  </a:t>
-            </a:r>
             <a:endParaRPr lang="en-US" sz="3200" b="1" dirty="0">
               <a:solidFill>
                 <a:schemeClr val="tx1">
@@ -2130,7 +2086,26 @@
           </a:bodyPr>
           <a:lstStyle/>
           <a:p>
-            <a:pPr algn="ctr"/>
+            <a:pPr algn="ctr">
+              <a:lnSpc>
+                <a:spcPct val="115000"/>
+              </a:lnSpc>
+              <a:spcBef>
+                <a:spcPts val="0"/>
+              </a:spcBef>
+              <a:spcAft>
+                <a:spcPts val="200"/>
+              </a:spcAft>
+              <a:defRPr sz="2800" b="1" i="0">
+                <a:solidFill>
+                  <a:srgbClr val="002060"/>
+                </a:solidFill>
+                <a:latin typeface="Calisto MT"/>
+              </a:defRPr>
+            </a:pPr>
+            <a:r>
+              <a:t>PRESENTATION OUTLINE</a:t>
+            </a:r>
             <a:endParaRPr lang="en-GB" sz="4000" b="1" u="sng" dirty="0">
               <a:solidFill>
                 <a:srgbClr val="C00000"/>
@@ -2173,6 +2148,143 @@
               <a:latin typeface="Gill Sans MT" panose="020B0502020104020203" pitchFamily="34" charset="0"/>
               <a:cs typeface="Gill Sans MT" panose="020B0502020104020203" pitchFamily="34" charset="0"/>
             </a:endParaRPr>
+          </a:p>
+        </p:txBody>
+      </p:sp>
+      <p:sp>
+        <p:nvSpPr>
+          <p:cNvPr id="6" name="Outline_Box"/>
+          <p:cNvSpPr txBox="1"/>
+          <p:nvPr/>
+        </p:nvSpPr>
+        <p:spPr>
+          <a:xfrm>
+            <a:off x="1371600" y="1645920"/>
+            <a:ext cx="9445752" cy="4114800"/>
+          </a:xfrm>
+          <a:prstGeom prst="rect">
+            <a:avLst/>
+          </a:prstGeom>
+          <a:noFill/>
+        </p:spPr>
+        <p:txBody>
+          <a:bodyPr wrap="square" tIns="91440" bIns="91440">
+            <a:spAutoFit/>
+          </a:bodyPr>
+          <a:lstStyle/>
+          <a:p>
+            <a:pPr algn="l">
+              <a:lnSpc>
+                <a:spcPct val="120000"/>
+              </a:lnSpc>
+              <a:spcAft>
+                <a:spcPts val="1800"/>
+              </a:spcAft>
+              <a:defRPr sz="2400" b="1">
+                <a:solidFill>
+                  <a:srgbClr val="002060"/>
+                </a:solidFill>
+                <a:latin typeface="Calisto MT"/>
+              </a:defRPr>
+            </a:pPr>
+            <a:r>
+              <a:t>01. Introduction, Problem Statement &amp; Objectives</a:t>
+            </a:r>
+          </a:p>
+          <a:p>
+            <a:pPr algn="l">
+              <a:lnSpc>
+                <a:spcPct val="120000"/>
+              </a:lnSpc>
+              <a:spcAft>
+                <a:spcPts val="1800"/>
+              </a:spcAft>
+              <a:defRPr sz="2400" b="1">
+                <a:solidFill>
+                  <a:srgbClr val="002060"/>
+                </a:solidFill>
+                <a:latin typeface="Calisto MT"/>
+              </a:defRPr>
+            </a:pPr>
+            <a:r>
+              <a:t>02. Literature Review &amp; Critical Research Gaps</a:t>
+            </a:r>
+          </a:p>
+          <a:p>
+            <a:pPr algn="l">
+              <a:lnSpc>
+                <a:spcPct val="120000"/>
+              </a:lnSpc>
+              <a:spcAft>
+                <a:spcPts val="1800"/>
+              </a:spcAft>
+              <a:defRPr sz="2400" b="1">
+                <a:solidFill>
+                  <a:srgbClr val="002060"/>
+                </a:solidFill>
+                <a:latin typeface="Calisto MT"/>
+              </a:defRPr>
+            </a:pPr>
+            <a:r>
+              <a:t>03. System Architecture &amp; 6-Phase Methodology</a:t>
+            </a:r>
+          </a:p>
+          <a:p>
+            <a:pPr algn="l">
+              <a:lnSpc>
+                <a:spcPct val="120000"/>
+              </a:lnSpc>
+              <a:spcAft>
+                <a:spcPts val="1800"/>
+              </a:spcAft>
+              <a:defRPr sz="2400" b="1">
+                <a:solidFill>
+                  <a:srgbClr val="002060"/>
+                </a:solidFill>
+                <a:latin typeface="Calisto MT"/>
+              </a:defRPr>
+            </a:pPr>
+            <a:r>
+              <a:t>04. Implementation &amp; Intelligent Algorithms</a:t>
+            </a:r>
+          </a:p>
+          <a:p>
+            <a:pPr algn="l">
+              <a:lnSpc>
+                <a:spcPct val="120000"/>
+              </a:lnSpc>
+              <a:spcAft>
+                <a:spcPts val="1800"/>
+              </a:spcAft>
+              <a:defRPr sz="2400" b="1">
+                <a:solidFill>
+                  <a:srgbClr val="002060"/>
+                </a:solidFill>
+                <a:latin typeface="Calisto MT"/>
+              </a:defRPr>
+            </a:pPr>
+            <a:r>
+              <a:t>05. Experimental Results &amp; ISO Safety Compliance</a:t>
+            </a:r>
+          </a:p>
+          <a:p>
+            <a:pPr algn="l">
+              <a:lnSpc>
+                <a:spcPct val="120000"/>
+              </a:lnSpc>
+              <a:spcAft>
+                <a:spcPts val="1800"/>
+              </a:spcAft>
+              <a:defRPr sz="2400" b="1">
+                <a:solidFill>
+                  <a:srgbClr val="002060"/>
+                </a:solidFill>
+                <a:latin typeface="Calisto MT"/>
+              </a:defRPr>
+            </a:pPr>
+            <a:r>
+              <a:t>06. Conclusion &amp; Physical Demonstration Transition</a:t>
+            </a:r>
           </a:p>
         </p:txBody>
       </p:sp>
@@ -2223,7 +2335,26 @@
           </a:bodyPr>
           <a:lstStyle/>
           <a:p>
-            <a:pPr algn="ctr"/>
+            <a:pPr algn="ctr">
+              <a:lnSpc>
+                <a:spcPct val="115000"/>
+              </a:lnSpc>
+              <a:spcBef>
+                <a:spcPts val="0"/>
+              </a:spcBef>
+              <a:spcAft>
+                <a:spcPts val="200"/>
+              </a:spcAft>
+              <a:defRPr sz="2800" b="1" i="0">
+                <a:solidFill>
+                  <a:srgbClr val="002060"/>
+                </a:solidFill>
+                <a:latin typeface="Calisto MT"/>
+              </a:defRPr>
+            </a:pPr>
+            <a:r>
+              <a:t>01. INTRODUCTION &amp; RESEARCH BACKGROUND</a:t>
+            </a:r>
             <a:endParaRPr lang="en-US" sz="4000" b="1" u="sng" dirty="0">
               <a:gradFill>
                 <a:gsLst>
@@ -2272,6 +2403,230 @@
               <a:latin typeface="Gill Sans MT" panose="020B0502020104020203" pitchFamily="34" charset="0"/>
               <a:cs typeface="Gill Sans MT" panose="020B0502020104020203" pitchFamily="34" charset="0"/>
             </a:endParaRPr>
+          </a:p>
+        </p:txBody>
+      </p:sp>
+      <p:sp>
+        <p:nvSpPr>
+          <p:cNvPr id="4" name="Intro_Text"/>
+          <p:cNvSpPr txBox="1"/>
+          <p:nvPr/>
+        </p:nvSpPr>
+        <p:spPr>
+          <a:xfrm>
+            <a:off x="777240" y="1325880"/>
+            <a:ext cx="6263640" cy="4480560"/>
+          </a:xfrm>
+          <a:prstGeom prst="rect">
+            <a:avLst/>
+          </a:prstGeom>
+          <a:noFill/>
+        </p:spPr>
+        <p:txBody>
+          <a:bodyPr wrap="square" tIns="91440" bIns="91440">
+            <a:spAutoFit/>
+          </a:bodyPr>
+          <a:lstStyle/>
+          <a:p>
+            <a:pPr algn="l">
+              <a:lnSpc>
+                <a:spcPct val="115000"/>
+              </a:lnSpc>
+              <a:spcBef>
+                <a:spcPts val="0"/>
+              </a:spcBef>
+              <a:spcAft>
+                <a:spcPts val="300"/>
+              </a:spcAft>
+              <a:defRPr sz="1800" b="1" i="0">
+                <a:solidFill>
+                  <a:srgbClr val="002060"/>
+                </a:solidFill>
+                <a:latin typeface="Calisto MT"/>
+              </a:defRPr>
+            </a:pPr>
+            <a:r>
+              <a:t>Robots Working Directly with Humans</a:t>
+            </a:r>
+          </a:p>
+          <a:p>
+            <a:pPr algn="l">
+              <a:lnSpc>
+                <a:spcPct val="118000"/>
+              </a:lnSpc>
+              <a:spcBef>
+                <a:spcPts val="0"/>
+              </a:spcBef>
+              <a:spcAft>
+                <a:spcPts val="1400"/>
+              </a:spcAft>
+              <a:defRPr sz="1500" b="0" i="0">
+                <a:solidFill>
+                  <a:srgbClr val="1E293B"/>
+                </a:solidFill>
+                <a:latin typeface="Calisto MT"/>
+              </a:defRPr>
+            </a:pPr>
+            <a:r>
+              <a:t>Robots are leaving safety cages to work alongside people in hospitals, warehouses, and homes. For humans and robots to coexist safely, the robot must understand where people are and respect their personal space.</a:t>
+            </a:r>
+          </a:p>
+          <a:p>
+            <a:pPr algn="l">
+              <a:lnSpc>
+                <a:spcPct val="115000"/>
+              </a:lnSpc>
+              <a:spcBef>
+                <a:spcPts val="0"/>
+              </a:spcBef>
+              <a:spcAft>
+                <a:spcPts val="300"/>
+              </a:spcAft>
+              <a:defRPr sz="1800" b="1" i="0">
+                <a:solidFill>
+                  <a:srgbClr val="002060"/>
+                </a:solidFill>
+                <a:latin typeface="Calisto MT"/>
+              </a:defRPr>
+            </a:pPr>
+            <a:r>
+              <a:t>Natural, Hands-Free Interaction</a:t>
+            </a:r>
+          </a:p>
+          <a:p>
+            <a:pPr algn="l">
+              <a:lnSpc>
+                <a:spcPct val="118000"/>
+              </a:lnSpc>
+              <a:spcBef>
+                <a:spcPts val="0"/>
+              </a:spcBef>
+              <a:spcAft>
+                <a:spcPts val="1400"/>
+              </a:spcAft>
+              <a:defRPr sz="1500" b="0" i="0">
+                <a:solidFill>
+                  <a:srgbClr val="1E293B"/>
+                </a:solidFill>
+                <a:latin typeface="Calisto MT"/>
+              </a:defRPr>
+            </a:pPr>
+            <a:r>
+              <a:t>Instead of requiring handheld controllers, touchscreens, or keyboards, humans can guide the robot using natural hand gestures and body movement—just like signaling to a human coworker.</a:t>
+            </a:r>
+          </a:p>
+          <a:p>
+            <a:pPr algn="l">
+              <a:lnSpc>
+                <a:spcPct val="115000"/>
+              </a:lnSpc>
+              <a:spcBef>
+                <a:spcPts val="0"/>
+              </a:spcBef>
+              <a:spcAft>
+                <a:spcPts val="300"/>
+              </a:spcAft>
+              <a:defRPr sz="1800" b="1" i="0">
+                <a:solidFill>
+                  <a:srgbClr val="002060"/>
+                </a:solidFill>
+                <a:latin typeface="Calisto MT"/>
+              </a:defRPr>
+            </a:pPr>
+            <a:r>
+              <a:t>Fast Onboard Intelligence (No Cloud Lag)</a:t>
+            </a:r>
+          </a:p>
+          <a:p>
+            <a:pPr algn="l">
+              <a:lnSpc>
+                <a:spcPct val="118000"/>
+              </a:lnSpc>
+              <a:spcBef>
+                <a:spcPts val="0"/>
+              </a:spcBef>
+              <a:spcAft>
+                <a:spcPts val="0"/>
+              </a:spcAft>
+              <a:defRPr sz="1500" b="0" i="0">
+                <a:solidFill>
+                  <a:srgbClr val="1E293B"/>
+                </a:solidFill>
+                <a:latin typeface="Calisto MT"/>
+              </a:defRPr>
+            </a:pPr>
+            <a:r>
+              <a:t>Sending live video over the internet causes dangerous delays (&gt;200 ms) and fails when Wi-Fi drops. In this project, all AI recognition and navigation decisions happen entirely inside the robot in real time.</a:t>
+            </a:r>
+          </a:p>
+        </p:txBody>
+      </p:sp>
+      <p:pic>
+        <p:nvPicPr>
+          <p:cNvPr id="5" name="Intro_Image" descr="shared_workspace_human_robot.jpg"/>
+          <p:cNvPicPr>
+            <a:picLocks noChangeAspect="1"/>
+          </p:cNvPicPr>
+          <p:nvPr/>
+        </p:nvPicPr>
+        <p:blipFill>
+          <a:blip r:embed="rId3"/>
+          <a:stretch>
+            <a:fillRect/>
+          </a:stretch>
+        </p:blipFill>
+        <p:spPr>
+          <a:xfrm>
+            <a:off x="7315200" y="1417320"/>
+            <a:ext cx="4206240" cy="3154680"/>
+          </a:xfrm>
+          <a:prstGeom prst="rect">
+            <a:avLst/>
+          </a:prstGeom>
+        </p:spPr>
+      </p:pic>
+      <p:sp>
+        <p:nvSpPr>
+          <p:cNvPr id="6" name="Intro_Caption"/>
+          <p:cNvSpPr txBox="1"/>
+          <p:nvPr/>
+        </p:nvSpPr>
+        <p:spPr>
+          <a:xfrm>
+            <a:off x="7315200" y="4681728"/>
+            <a:ext cx="4206240" cy="731520"/>
+          </a:xfrm>
+          <a:prstGeom prst="rect">
+            <a:avLst/>
+          </a:prstGeom>
+          <a:noFill/>
+        </p:spPr>
+        <p:txBody>
+          <a:bodyPr wrap="square" lIns="45720" rIns="45720">
+            <a:spAutoFit/>
+          </a:bodyPr>
+          <a:lstStyle/>
+          <a:p>
+            <a:pPr algn="ctr">
+              <a:lnSpc>
+                <a:spcPct val="115000"/>
+              </a:lnSpc>
+              <a:spcBef>
+                <a:spcPts val="0"/>
+              </a:spcBef>
+              <a:spcAft>
+                <a:spcPts val="200"/>
+              </a:spcAft>
+              <a:defRPr sz="1200" b="0" i="1">
+                <a:solidFill>
+                  <a:srgbClr val="475569"/>
+                </a:solidFill>
+                <a:latin typeface="Calisto MT"/>
+              </a:defRPr>
+            </a:pPr>
+            <a:r>
+              <a:t>Figure 1.1: Collaborative Human-Robot Interaction (HRI) in an industrial shared workspace, illustrating contactless gesture coordination.</a:t>
+            </a:r>
           </a:p>
         </p:txBody>
       </p:sp>
@@ -2322,7 +2677,26 @@
           </a:bodyPr>
           <a:lstStyle/>
           <a:p>
-            <a:pPr algn="ctr"/>
+            <a:pPr algn="ctr">
+              <a:lnSpc>
+                <a:spcPct val="115000"/>
+              </a:lnSpc>
+              <a:spcBef>
+                <a:spcPts val="0"/>
+              </a:spcBef>
+              <a:spcAft>
+                <a:spcPts val="200"/>
+              </a:spcAft>
+              <a:defRPr sz="2800" b="1" i="0">
+                <a:solidFill>
+                  <a:srgbClr val="002060"/>
+                </a:solidFill>
+                <a:latin typeface="Calisto MT"/>
+              </a:defRPr>
+            </a:pPr>
+            <a:r>
+              <a:t>02. PROBLEM STATEMENT</a:t>
+            </a:r>
             <a:endParaRPr lang="en-US" sz="4000" b="1" u="sng" dirty="0">
               <a:solidFill>
                 <a:srgbClr val="C00000"/>
@@ -2363,6 +2737,335 @@
               <a:latin typeface="Gill Sans MT" panose="020B0502020104020203" pitchFamily="34" charset="0"/>
               <a:cs typeface="Times New Roman" panose="02020603050405020304" pitchFamily="18" charset="0"/>
             </a:endParaRPr>
+          </a:p>
+        </p:txBody>
+      </p:sp>
+      <p:sp>
+        <p:nvSpPr>
+          <p:cNvPr id="4" name="Prob_Core"/>
+          <p:cNvSpPr txBox="1"/>
+          <p:nvPr/>
+        </p:nvSpPr>
+        <p:spPr>
+          <a:xfrm>
+            <a:off x="777240" y="1234440"/>
+            <a:ext cx="10634472" cy="2011680"/>
+          </a:xfrm>
+          <a:prstGeom prst="rect">
+            <a:avLst/>
+          </a:prstGeom>
+          <a:noFill/>
+        </p:spPr>
+        <p:txBody>
+          <a:bodyPr wrap="square">
+            <a:spAutoFit/>
+          </a:bodyPr>
+          <a:lstStyle/>
+          <a:p>
+            <a:pPr algn="ctr">
+              <a:lnSpc>
+                <a:spcPct val="120000"/>
+              </a:lnSpc>
+              <a:spcBef>
+                <a:spcPts val="0"/>
+              </a:spcBef>
+              <a:spcAft>
+                <a:spcPts val="1200"/>
+              </a:spcAft>
+              <a:defRPr sz="2100" b="0" i="0">
+                <a:solidFill>
+                  <a:srgbClr val="1E293B"/>
+                </a:solidFill>
+                <a:latin typeface="Calisto MT"/>
+              </a:defRPr>
+            </a:pPr>
+            <a:r>
+              <a:t>Current mobile robots separate vision recognition from active navigation, relying on remote cloud servers that suffer from high network lag (&gt;200 ms) and connection dropouts.</a:t>
+            </a:r>
+          </a:p>
+          <a:p>
+            <a:pPr algn="ctr">
+              <a:lnSpc>
+                <a:spcPct val="120000"/>
+              </a:lnSpc>
+              <a:spcBef>
+                <a:spcPts val="0"/>
+              </a:spcBef>
+              <a:spcAft>
+                <a:spcPts val="0"/>
+              </a:spcAft>
+              <a:defRPr sz="2100" b="0" i="0">
+                <a:solidFill>
+                  <a:srgbClr val="1E293B"/>
+                </a:solidFill>
+                <a:latin typeface="Calisto MT"/>
+              </a:defRPr>
+            </a:pPr>
+            <a:r>
+              <a:t>In shared human-robot workspaces, this delay prevents robots from reacting in real time to human gestures, creating severe collision hazards under ISO 15066 safety standards.</a:t>
+            </a:r>
+          </a:p>
+        </p:txBody>
+      </p:sp>
+      <p:sp>
+        <p:nvSpPr>
+          <p:cNvPr id="5" name="Prob_Card_0"/>
+          <p:cNvSpPr/>
+          <p:nvPr/>
+        </p:nvSpPr>
+        <p:spPr>
+          <a:xfrm>
+            <a:off x="777240" y="3886200"/>
+            <a:ext cx="3319272" cy="1691640"/>
+          </a:xfrm>
+          <a:prstGeom prst="roundRect">
+            <a:avLst/>
+          </a:prstGeom>
+          <a:solidFill>
+            <a:srgbClr val="FFFFFF"/>
+          </a:solidFill>
+          <a:ln w="15240">
+            <a:solidFill>
+              <a:srgbClr val="CBD5E1"/>
+            </a:solidFill>
+          </a:ln>
+        </p:spPr>
+        <p:style>
+          <a:lnRef idx="1">
+            <a:schemeClr val="accent1"/>
+          </a:lnRef>
+          <a:fillRef idx="3">
+            <a:schemeClr val="accent1"/>
+          </a:fillRef>
+          <a:effectRef idx="2">
+            <a:schemeClr val="accent1"/>
+          </a:effectRef>
+          <a:fontRef idx="minor">
+            <a:schemeClr val="lt1"/>
+          </a:fontRef>
+        </p:style>
+        <p:txBody>
+          <a:bodyPr rtlCol="0" anchor="ctr" wrap="square" lIns="164592" rIns="164592" tIns="164592" bIns="137160"/>
+          <a:lstStyle/>
+          <a:p>
+            <a:pPr algn="ctr">
+              <a:lnSpc>
+                <a:spcPct val="115000"/>
+              </a:lnSpc>
+              <a:spcBef>
+                <a:spcPts val="0"/>
+              </a:spcBef>
+              <a:spcAft>
+                <a:spcPts val="600"/>
+              </a:spcAft>
+              <a:defRPr sz="1500" b="1" i="0">
+                <a:solidFill>
+                  <a:srgbClr val="002060"/>
+                </a:solidFill>
+                <a:latin typeface="Calisto MT"/>
+              </a:defRPr>
+            </a:pPr>
+            <a:r>
+              <a:t>PERCEPTION-ACTION GAP</a:t>
+            </a:r>
+          </a:p>
+          <a:p>
+            <a:pPr algn="ctr">
+              <a:lnSpc>
+                <a:spcPct val="118000"/>
+              </a:lnSpc>
+              <a:spcBef>
+                <a:spcPts val="0"/>
+              </a:spcBef>
+              <a:spcAft>
+                <a:spcPts val="200"/>
+              </a:spcAft>
+              <a:defRPr sz="1300" b="0" i="0">
+                <a:solidFill>
+                  <a:srgbClr val="1E293B"/>
+                </a:solidFill>
+                <a:latin typeface="Calisto MT"/>
+              </a:defRPr>
+            </a:pPr>
+            <a:r>
+              <a:t>Vision AI isolated from wheel motors &amp; obstacle avoidance</a:t>
+            </a:r>
+            <a:br/>
+            <a:r>
+              <a:t>(Tsitos et al., 2022)</a:t>
+            </a:r>
+          </a:p>
+        </p:txBody>
+      </p:sp>
+      <p:sp>
+        <p:nvSpPr>
+          <p:cNvPr id="6" name="Prob_Card_1"/>
+          <p:cNvSpPr/>
+          <p:nvPr/>
+        </p:nvSpPr>
+        <p:spPr>
+          <a:xfrm>
+            <a:off x="4434840" y="3886200"/>
+            <a:ext cx="3319272" cy="1691640"/>
+          </a:xfrm>
+          <a:prstGeom prst="roundRect">
+            <a:avLst/>
+          </a:prstGeom>
+          <a:solidFill>
+            <a:srgbClr val="FFFFFF"/>
+          </a:solidFill>
+          <a:ln w="15240">
+            <a:solidFill>
+              <a:srgbClr val="CBD5E1"/>
+            </a:solidFill>
+          </a:ln>
+        </p:spPr>
+        <p:style>
+          <a:lnRef idx="1">
+            <a:schemeClr val="accent1"/>
+          </a:lnRef>
+          <a:fillRef idx="3">
+            <a:schemeClr val="accent1"/>
+          </a:fillRef>
+          <a:effectRef idx="2">
+            <a:schemeClr val="accent1"/>
+          </a:effectRef>
+          <a:fontRef idx="minor">
+            <a:schemeClr val="lt1"/>
+          </a:fontRef>
+        </p:style>
+        <p:txBody>
+          <a:bodyPr rtlCol="0" anchor="ctr" wrap="square" lIns="164592" rIns="164592" tIns="164592" bIns="137160"/>
+          <a:lstStyle/>
+          <a:p>
+            <a:pPr algn="ctr">
+              <a:lnSpc>
+                <a:spcPct val="115000"/>
+              </a:lnSpc>
+              <a:spcBef>
+                <a:spcPts val="0"/>
+              </a:spcBef>
+              <a:spcAft>
+                <a:spcPts val="600"/>
+              </a:spcAft>
+              <a:defRPr sz="1500" b="1" i="0">
+                <a:solidFill>
+                  <a:srgbClr val="002060"/>
+                </a:solidFill>
+                <a:latin typeface="Calisto MT"/>
+              </a:defRPr>
+            </a:pPr>
+            <a:r>
+              <a:t>CLOUD LATENCY HAZARD</a:t>
+            </a:r>
+          </a:p>
+          <a:p>
+            <a:pPr algn="ctr">
+              <a:lnSpc>
+                <a:spcPct val="118000"/>
+              </a:lnSpc>
+              <a:spcBef>
+                <a:spcPts val="0"/>
+              </a:spcBef>
+              <a:spcAft>
+                <a:spcPts val="200"/>
+              </a:spcAft>
+              <a:defRPr sz="1300" b="0" i="0">
+                <a:solidFill>
+                  <a:srgbClr val="1E293B"/>
+                </a:solidFill>
+                <a:latin typeface="Calisto MT"/>
+              </a:defRPr>
+            </a:pPr>
+            <a:r>
+              <a:t>Network lag &gt; 200 ms &amp; Wi-Fi drops violate ISO 15066 safe stopping margins</a:t>
+            </a:r>
+          </a:p>
+        </p:txBody>
+      </p:sp>
+      <p:sp>
+        <p:nvSpPr>
+          <p:cNvPr id="7" name="Prob_Card_2"/>
+          <p:cNvSpPr/>
+          <p:nvPr/>
+        </p:nvSpPr>
+        <p:spPr>
+          <a:xfrm>
+            <a:off x="8092440" y="3886200"/>
+            <a:ext cx="3319272" cy="1691640"/>
+          </a:xfrm>
+          <a:prstGeom prst="roundRect">
+            <a:avLst/>
+          </a:prstGeom>
+          <a:solidFill>
+            <a:srgbClr val="FFFFFF"/>
+          </a:solidFill>
+          <a:ln w="15240">
+            <a:solidFill>
+              <a:srgbClr val="CBD5E1"/>
+            </a:solidFill>
+          </a:ln>
+        </p:spPr>
+        <p:style>
+          <a:lnRef idx="1">
+            <a:schemeClr val="accent1"/>
+          </a:lnRef>
+          <a:fillRef idx="3">
+            <a:schemeClr val="accent1"/>
+          </a:fillRef>
+          <a:effectRef idx="2">
+            <a:schemeClr val="accent1"/>
+          </a:effectRef>
+          <a:fontRef idx="minor">
+            <a:schemeClr val="lt1"/>
+          </a:fontRef>
+        </p:style>
+        <p:txBody>
+          <a:bodyPr rtlCol="0" anchor="ctr" wrap="square" lIns="164592" rIns="164592" tIns="164592" bIns="137160"/>
+          <a:lstStyle/>
+          <a:p>
+            <a:pPr algn="ctr">
+              <a:lnSpc>
+                <a:spcPct val="115000"/>
+              </a:lnSpc>
+              <a:spcBef>
+                <a:spcPts val="0"/>
+              </a:spcBef>
+              <a:spcAft>
+                <a:spcPts val="600"/>
+              </a:spcAft>
+              <a:defRPr sz="1500" b="1" i="0">
+                <a:solidFill>
+                  <a:srgbClr val="002060"/>
+                </a:solidFill>
+                <a:latin typeface="Calisto MT"/>
+              </a:defRPr>
+            </a:pPr>
+            <a:r>
+              <a:t>EDGE COMPUTING LIMIT</a:t>
+            </a:r>
+          </a:p>
+          <a:p>
+            <a:pPr algn="ctr">
+              <a:lnSpc>
+                <a:spcPct val="118000"/>
+              </a:lnSpc>
+              <a:spcBef>
+                <a:spcPts val="0"/>
+              </a:spcBef>
+              <a:spcAft>
+                <a:spcPts val="200"/>
+              </a:spcAft>
+              <a:defRPr sz="1300" b="0" i="0">
+                <a:solidFill>
+                  <a:srgbClr val="1E293B"/>
+                </a:solidFill>
+                <a:latin typeface="Calisto MT"/>
+              </a:defRPr>
+            </a:pPr>
+            <a:r>
+              <a:t>Heavy vision AI overheats mobile chips; demands a sub-135 ms onboard pipeline</a:t>
+            </a:r>
           </a:p>
         </p:txBody>
       </p:sp>
@@ -2419,7 +3122,26 @@
           </a:bodyPr>
           <a:lstStyle/>
           <a:p>
-            <a:pPr algn="ctr"/>
+            <a:pPr algn="ctr">
+              <a:lnSpc>
+                <a:spcPct val="115000"/>
+              </a:lnSpc>
+              <a:spcBef>
+                <a:spcPts val="0"/>
+              </a:spcBef>
+              <a:spcAft>
+                <a:spcPts val="200"/>
+              </a:spcAft>
+              <a:defRPr sz="2800" b="1" i="0">
+                <a:solidFill>
+                  <a:srgbClr val="002060"/>
+                </a:solidFill>
+                <a:latin typeface="Calisto MT"/>
+              </a:defRPr>
+            </a:pPr>
+            <a:r>
+              <a:t>03. PROJECT OBJECTIVES</a:t>
+            </a:r>
             <a:endParaRPr lang="en-US" sz="4000" b="1" u="sng" dirty="0">
               <a:solidFill>
                 <a:srgbClr val="C00000"/>
@@ -2461,12 +3183,1199 @@
           </a:p>
         </p:txBody>
       </p:sp>
+      <p:sp>
+        <p:nvSpPr>
+          <p:cNvPr id="4" name="Obj_Gen_Text"/>
+          <p:cNvSpPr txBox="1"/>
+          <p:nvPr/>
+        </p:nvSpPr>
+        <p:spPr>
+          <a:xfrm>
+            <a:off x="914400" y="1143000"/>
+            <a:ext cx="10360152" cy="960120"/>
+          </a:xfrm>
+          <a:prstGeom prst="rect">
+            <a:avLst/>
+          </a:prstGeom>
+          <a:noFill/>
+        </p:spPr>
+        <p:txBody>
+          <a:bodyPr wrap="square" lIns="45720" rIns="45720" tIns="18288" bIns="18288">
+            <a:spAutoFit/>
+          </a:bodyPr>
+          <a:lstStyle/>
+          <a:p>
+            <a:pPr algn="ctr">
+              <a:lnSpc>
+                <a:spcPct val="115000"/>
+              </a:lnSpc>
+              <a:spcBef>
+                <a:spcPts val="0"/>
+              </a:spcBef>
+              <a:spcAft>
+                <a:spcPts val="400"/>
+              </a:spcAft>
+              <a:defRPr sz="1300" b="1" i="0">
+                <a:solidFill>
+                  <a:srgbClr val="B8860B"/>
+                </a:solidFill>
+                <a:latin typeface="Calisto MT"/>
+              </a:defRPr>
+            </a:pPr>
+            <a:r>
+              <a:t>GENERAL OBJECTIVE</a:t>
+            </a:r>
+          </a:p>
+          <a:p>
+            <a:pPr algn="ctr">
+              <a:lnSpc>
+                <a:spcPct val="118000"/>
+              </a:lnSpc>
+              <a:spcBef>
+                <a:spcPts val="0"/>
+              </a:spcBef>
+              <a:spcAft>
+                <a:spcPts val="200"/>
+              </a:spcAft>
+              <a:defRPr sz="1500" b="0" i="0">
+                <a:solidFill>
+                  <a:srgbClr val="1E293B"/>
+                </a:solidFill>
+                <a:latin typeface="Calisto MT"/>
+              </a:defRPr>
+            </a:pPr>
+            <a:r>
+              <a:t>To design, implement, and evaluate an edge-deployed, real-time human intention recognition and autonomous navigation system powered by ROS 2 on an embedded mobile robot.</a:t>
+            </a:r>
+          </a:p>
+        </p:txBody>
+      </p:sp>
+      <p:cxnSp>
+        <p:nvCxnSpPr>
+          <p:cNvPr id="5" name="Obj_Divider_Line"/>
+          <p:cNvCxnSpPr/>
+          <p:nvPr/>
+        </p:nvCxnSpPr>
+        <p:spPr>
+          <a:xfrm>
+            <a:off x="2286000" y="2240280"/>
+            <a:ext cx="7616952" cy="0"/>
+          </a:xfrm>
+          <a:prstGeom prst="line">
+            <a:avLst/>
+          </a:prstGeom>
+          <a:ln w="10160">
+            <a:solidFill>
+              <a:srgbClr val="CBD5E1"/>
+            </a:solidFill>
+          </a:ln>
+        </p:spPr>
+        <p:style>
+          <a:lnRef idx="2">
+            <a:schemeClr val="accent1"/>
+          </a:lnRef>
+          <a:fillRef idx="0">
+            <a:schemeClr val="accent1"/>
+          </a:fillRef>
+          <a:effectRef idx="1">
+            <a:schemeClr val="accent1"/>
+          </a:effectRef>
+          <a:fontRef idx="minor">
+            <a:schemeClr val="tx1"/>
+          </a:fontRef>
+        </p:style>
+      </p:cxnSp>
+      <p:sp>
+        <p:nvSpPr>
+          <p:cNvPr id="6" name="Obj_Item_0"/>
+          <p:cNvSpPr txBox="1"/>
+          <p:nvPr/>
+        </p:nvSpPr>
+        <p:spPr>
+          <a:xfrm>
+            <a:off x="914400" y="2423160"/>
+            <a:ext cx="4892040" cy="960120"/>
+          </a:xfrm>
+          <a:prstGeom prst="rect">
+            <a:avLst/>
+          </a:prstGeom>
+          <a:noFill/>
+        </p:spPr>
+        <p:txBody>
+          <a:bodyPr wrap="square" lIns="45720" rIns="45720" tIns="18288" bIns="18288">
+            <a:spAutoFit/>
+          </a:bodyPr>
+          <a:lstStyle/>
+          <a:p>
+            <a:pPr algn="l">
+              <a:spcAft>
+                <a:spcPts val="200"/>
+              </a:spcAft>
+              <a:defRPr sz="1400" b="1">
+                <a:solidFill>
+                  <a:srgbClr val="002060"/>
+                </a:solidFill>
+                <a:latin typeface="Calisto MT"/>
+              </a:defRPr>
+            </a:pPr>
+            <a:r>
+              <a:t>01.  Invariant Vision Pipeline</a:t>
+            </a:r>
+          </a:p>
+          <a:p>
+            <a:pPr algn="l">
+              <a:lnSpc>
+                <a:spcPct val="115000"/>
+              </a:lnSpc>
+              <a:spcBef>
+                <a:spcPts val="0"/>
+              </a:spcBef>
+              <a:spcAft>
+                <a:spcPts val="200"/>
+              </a:spcAft>
+              <a:defRPr sz="1200" b="0" i="0">
+                <a:solidFill>
+                  <a:srgbClr val="334155"/>
+                </a:solidFill>
+                <a:latin typeface="Calisto MT"/>
+              </a:defRPr>
+            </a:pPr>
+            <a:r>
+              <a:t>Compute 19 scale-invariant geometric features from 21 hand landmarks for real-time onboard MLP classification.</a:t>
+            </a:r>
+          </a:p>
+        </p:txBody>
+      </p:sp>
+      <p:sp>
+        <p:nvSpPr>
+          <p:cNvPr id="7" name="Obj_Item_1"/>
+          <p:cNvSpPr txBox="1"/>
+          <p:nvPr/>
+        </p:nvSpPr>
+        <p:spPr>
+          <a:xfrm>
+            <a:off x="914400" y="3493008"/>
+            <a:ext cx="4892040" cy="960120"/>
+          </a:xfrm>
+          <a:prstGeom prst="rect">
+            <a:avLst/>
+          </a:prstGeom>
+          <a:noFill/>
+        </p:spPr>
+        <p:txBody>
+          <a:bodyPr wrap="square" lIns="45720" rIns="45720" tIns="18288" bIns="18288">
+            <a:spAutoFit/>
+          </a:bodyPr>
+          <a:lstStyle/>
+          <a:p>
+            <a:pPr algn="l">
+              <a:spcAft>
+                <a:spcPts val="200"/>
+              </a:spcAft>
+              <a:defRPr sz="1400" b="1">
+                <a:solidFill>
+                  <a:srgbClr val="002060"/>
+                </a:solidFill>
+                <a:latin typeface="Calisto MT"/>
+              </a:defRPr>
+            </a:pPr>
+            <a:r>
+              <a:t>02.  Balanced 6,000-Sample Dataset</a:t>
+            </a:r>
+          </a:p>
+          <a:p>
+            <a:pPr algn="l">
+              <a:lnSpc>
+                <a:spcPct val="115000"/>
+              </a:lnSpc>
+              <a:spcBef>
+                <a:spcPts val="0"/>
+              </a:spcBef>
+              <a:spcAft>
+                <a:spcPts val="200"/>
+              </a:spcAft>
+              <a:defRPr sz="1200" b="0" i="0">
+                <a:solidFill>
+                  <a:srgbClr val="334155"/>
+                </a:solidFill>
+                <a:latin typeface="Calisto MT"/>
+              </a:defRPr>
+            </a:pPr>
+            <a:r>
+              <a:t>Capture and balance a custom 6-class dataset directly through the onboard camera to eliminate perspective domain shift.</a:t>
+            </a:r>
+          </a:p>
+        </p:txBody>
+      </p:sp>
+      <p:sp>
+        <p:nvSpPr>
+          <p:cNvPr id="8" name="Obj_Item_2"/>
+          <p:cNvSpPr txBox="1"/>
+          <p:nvPr/>
+        </p:nvSpPr>
+        <p:spPr>
+          <a:xfrm>
+            <a:off x="914400" y="4562856"/>
+            <a:ext cx="4892040" cy="960120"/>
+          </a:xfrm>
+          <a:prstGeom prst="rect">
+            <a:avLst/>
+          </a:prstGeom>
+          <a:noFill/>
+        </p:spPr>
+        <p:txBody>
+          <a:bodyPr wrap="square" lIns="45720" rIns="45720" tIns="18288" bIns="18288">
+            <a:spAutoFit/>
+          </a:bodyPr>
+          <a:lstStyle/>
+          <a:p>
+            <a:pPr algn="l">
+              <a:spcAft>
+                <a:spcPts val="200"/>
+              </a:spcAft>
+              <a:defRPr sz="1400" b="1">
+                <a:solidFill>
+                  <a:srgbClr val="002060"/>
+                </a:solidFill>
+                <a:latin typeface="Calisto MT"/>
+              </a:defRPr>
+            </a:pPr>
+            <a:r>
+              <a:t>03.  LSTM Trajectory Prediction</a:t>
+            </a:r>
+          </a:p>
+          <a:p>
+            <a:pPr algn="l">
+              <a:lnSpc>
+                <a:spcPct val="115000"/>
+              </a:lnSpc>
+              <a:spcBef>
+                <a:spcPts val="0"/>
+              </a:spcBef>
+              <a:spcAft>
+                <a:spcPts val="200"/>
+              </a:spcAft>
+              <a:defRPr sz="1200" b="0" i="0">
+                <a:solidFill>
+                  <a:srgbClr val="334155"/>
+                </a:solidFill>
+                <a:latin typeface="Calisto MT"/>
+              </a:defRPr>
+            </a:pPr>
+            <a:r>
+              <a:t>Forecast short-horizon operator motion trajectories from continuous body pose landmarks using recurrent neural networks.</a:t>
+            </a:r>
+          </a:p>
+        </p:txBody>
+      </p:sp>
+      <p:sp>
+        <p:nvSpPr>
+          <p:cNvPr id="9" name="Obj_Item_3"/>
+          <p:cNvSpPr txBox="1"/>
+          <p:nvPr/>
+        </p:nvSpPr>
+        <p:spPr>
+          <a:xfrm>
+            <a:off x="6382512" y="2423160"/>
+            <a:ext cx="4892040" cy="960120"/>
+          </a:xfrm>
+          <a:prstGeom prst="rect">
+            <a:avLst/>
+          </a:prstGeom>
+          <a:noFill/>
+        </p:spPr>
+        <p:txBody>
+          <a:bodyPr wrap="square" lIns="45720" rIns="45720" tIns="18288" bIns="18288">
+            <a:spAutoFit/>
+          </a:bodyPr>
+          <a:lstStyle/>
+          <a:p>
+            <a:pPr algn="l">
+              <a:spcAft>
+                <a:spcPts val="200"/>
+              </a:spcAft>
+              <a:defRPr sz="1400" b="1">
+                <a:solidFill>
+                  <a:srgbClr val="002060"/>
+                </a:solidFill>
+                <a:latin typeface="Calisto MT"/>
+              </a:defRPr>
+            </a:pPr>
+            <a:r>
+              <a:t>04.  Supervisory Brain Node</a:t>
+            </a:r>
+          </a:p>
+          <a:p>
+            <a:pPr algn="l">
+              <a:lnSpc>
+                <a:spcPct val="115000"/>
+              </a:lnSpc>
+              <a:spcBef>
+                <a:spcPts val="0"/>
+              </a:spcBef>
+              <a:spcAft>
+                <a:spcPts val="200"/>
+              </a:spcAft>
+              <a:defRPr sz="1200" b="0" i="0">
+                <a:solidFill>
+                  <a:srgbClr val="334155"/>
+                </a:solidFill>
+                <a:latin typeface="Calisto MT"/>
+              </a:defRPr>
+            </a:pPr>
+            <a:r>
+              <a:t>Execute a deterministic finite state machine with 5-frame rolling consensus, active operator lock, and visual servoing.</a:t>
+            </a:r>
+          </a:p>
+        </p:txBody>
+      </p:sp>
+      <p:sp>
+        <p:nvSpPr>
+          <p:cNvPr id="10" name="Obj_Item_4"/>
+          <p:cNvSpPr txBox="1"/>
+          <p:nvPr/>
+        </p:nvSpPr>
+        <p:spPr>
+          <a:xfrm>
+            <a:off x="6382512" y="3493008"/>
+            <a:ext cx="4892040" cy="960120"/>
+          </a:xfrm>
+          <a:prstGeom prst="rect">
+            <a:avLst/>
+          </a:prstGeom>
+          <a:noFill/>
+        </p:spPr>
+        <p:txBody>
+          <a:bodyPr wrap="square" lIns="45720" rIns="45720" tIns="18288" bIns="18288">
+            <a:spAutoFit/>
+          </a:bodyPr>
+          <a:lstStyle/>
+          <a:p>
+            <a:pPr algn="l">
+              <a:spcAft>
+                <a:spcPts val="200"/>
+              </a:spcAft>
+              <a:defRPr sz="1400" b="1">
+                <a:solidFill>
+                  <a:srgbClr val="002060"/>
+                </a:solidFill>
+                <a:latin typeface="Calisto MT"/>
+              </a:defRPr>
+            </a:pPr>
+            <a:r>
+              <a:t>05.  2D LiDAR SLAM &amp; Nav2</a:t>
+            </a:r>
+          </a:p>
+          <a:p>
+            <a:pPr algn="l">
+              <a:lnSpc>
+                <a:spcPct val="115000"/>
+              </a:lnSpc>
+              <a:spcBef>
+                <a:spcPts val="0"/>
+              </a:spcBef>
+              <a:spcAft>
+                <a:spcPts val="200"/>
+              </a:spcAft>
+              <a:defRPr sz="1200" b="0" i="0">
+                <a:solidFill>
+                  <a:srgbClr val="334155"/>
+                </a:solidFill>
+                <a:latin typeface="Calisto MT"/>
+              </a:defRPr>
+            </a:pPr>
+            <a:r>
+              <a:t>Deploy real-time Cartographer mapping and the Nav2 navigation stack for socially aware, collision-free path execution.</a:t>
+            </a:r>
+          </a:p>
+        </p:txBody>
+      </p:sp>
+      <p:sp>
+        <p:nvSpPr>
+          <p:cNvPr id="11" name="Obj_Item_5"/>
+          <p:cNvSpPr txBox="1"/>
+          <p:nvPr/>
+        </p:nvSpPr>
+        <p:spPr>
+          <a:xfrm>
+            <a:off x="6382512" y="4562856"/>
+            <a:ext cx="4892040" cy="960120"/>
+          </a:xfrm>
+          <a:prstGeom prst="rect">
+            <a:avLst/>
+          </a:prstGeom>
+          <a:noFill/>
+        </p:spPr>
+        <p:txBody>
+          <a:bodyPr wrap="square" lIns="45720" rIns="45720" tIns="18288" bIns="18288">
+            <a:spAutoFit/>
+          </a:bodyPr>
+          <a:lstStyle/>
+          <a:p>
+            <a:pPr algn="l">
+              <a:spcAft>
+                <a:spcPts val="200"/>
+              </a:spcAft>
+              <a:defRPr sz="1400" b="1">
+                <a:solidFill>
+                  <a:srgbClr val="002060"/>
+                </a:solidFill>
+                <a:latin typeface="Calisto MT"/>
+              </a:defRPr>
+            </a:pPr>
+            <a:r>
+              <a:t>06.  Empirical Safety Benchmarking</a:t>
+            </a:r>
+          </a:p>
+          <a:p>
+            <a:pPr algn="l">
+              <a:lnSpc>
+                <a:spcPct val="115000"/>
+              </a:lnSpc>
+              <a:spcBef>
+                <a:spcPts val="0"/>
+              </a:spcBef>
+              <a:spcAft>
+                <a:spcPts val="200"/>
+              </a:spcAft>
+              <a:defRPr sz="1200" b="0" i="0">
+                <a:solidFill>
+                  <a:srgbClr val="334155"/>
+                </a:solidFill>
+                <a:latin typeface="Calisto MT"/>
+              </a:defRPr>
+            </a:pPr>
+            <a:r>
+              <a:t>Quantify end-to-end latency (132 ms), physical classification accuracy (96.7%), and compliance with ISO 15066 safety margins.</a:t>
+            </a:r>
+          </a:p>
+        </p:txBody>
+      </p:sp>
     </p:spTree>
     <p:extLst>
       <p:ext uri="{BB962C8B-B14F-4D97-AF65-F5344CB8AC3E}">
         <p14:creationId xmlns:p14="http://schemas.microsoft.com/office/powerpoint/2010/main" val="3882807801"/>
       </p:ext>
     </p:extLst>
+  </p:cSld>
+  <p:clrMapOvr>
+    <a:masterClrMapping/>
+  </p:clrMapOvr>
+</p:sld>
+</file>
+
+<file path=ppt/slides/slide6.xml><?xml version="1.0" encoding="utf-8"?>
+<p:sld xmlns:a="http://schemas.openxmlformats.org/drawingml/2006/main" xmlns:p="http://schemas.openxmlformats.org/presentationml/2006/main" xmlns:r="http://schemas.openxmlformats.org/officeDocument/2006/relationships">
+  <p:cSld>
+    <p:spTree>
+      <p:nvGrpSpPr>
+        <p:cNvPr id="1" name=""/>
+        <p:cNvGrpSpPr/>
+        <p:nvPr/>
+      </p:nvGrpSpPr>
+      <p:grpSpPr/>
+      <p:sp>
+        <p:nvSpPr>
+          <p:cNvPr id="2" name="Title 1"/>
+          <p:cNvSpPr>
+            <a:spLocks noGrp="1"/>
+          </p:cNvSpPr>
+          <p:nvPr>
+            <p:ph type="title"/>
+          </p:nvPr>
+        </p:nvSpPr>
+        <p:spPr>
+          <a:xfrm>
+            <a:off x="841248" y="365760"/>
+            <a:ext cx="10515600" cy="685800"/>
+          </a:xfrm>
+        </p:spPr>
+        <p:txBody>
+          <a:bodyPr/>
+          <a:lstStyle/>
+          <a:p>
+            <a:pPr algn="ctr">
+              <a:lnSpc>
+                <a:spcPct val="115000"/>
+              </a:lnSpc>
+              <a:spcBef>
+                <a:spcPts val="0"/>
+              </a:spcBef>
+              <a:spcAft>
+                <a:spcPts val="200"/>
+              </a:spcAft>
+              <a:defRPr sz="2800" b="1" i="0">
+                <a:solidFill>
+                  <a:srgbClr val="002060"/>
+                </a:solidFill>
+                <a:latin typeface="Calisto MT"/>
+              </a:defRPr>
+            </a:pPr>
+            <a:r>
+              <a:t>04. LITERATURE REVIEW &amp; RESEARCH GAPS</a:t>
+            </a:r>
+          </a:p>
+        </p:txBody>
+      </p:sp>
+      <p:sp>
+        <p:nvSpPr>
+          <p:cNvPr id="3" name="Content Placeholder 2"/>
+          <p:cNvSpPr>
+            <a:spLocks noGrp="1"/>
+          </p:cNvSpPr>
+          <p:nvPr>
+            <p:ph idx="1"/>
+          </p:nvPr>
+        </p:nvSpPr>
+        <p:spPr/>
+        <p:txBody>
+          <a:bodyPr/>
+          <a:lstStyle/>
+          <a:p/>
+        </p:txBody>
+      </p:sp>
+      <p:sp>
+        <p:nvSpPr>
+          <p:cNvPr id="4" name="Lit_Bench_Label"/>
+          <p:cNvSpPr txBox="1"/>
+          <p:nvPr/>
+        </p:nvSpPr>
+        <p:spPr>
+          <a:xfrm>
+            <a:off x="914400" y="1097280"/>
+            <a:ext cx="4114800" cy="256032"/>
+          </a:xfrm>
+          <a:prstGeom prst="rect">
+            <a:avLst/>
+          </a:prstGeom>
+          <a:noFill/>
+        </p:spPr>
+        <p:txBody>
+          <a:bodyPr wrap="square" lIns="0" rIns="0" tIns="0" bIns="0">
+            <a:spAutoFit/>
+          </a:bodyPr>
+          <a:lstStyle/>
+          <a:p>
+            <a:pPr algn="l">
+              <a:lnSpc>
+                <a:spcPct val="115000"/>
+              </a:lnSpc>
+              <a:spcBef>
+                <a:spcPts val="0"/>
+              </a:spcBef>
+              <a:spcAft>
+                <a:spcPts val="200"/>
+              </a:spcAft>
+              <a:defRPr sz="1200" b="1" i="0">
+                <a:solidFill>
+                  <a:srgbClr val="B8860B"/>
+                </a:solidFill>
+                <a:latin typeface="Calisto MT"/>
+              </a:defRPr>
+            </a:pPr>
+            <a:r>
+              <a:t>BENCHMARK LITERATURE EVALUATION</a:t>
+            </a:r>
+          </a:p>
+        </p:txBody>
+      </p:sp>
+      <p:sp>
+        <p:nvSpPr>
+          <p:cNvPr id="5" name="Lit_Study_0"/>
+          <p:cNvSpPr txBox="1"/>
+          <p:nvPr/>
+        </p:nvSpPr>
+        <p:spPr>
+          <a:xfrm>
+            <a:off x="914400" y="1371600"/>
+            <a:ext cx="3227832" cy="1691640"/>
+          </a:xfrm>
+          <a:prstGeom prst="rect">
+            <a:avLst/>
+          </a:prstGeom>
+          <a:noFill/>
+        </p:spPr>
+        <p:txBody>
+          <a:bodyPr wrap="square" lIns="36576" rIns="36576" tIns="36576" bIns="36576">
+            <a:spAutoFit/>
+          </a:bodyPr>
+          <a:lstStyle/>
+          <a:p>
+            <a:pPr algn="l">
+              <a:lnSpc>
+                <a:spcPct val="115000"/>
+              </a:lnSpc>
+              <a:spcBef>
+                <a:spcPts val="0"/>
+              </a:spcBef>
+              <a:spcAft>
+                <a:spcPts val="100"/>
+              </a:spcAft>
+              <a:defRPr sz="1400" b="1" i="0">
+                <a:solidFill>
+                  <a:srgbClr val="002060"/>
+                </a:solidFill>
+                <a:latin typeface="Calisto MT"/>
+              </a:defRPr>
+            </a:pPr>
+            <a:r>
+              <a:t>Tsitos et al. (2022)</a:t>
+            </a:r>
+          </a:p>
+          <a:p>
+            <a:pPr algn="l">
+              <a:lnSpc>
+                <a:spcPct val="115000"/>
+              </a:lnSpc>
+              <a:spcBef>
+                <a:spcPts val="0"/>
+              </a:spcBef>
+              <a:spcAft>
+                <a:spcPts val="400"/>
+              </a:spcAft>
+              <a:defRPr sz="1100" b="0" i="1">
+                <a:solidFill>
+                  <a:srgbClr val="64748B"/>
+                </a:solidFill>
+                <a:latin typeface="Calisto MT"/>
+              </a:defRPr>
+            </a:pPr>
+            <a:r>
+              <a:t>Kinematic Intention on Robotic Arm</a:t>
+            </a:r>
+          </a:p>
+          <a:p>
+            <a:pPr algn="l">
+              <a:lnSpc>
+                <a:spcPct val="112000"/>
+              </a:lnSpc>
+              <a:spcBef>
+                <a:spcPts val="0"/>
+              </a:spcBef>
+              <a:spcAft>
+                <a:spcPts val="300"/>
+              </a:spcAft>
+              <a:defRPr sz="1100" b="0" i="0">
+                <a:solidFill>
+                  <a:srgbClr val="15803D"/>
+                </a:solidFill>
+                <a:latin typeface="Calisto MT"/>
+              </a:defRPr>
+            </a:pPr>
+            <a:r>
+              <a:t>[+] Proved sub-150 ms latency threshold on industrial UR3 manipulator.</a:t>
+            </a:r>
+          </a:p>
+          <a:p>
+            <a:pPr algn="l">
+              <a:lnSpc>
+                <a:spcPct val="112000"/>
+              </a:lnSpc>
+              <a:spcBef>
+                <a:spcPts val="0"/>
+              </a:spcBef>
+              <a:spcAft>
+                <a:spcPts val="0"/>
+              </a:spcAft>
+              <a:defRPr sz="1100" b="0" i="0">
+                <a:solidFill>
+                  <a:srgbClr val="B91C1C"/>
+                </a:solidFill>
+                <a:latin typeface="Calisto MT"/>
+              </a:defRPr>
+            </a:pPr>
+            <a:r>
+              <a:t>[-] Confined to stationary tabletop; zero mobile navigation or explicit gestures.</a:t>
+            </a:r>
+          </a:p>
+        </p:txBody>
+      </p:sp>
+      <p:sp>
+        <p:nvSpPr>
+          <p:cNvPr id="6" name="Lit_Study_1"/>
+          <p:cNvSpPr txBox="1"/>
+          <p:nvPr/>
+        </p:nvSpPr>
+        <p:spPr>
+          <a:xfrm>
+            <a:off x="4480560" y="1371600"/>
+            <a:ext cx="3227832" cy="1691640"/>
+          </a:xfrm>
+          <a:prstGeom prst="rect">
+            <a:avLst/>
+          </a:prstGeom>
+          <a:noFill/>
+        </p:spPr>
+        <p:txBody>
+          <a:bodyPr wrap="square" lIns="36576" rIns="36576" tIns="36576" bIns="36576">
+            <a:spAutoFit/>
+          </a:bodyPr>
+          <a:lstStyle/>
+          <a:p>
+            <a:pPr algn="l">
+              <a:lnSpc>
+                <a:spcPct val="115000"/>
+              </a:lnSpc>
+              <a:spcBef>
+                <a:spcPts val="0"/>
+              </a:spcBef>
+              <a:spcAft>
+                <a:spcPts val="100"/>
+              </a:spcAft>
+              <a:defRPr sz="1400" b="1" i="0">
+                <a:solidFill>
+                  <a:srgbClr val="002060"/>
+                </a:solidFill>
+                <a:latin typeface="Calisto MT"/>
+              </a:defRPr>
+            </a:pPr>
+            <a:r>
+              <a:t>Mahmud et al. (2023)</a:t>
+            </a:r>
+          </a:p>
+          <a:p>
+            <a:pPr algn="l">
+              <a:lnSpc>
+                <a:spcPct val="115000"/>
+              </a:lnSpc>
+              <a:spcBef>
+                <a:spcPts val="0"/>
+              </a:spcBef>
+              <a:spcAft>
+                <a:spcPts val="400"/>
+              </a:spcAft>
+              <a:defRPr sz="1100" b="0" i="1">
+                <a:solidFill>
+                  <a:srgbClr val="64748B"/>
+                </a:solidFill>
+                <a:latin typeface="Calisto MT"/>
+              </a:defRPr>
+            </a:pPr>
+            <a:r>
+              <a:t>3D Skeletal Tracking &amp; Gesture AI</a:t>
+            </a:r>
+          </a:p>
+          <a:p>
+            <a:pPr algn="l">
+              <a:lnSpc>
+                <a:spcPct val="112000"/>
+              </a:lnSpc>
+              <a:spcBef>
+                <a:spcPts val="0"/>
+              </a:spcBef>
+              <a:spcAft>
+                <a:spcPts val="300"/>
+              </a:spcAft>
+              <a:defRPr sz="1100" b="0" i="0">
+                <a:solidFill>
+                  <a:srgbClr val="15803D"/>
+                </a:solidFill>
+                <a:latin typeface="Calisto MT"/>
+              </a:defRPr>
+            </a:pPr>
+            <a:r>
+              <a:t>[+] High multi-gesture classification accuracy using deep vision models.</a:t>
+            </a:r>
+          </a:p>
+          <a:p>
+            <a:pPr algn="l">
+              <a:lnSpc>
+                <a:spcPct val="112000"/>
+              </a:lnSpc>
+              <a:spcBef>
+                <a:spcPts val="0"/>
+              </a:spcBef>
+              <a:spcAft>
+                <a:spcPts val="0"/>
+              </a:spcAft>
+              <a:defRPr sz="1100" b="0" i="0">
+                <a:solidFill>
+                  <a:srgbClr val="B91C1C"/>
+                </a:solidFill>
+                <a:latin typeface="Calisto MT"/>
+              </a:defRPr>
+            </a:pPr>
+            <a:r>
+              <a:t>[-] Relies on heavy GPU / cloud servers; vulnerable to network lag &amp; dropouts.</a:t>
+            </a:r>
+          </a:p>
+        </p:txBody>
+      </p:sp>
+      <p:sp>
+        <p:nvSpPr>
+          <p:cNvPr id="7" name="Lit_Study_2"/>
+          <p:cNvSpPr txBox="1"/>
+          <p:nvPr/>
+        </p:nvSpPr>
+        <p:spPr>
+          <a:xfrm>
+            <a:off x="8046720" y="1371600"/>
+            <a:ext cx="3227832" cy="1691640"/>
+          </a:xfrm>
+          <a:prstGeom prst="rect">
+            <a:avLst/>
+          </a:prstGeom>
+          <a:noFill/>
+        </p:spPr>
+        <p:txBody>
+          <a:bodyPr wrap="square" lIns="36576" rIns="36576" tIns="36576" bIns="36576">
+            <a:spAutoFit/>
+          </a:bodyPr>
+          <a:lstStyle/>
+          <a:p>
+            <a:pPr algn="l">
+              <a:lnSpc>
+                <a:spcPct val="115000"/>
+              </a:lnSpc>
+              <a:spcBef>
+                <a:spcPts val="0"/>
+              </a:spcBef>
+              <a:spcAft>
+                <a:spcPts val="100"/>
+              </a:spcAft>
+              <a:defRPr sz="1400" b="1" i="0">
+                <a:solidFill>
+                  <a:srgbClr val="002060"/>
+                </a:solidFill>
+                <a:latin typeface="Calisto MT"/>
+              </a:defRPr>
+            </a:pPr>
+            <a:r>
+              <a:t>Li et al. (2024)</a:t>
+            </a:r>
+          </a:p>
+          <a:p>
+            <a:pPr algn="l">
+              <a:lnSpc>
+                <a:spcPct val="115000"/>
+              </a:lnSpc>
+              <a:spcBef>
+                <a:spcPts val="0"/>
+              </a:spcBef>
+              <a:spcAft>
+                <a:spcPts val="400"/>
+              </a:spcAft>
+              <a:defRPr sz="1100" b="0" i="1">
+                <a:solidFill>
+                  <a:srgbClr val="64748B"/>
+                </a:solidFill>
+                <a:latin typeface="Calisto MT"/>
+              </a:defRPr>
+            </a:pPr>
+            <a:r>
+              <a:t>Predictive Costmaps &amp; ROS 2 Nav2</a:t>
+            </a:r>
+          </a:p>
+          <a:p>
+            <a:pPr algn="l">
+              <a:lnSpc>
+                <a:spcPct val="112000"/>
+              </a:lnSpc>
+              <a:spcBef>
+                <a:spcPts val="0"/>
+              </a:spcBef>
+              <a:spcAft>
+                <a:spcPts val="300"/>
+              </a:spcAft>
+              <a:defRPr sz="1100" b="0" i="0">
+                <a:solidFill>
+                  <a:srgbClr val="15803D"/>
+                </a:solidFill>
+                <a:latin typeface="Calisto MT"/>
+              </a:defRPr>
+            </a:pPr>
+            <a:r>
+              <a:t>[+] Adapted ROS 2 costmaps dynamically based on obstacle movement.</a:t>
+            </a:r>
+          </a:p>
+          <a:p>
+            <a:pPr algn="l">
+              <a:lnSpc>
+                <a:spcPct val="112000"/>
+              </a:lnSpc>
+              <a:spcBef>
+                <a:spcPts val="0"/>
+              </a:spcBef>
+              <a:spcAft>
+                <a:spcPts val="0"/>
+              </a:spcAft>
+              <a:defRPr sz="1100" b="0" i="0">
+                <a:solidFill>
+                  <a:srgbClr val="B91C1C"/>
+                </a:solidFill>
+                <a:latin typeface="Calisto MT"/>
+              </a:defRPr>
+            </a:pPr>
+            <a:r>
+              <a:t>[-] Simulation-only (Isaac Sim); unverified on physical embedded edge hardware.</a:t>
+            </a:r>
+          </a:p>
+        </p:txBody>
+      </p:sp>
+      <p:cxnSp>
+        <p:nvCxnSpPr>
+          <p:cNvPr id="8" name="Lit_Divider_Line"/>
+          <p:cNvCxnSpPr/>
+          <p:nvPr/>
+        </p:nvCxnSpPr>
+        <p:spPr>
+          <a:xfrm>
+            <a:off x="914400" y="3246120"/>
+            <a:ext cx="10360152" cy="0"/>
+          </a:xfrm>
+          <a:prstGeom prst="line">
+            <a:avLst/>
+          </a:prstGeom>
+          <a:ln w="10160">
+            <a:solidFill>
+              <a:srgbClr val="CBD5E1"/>
+            </a:solidFill>
+          </a:ln>
+        </p:spPr>
+        <p:style>
+          <a:lnRef idx="2">
+            <a:schemeClr val="accent1"/>
+          </a:lnRef>
+          <a:fillRef idx="0">
+            <a:schemeClr val="accent1"/>
+          </a:fillRef>
+          <a:effectRef idx="1">
+            <a:schemeClr val="accent1"/>
+          </a:effectRef>
+          <a:fontRef idx="minor">
+            <a:schemeClr val="tx1"/>
+          </a:fontRef>
+        </p:style>
+      </p:cxnSp>
+      <p:sp>
+        <p:nvSpPr>
+          <p:cNvPr id="9" name="Lit_Gap_Label"/>
+          <p:cNvSpPr txBox="1"/>
+          <p:nvPr/>
+        </p:nvSpPr>
+        <p:spPr>
+          <a:xfrm>
+            <a:off x="914400" y="3429000"/>
+            <a:ext cx="5029200" cy="256032"/>
+          </a:xfrm>
+          <a:prstGeom prst="rect">
+            <a:avLst/>
+          </a:prstGeom>
+          <a:noFill/>
+        </p:spPr>
+        <p:txBody>
+          <a:bodyPr wrap="square" lIns="0" rIns="0" tIns="0" bIns="0">
+            <a:spAutoFit/>
+          </a:bodyPr>
+          <a:lstStyle/>
+          <a:p>
+            <a:pPr algn="l">
+              <a:lnSpc>
+                <a:spcPct val="115000"/>
+              </a:lnSpc>
+              <a:spcBef>
+                <a:spcPts val="0"/>
+              </a:spcBef>
+              <a:spcAft>
+                <a:spcPts val="200"/>
+              </a:spcAft>
+              <a:defRPr sz="1200" b="1" i="0">
+                <a:solidFill>
+                  <a:srgbClr val="B8860B"/>
+                </a:solidFill>
+                <a:latin typeface="Calisto MT"/>
+              </a:defRPr>
+            </a:pPr>
+            <a:r>
+              <a:t>CRITICAL RESEARCH GAPS RESOLVED IN THIS WORK</a:t>
+            </a:r>
+          </a:p>
+        </p:txBody>
+      </p:sp>
+      <p:sp>
+        <p:nvSpPr>
+          <p:cNvPr id="10" name="Lit_Gap_0"/>
+          <p:cNvSpPr txBox="1"/>
+          <p:nvPr/>
+        </p:nvSpPr>
+        <p:spPr>
+          <a:xfrm>
+            <a:off x="914400" y="3730752"/>
+            <a:ext cx="3227832" cy="1783080"/>
+          </a:xfrm>
+          <a:prstGeom prst="rect">
+            <a:avLst/>
+          </a:prstGeom>
+          <a:noFill/>
+        </p:spPr>
+        <p:txBody>
+          <a:bodyPr wrap="square" lIns="36576" rIns="36576" tIns="36576" bIns="36576">
+            <a:spAutoFit/>
+          </a:bodyPr>
+          <a:lstStyle/>
+          <a:p>
+            <a:pPr algn="l">
+              <a:spcAft>
+                <a:spcPts val="300"/>
+              </a:spcAft>
+              <a:defRPr sz="1350" b="1">
+                <a:solidFill>
+                  <a:srgbClr val="002060"/>
+                </a:solidFill>
+                <a:latin typeface="Calisto MT"/>
+              </a:defRPr>
+            </a:pPr>
+            <a:r>
+              <a:t>01.  Edge-Native Processing</a:t>
+            </a:r>
+          </a:p>
+          <a:p>
+            <a:pPr algn="l">
+              <a:lnSpc>
+                <a:spcPct val="115000"/>
+              </a:lnSpc>
+              <a:spcBef>
+                <a:spcPts val="0"/>
+              </a:spcBef>
+              <a:spcAft>
+                <a:spcPts val="200"/>
+              </a:spcAft>
+              <a:defRPr sz="1150" b="0" i="0">
+                <a:solidFill>
+                  <a:srgbClr val="334155"/>
+                </a:solidFill>
+                <a:latin typeface="Calisto MT"/>
+              </a:defRPr>
+            </a:pPr>
+            <a:r>
+              <a:t>Eliminates remote cloud latency (&gt;200 ms) and connection dropouts by executing the entire vision pipeline onboard an embedded Raspberry Pi 5.</a:t>
+            </a:r>
+          </a:p>
+        </p:txBody>
+      </p:sp>
+      <p:sp>
+        <p:nvSpPr>
+          <p:cNvPr id="11" name="Lit_Gap_1"/>
+          <p:cNvSpPr txBox="1"/>
+          <p:nvPr/>
+        </p:nvSpPr>
+        <p:spPr>
+          <a:xfrm>
+            <a:off x="4480560" y="3730752"/>
+            <a:ext cx="3227832" cy="1783080"/>
+          </a:xfrm>
+          <a:prstGeom prst="rect">
+            <a:avLst/>
+          </a:prstGeom>
+          <a:noFill/>
+        </p:spPr>
+        <p:txBody>
+          <a:bodyPr wrap="square" lIns="36576" rIns="36576" tIns="36576" bIns="36576">
+            <a:spAutoFit/>
+          </a:bodyPr>
+          <a:lstStyle/>
+          <a:p>
+            <a:pPr algn="l">
+              <a:spcAft>
+                <a:spcPts val="300"/>
+              </a:spcAft>
+              <a:defRPr sz="1350" b="1">
+                <a:solidFill>
+                  <a:srgbClr val="002060"/>
+                </a:solidFill>
+                <a:latin typeface="Calisto MT"/>
+              </a:defRPr>
+            </a:pPr>
+            <a:r>
+              <a:t>02.  Perception-Action Coupling</a:t>
+            </a:r>
+          </a:p>
+          <a:p>
+            <a:pPr algn="l">
+              <a:lnSpc>
+                <a:spcPct val="115000"/>
+              </a:lnSpc>
+              <a:spcBef>
+                <a:spcPts val="0"/>
+              </a:spcBef>
+              <a:spcAft>
+                <a:spcPts val="200"/>
+              </a:spcAft>
+              <a:defRPr sz="1150" b="0" i="0">
+                <a:solidFill>
+                  <a:srgbClr val="334155"/>
+                </a:solidFill>
+                <a:latin typeface="Calisto MT"/>
+              </a:defRPr>
+            </a:pPr>
+            <a:r>
+              <a:t>Bridges isolated vision AI to real-time wheel actuation via ROS 2 DDS middleware, active visual servoing, and a 5-frame rolling consensus FSM.</a:t>
+            </a:r>
+          </a:p>
+        </p:txBody>
+      </p:sp>
+      <p:sp>
+        <p:nvSpPr>
+          <p:cNvPr id="12" name="Lit_Gap_2"/>
+          <p:cNvSpPr txBox="1"/>
+          <p:nvPr/>
+        </p:nvSpPr>
+        <p:spPr>
+          <a:xfrm>
+            <a:off x="8046720" y="3730752"/>
+            <a:ext cx="3227832" cy="1783080"/>
+          </a:xfrm>
+          <a:prstGeom prst="rect">
+            <a:avLst/>
+          </a:prstGeom>
+          <a:noFill/>
+        </p:spPr>
+        <p:txBody>
+          <a:bodyPr wrap="square" lIns="36576" rIns="36576" tIns="36576" bIns="36576">
+            <a:spAutoFit/>
+          </a:bodyPr>
+          <a:lstStyle/>
+          <a:p>
+            <a:pPr algn="l">
+              <a:spcAft>
+                <a:spcPts val="300"/>
+              </a:spcAft>
+              <a:defRPr sz="1350" b="1">
+                <a:solidFill>
+                  <a:srgbClr val="002060"/>
+                </a:solidFill>
+                <a:latin typeface="Calisto MT"/>
+              </a:defRPr>
+            </a:pPr>
+            <a:r>
+              <a:t>03.  Dual-Modality HRI &amp; Safety</a:t>
+            </a:r>
+          </a:p>
+          <a:p>
+            <a:pPr algn="l">
+              <a:lnSpc>
+                <a:spcPct val="115000"/>
+              </a:lnSpc>
+              <a:spcBef>
+                <a:spcPts val="0"/>
+              </a:spcBef>
+              <a:spcAft>
+                <a:spcPts val="200"/>
+              </a:spcAft>
+              <a:defRPr sz="1150" b="0" i="0">
+                <a:solidFill>
+                  <a:srgbClr val="334155"/>
+                </a:solidFill>
+                <a:latin typeface="Calisto MT"/>
+              </a:defRPr>
+            </a:pPr>
+            <a:r>
+              <a:t>Unifies discrete hand gestures with continuous LSTM trajectory prediction and 2D LiDAR SLAM, strictly complying with ISO 15066 safety stopping margins.</a:t>
+            </a:r>
+          </a:p>
+        </p:txBody>
+      </p:sp>
+    </p:spTree>
   </p:cSld>
   <p:clrMapOvr>
     <a:masterClrMapping/>

</xml_diff>

<commit_message>
fix(slides): polish Slide 6 with calm 2-tone palette and plain-English text
</commit_message>
<xml_diff>
--- a/write_up/Project Final Defense Slides_FINAL.pptx
+++ b/write_up/Project Final Defense Slides_FINAL.pptx
@@ -3787,8 +3787,8 @@
         </p:nvSpPr>
         <p:spPr>
           <a:xfrm>
-            <a:off x="914400" y="1371600"/>
-            <a:ext cx="3227832" cy="1691640"/>
+            <a:off x="914400" y="1353312"/>
+            <a:ext cx="3227832" cy="1737360"/>
           </a:xfrm>
           <a:prstGeom prst="rect">
             <a:avLst/>
@@ -3841,51 +3841,63 @@
               </a:defRPr>
             </a:pPr>
             <a:r>
-              <a:t>Kinematic Intention on Robotic Arm</a:t>
+              <a:t>Fast Reaching Intention (Robotic Arm)</a:t>
             </a:r>
           </a:p>
           <a:p>
             <a:pPr algn="l">
               <a:lnSpc>
-                <a:spcPct val="112000"/>
-              </a:lnSpc>
-              <a:spcBef>
+                <a:spcPct val="115000"/>
+              </a:lnSpc>
+              <a:spcAft>
+                <a:spcPts val="300"/>
+              </a:spcAft>
+            </a:pPr>
+            <a:r>
+              <a:rPr sz="1150" b="1">
+                <a:solidFill>
+                  <a:srgbClr val="1E293B"/>
+                </a:solidFill>
+                <a:latin typeface="Calisto MT"/>
+              </a:rPr>
+              <a:t>• Strength: </a:t>
+            </a:r>
+            <a:r>
+              <a:rPr sz="1150" b="0">
+                <a:solidFill>
+                  <a:srgbClr val="334155"/>
+                </a:solidFill>
+                <a:latin typeface="Calisto MT"/>
+              </a:rPr>
+              <a:t>Fast reaction time under 150 ms threshold.</a:t>
+            </a:r>
+          </a:p>
+          <a:p>
+            <a:pPr algn="l">
+              <a:lnSpc>
+                <a:spcPct val="115000"/>
+              </a:lnSpc>
+              <a:spcAft>
                 <a:spcPts val="0"/>
-              </a:spcBef>
-              <a:spcAft>
-                <a:spcPts val="300"/>
-              </a:spcAft>
-              <a:defRPr sz="1100" b="0" i="0">
-                <a:solidFill>
-                  <a:srgbClr val="15803D"/>
-                </a:solidFill>
-                <a:latin typeface="Calisto MT"/>
-              </a:defRPr>
-            </a:pPr>
-            <a:r>
-              <a:t>[+] Proved sub-150 ms latency threshold on industrial UR3 manipulator.</a:t>
-            </a:r>
-          </a:p>
-          <a:p>
-            <a:pPr algn="l">
-              <a:lnSpc>
-                <a:spcPct val="112000"/>
-              </a:lnSpc>
-              <a:spcBef>
-                <a:spcPts val="0"/>
-              </a:spcBef>
-              <a:spcAft>
-                <a:spcPts val="0"/>
-              </a:spcAft>
-              <a:defRPr sz="1100" b="0" i="0">
-                <a:solidFill>
-                  <a:srgbClr val="B91C1C"/>
-                </a:solidFill>
-                <a:latin typeface="Calisto MT"/>
-              </a:defRPr>
-            </a:pPr>
-            <a:r>
-              <a:t>[-] Confined to stationary tabletop; zero mobile navigation or explicit gestures.</a:t>
+              </a:spcAft>
+            </a:pPr>
+            <a:r>
+              <a:rPr sz="1150" b="1">
+                <a:solidFill>
+                  <a:srgbClr val="1E293B"/>
+                </a:solidFill>
+                <a:latin typeface="Calisto MT"/>
+              </a:rPr>
+              <a:t>• Limitation: </a:t>
+            </a:r>
+            <a:r>
+              <a:rPr sz="1150" b="0">
+                <a:solidFill>
+                  <a:srgbClr val="334155"/>
+                </a:solidFill>
+                <a:latin typeface="Calisto MT"/>
+              </a:rPr>
+              <a:t>Fixed on a desk — cannot drive on wheels or accept hand gestures.</a:t>
             </a:r>
           </a:p>
         </p:txBody>
@@ -3898,8 +3910,8 @@
         </p:nvSpPr>
         <p:spPr>
           <a:xfrm>
-            <a:off x="4480560" y="1371600"/>
-            <a:ext cx="3227832" cy="1691640"/>
+            <a:off x="4480560" y="1353312"/>
+            <a:ext cx="3227832" cy="1737360"/>
           </a:xfrm>
           <a:prstGeom prst="rect">
             <a:avLst/>
@@ -3930,7 +3942,7 @@
               </a:defRPr>
             </a:pPr>
             <a:r>
-              <a:t>Mahmud et al. (2023)</a:t>
+              <a:t>Mahmud et al. (2022)</a:t>
             </a:r>
           </a:p>
           <a:p>
@@ -3952,51 +3964,63 @@
               </a:defRPr>
             </a:pPr>
             <a:r>
-              <a:t>3D Skeletal Tracking &amp; Gesture AI</a:t>
+              <a:t>3D Deep Gesture Tracking</a:t>
             </a:r>
           </a:p>
           <a:p>
             <a:pPr algn="l">
               <a:lnSpc>
-                <a:spcPct val="112000"/>
-              </a:lnSpc>
-              <a:spcBef>
+                <a:spcPct val="115000"/>
+              </a:lnSpc>
+              <a:spcAft>
+                <a:spcPts val="300"/>
+              </a:spcAft>
+            </a:pPr>
+            <a:r>
+              <a:rPr sz="1150" b="1">
+                <a:solidFill>
+                  <a:srgbClr val="1E293B"/>
+                </a:solidFill>
+                <a:latin typeface="Calisto MT"/>
+              </a:rPr>
+              <a:t>• Strength: </a:t>
+            </a:r>
+            <a:r>
+              <a:rPr sz="1150" b="0">
+                <a:solidFill>
+                  <a:srgbClr val="334155"/>
+                </a:solidFill>
+                <a:latin typeface="Calisto MT"/>
+              </a:rPr>
+              <a:t>High accuracy across multi-class hand gestures.</a:t>
+            </a:r>
+          </a:p>
+          <a:p>
+            <a:pPr algn="l">
+              <a:lnSpc>
+                <a:spcPct val="115000"/>
+              </a:lnSpc>
+              <a:spcAft>
                 <a:spcPts val="0"/>
-              </a:spcBef>
-              <a:spcAft>
-                <a:spcPts val="300"/>
-              </a:spcAft>
-              <a:defRPr sz="1100" b="0" i="0">
-                <a:solidFill>
-                  <a:srgbClr val="15803D"/>
-                </a:solidFill>
-                <a:latin typeface="Calisto MT"/>
-              </a:defRPr>
-            </a:pPr>
-            <a:r>
-              <a:t>[+] High multi-gesture classification accuracy using deep vision models.</a:t>
-            </a:r>
-          </a:p>
-          <a:p>
-            <a:pPr algn="l">
-              <a:lnSpc>
-                <a:spcPct val="112000"/>
-              </a:lnSpc>
-              <a:spcBef>
-                <a:spcPts val="0"/>
-              </a:spcBef>
-              <a:spcAft>
-                <a:spcPts val="0"/>
-              </a:spcAft>
-              <a:defRPr sz="1100" b="0" i="0">
-                <a:solidFill>
-                  <a:srgbClr val="B91C1C"/>
-                </a:solidFill>
-                <a:latin typeface="Calisto MT"/>
-              </a:defRPr>
-            </a:pPr>
-            <a:r>
-              <a:t>[-] Relies on heavy GPU / cloud servers; vulnerable to network lag &amp; dropouts.</a:t>
+              </a:spcAft>
+            </a:pPr>
+            <a:r>
+              <a:rPr sz="1150" b="1">
+                <a:solidFill>
+                  <a:srgbClr val="1E293B"/>
+                </a:solidFill>
+                <a:latin typeface="Calisto MT"/>
+              </a:rPr>
+              <a:t>• Limitation: </a:t>
+            </a:r>
+            <a:r>
+              <a:rPr sz="1150" b="0">
+                <a:solidFill>
+                  <a:srgbClr val="334155"/>
+                </a:solidFill>
+                <a:latin typeface="Calisto MT"/>
+              </a:rPr>
+              <a:t>Relies on cloud servers — suffers from network lag and Wi-Fi dropouts.</a:t>
             </a:r>
           </a:p>
         </p:txBody>
@@ -4009,8 +4033,8 @@
         </p:nvSpPr>
         <p:spPr>
           <a:xfrm>
-            <a:off x="8046720" y="1371600"/>
-            <a:ext cx="3227832" cy="1691640"/>
+            <a:off x="8046720" y="1353312"/>
+            <a:ext cx="3227832" cy="1737360"/>
           </a:xfrm>
           <a:prstGeom prst="rect">
             <a:avLst/>
@@ -4041,7 +4065,7 @@
               </a:defRPr>
             </a:pPr>
             <a:r>
-              <a:t>Li et al. (2024)</a:t>
+              <a:t>Li et al. (2023)</a:t>
             </a:r>
           </a:p>
           <a:p>
@@ -4063,51 +4087,63 @@
               </a:defRPr>
             </a:pPr>
             <a:r>
-              <a:t>Predictive Costmaps &amp; ROS 2 Nav2</a:t>
+              <a:t>Intention-Aware Navigation</a:t>
             </a:r>
           </a:p>
           <a:p>
             <a:pPr algn="l">
               <a:lnSpc>
-                <a:spcPct val="112000"/>
-              </a:lnSpc>
-              <a:spcBef>
+                <a:spcPct val="115000"/>
+              </a:lnSpc>
+              <a:spcAft>
+                <a:spcPts val="300"/>
+              </a:spcAft>
+            </a:pPr>
+            <a:r>
+              <a:rPr sz="1150" b="1">
+                <a:solidFill>
+                  <a:srgbClr val="1E293B"/>
+                </a:solidFill>
+                <a:latin typeface="Calisto MT"/>
+              </a:rPr>
+              <a:t>• Strength: </a:t>
+            </a:r>
+            <a:r>
+              <a:rPr sz="1150" b="0">
+                <a:solidFill>
+                  <a:srgbClr val="334155"/>
+                </a:solidFill>
+                <a:latin typeface="Calisto MT"/>
+              </a:rPr>
+              <a:t>Smart path planning around moving humans.</a:t>
+            </a:r>
+          </a:p>
+          <a:p>
+            <a:pPr algn="l">
+              <a:lnSpc>
+                <a:spcPct val="115000"/>
+              </a:lnSpc>
+              <a:spcAft>
                 <a:spcPts val="0"/>
-              </a:spcBef>
-              <a:spcAft>
-                <a:spcPts val="300"/>
-              </a:spcAft>
-              <a:defRPr sz="1100" b="0" i="0">
-                <a:solidFill>
-                  <a:srgbClr val="15803D"/>
-                </a:solidFill>
-                <a:latin typeface="Calisto MT"/>
-              </a:defRPr>
-            </a:pPr>
-            <a:r>
-              <a:t>[+] Adapted ROS 2 costmaps dynamically based on obstacle movement.</a:t>
-            </a:r>
-          </a:p>
-          <a:p>
-            <a:pPr algn="l">
-              <a:lnSpc>
-                <a:spcPct val="112000"/>
-              </a:lnSpc>
-              <a:spcBef>
-                <a:spcPts val="0"/>
-              </a:spcBef>
-              <a:spcAft>
-                <a:spcPts val="0"/>
-              </a:spcAft>
-              <a:defRPr sz="1100" b="0" i="0">
-                <a:solidFill>
-                  <a:srgbClr val="B91C1C"/>
-                </a:solidFill>
-                <a:latin typeface="Calisto MT"/>
-              </a:defRPr>
-            </a:pPr>
-            <a:r>
-              <a:t>[-] Simulation-only (Isaac Sim); unverified on physical embedded edge hardware.</a:t>
+              </a:spcAft>
+            </a:pPr>
+            <a:r>
+              <a:rPr sz="1150" b="1">
+                <a:solidFill>
+                  <a:srgbClr val="1E293B"/>
+                </a:solidFill>
+                <a:latin typeface="Calisto MT"/>
+              </a:rPr>
+              <a:t>• Limitation: </a:t>
+            </a:r>
+            <a:r>
+              <a:rPr sz="1150" b="0">
+                <a:solidFill>
+                  <a:srgbClr val="334155"/>
+                </a:solidFill>
+                <a:latin typeface="Calisto MT"/>
+              </a:rPr>
+              <a:t>Computer simulation only — never tested on a real physical robot.</a:t>
             </a:r>
           </a:p>
         </p:txBody>
@@ -4226,7 +4262,7 @@
               </a:defRPr>
             </a:pPr>
             <a:r>
-              <a:t>01.  Edge-Native Processing</a:t>
+              <a:t>01.  All-Onboard Edge AI</a:t>
             </a:r>
           </a:p>
           <a:p>
@@ -4248,7 +4284,7 @@
               </a:defRPr>
             </a:pPr>
             <a:r>
-              <a:t>Eliminates remote cloud latency (&gt;200 ms) and connection dropouts by executing the entire vision pipeline onboard an embedded Raspberry Pi 5.</a:t>
+              <a:t>All computer vision runs directly on the robot (Raspberry Pi 5) without cloud lag, internet dependency, or Wi-Fi dropouts.</a:t>
             </a:r>
           </a:p>
         </p:txBody>
@@ -4287,7 +4323,7 @@
               </a:defRPr>
             </a:pPr>
             <a:r>
-              <a:t>02.  Perception-Action Coupling</a:t>
+              <a:t>02.  Direct Vision-to-Wheels</a:t>
             </a:r>
           </a:p>
           <a:p>
@@ -4309,7 +4345,7 @@
               </a:defRPr>
             </a:pPr>
             <a:r>
-              <a:t>Bridges isolated vision AI to real-time wheel actuation via ROS 2 DDS middleware, active visual servoing, and a 5-frame rolling consensus FSM.</a:t>
+              <a:t>Hand gestures directly guide the robot's physical wheel motors in real time through an active visual-tracking camera gimbal.</a:t>
             </a:r>
           </a:p>
         </p:txBody>
@@ -4348,7 +4384,7 @@
               </a:defRPr>
             </a:pPr>
             <a:r>
-              <a:t>03.  Dual-Modality HRI &amp; Safety</a:t>
+              <a:t>03.  Dual-Modality &amp; Safety</a:t>
             </a:r>
           </a:p>
           <a:p>
@@ -4370,7 +4406,7 @@
               </a:defRPr>
             </a:pPr>
             <a:r>
-              <a:t>Unifies discrete hand gestures with continuous LSTM trajectory prediction and 2D LiDAR SLAM, strictly complying with ISO 15066 safety stopping margins.</a:t>
+              <a:t>Unifies 6 deliberate hand gestures with continuous human tracking and automatic 360° LiDAR collision safety stops.</a:t>
             </a:r>
           </a:p>
         </p:txBody>

</xml_diff>

<commit_message>
feat(slides): align Slide 6 into 1-to-1 literature gaps and engineering solutions
</commit_message>
<xml_diff>
--- a/write_up/Project Final Defense Slides_FINAL.pptx
+++ b/write_up/Project Final Defense Slides_FINAL.pptx
@@ -3743,7 +3743,7 @@
         <p:spPr>
           <a:xfrm>
             <a:off x="914400" y="1097280"/>
-            <a:ext cx="4114800" cy="256032"/>
+            <a:ext cx="5029200" cy="256032"/>
           </a:xfrm>
           <a:prstGeom prst="rect">
             <a:avLst/>
@@ -3774,7 +3774,7 @@
               </a:defRPr>
             </a:pPr>
             <a:r>
-              <a:t>BENCHMARK LITERATURE EVALUATION</a:t>
+              <a:t>BENCHMARK RESEARCH GAPS IN LITERATURE</a:t>
             </a:r>
           </a:p>
         </p:txBody>
@@ -3819,7 +3819,7 @@
               </a:defRPr>
             </a:pPr>
             <a:r>
-              <a:t>Tsitos et al. (2022)</a:t>
+              <a:t>Mahmud et al. (2022)</a:t>
             </a:r>
           </a:p>
           <a:p>
@@ -3841,7 +3841,7 @@
               </a:defRPr>
             </a:pPr>
             <a:r>
-              <a:t>Fast Reaching Intention (Robotic Arm)</a:t>
+              <a:t>3D Deep Gesture Tracking</a:t>
             </a:r>
           </a:p>
           <a:p>
@@ -3860,7 +3860,7 @@
                 </a:solidFill>
                 <a:latin typeface="Calisto MT"/>
               </a:rPr>
-              <a:t>• Strength: </a:t>
+              <a:t>• Method: </a:t>
             </a:r>
             <a:r>
               <a:rPr sz="1150" b="0">
@@ -3869,7 +3869,7 @@
                 </a:solidFill>
                 <a:latin typeface="Calisto MT"/>
               </a:rPr>
-              <a:t>Fast reaction time under 150 ms threshold.</a:t>
+              <a:t>Kinect v2 3D skeleton + deep neural nets.</a:t>
             </a:r>
           </a:p>
           <a:p>
@@ -3888,7 +3888,7 @@
                 </a:solidFill>
                 <a:latin typeface="Calisto MT"/>
               </a:rPr>
-              <a:t>• Limitation: </a:t>
+              <a:t>• Gap: </a:t>
             </a:r>
             <a:r>
               <a:rPr sz="1150" b="0">
@@ -3897,7 +3897,7 @@
                 </a:solidFill>
                 <a:latin typeface="Calisto MT"/>
               </a:rPr>
-              <a:t>Fixed on a desk — cannot drive on wheels or accept hand gestures.</a:t>
+              <a:t>Cloud/GPU Dependency: Relies on offboard computing clusters; vulnerable to network lag &amp; Wi-Fi drops.</a:t>
             </a:r>
           </a:p>
         </p:txBody>
@@ -3942,7 +3942,7 @@
               </a:defRPr>
             </a:pPr>
             <a:r>
-              <a:t>Mahmud et al. (2022)</a:t>
+              <a:t>Tsitos et al. (2022)</a:t>
             </a:r>
           </a:p>
           <a:p>
@@ -3964,7 +3964,7 @@
               </a:defRPr>
             </a:pPr>
             <a:r>
-              <a:t>3D Deep Gesture Tracking</a:t>
+              <a:t>Fast Reaching Intention (Robotic Arm)</a:t>
             </a:r>
           </a:p>
           <a:p>
@@ -3983,7 +3983,7 @@
                 </a:solidFill>
                 <a:latin typeface="Calisto MT"/>
               </a:rPr>
-              <a:t>• Strength: </a:t>
+              <a:t>• Method: </a:t>
             </a:r>
             <a:r>
               <a:rPr sz="1150" b="0">
@@ -3992,7 +3992,7 @@
                 </a:solidFill>
                 <a:latin typeface="Calisto MT"/>
               </a:rPr>
-              <a:t>High accuracy across multi-class hand gestures.</a:t>
+              <a:t>Monocular depth camera + SVM on UR3 arm.</a:t>
             </a:r>
           </a:p>
           <a:p>
@@ -4011,7 +4011,7 @@
                 </a:solidFill>
                 <a:latin typeface="Calisto MT"/>
               </a:rPr>
-              <a:t>• Limitation: </a:t>
+              <a:t>• Gap: </a:t>
             </a:r>
             <a:r>
               <a:rPr sz="1150" b="0">
@@ -4020,7 +4020,7 @@
                 </a:solidFill>
                 <a:latin typeface="Calisto MT"/>
               </a:rPr>
-              <a:t>Relies on cloud servers — suffers from network lag and Wi-Fi dropouts.</a:t>
+              <a:t>No Mobile Navigation: Confined to a static tabletop; cannot drive on wheels or accept gesture navigation.</a:t>
             </a:r>
           </a:p>
         </p:txBody>
@@ -4106,7 +4106,7 @@
                 </a:solidFill>
                 <a:latin typeface="Calisto MT"/>
               </a:rPr>
-              <a:t>• Strength: </a:t>
+              <a:t>• Method: </a:t>
             </a:r>
             <a:r>
               <a:rPr sz="1150" b="0">
@@ -4115,7 +4115,7 @@
                 </a:solidFill>
                 <a:latin typeface="Calisto MT"/>
               </a:rPr>
-              <a:t>Smart path planning around moving humans.</a:t>
+              <a:t>2D LiDAR + CNN in Isaac Sim simulator.</a:t>
             </a:r>
           </a:p>
           <a:p>
@@ -4134,7 +4134,7 @@
                 </a:solidFill>
                 <a:latin typeface="Calisto MT"/>
               </a:rPr>
-              <a:t>• Limitation: </a:t>
+              <a:t>• Gap: </a:t>
             </a:r>
             <a:r>
               <a:rPr sz="1150" b="0">
@@ -4143,7 +4143,7 @@
                 </a:solidFill>
                 <a:latin typeface="Calisto MT"/>
               </a:rPr>
-              <a:t>Computer simulation only — never tested on a real physical robot.</a:t>
+              <a:t>Simulation Only: Never verified on physical robot hardware; lacks touchless human gesture steering.</a:t>
             </a:r>
           </a:p>
         </p:txBody>
@@ -4223,7 +4223,7 @@
               </a:defRPr>
             </a:pPr>
             <a:r>
-              <a:t>CRITICAL RESEARCH GAPS RESOLVED IN THIS WORK</a:t>
+              <a:t>HOW OUR SYSTEM CLOSES THESE GAPS</a:t>
             </a:r>
           </a:p>
         </p:txBody>
@@ -4284,7 +4284,7 @@
               </a:defRPr>
             </a:pPr>
             <a:r>
-              <a:t>All computer vision runs directly on the robot (Raspberry Pi 5) without cloud lag, internet dependency, or Wi-Fi dropouts.</a:t>
+              <a:t>Executes 100% of vision AI directly on the robot (Raspberry Pi 5) with zero cloud lag, zero internet dependency, and zero Wi-Fi dropouts.</a:t>
             </a:r>
           </a:p>
         </p:txBody>
@@ -4345,7 +4345,7 @@
               </a:defRPr>
             </a:pPr>
             <a:r>
-              <a:t>Hand gestures directly guide the robot's physical wheel motors in real time through an active visual-tracking camera gimbal.</a:t>
+              <a:t>Bridges hand gestures directly to physical wheel motors in real time through an active visual-tracking camera gimbal and ROS 2 middleware.</a:t>
             </a:r>
           </a:p>
         </p:txBody>
@@ -4384,7 +4384,7 @@
               </a:defRPr>
             </a:pPr>
             <a:r>
-              <a:t>03.  Dual-Modality &amp; Safety</a:t>
+              <a:t>03.  Physical Hardware &amp; Safety</a:t>
             </a:r>
           </a:p>
           <a:p>
@@ -4406,7 +4406,7 @@
               </a:defRPr>
             </a:pPr>
             <a:r>
-              <a:t>Unifies 6 deliberate hand gestures with continuous human tracking and automatic 360° LiDAR collision safety stops.</a:t>
+              <a:t>Empirically validated on a physical robot with 2D LiDAR SLAM, continuous human tracking, and automatic ISO 15066 safety stops.</a:t>
             </a:r>
           </a:p>
         </p:txBody>

</xml_diff>

<commit_message>
feat(slides): capture full author names, objective, method, gap, and solution on Slide 6
</commit_message>
<xml_diff>
--- a/write_up/Project Final Defense Slides_FINAL.pptx
+++ b/write_up/Project Final Defense Slides_FINAL.pptx
@@ -3686,8 +3686,8 @@
         </p:nvSpPr>
         <p:spPr>
           <a:xfrm>
-            <a:off x="841248" y="365760"/>
-            <a:ext cx="10515600" cy="685800"/>
+            <a:off x="841248" y="320040"/>
+            <a:ext cx="10515600" cy="640080"/>
           </a:xfrm>
         </p:spPr>
         <p:txBody>
@@ -3736,14 +3736,14 @@
       </p:sp>
       <p:sp>
         <p:nvSpPr>
-          <p:cNvPr id="4" name="Lit_Bench_Label"/>
+          <p:cNvPr id="4" name="Lit_Subhead"/>
           <p:cNvSpPr txBox="1"/>
           <p:nvPr/>
         </p:nvSpPr>
         <p:spPr>
           <a:xfrm>
-            <a:off x="914400" y="1097280"/>
-            <a:ext cx="5029200" cy="256032"/>
+            <a:off x="822960" y="1051560"/>
+            <a:ext cx="10515600" cy="256032"/>
           </a:xfrm>
           <a:prstGeom prst="rect">
             <a:avLst/>
@@ -3766,7 +3766,7 @@
               <a:spcAft>
                 <a:spcPts val="200"/>
               </a:spcAft>
-              <a:defRPr sz="1200" b="1" i="0">
+              <a:defRPr sz="1150" b="1" i="0">
                 <a:solidFill>
                   <a:srgbClr val="B8860B"/>
                 </a:solidFill>
@@ -3774,21 +3774,21 @@
               </a:defRPr>
             </a:pPr>
             <a:r>
-              <a:t>BENCHMARK RESEARCH GAPS IN LITERATURE</a:t>
-            </a:r>
-          </a:p>
-        </p:txBody>
-      </p:sp>
-      <p:sp>
-        <p:nvSpPr>
-          <p:cNvPr id="5" name="Lit_Study_0"/>
+              <a:t>CRITICAL APPRAISAL OF CORE BENCHMARK STUDIES (THESIS CHAPTER 2)</a:t>
+            </a:r>
+          </a:p>
+        </p:txBody>
+      </p:sp>
+      <p:sp>
+        <p:nvSpPr>
+          <p:cNvPr id="5" name="Lit_Paper_0"/>
           <p:cNvSpPr txBox="1"/>
           <p:nvPr/>
         </p:nvSpPr>
         <p:spPr>
           <a:xfrm>
-            <a:off x="914400" y="1353312"/>
-            <a:ext cx="3227832" cy="1737360"/>
+            <a:off x="822960" y="1325880"/>
+            <a:ext cx="3227832" cy="4251960"/>
           </a:xfrm>
           <a:prstGeom prst="rect">
             <a:avLst/>
@@ -3796,7 +3796,7 @@
           <a:noFill/>
         </p:spPr>
         <p:txBody>
-          <a:bodyPr wrap="square" lIns="36576" rIns="36576" tIns="36576" bIns="36576">
+          <a:bodyPr wrap="square" lIns="18288" rIns="18288" tIns="18288" bIns="18288">
             <a:spAutoFit/>
           </a:bodyPr>
           <a:lstStyle/>
@@ -3811,7 +3811,7 @@
               <a:spcAft>
                 <a:spcPts val="100"/>
               </a:spcAft>
-              <a:defRPr sz="1400" b="1" i="0">
+              <a:defRPr sz="1350" b="1" i="0">
                 <a:solidFill>
                   <a:srgbClr val="002060"/>
                 </a:solidFill>
@@ -3819,7 +3819,7 @@
               </a:defRPr>
             </a:pPr>
             <a:r>
-              <a:t>Mahmud et al. (2022)</a:t>
+              <a:t>Athanasios Tsitos et al. (2022)</a:t>
             </a:r>
           </a:p>
           <a:p>
@@ -3831,9 +3831,9 @@
                 <a:spcPts val="0"/>
               </a:spcBef>
               <a:spcAft>
-                <a:spcPts val="400"/>
-              </a:spcAft>
-              <a:defRPr sz="1100" b="0" i="1">
+                <a:spcPts val="600"/>
+              </a:spcAft>
+              <a:defRPr sz="1050" b="0" i="1">
                 <a:solidFill>
                   <a:srgbClr val="64748B"/>
                 </a:solidFill>
@@ -3841,7 +3841,7 @@
               </a:defRPr>
             </a:pPr>
             <a:r>
-              <a:t>3D Deep Gesture Tracking</a:t>
+              <a:t>Competitive Reaching Intention Game</a:t>
             </a:r>
           </a:p>
           <a:p>
@@ -3850,11 +3850,39 @@
                 <a:spcPct val="115000"/>
               </a:lnSpc>
               <a:spcAft>
-                <a:spcPts val="300"/>
-              </a:spcAft>
-            </a:pPr>
-            <a:r>
-              <a:rPr sz="1150" b="1">
+                <a:spcPts val="500"/>
+              </a:spcAft>
+            </a:pPr>
+            <a:r>
+              <a:rPr sz="1080" b="1">
+                <a:solidFill>
+                  <a:srgbClr val="1E293B"/>
+                </a:solidFill>
+                <a:latin typeface="Calisto MT"/>
+              </a:rPr>
+              <a:t>• Objective: </a:t>
+            </a:r>
+            <a:r>
+              <a:rPr sz="1080" b="0">
+                <a:solidFill>
+                  <a:srgbClr val="334155"/>
+                </a:solidFill>
+                <a:latin typeface="Calisto MT"/>
+              </a:rPr>
+              <a:t>Predict human reaching intent early to govern robot arm trajectories within a 150 ms reaction threshold.</a:t>
+            </a:r>
+          </a:p>
+          <a:p>
+            <a:pPr algn="l">
+              <a:lnSpc>
+                <a:spcPct val="115000"/>
+              </a:lnSpc>
+              <a:spcAft>
+                <a:spcPts val="500"/>
+              </a:spcAft>
+            </a:pPr>
+            <a:r>
+              <a:rPr sz="1080" b="1">
                 <a:solidFill>
                   <a:srgbClr val="1E293B"/>
                 </a:solidFill>
@@ -3863,13 +3891,13 @@
               <a:t>• Method: </a:t>
             </a:r>
             <a:r>
-              <a:rPr sz="1150" b="0">
+              <a:rPr sz="1080" b="0">
                 <a:solidFill>
                   <a:srgbClr val="334155"/>
                 </a:solidFill>
                 <a:latin typeface="Calisto MT"/>
               </a:rPr>
-              <a:t>Kinect v2 3D skeleton + deep neural nets.</a:t>
+              <a:t>RGB-D camera + OpenPose wrist tracking + SVM / Decision Trees on an industrial 6-DOF UR3 robotic arm.</a:t>
             </a:r>
           </a:p>
           <a:p>
@@ -3878,40 +3906,68 @@
                 <a:spcPct val="115000"/>
               </a:lnSpc>
               <a:spcAft>
+                <a:spcPts val="700"/>
+              </a:spcAft>
+            </a:pPr>
+            <a:r>
+              <a:rPr sz="1080" b="1">
+                <a:solidFill>
+                  <a:srgbClr val="1E293B"/>
+                </a:solidFill>
+                <a:latin typeface="Calisto MT"/>
+              </a:rPr>
+              <a:t>• Research Gap: </a:t>
+            </a:r>
+            <a:r>
+              <a:rPr sz="1080" b="0">
+                <a:solidFill>
+                  <a:srgbClr val="334155"/>
+                </a:solidFill>
+                <a:latin typeface="Calisto MT"/>
+              </a:rPr>
+              <a:t>Confined to a static desk — lacks mobile base movement and provides no explicit hand gesture command channel.</a:t>
+            </a:r>
+          </a:p>
+          <a:p>
+            <a:pPr algn="l">
+              <a:lnSpc>
+                <a:spcPct val="115000"/>
+              </a:lnSpc>
+              <a:spcAft>
                 <a:spcPts val="0"/>
               </a:spcAft>
             </a:pPr>
             <a:r>
-              <a:rPr sz="1150" b="1">
+              <a:rPr sz="1080" b="1">
+                <a:solidFill>
+                  <a:srgbClr val="002060"/>
+                </a:solidFill>
+                <a:latin typeface="Calisto MT"/>
+              </a:rPr>
+              <a:t>👉 Our Solution: </a:t>
+            </a:r>
+            <a:r>
+              <a:rPr sz="1080" b="0">
                 <a:solidFill>
                   <a:srgbClr val="1E293B"/>
                 </a:solidFill>
                 <a:latin typeface="Calisto MT"/>
               </a:rPr>
-              <a:t>• Gap: </a:t>
-            </a:r>
-            <a:r>
-              <a:rPr sz="1150" b="0">
-                <a:solidFill>
-                  <a:srgbClr val="334155"/>
-                </a:solidFill>
-                <a:latin typeface="Calisto MT"/>
-              </a:rPr>
-              <a:t>Cloud/GPU Dependency: Relies on offboard computing clusters; vulnerable to network lag &amp; Wi-Fi drops.</a:t>
-            </a:r>
-          </a:p>
-        </p:txBody>
-      </p:sp>
-      <p:sp>
-        <p:nvSpPr>
-          <p:cNvPr id="6" name="Lit_Study_1"/>
+              <a:t>Bridges intention directly to mobile wheels via 6 explicit hand gestures and autonomous navigation.</a:t>
+            </a:r>
+          </a:p>
+        </p:txBody>
+      </p:sp>
+      <p:sp>
+        <p:nvSpPr>
+          <p:cNvPr id="6" name="Lit_Paper_1"/>
           <p:cNvSpPr txBox="1"/>
           <p:nvPr/>
         </p:nvSpPr>
         <p:spPr>
           <a:xfrm>
-            <a:off x="4480560" y="1353312"/>
-            <a:ext cx="3227832" cy="1737360"/>
+            <a:off x="4480560" y="1325880"/>
+            <a:ext cx="3227832" cy="4251960"/>
           </a:xfrm>
           <a:prstGeom prst="rect">
             <a:avLst/>
@@ -3919,7 +3975,7 @@
           <a:noFill/>
         </p:spPr>
         <p:txBody>
-          <a:bodyPr wrap="square" lIns="36576" rIns="36576" tIns="36576" bIns="36576">
+          <a:bodyPr wrap="square" lIns="18288" rIns="18288" tIns="18288" bIns="18288">
             <a:spAutoFit/>
           </a:bodyPr>
           <a:lstStyle/>
@@ -3934,7 +3990,7 @@
               <a:spcAft>
                 <a:spcPts val="100"/>
               </a:spcAft>
-              <a:defRPr sz="1400" b="1" i="0">
+              <a:defRPr sz="1350" b="1" i="0">
                 <a:solidFill>
                   <a:srgbClr val="002060"/>
                 </a:solidFill>
@@ -3942,7 +3998,7 @@
               </a:defRPr>
             </a:pPr>
             <a:r>
-              <a:t>Tsitos et al. (2022)</a:t>
+              <a:t>J. A. Mahmud et al. (2022)</a:t>
             </a:r>
           </a:p>
           <a:p>
@@ -3954,9 +4010,9 @@
                 <a:spcPts val="0"/>
               </a:spcBef>
               <a:spcAft>
-                <a:spcPts val="400"/>
-              </a:spcAft>
-              <a:defRPr sz="1100" b="0" i="1">
+                <a:spcPts val="600"/>
+              </a:spcAft>
+              <a:defRPr sz="1050" b="0" i="1">
                 <a:solidFill>
                   <a:srgbClr val="64748B"/>
                 </a:solidFill>
@@ -3964,7 +4020,7 @@
               </a:defRPr>
             </a:pPr>
             <a:r>
-              <a:t>Fast Reaching Intention (Robotic Arm)</a:t>
+              <a:t>3D Gesture Recognition &amp; Adaptation</a:t>
             </a:r>
           </a:p>
           <a:p>
@@ -3973,11 +4029,39 @@
                 <a:spcPct val="115000"/>
               </a:lnSpc>
               <a:spcAft>
-                <a:spcPts val="300"/>
-              </a:spcAft>
-            </a:pPr>
-            <a:r>
-              <a:rPr sz="1150" b="1">
+                <a:spcPts val="500"/>
+              </a:spcAft>
+            </a:pPr>
+            <a:r>
+              <a:rPr sz="1080" b="1">
+                <a:solidFill>
+                  <a:srgbClr val="1E293B"/>
+                </a:solidFill>
+                <a:latin typeface="Calisto MT"/>
+              </a:rPr>
+              <a:t>• Objective: </a:t>
+            </a:r>
+            <a:r>
+              <a:rPr sz="1080" b="0">
+                <a:solidFill>
+                  <a:srgbClr val="334155"/>
+                </a:solidFill>
+                <a:latin typeface="Calisto MT"/>
+              </a:rPr>
+              <a:t>Classify 3D pointing and dynamic gestures in real time to guide robot interaction across age groups.</a:t>
+            </a:r>
+          </a:p>
+          <a:p>
+            <a:pPr algn="l">
+              <a:lnSpc>
+                <a:spcPct val="115000"/>
+              </a:lnSpc>
+              <a:spcAft>
+                <a:spcPts val="500"/>
+              </a:spcAft>
+            </a:pPr>
+            <a:r>
+              <a:rPr sz="1080" b="1">
                 <a:solidFill>
                   <a:srgbClr val="1E293B"/>
                 </a:solidFill>
@@ -3986,13 +4070,13 @@
               <a:t>• Method: </a:t>
             </a:r>
             <a:r>
-              <a:rPr sz="1150" b="0">
+              <a:rPr sz="1080" b="0">
                 <a:solidFill>
                   <a:srgbClr val="334155"/>
                 </a:solidFill>
                 <a:latin typeface="Calisto MT"/>
               </a:rPr>
-              <a:t>Monocular depth camera + SVM on UR3 arm.</a:t>
+              <a:t>Kinect v2 depth sensor + 3D skeletal normalization + CNN / SVM classifiers on 3,600 gesture samples.</a:t>
             </a:r>
           </a:p>
           <a:p>
@@ -4001,40 +4085,68 @@
                 <a:spcPct val="115000"/>
               </a:lnSpc>
               <a:spcAft>
+                <a:spcPts val="700"/>
+              </a:spcAft>
+            </a:pPr>
+            <a:r>
+              <a:rPr sz="1080" b="1">
+                <a:solidFill>
+                  <a:srgbClr val="1E293B"/>
+                </a:solidFill>
+                <a:latin typeface="Calisto MT"/>
+              </a:rPr>
+              <a:t>• Research Gap: </a:t>
+            </a:r>
+            <a:r>
+              <a:rPr sz="1080" b="0">
+                <a:solidFill>
+                  <a:srgbClr val="334155"/>
+                </a:solidFill>
+                <a:latin typeface="Calisto MT"/>
+              </a:rPr>
+              <a:t>Relies on heavy cloud / GPU computers; vulnerable to network latency (&gt;200 ms) and connection dropouts.</a:t>
+            </a:r>
+          </a:p>
+          <a:p>
+            <a:pPr algn="l">
+              <a:lnSpc>
+                <a:spcPct val="115000"/>
+              </a:lnSpc>
+              <a:spcAft>
                 <a:spcPts val="0"/>
               </a:spcAft>
             </a:pPr>
             <a:r>
-              <a:rPr sz="1150" b="1">
+              <a:rPr sz="1080" b="1">
+                <a:solidFill>
+                  <a:srgbClr val="002060"/>
+                </a:solidFill>
+                <a:latin typeface="Calisto MT"/>
+              </a:rPr>
+              <a:t>👉 Our Solution: </a:t>
+            </a:r>
+            <a:r>
+              <a:rPr sz="1080" b="0">
                 <a:solidFill>
                   <a:srgbClr val="1E293B"/>
                 </a:solidFill>
                 <a:latin typeface="Calisto MT"/>
               </a:rPr>
-              <a:t>• Gap: </a:t>
-            </a:r>
-            <a:r>
-              <a:rPr sz="1150" b="0">
-                <a:solidFill>
-                  <a:srgbClr val="334155"/>
-                </a:solidFill>
-                <a:latin typeface="Calisto MT"/>
-              </a:rPr>
-              <a:t>No Mobile Navigation: Confined to a static tabletop; cannot drive on wheels or accept gesture navigation.</a:t>
-            </a:r>
-          </a:p>
-        </p:txBody>
-      </p:sp>
-      <p:sp>
-        <p:nvSpPr>
-          <p:cNvPr id="7" name="Lit_Study_2"/>
+              <a:t>Executes 100% of vision AI directly onboard a low-cost Raspberry Pi 5 with zero cloud dependency.</a:t>
+            </a:r>
+          </a:p>
+        </p:txBody>
+      </p:sp>
+      <p:sp>
+        <p:nvSpPr>
+          <p:cNvPr id="7" name="Lit_Paper_2"/>
           <p:cNvSpPr txBox="1"/>
           <p:nvPr/>
         </p:nvSpPr>
         <p:spPr>
           <a:xfrm>
-            <a:off x="8046720" y="1353312"/>
-            <a:ext cx="3227832" cy="1737360"/>
+            <a:off x="8138160" y="1325880"/>
+            <a:ext cx="3227832" cy="4251960"/>
           </a:xfrm>
           <a:prstGeom prst="rect">
             <a:avLst/>
@@ -4042,7 +4154,7 @@
           <a:noFill/>
         </p:spPr>
         <p:txBody>
-          <a:bodyPr wrap="square" lIns="36576" rIns="36576" tIns="36576" bIns="36576">
+          <a:bodyPr wrap="square" lIns="18288" rIns="18288" tIns="18288" bIns="18288">
             <a:spAutoFit/>
           </a:bodyPr>
           <a:lstStyle/>
@@ -4057,7 +4169,7 @@
               <a:spcAft>
                 <a:spcPts val="100"/>
               </a:spcAft>
-              <a:defRPr sz="1400" b="1" i="0">
+              <a:defRPr sz="1350" b="1" i="0">
                 <a:solidFill>
                   <a:srgbClr val="002060"/>
                 </a:solidFill>
@@ -4065,7 +4177,7 @@
               </a:defRPr>
             </a:pPr>
             <a:r>
-              <a:t>Li et al. (2023)</a:t>
+              <a:t>Y. Li &amp; H. Zhang et al. (2023)</a:t>
             </a:r>
           </a:p>
           <a:p>
@@ -4077,9 +4189,9 @@
                 <a:spcPts val="0"/>
               </a:spcBef>
               <a:spcAft>
-                <a:spcPts val="400"/>
-              </a:spcAft>
-              <a:defRPr sz="1100" b="0" i="1">
+                <a:spcPts val="600"/>
+              </a:spcAft>
+              <a:defRPr sz="1050" b="0" i="1">
                 <a:solidFill>
                   <a:srgbClr val="64748B"/>
                 </a:solidFill>
@@ -4087,7 +4199,7 @@
               </a:defRPr>
             </a:pPr>
             <a:r>
-              <a:t>Intention-Aware Navigation</a:t>
+              <a:t>Intention-Aware Motion Planning</a:t>
             </a:r>
           </a:p>
           <a:p>
@@ -4096,11 +4208,39 @@
                 <a:spcPct val="115000"/>
               </a:lnSpc>
               <a:spcAft>
-                <a:spcPts val="300"/>
-              </a:spcAft>
-            </a:pPr>
-            <a:r>
-              <a:rPr sz="1150" b="1">
+                <a:spcPts val="500"/>
+              </a:spcAft>
+            </a:pPr>
+            <a:r>
+              <a:rPr sz="1080" b="1">
+                <a:solidFill>
+                  <a:srgbClr val="1E293B"/>
+                </a:solidFill>
+                <a:latin typeface="Calisto MT"/>
+              </a:rPr>
+              <a:t>• Objective: </a:t>
+            </a:r>
+            <a:r>
+              <a:rPr sz="1080" b="0">
+                <a:solidFill>
+                  <a:srgbClr val="334155"/>
+                </a:solidFill>
+                <a:latin typeface="Calisto MT"/>
+              </a:rPr>
+              <a:t>Plan mobile robot paths around moving site workers by predicting whether obstacles will clear the hallway.</a:t>
+            </a:r>
+          </a:p>
+          <a:p>
+            <a:pPr algn="l">
+              <a:lnSpc>
+                <a:spcPct val="115000"/>
+              </a:lnSpc>
+              <a:spcAft>
+                <a:spcPts val="500"/>
+              </a:spcAft>
+            </a:pPr>
+            <a:r>
+              <a:rPr sz="1080" b="1">
                 <a:solidFill>
                   <a:srgbClr val="1E293B"/>
                 </a:solidFill>
@@ -4109,13 +4249,13 @@
               <a:t>• Method: </a:t>
             </a:r>
             <a:r>
-              <a:rPr sz="1150" b="0">
+              <a:rPr sz="1080" b="0">
                 <a:solidFill>
                   <a:srgbClr val="334155"/>
                 </a:solidFill>
                 <a:latin typeface="Calisto MT"/>
               </a:rPr>
-              <a:t>2D LiDAR + CNN in Isaac Sim simulator.</a:t>
+              <a:t>2D LiDAR + camera object detection + CNN intention prediction integrated into ROS 2 Nav2 in Isaac Sim.</a:t>
             </a:r>
           </a:p>
           <a:p>
@@ -4124,289 +4264,54 @@
                 <a:spcPct val="115000"/>
               </a:lnSpc>
               <a:spcAft>
+                <a:spcPts val="700"/>
+              </a:spcAft>
+            </a:pPr>
+            <a:r>
+              <a:rPr sz="1080" b="1">
+                <a:solidFill>
+                  <a:srgbClr val="1E293B"/>
+                </a:solidFill>
+                <a:latin typeface="Calisto MT"/>
+              </a:rPr>
+              <a:t>• Research Gap: </a:t>
+            </a:r>
+            <a:r>
+              <a:rPr sz="1080" b="0">
+                <a:solidFill>
+                  <a:srgbClr val="334155"/>
+                </a:solidFill>
+                <a:latin typeface="Calisto MT"/>
+              </a:rPr>
+              <a:t>Tested only in computer simulation — unverified on real physical robot hardware; lacks touchless gesture control.</a:t>
+            </a:r>
+          </a:p>
+          <a:p>
+            <a:pPr algn="l">
+              <a:lnSpc>
+                <a:spcPct val="115000"/>
+              </a:lnSpc>
+              <a:spcAft>
                 <a:spcPts val="0"/>
               </a:spcAft>
             </a:pPr>
             <a:r>
-              <a:rPr sz="1150" b="1">
+              <a:rPr sz="1080" b="1">
+                <a:solidFill>
+                  <a:srgbClr val="002060"/>
+                </a:solidFill>
+                <a:latin typeface="Calisto MT"/>
+              </a:rPr>
+              <a:t>👉 Our Solution: </a:t>
+            </a:r>
+            <a:r>
+              <a:rPr sz="1080" b="0">
                 <a:solidFill>
                   <a:srgbClr val="1E293B"/>
                 </a:solidFill>
                 <a:latin typeface="Calisto MT"/>
               </a:rPr>
-              <a:t>• Gap: </a:t>
-            </a:r>
-            <a:r>
-              <a:rPr sz="1150" b="0">
-                <a:solidFill>
-                  <a:srgbClr val="334155"/>
-                </a:solidFill>
-                <a:latin typeface="Calisto MT"/>
-              </a:rPr>
-              <a:t>Simulation Only: Never verified on physical robot hardware; lacks touchless human gesture steering.</a:t>
-            </a:r>
-          </a:p>
-        </p:txBody>
-      </p:sp>
-      <p:cxnSp>
-        <p:nvCxnSpPr>
-          <p:cNvPr id="8" name="Lit_Divider_Line"/>
-          <p:cNvCxnSpPr/>
-          <p:nvPr/>
-        </p:nvCxnSpPr>
-        <p:spPr>
-          <a:xfrm>
-            <a:off x="914400" y="3246120"/>
-            <a:ext cx="10360152" cy="0"/>
-          </a:xfrm>
-          <a:prstGeom prst="line">
-            <a:avLst/>
-          </a:prstGeom>
-          <a:ln w="10160">
-            <a:solidFill>
-              <a:srgbClr val="CBD5E1"/>
-            </a:solidFill>
-          </a:ln>
-        </p:spPr>
-        <p:style>
-          <a:lnRef idx="2">
-            <a:schemeClr val="accent1"/>
-          </a:lnRef>
-          <a:fillRef idx="0">
-            <a:schemeClr val="accent1"/>
-          </a:fillRef>
-          <a:effectRef idx="1">
-            <a:schemeClr val="accent1"/>
-          </a:effectRef>
-          <a:fontRef idx="minor">
-            <a:schemeClr val="tx1"/>
-          </a:fontRef>
-        </p:style>
-      </p:cxnSp>
-      <p:sp>
-        <p:nvSpPr>
-          <p:cNvPr id="9" name="Lit_Gap_Label"/>
-          <p:cNvSpPr txBox="1"/>
-          <p:nvPr/>
-        </p:nvSpPr>
-        <p:spPr>
-          <a:xfrm>
-            <a:off x="914400" y="3429000"/>
-            <a:ext cx="5029200" cy="256032"/>
-          </a:xfrm>
-          <a:prstGeom prst="rect">
-            <a:avLst/>
-          </a:prstGeom>
-          <a:noFill/>
-        </p:spPr>
-        <p:txBody>
-          <a:bodyPr wrap="square" lIns="0" rIns="0" tIns="0" bIns="0">
-            <a:spAutoFit/>
-          </a:bodyPr>
-          <a:lstStyle/>
-          <a:p>
-            <a:pPr algn="l">
-              <a:lnSpc>
-                <a:spcPct val="115000"/>
-              </a:lnSpc>
-              <a:spcBef>
-                <a:spcPts val="0"/>
-              </a:spcBef>
-              <a:spcAft>
-                <a:spcPts val="200"/>
-              </a:spcAft>
-              <a:defRPr sz="1200" b="1" i="0">
-                <a:solidFill>
-                  <a:srgbClr val="B8860B"/>
-                </a:solidFill>
-                <a:latin typeface="Calisto MT"/>
-              </a:defRPr>
-            </a:pPr>
-            <a:r>
-              <a:t>HOW OUR SYSTEM CLOSES THESE GAPS</a:t>
-            </a:r>
-          </a:p>
-        </p:txBody>
-      </p:sp>
-      <p:sp>
-        <p:nvSpPr>
-          <p:cNvPr id="10" name="Lit_Gap_0"/>
-          <p:cNvSpPr txBox="1"/>
-          <p:nvPr/>
-        </p:nvSpPr>
-        <p:spPr>
-          <a:xfrm>
-            <a:off x="914400" y="3730752"/>
-            <a:ext cx="3227832" cy="1783080"/>
-          </a:xfrm>
-          <a:prstGeom prst="rect">
-            <a:avLst/>
-          </a:prstGeom>
-          <a:noFill/>
-        </p:spPr>
-        <p:txBody>
-          <a:bodyPr wrap="square" lIns="36576" rIns="36576" tIns="36576" bIns="36576">
-            <a:spAutoFit/>
-          </a:bodyPr>
-          <a:lstStyle/>
-          <a:p>
-            <a:pPr algn="l">
-              <a:spcAft>
-                <a:spcPts val="300"/>
-              </a:spcAft>
-              <a:defRPr sz="1350" b="1">
-                <a:solidFill>
-                  <a:srgbClr val="002060"/>
-                </a:solidFill>
-                <a:latin typeface="Calisto MT"/>
-              </a:defRPr>
-            </a:pPr>
-            <a:r>
-              <a:t>01.  All-Onboard Edge AI</a:t>
-            </a:r>
-          </a:p>
-          <a:p>
-            <a:pPr algn="l">
-              <a:lnSpc>
-                <a:spcPct val="115000"/>
-              </a:lnSpc>
-              <a:spcBef>
-                <a:spcPts val="0"/>
-              </a:spcBef>
-              <a:spcAft>
-                <a:spcPts val="200"/>
-              </a:spcAft>
-              <a:defRPr sz="1150" b="0" i="0">
-                <a:solidFill>
-                  <a:srgbClr val="334155"/>
-                </a:solidFill>
-                <a:latin typeface="Calisto MT"/>
-              </a:defRPr>
-            </a:pPr>
-            <a:r>
-              <a:t>Executes 100% of vision AI directly on the robot (Raspberry Pi 5) with zero cloud lag, zero internet dependency, and zero Wi-Fi dropouts.</a:t>
-            </a:r>
-          </a:p>
-        </p:txBody>
-      </p:sp>
-      <p:sp>
-        <p:nvSpPr>
-          <p:cNvPr id="11" name="Lit_Gap_1"/>
-          <p:cNvSpPr txBox="1"/>
-          <p:nvPr/>
-        </p:nvSpPr>
-        <p:spPr>
-          <a:xfrm>
-            <a:off x="4480560" y="3730752"/>
-            <a:ext cx="3227832" cy="1783080"/>
-          </a:xfrm>
-          <a:prstGeom prst="rect">
-            <a:avLst/>
-          </a:prstGeom>
-          <a:noFill/>
-        </p:spPr>
-        <p:txBody>
-          <a:bodyPr wrap="square" lIns="36576" rIns="36576" tIns="36576" bIns="36576">
-            <a:spAutoFit/>
-          </a:bodyPr>
-          <a:lstStyle/>
-          <a:p>
-            <a:pPr algn="l">
-              <a:spcAft>
-                <a:spcPts val="300"/>
-              </a:spcAft>
-              <a:defRPr sz="1350" b="1">
-                <a:solidFill>
-                  <a:srgbClr val="002060"/>
-                </a:solidFill>
-                <a:latin typeface="Calisto MT"/>
-              </a:defRPr>
-            </a:pPr>
-            <a:r>
-              <a:t>02.  Direct Vision-to-Wheels</a:t>
-            </a:r>
-          </a:p>
-          <a:p>
-            <a:pPr algn="l">
-              <a:lnSpc>
-                <a:spcPct val="115000"/>
-              </a:lnSpc>
-              <a:spcBef>
-                <a:spcPts val="0"/>
-              </a:spcBef>
-              <a:spcAft>
-                <a:spcPts val="200"/>
-              </a:spcAft>
-              <a:defRPr sz="1150" b="0" i="0">
-                <a:solidFill>
-                  <a:srgbClr val="334155"/>
-                </a:solidFill>
-                <a:latin typeface="Calisto MT"/>
-              </a:defRPr>
-            </a:pPr>
-            <a:r>
-              <a:t>Bridges hand gestures directly to physical wheel motors in real time through an active visual-tracking camera gimbal and ROS 2 middleware.</a:t>
-            </a:r>
-          </a:p>
-        </p:txBody>
-      </p:sp>
-      <p:sp>
-        <p:nvSpPr>
-          <p:cNvPr id="12" name="Lit_Gap_2"/>
-          <p:cNvSpPr txBox="1"/>
-          <p:nvPr/>
-        </p:nvSpPr>
-        <p:spPr>
-          <a:xfrm>
-            <a:off x="8046720" y="3730752"/>
-            <a:ext cx="3227832" cy="1783080"/>
-          </a:xfrm>
-          <a:prstGeom prst="rect">
-            <a:avLst/>
-          </a:prstGeom>
-          <a:noFill/>
-        </p:spPr>
-        <p:txBody>
-          <a:bodyPr wrap="square" lIns="36576" rIns="36576" tIns="36576" bIns="36576">
-            <a:spAutoFit/>
-          </a:bodyPr>
-          <a:lstStyle/>
-          <a:p>
-            <a:pPr algn="l">
-              <a:spcAft>
-                <a:spcPts val="300"/>
-              </a:spcAft>
-              <a:defRPr sz="1350" b="1">
-                <a:solidFill>
-                  <a:srgbClr val="002060"/>
-                </a:solidFill>
-                <a:latin typeface="Calisto MT"/>
-              </a:defRPr>
-            </a:pPr>
-            <a:r>
-              <a:t>03.  Physical Hardware &amp; Safety</a:t>
-            </a:r>
-          </a:p>
-          <a:p>
-            <a:pPr algn="l">
-              <a:lnSpc>
-                <a:spcPct val="115000"/>
-              </a:lnSpc>
-              <a:spcBef>
-                <a:spcPts val="0"/>
-              </a:spcBef>
-              <a:spcAft>
-                <a:spcPts val="200"/>
-              </a:spcAft>
-              <a:defRPr sz="1150" b="0" i="0">
-                <a:solidFill>
-                  <a:srgbClr val="334155"/>
-                </a:solidFill>
-                <a:latin typeface="Calisto MT"/>
-              </a:defRPr>
-            </a:pPr>
-            <a:r>
-              <a:t>Empirically validated on a physical robot with 2D LiDAR SLAM, continuous human tracking, and automatic ISO 15066 safety stops.</a:t>
+              <a:t>Physically deployed on a real mobile robot with 2D LiDAR SLAM, active visual servoing, and ISO 15066 safety stops.</a:t>
             </a:r>
           </a:p>
         </p:txBody>

</xml_diff>

<commit_message>
feat(slides): add full co-author names and formal academic styling to Slide 6
</commit_message>
<xml_diff>
--- a/write_up/Project Final Defense Slides_FINAL.pptx
+++ b/write_up/Project Final Defense Slides_FINAL.pptx
@@ -3743,7 +3743,7 @@
         <p:spPr>
           <a:xfrm>
             <a:off x="822960" y="1051560"/>
-            <a:ext cx="10515600" cy="256032"/>
+            <a:ext cx="10515600" cy="228600"/>
           </a:xfrm>
           <a:prstGeom prst="rect">
             <a:avLst/>
@@ -3787,8 +3787,8 @@
         </p:nvSpPr>
         <p:spPr>
           <a:xfrm>
-            <a:off x="822960" y="1325880"/>
-            <a:ext cx="3227832" cy="4251960"/>
+            <a:off x="822960" y="1298448"/>
+            <a:ext cx="3227832" cy="4297680"/>
           </a:xfrm>
           <a:prstGeom prst="rect">
             <a:avLst/>
@@ -3803,7 +3803,7 @@
           <a:p>
             <a:pPr algn="l">
               <a:lnSpc>
-                <a:spcPct val="115000"/>
+                <a:spcPct val="112000"/>
               </a:lnSpc>
               <a:spcBef>
                 <a:spcPts val="0"/>
@@ -3811,7 +3811,7 @@
               <a:spcAft>
                 <a:spcPts val="100"/>
               </a:spcAft>
-              <a:defRPr sz="1350" b="1" i="0">
+              <a:defRPr sz="1200" b="1" i="0">
                 <a:solidFill>
                   <a:srgbClr val="002060"/>
                 </a:solidFill>
@@ -3819,7 +3819,7 @@
               </a:defRPr>
             </a:pPr>
             <a:r>
-              <a:t>Athanasios Tsitos et al. (2022)</a:t>
+              <a:t>Athanasios Tsitos, Maria Dagioglou &amp; Theodoros Giannakopoulos (2022)</a:t>
             </a:r>
           </a:p>
           <a:p>
@@ -3831,9 +3831,9 @@
                 <a:spcPts val="0"/>
               </a:spcBef>
               <a:spcAft>
-                <a:spcPts val="600"/>
-              </a:spcAft>
-              <a:defRPr sz="1050" b="0" i="1">
+                <a:spcPts val="500"/>
+              </a:spcAft>
+              <a:defRPr sz="1000" b="0" i="1">
                 <a:solidFill>
                   <a:srgbClr val="64748B"/>
                 </a:solidFill>
@@ -3847,14 +3847,14 @@
           <a:p>
             <a:pPr algn="l">
               <a:lnSpc>
-                <a:spcPct val="115000"/>
-              </a:lnSpc>
-              <a:spcAft>
-                <a:spcPts val="500"/>
-              </a:spcAft>
-            </a:pPr>
-            <a:r>
-              <a:rPr sz="1080" b="1">
+                <a:spcPct val="112000"/>
+              </a:lnSpc>
+              <a:spcAft>
+                <a:spcPts val="400"/>
+              </a:spcAft>
+            </a:pPr>
+            <a:r>
+              <a:rPr sz="1019" b="1">
                 <a:solidFill>
                   <a:srgbClr val="1E293B"/>
                 </a:solidFill>
@@ -3863,7 +3863,7 @@
               <a:t>• Objective: </a:t>
             </a:r>
             <a:r>
-              <a:rPr sz="1080" b="0">
+              <a:rPr sz="1019" b="0">
                 <a:solidFill>
                   <a:srgbClr val="334155"/>
                 </a:solidFill>
@@ -3875,42 +3875,42 @@
           <a:p>
             <a:pPr algn="l">
               <a:lnSpc>
-                <a:spcPct val="115000"/>
+                <a:spcPct val="112000"/>
+              </a:lnSpc>
+              <a:spcAft>
+                <a:spcPts val="400"/>
+              </a:spcAft>
+            </a:pPr>
+            <a:r>
+              <a:rPr sz="1019" b="1">
+                <a:solidFill>
+                  <a:srgbClr val="1E293B"/>
+                </a:solidFill>
+                <a:latin typeface="Calisto MT"/>
+              </a:rPr>
+              <a:t>• Methodology: </a:t>
+            </a:r>
+            <a:r>
+              <a:rPr sz="1019" b="0">
+                <a:solidFill>
+                  <a:srgbClr val="334155"/>
+                </a:solidFill>
+                <a:latin typeface="Calisto MT"/>
+              </a:rPr>
+              <a:t>RGB-D camera + OpenPose wrist tracking + SVM on a 6-DOF UR3 industrial robotic arm.</a:t>
+            </a:r>
+          </a:p>
+          <a:p>
+            <a:pPr algn="l">
+              <a:lnSpc>
+                <a:spcPct val="112000"/>
               </a:lnSpc>
               <a:spcAft>
                 <a:spcPts val="500"/>
               </a:spcAft>
             </a:pPr>
             <a:r>
-              <a:rPr sz="1080" b="1">
-                <a:solidFill>
-                  <a:srgbClr val="1E293B"/>
-                </a:solidFill>
-                <a:latin typeface="Calisto MT"/>
-              </a:rPr>
-              <a:t>• Method: </a:t>
-            </a:r>
-            <a:r>
-              <a:rPr sz="1080" b="0">
-                <a:solidFill>
-                  <a:srgbClr val="334155"/>
-                </a:solidFill>
-                <a:latin typeface="Calisto MT"/>
-              </a:rPr>
-              <a:t>RGB-D camera + OpenPose wrist tracking + SVM / Decision Trees on an industrial 6-DOF UR3 robotic arm.</a:t>
-            </a:r>
-          </a:p>
-          <a:p>
-            <a:pPr algn="l">
-              <a:lnSpc>
-                <a:spcPct val="115000"/>
-              </a:lnSpc>
-              <a:spcAft>
-                <a:spcPts val="700"/>
-              </a:spcAft>
-            </a:pPr>
-            <a:r>
-              <a:rPr sz="1080" b="1">
+              <a:rPr sz="1019" b="1">
                 <a:solidFill>
                   <a:srgbClr val="1E293B"/>
                 </a:solidFill>
@@ -3919,41 +3919,41 @@
               <a:t>• Research Gap: </a:t>
             </a:r>
             <a:r>
-              <a:rPr sz="1080" b="0">
+              <a:rPr sz="1019" b="0">
                 <a:solidFill>
                   <a:srgbClr val="334155"/>
                 </a:solidFill>
                 <a:latin typeface="Calisto MT"/>
               </a:rPr>
-              <a:t>Confined to a static desk — lacks mobile base movement and provides no explicit hand gesture command channel.</a:t>
+              <a:t>Confined to a stationary desk — lacks mobile base movement and provides no explicit hand gesture command channel.</a:t>
             </a:r>
           </a:p>
           <a:p>
             <a:pPr algn="l">
               <a:lnSpc>
-                <a:spcPct val="115000"/>
+                <a:spcPct val="112000"/>
               </a:lnSpc>
               <a:spcAft>
                 <a:spcPts val="0"/>
               </a:spcAft>
             </a:pPr>
             <a:r>
-              <a:rPr sz="1080" b="1">
+              <a:rPr sz="1019" b="1">
                 <a:solidFill>
                   <a:srgbClr val="002060"/>
                 </a:solidFill>
                 <a:latin typeface="Calisto MT"/>
               </a:rPr>
-              <a:t>👉 Our Solution: </a:t>
-            </a:r>
-            <a:r>
-              <a:rPr sz="1080" b="0">
+              <a:t>• Project Resolution: </a:t>
+            </a:r>
+            <a:r>
+              <a:rPr sz="1019" b="0">
                 <a:solidFill>
                   <a:srgbClr val="1E293B"/>
                 </a:solidFill>
                 <a:latin typeface="Calisto MT"/>
               </a:rPr>
-              <a:t>Bridges intention directly to mobile wheels via 6 explicit hand gestures and autonomous navigation.</a:t>
+              <a:t>Direct vision-to-wheels coupling for mobile navigation guided by 6 touchless hand gestures.</a:t>
             </a:r>
           </a:p>
         </p:txBody>
@@ -3966,8 +3966,8 @@
         </p:nvSpPr>
         <p:spPr>
           <a:xfrm>
-            <a:off x="4480560" y="1325880"/>
-            <a:ext cx="3227832" cy="4251960"/>
+            <a:off x="4480560" y="1298448"/>
+            <a:ext cx="3227832" cy="4297680"/>
           </a:xfrm>
           <a:prstGeom prst="rect">
             <a:avLst/>
@@ -3982,7 +3982,7 @@
           <a:p>
             <a:pPr algn="l">
               <a:lnSpc>
-                <a:spcPct val="115000"/>
+                <a:spcPct val="112000"/>
               </a:lnSpc>
               <a:spcBef>
                 <a:spcPts val="0"/>
@@ -3990,7 +3990,7 @@
               <a:spcAft>
                 <a:spcPts val="100"/>
               </a:spcAft>
-              <a:defRPr sz="1350" b="1" i="0">
+              <a:defRPr sz="1200" b="1" i="0">
                 <a:solidFill>
                   <a:srgbClr val="002060"/>
                 </a:solidFill>
@@ -3998,7 +3998,7 @@
               </a:defRPr>
             </a:pPr>
             <a:r>
-              <a:t>J. A. Mahmud et al. (2022)</a:t>
+              <a:t>Jubayer Al Mahmud (2022)</a:t>
             </a:r>
           </a:p>
           <a:p>
@@ -4010,9 +4010,9 @@
                 <a:spcPts val="0"/>
               </a:spcBef>
               <a:spcAft>
-                <a:spcPts val="600"/>
-              </a:spcAft>
-              <a:defRPr sz="1050" b="0" i="1">
+                <a:spcPts val="500"/>
+              </a:spcAft>
+              <a:defRPr sz="1000" b="0" i="1">
                 <a:solidFill>
                   <a:srgbClr val="64748B"/>
                 </a:solidFill>
@@ -4026,14 +4026,14 @@
           <a:p>
             <a:pPr algn="l">
               <a:lnSpc>
-                <a:spcPct val="115000"/>
-              </a:lnSpc>
-              <a:spcAft>
-                <a:spcPts val="500"/>
-              </a:spcAft>
-            </a:pPr>
-            <a:r>
-              <a:rPr sz="1080" b="1">
+                <a:spcPct val="112000"/>
+              </a:lnSpc>
+              <a:spcAft>
+                <a:spcPts val="400"/>
+              </a:spcAft>
+            </a:pPr>
+            <a:r>
+              <a:rPr sz="1019" b="1">
                 <a:solidFill>
                   <a:srgbClr val="1E293B"/>
                 </a:solidFill>
@@ -4042,54 +4042,54 @@
               <a:t>• Objective: </a:t>
             </a:r>
             <a:r>
-              <a:rPr sz="1080" b="0">
+              <a:rPr sz="1019" b="0">
                 <a:solidFill>
                   <a:srgbClr val="334155"/>
                 </a:solidFill>
                 <a:latin typeface="Calisto MT"/>
               </a:rPr>
-              <a:t>Classify 3D pointing and dynamic gestures in real time to guide robot interaction across age groups.</a:t>
+              <a:t>Classify 3D pointing and dynamic hand gestures in real time to guide robot interaction across age groups.</a:t>
             </a:r>
           </a:p>
           <a:p>
             <a:pPr algn="l">
               <a:lnSpc>
-                <a:spcPct val="115000"/>
+                <a:spcPct val="112000"/>
+              </a:lnSpc>
+              <a:spcAft>
+                <a:spcPts val="400"/>
+              </a:spcAft>
+            </a:pPr>
+            <a:r>
+              <a:rPr sz="1019" b="1">
+                <a:solidFill>
+                  <a:srgbClr val="1E293B"/>
+                </a:solidFill>
+                <a:latin typeface="Calisto MT"/>
+              </a:rPr>
+              <a:t>• Methodology: </a:t>
+            </a:r>
+            <a:r>
+              <a:rPr sz="1019" b="0">
+                <a:solidFill>
+                  <a:srgbClr val="334155"/>
+                </a:solidFill>
+                <a:latin typeface="Calisto MT"/>
+              </a:rPr>
+              <a:t>Kinect v2 depth sensor + 3D skeletal normalization + CNN / SVM classifiers on 3,600 samples.</a:t>
+            </a:r>
+          </a:p>
+          <a:p>
+            <a:pPr algn="l">
+              <a:lnSpc>
+                <a:spcPct val="112000"/>
               </a:lnSpc>
               <a:spcAft>
                 <a:spcPts val="500"/>
               </a:spcAft>
             </a:pPr>
             <a:r>
-              <a:rPr sz="1080" b="1">
-                <a:solidFill>
-                  <a:srgbClr val="1E293B"/>
-                </a:solidFill>
-                <a:latin typeface="Calisto MT"/>
-              </a:rPr>
-              <a:t>• Method: </a:t>
-            </a:r>
-            <a:r>
-              <a:rPr sz="1080" b="0">
-                <a:solidFill>
-                  <a:srgbClr val="334155"/>
-                </a:solidFill>
-                <a:latin typeface="Calisto MT"/>
-              </a:rPr>
-              <a:t>Kinect v2 depth sensor + 3D skeletal normalization + CNN / SVM classifiers on 3,600 gesture samples.</a:t>
-            </a:r>
-          </a:p>
-          <a:p>
-            <a:pPr algn="l">
-              <a:lnSpc>
-                <a:spcPct val="115000"/>
-              </a:lnSpc>
-              <a:spcAft>
-                <a:spcPts val="700"/>
-              </a:spcAft>
-            </a:pPr>
-            <a:r>
-              <a:rPr sz="1080" b="1">
+              <a:rPr sz="1019" b="1">
                 <a:solidFill>
                   <a:srgbClr val="1E293B"/>
                 </a:solidFill>
@@ -4098,35 +4098,35 @@
               <a:t>• Research Gap: </a:t>
             </a:r>
             <a:r>
-              <a:rPr sz="1080" b="0">
+              <a:rPr sz="1019" b="0">
                 <a:solidFill>
                   <a:srgbClr val="334155"/>
                 </a:solidFill>
                 <a:latin typeface="Calisto MT"/>
               </a:rPr>
-              <a:t>Relies on heavy cloud / GPU computers; vulnerable to network latency (&gt;200 ms) and connection dropouts.</a:t>
+              <a:t>Relies on heavy cloud / GPU computers; vulnerable to network latency (&gt;200 ms) and Wi-Fi connection drops.</a:t>
             </a:r>
           </a:p>
           <a:p>
             <a:pPr algn="l">
               <a:lnSpc>
-                <a:spcPct val="115000"/>
+                <a:spcPct val="112000"/>
               </a:lnSpc>
               <a:spcAft>
                 <a:spcPts val="0"/>
               </a:spcAft>
             </a:pPr>
             <a:r>
-              <a:rPr sz="1080" b="1">
+              <a:rPr sz="1019" b="1">
                 <a:solidFill>
                   <a:srgbClr val="002060"/>
                 </a:solidFill>
                 <a:latin typeface="Calisto MT"/>
               </a:rPr>
-              <a:t>👉 Our Solution: </a:t>
-            </a:r>
-            <a:r>
-              <a:rPr sz="1080" b="0">
+              <a:t>• Project Resolution: </a:t>
+            </a:r>
+            <a:r>
+              <a:rPr sz="1019" b="0">
                 <a:solidFill>
                   <a:srgbClr val="1E293B"/>
                 </a:solidFill>
@@ -4145,8 +4145,8 @@
         </p:nvSpPr>
         <p:spPr>
           <a:xfrm>
-            <a:off x="8138160" y="1325880"/>
-            <a:ext cx="3227832" cy="4251960"/>
+            <a:off x="8138160" y="1298448"/>
+            <a:ext cx="3227832" cy="4297680"/>
           </a:xfrm>
           <a:prstGeom prst="rect">
             <a:avLst/>
@@ -4161,7 +4161,7 @@
           <a:p>
             <a:pPr algn="l">
               <a:lnSpc>
-                <a:spcPct val="115000"/>
+                <a:spcPct val="112000"/>
               </a:lnSpc>
               <a:spcBef>
                 <a:spcPts val="0"/>
@@ -4169,7 +4169,7 @@
               <a:spcAft>
                 <a:spcPts val="100"/>
               </a:spcAft>
-              <a:defRPr sz="1350" b="1" i="0">
+              <a:defRPr sz="1200" b="1" i="0">
                 <a:solidFill>
                   <a:srgbClr val="002060"/>
                 </a:solidFill>
@@ -4177,7 +4177,7 @@
               </a:defRPr>
             </a:pPr>
             <a:r>
-              <a:t>Y. Li &amp; H. Zhang et al. (2023)</a:t>
+              <a:t>Y. Li, H. Zhang, Guang Yang &amp; Shuoyu Wang (2023)</a:t>
             </a:r>
           </a:p>
           <a:p>
@@ -4189,9 +4189,9 @@
                 <a:spcPts val="0"/>
               </a:spcBef>
               <a:spcAft>
-                <a:spcPts val="600"/>
-              </a:spcAft>
-              <a:defRPr sz="1050" b="0" i="1">
+                <a:spcPts val="500"/>
+              </a:spcAft>
+              <a:defRPr sz="1000" b="0" i="1">
                 <a:solidFill>
                   <a:srgbClr val="64748B"/>
                 </a:solidFill>
@@ -4205,14 +4205,14 @@
           <a:p>
             <a:pPr algn="l">
               <a:lnSpc>
-                <a:spcPct val="115000"/>
-              </a:lnSpc>
-              <a:spcAft>
-                <a:spcPts val="500"/>
-              </a:spcAft>
-            </a:pPr>
-            <a:r>
-              <a:rPr sz="1080" b="1">
+                <a:spcPct val="112000"/>
+              </a:lnSpc>
+              <a:spcAft>
+                <a:spcPts val="400"/>
+              </a:spcAft>
+            </a:pPr>
+            <a:r>
+              <a:rPr sz="1019" b="1">
                 <a:solidFill>
                   <a:srgbClr val="1E293B"/>
                 </a:solidFill>
@@ -4221,7 +4221,7 @@
               <a:t>• Objective: </a:t>
             </a:r>
             <a:r>
-              <a:rPr sz="1080" b="0">
+              <a:rPr sz="1019" b="0">
                 <a:solidFill>
                   <a:srgbClr val="334155"/>
                 </a:solidFill>
@@ -4233,42 +4233,42 @@
           <a:p>
             <a:pPr algn="l">
               <a:lnSpc>
-                <a:spcPct val="115000"/>
+                <a:spcPct val="112000"/>
+              </a:lnSpc>
+              <a:spcAft>
+                <a:spcPts val="400"/>
+              </a:spcAft>
+            </a:pPr>
+            <a:r>
+              <a:rPr sz="1019" b="1">
+                <a:solidFill>
+                  <a:srgbClr val="1E293B"/>
+                </a:solidFill>
+                <a:latin typeface="Calisto MT"/>
+              </a:rPr>
+              <a:t>• Methodology: </a:t>
+            </a:r>
+            <a:r>
+              <a:rPr sz="1019" b="0">
+                <a:solidFill>
+                  <a:srgbClr val="334155"/>
+                </a:solidFill>
+                <a:latin typeface="Calisto MT"/>
+              </a:rPr>
+              <a:t>2D LiDAR + camera CNN object detection + costmap updates in Isaac Sim virtual simulation.</a:t>
+            </a:r>
+          </a:p>
+          <a:p>
+            <a:pPr algn="l">
+              <a:lnSpc>
+                <a:spcPct val="112000"/>
               </a:lnSpc>
               <a:spcAft>
                 <a:spcPts val="500"/>
               </a:spcAft>
             </a:pPr>
             <a:r>
-              <a:rPr sz="1080" b="1">
-                <a:solidFill>
-                  <a:srgbClr val="1E293B"/>
-                </a:solidFill>
-                <a:latin typeface="Calisto MT"/>
-              </a:rPr>
-              <a:t>• Method: </a:t>
-            </a:r>
-            <a:r>
-              <a:rPr sz="1080" b="0">
-                <a:solidFill>
-                  <a:srgbClr val="334155"/>
-                </a:solidFill>
-                <a:latin typeface="Calisto MT"/>
-              </a:rPr>
-              <a:t>2D LiDAR + camera object detection + CNN intention prediction integrated into ROS 2 Nav2 in Isaac Sim.</a:t>
-            </a:r>
-          </a:p>
-          <a:p>
-            <a:pPr algn="l">
-              <a:lnSpc>
-                <a:spcPct val="115000"/>
-              </a:lnSpc>
-              <a:spcAft>
-                <a:spcPts val="700"/>
-              </a:spcAft>
-            </a:pPr>
-            <a:r>
-              <a:rPr sz="1080" b="1">
+              <a:rPr sz="1019" b="1">
                 <a:solidFill>
                   <a:srgbClr val="1E293B"/>
                 </a:solidFill>
@@ -4277,41 +4277,41 @@
               <a:t>• Research Gap: </a:t>
             </a:r>
             <a:r>
-              <a:rPr sz="1080" b="0">
+              <a:rPr sz="1019" b="0">
                 <a:solidFill>
                   <a:srgbClr val="334155"/>
                 </a:solidFill>
                 <a:latin typeface="Calisto MT"/>
               </a:rPr>
-              <a:t>Tested only in computer simulation — unverified on real physical robot hardware; lacks touchless gesture control.</a:t>
+              <a:t>Tested only in computer simulation — never validated on physical robot hardware; lacks touchless gesture steering.</a:t>
             </a:r>
           </a:p>
           <a:p>
             <a:pPr algn="l">
               <a:lnSpc>
-                <a:spcPct val="115000"/>
+                <a:spcPct val="112000"/>
               </a:lnSpc>
               <a:spcAft>
                 <a:spcPts val="0"/>
               </a:spcAft>
             </a:pPr>
             <a:r>
-              <a:rPr sz="1080" b="1">
+              <a:rPr sz="1019" b="1">
                 <a:solidFill>
                   <a:srgbClr val="002060"/>
                 </a:solidFill>
                 <a:latin typeface="Calisto MT"/>
               </a:rPr>
-              <a:t>👉 Our Solution: </a:t>
-            </a:r>
-            <a:r>
-              <a:rPr sz="1080" b="0">
+              <a:t>• Project Resolution: </a:t>
+            </a:r>
+            <a:r>
+              <a:rPr sz="1019" b="0">
                 <a:solidFill>
                   <a:srgbClr val="1E293B"/>
                 </a:solidFill>
                 <a:latin typeface="Calisto MT"/>
               </a:rPr>
-              <a:t>Physically deployed on a real mobile robot with 2D LiDAR SLAM, active visual servoing, and ISO 15066 safety stops.</a:t>
+              <a:t>Physically validated on a real mobile robot with 2D LiDAR SLAM, active visual servoing, and ISO 15066 safety stops.</a:t>
             </a:r>
           </a:p>
         </p:txBody>

</xml_diff>

<commit_message>
feat(slides): add exact publication titles and optimize font sizes on Slide 6
</commit_message>
<xml_diff>
--- a/write_up/Project Final Defense Slides_FINAL.pptx
+++ b/write_up/Project Final Defense Slides_FINAL.pptx
@@ -3696,7 +3696,7 @@
           <a:p>
             <a:pPr algn="ctr">
               <a:lnSpc>
-                <a:spcPct val="115000"/>
+                <a:spcPct val="112000"/>
               </a:lnSpc>
               <a:spcBef>
                 <a:spcPts val="0"/>
@@ -3742,7 +3742,7 @@
         </p:nvSpPr>
         <p:spPr>
           <a:xfrm>
-            <a:off x="822960" y="1051560"/>
+            <a:off x="822960" y="1024128"/>
             <a:ext cx="10515600" cy="228600"/>
           </a:xfrm>
           <a:prstGeom prst="rect">
@@ -3758,7 +3758,7 @@
           <a:p>
             <a:pPr algn="l">
               <a:lnSpc>
-                <a:spcPct val="115000"/>
+                <a:spcPct val="112000"/>
               </a:lnSpc>
               <a:spcBef>
                 <a:spcPts val="0"/>
@@ -3787,8 +3787,8 @@
         </p:nvSpPr>
         <p:spPr>
           <a:xfrm>
-            <a:off x="822960" y="1298448"/>
-            <a:ext cx="3227832" cy="4297680"/>
+            <a:off x="822960" y="1261872"/>
+            <a:ext cx="3227832" cy="4389120"/>
           </a:xfrm>
           <a:prstGeom prst="rect">
             <a:avLst/>
@@ -3803,7 +3803,7 @@
           <a:p>
             <a:pPr algn="l">
               <a:lnSpc>
-                <a:spcPct val="112000"/>
+                <a:spcPct val="110000"/>
               </a:lnSpc>
               <a:spcBef>
                 <a:spcPts val="0"/>
@@ -3811,7 +3811,7 @@
               <a:spcAft>
                 <a:spcPts val="100"/>
               </a:spcAft>
-              <a:defRPr sz="1200" b="1" i="0">
+              <a:defRPr sz="1150" b="1" i="0">
                 <a:solidFill>
                   <a:srgbClr val="002060"/>
                 </a:solidFill>
@@ -3825,7 +3825,7 @@
           <a:p>
             <a:pPr algn="l">
               <a:lnSpc>
-                <a:spcPct val="115000"/>
+                <a:spcPct val="110000"/>
               </a:lnSpc>
               <a:spcBef>
                 <a:spcPts val="0"/>
@@ -3833,7 +3833,7 @@
               <a:spcAft>
                 <a:spcPts val="500"/>
               </a:spcAft>
-              <a:defRPr sz="1000" b="0" i="1">
+              <a:defRPr sz="950" b="0" i="1">
                 <a:solidFill>
                   <a:srgbClr val="64748B"/>
                 </a:solidFill>
@@ -3841,7 +3841,7 @@
               </a:defRPr>
             </a:pPr>
             <a:r>
-              <a:t>Competitive Reaching Intention Game</a:t>
+              <a:t>"Real-Time Feasibility of a Human Intention Method Evaluated Through a Competitive Human-Robot Reaching Game"</a:t>
             </a:r>
           </a:p>
           <a:p>
@@ -3854,7 +3854,7 @@
               </a:spcAft>
             </a:pPr>
             <a:r>
-              <a:rPr sz="1019" b="1">
+              <a:rPr sz="1050" b="1">
                 <a:solidFill>
                   <a:srgbClr val="1E293B"/>
                 </a:solidFill>
@@ -3863,13 +3863,13 @@
               <a:t>• Objective: </a:t>
             </a:r>
             <a:r>
-              <a:rPr sz="1019" b="0">
+              <a:rPr sz="1050" b="0">
                 <a:solidFill>
                   <a:srgbClr val="334155"/>
                 </a:solidFill>
                 <a:latin typeface="Calisto MT"/>
               </a:rPr>
-              <a:t>Predict human reaching intent early to govern robot arm trajectories within a 150 ms reaction threshold.</a:t>
+              <a:t>Predict human reaching intent early to guide robot arm trajectories within a 150 ms reaction threshold.</a:t>
             </a:r>
           </a:p>
           <a:p>
@@ -3882,7 +3882,7 @@
               </a:spcAft>
             </a:pPr>
             <a:r>
-              <a:rPr sz="1019" b="1">
+              <a:rPr sz="1050" b="1">
                 <a:solidFill>
                   <a:srgbClr val="1E293B"/>
                 </a:solidFill>
@@ -3891,13 +3891,13 @@
               <a:t>• Methodology: </a:t>
             </a:r>
             <a:r>
-              <a:rPr sz="1019" b="0">
+              <a:rPr sz="1050" b="0">
                 <a:solidFill>
                   <a:srgbClr val="334155"/>
                 </a:solidFill>
                 <a:latin typeface="Calisto MT"/>
               </a:rPr>
-              <a:t>RGB-D camera + OpenPose wrist tracking + SVM on a 6-DOF UR3 industrial robotic arm.</a:t>
+              <a:t>RGB-D camera tracking wrist kinematics with SVM on a 6-DOF UR3 industrial robotic arm.</a:t>
             </a:r>
           </a:p>
           <a:p>
@@ -3910,7 +3910,7 @@
               </a:spcAft>
             </a:pPr>
             <a:r>
-              <a:rPr sz="1019" b="1">
+              <a:rPr sz="1050" b="1">
                 <a:solidFill>
                   <a:srgbClr val="1E293B"/>
                 </a:solidFill>
@@ -3919,13 +3919,13 @@
               <a:t>• Research Gap: </a:t>
             </a:r>
             <a:r>
-              <a:rPr sz="1019" b="0">
+              <a:rPr sz="1050" b="0">
                 <a:solidFill>
                   <a:srgbClr val="334155"/>
                 </a:solidFill>
                 <a:latin typeface="Calisto MT"/>
               </a:rPr>
-              <a:t>Confined to a stationary desk — lacks mobile base movement and provides no explicit hand gesture command channel.</a:t>
+              <a:t>Confined to a static desk — lacks mobile base movement and provides no explicit hand gesture command channel.</a:t>
             </a:r>
           </a:p>
           <a:p>
@@ -3938,7 +3938,7 @@
               </a:spcAft>
             </a:pPr>
             <a:r>
-              <a:rPr sz="1019" b="1">
+              <a:rPr sz="1050" b="1">
                 <a:solidFill>
                   <a:srgbClr val="002060"/>
                 </a:solidFill>
@@ -3947,7 +3947,7 @@
               <a:t>• Project Resolution: </a:t>
             </a:r>
             <a:r>
-              <a:rPr sz="1019" b="0">
+              <a:rPr sz="1050" b="0">
                 <a:solidFill>
                   <a:srgbClr val="1E293B"/>
                 </a:solidFill>
@@ -3966,8 +3966,8 @@
         </p:nvSpPr>
         <p:spPr>
           <a:xfrm>
-            <a:off x="4480560" y="1298448"/>
-            <a:ext cx="3227832" cy="4297680"/>
+            <a:off x="4480560" y="1261872"/>
+            <a:ext cx="3227832" cy="4389120"/>
           </a:xfrm>
           <a:prstGeom prst="rect">
             <a:avLst/>
@@ -3982,7 +3982,7 @@
           <a:p>
             <a:pPr algn="l">
               <a:lnSpc>
-                <a:spcPct val="112000"/>
+                <a:spcPct val="110000"/>
               </a:lnSpc>
               <a:spcBef>
                 <a:spcPts val="0"/>
@@ -3990,7 +3990,7 @@
               <a:spcAft>
                 <a:spcPts val="100"/>
               </a:spcAft>
-              <a:defRPr sz="1200" b="1" i="0">
+              <a:defRPr sz="1150" b="1" i="0">
                 <a:solidFill>
                   <a:srgbClr val="002060"/>
                 </a:solidFill>
@@ -4004,7 +4004,7 @@
           <a:p>
             <a:pPr algn="l">
               <a:lnSpc>
-                <a:spcPct val="115000"/>
+                <a:spcPct val="110000"/>
               </a:lnSpc>
               <a:spcBef>
                 <a:spcPts val="0"/>
@@ -4012,7 +4012,7 @@
               <a:spcAft>
                 <a:spcPts val="500"/>
               </a:spcAft>
-              <a:defRPr sz="1000" b="0" i="1">
+              <a:defRPr sz="950" b="0" i="1">
                 <a:solidFill>
                   <a:srgbClr val="64748B"/>
                 </a:solidFill>
@@ -4020,7 +4020,7 @@
               </a:defRPr>
             </a:pPr>
             <a:r>
-              <a:t>3D Gesture Recognition &amp; Adaptation</a:t>
+              <a:t>"3D Gesture Recognition and Adaptation for Human–Robot Interaction"</a:t>
             </a:r>
           </a:p>
           <a:p>
@@ -4033,7 +4033,7 @@
               </a:spcAft>
             </a:pPr>
             <a:r>
-              <a:rPr sz="1019" b="1">
+              <a:rPr sz="1050" b="1">
                 <a:solidFill>
                   <a:srgbClr val="1E293B"/>
                 </a:solidFill>
@@ -4042,7 +4042,7 @@
               <a:t>• Objective: </a:t>
             </a:r>
             <a:r>
-              <a:rPr sz="1019" b="0">
+              <a:rPr sz="1050" b="0">
                 <a:solidFill>
                   <a:srgbClr val="334155"/>
                 </a:solidFill>
@@ -4061,7 +4061,7 @@
               </a:spcAft>
             </a:pPr>
             <a:r>
-              <a:rPr sz="1019" b="1">
+              <a:rPr sz="1050" b="1">
                 <a:solidFill>
                   <a:srgbClr val="1E293B"/>
                 </a:solidFill>
@@ -4070,7 +4070,7 @@
               <a:t>• Methodology: </a:t>
             </a:r>
             <a:r>
-              <a:rPr sz="1019" b="0">
+              <a:rPr sz="1050" b="0">
                 <a:solidFill>
                   <a:srgbClr val="334155"/>
                 </a:solidFill>
@@ -4089,7 +4089,7 @@
               </a:spcAft>
             </a:pPr>
             <a:r>
-              <a:rPr sz="1019" b="1">
+              <a:rPr sz="1050" b="1">
                 <a:solidFill>
                   <a:srgbClr val="1E293B"/>
                 </a:solidFill>
@@ -4098,13 +4098,13 @@
               <a:t>• Research Gap: </a:t>
             </a:r>
             <a:r>
-              <a:rPr sz="1019" b="0">
+              <a:rPr sz="1050" b="0">
                 <a:solidFill>
                   <a:srgbClr val="334155"/>
                 </a:solidFill>
                 <a:latin typeface="Calisto MT"/>
               </a:rPr>
-              <a:t>Relies on heavy cloud / GPU computers; vulnerable to network latency (&gt;200 ms) and Wi-Fi connection drops.</a:t>
+              <a:t>Relies on heavy cloud / GPU computing clusters; vulnerable to network lag (&gt;200 ms) and connection drops.</a:t>
             </a:r>
           </a:p>
           <a:p>
@@ -4117,7 +4117,7 @@
               </a:spcAft>
             </a:pPr>
             <a:r>
-              <a:rPr sz="1019" b="1">
+              <a:rPr sz="1050" b="1">
                 <a:solidFill>
                   <a:srgbClr val="002060"/>
                 </a:solidFill>
@@ -4126,7 +4126,7 @@
               <a:t>• Project Resolution: </a:t>
             </a:r>
             <a:r>
-              <a:rPr sz="1019" b="0">
+              <a:rPr sz="1050" b="0">
                 <a:solidFill>
                   <a:srgbClr val="1E293B"/>
                 </a:solidFill>
@@ -4145,8 +4145,8 @@
         </p:nvSpPr>
         <p:spPr>
           <a:xfrm>
-            <a:off x="8138160" y="1298448"/>
-            <a:ext cx="3227832" cy="4297680"/>
+            <a:off x="8138160" y="1261872"/>
+            <a:ext cx="3227832" cy="4389120"/>
           </a:xfrm>
           <a:prstGeom prst="rect">
             <a:avLst/>
@@ -4161,7 +4161,7 @@
           <a:p>
             <a:pPr algn="l">
               <a:lnSpc>
-                <a:spcPct val="112000"/>
+                <a:spcPct val="110000"/>
               </a:lnSpc>
               <a:spcBef>
                 <a:spcPts val="0"/>
@@ -4169,7 +4169,7 @@
               <a:spcAft>
                 <a:spcPts val="100"/>
               </a:spcAft>
-              <a:defRPr sz="1200" b="1" i="0">
+              <a:defRPr sz="1150" b="1" i="0">
                 <a:solidFill>
                   <a:srgbClr val="002060"/>
                 </a:solidFill>
@@ -4183,7 +4183,7 @@
           <a:p>
             <a:pPr algn="l">
               <a:lnSpc>
-                <a:spcPct val="115000"/>
+                <a:spcPct val="110000"/>
               </a:lnSpc>
               <a:spcBef>
                 <a:spcPts val="0"/>
@@ -4191,7 +4191,7 @@
               <a:spcAft>
                 <a:spcPts val="500"/>
               </a:spcAft>
-              <a:defRPr sz="1000" b="0" i="1">
+              <a:defRPr sz="950" b="0" i="1">
                 <a:solidFill>
                   <a:srgbClr val="64748B"/>
                 </a:solidFill>
@@ -4199,7 +4199,7 @@
               </a:defRPr>
             </a:pPr>
             <a:r>
-              <a:t>Intention-Aware Motion Planning</a:t>
+              <a:t>"Safe and Efficient Motion Planning for Material Transportation Robots Considering Intention Prediction of Obstacles"</a:t>
             </a:r>
           </a:p>
           <a:p>
@@ -4212,7 +4212,7 @@
               </a:spcAft>
             </a:pPr>
             <a:r>
-              <a:rPr sz="1019" b="1">
+              <a:rPr sz="1050" b="1">
                 <a:solidFill>
                   <a:srgbClr val="1E293B"/>
                 </a:solidFill>
@@ -4221,13 +4221,13 @@
               <a:t>• Objective: </a:t>
             </a:r>
             <a:r>
-              <a:rPr sz="1019" b="0">
+              <a:rPr sz="1050" b="0">
                 <a:solidFill>
                   <a:srgbClr val="334155"/>
                 </a:solidFill>
                 <a:latin typeface="Calisto MT"/>
               </a:rPr>
-              <a:t>Plan mobile robot paths around moving site workers by predicting whether obstacles will clear the hallway.</a:t>
+              <a:t>Plan collision-free mobile robot paths by predicting whether human workers will clear the hallway.</a:t>
             </a:r>
           </a:p>
           <a:p>
@@ -4240,7 +4240,7 @@
               </a:spcAft>
             </a:pPr>
             <a:r>
-              <a:rPr sz="1019" b="1">
+              <a:rPr sz="1050" b="1">
                 <a:solidFill>
                   <a:srgbClr val="1E293B"/>
                 </a:solidFill>
@@ -4249,13 +4249,13 @@
               <a:t>• Methodology: </a:t>
             </a:r>
             <a:r>
-              <a:rPr sz="1019" b="0">
+              <a:rPr sz="1050" b="0">
                 <a:solidFill>
                   <a:srgbClr val="334155"/>
                 </a:solidFill>
                 <a:latin typeface="Calisto MT"/>
               </a:rPr>
-              <a:t>2D LiDAR + camera CNN object detection + costmap updates in Isaac Sim virtual simulation.</a:t>
+              <a:t>2D LiDAR + CNN obstacle prediction dynamically updating ROS 2 Nav2 costmaps in Isaac Sim.</a:t>
             </a:r>
           </a:p>
           <a:p>
@@ -4268,7 +4268,7 @@
               </a:spcAft>
             </a:pPr>
             <a:r>
-              <a:rPr sz="1019" b="1">
+              <a:rPr sz="1050" b="1">
                 <a:solidFill>
                   <a:srgbClr val="1E293B"/>
                 </a:solidFill>
@@ -4277,13 +4277,13 @@
               <a:t>• Research Gap: </a:t>
             </a:r>
             <a:r>
-              <a:rPr sz="1019" b="0">
+              <a:rPr sz="1050" b="0">
                 <a:solidFill>
                   <a:srgbClr val="334155"/>
                 </a:solidFill>
                 <a:latin typeface="Calisto MT"/>
               </a:rPr>
-              <a:t>Tested only in computer simulation — never validated on physical robot hardware; lacks touchless gesture steering.</a:t>
+              <a:t>Tested only in computer simulation — never validated on physical robot hardware; lacks touchless gesture control.</a:t>
             </a:r>
           </a:p>
           <a:p>
@@ -4296,7 +4296,7 @@
               </a:spcAft>
             </a:pPr>
             <a:r>
-              <a:rPr sz="1019" b="1">
+              <a:rPr sz="1050" b="1">
                 <a:solidFill>
                   <a:srgbClr val="002060"/>
                 </a:solidFill>
@@ -4305,13 +4305,13 @@
               <a:t>• Project Resolution: </a:t>
             </a:r>
             <a:r>
-              <a:rPr sz="1019" b="0">
+              <a:rPr sz="1050" b="0">
                 <a:solidFill>
                   <a:srgbClr val="1E293B"/>
                 </a:solidFill>
                 <a:latin typeface="Calisto MT"/>
               </a:rPr>
-              <a:t>Physically validated on a real mobile robot with 2D LiDAR SLAM, active visual servoing, and ISO 15066 safety stops.</a:t>
+              <a:t>Physically validated on a real mobile robot with 2D LiDAR SLAM, active visual servoing, and ISO safety stops.</a:t>
             </a:r>
           </a:p>
         </p:txBody>

</xml_diff>

<commit_message>
feat(slides): construct and verify formal academic Slide 7 (6-Phase Methodology)
</commit_message>
<xml_diff>
--- a/write_up/Project Final Defense Slides_FINAL.pptx
+++ b/write_up/Project Final Defense Slides_FINAL.pptx
@@ -14,6 +14,7 @@
     <p:sldId id="558" r:id="rId5"/>
     <p:sldId id="561" r:id="rId6"/>
     <p:sldId id="562" r:id="rId13"/>
+    <p:sldId id="563" r:id="rId14"/>
   </p:sldIdLst>
   <p:sldSz cx="12192000" cy="6858000"/>
   <p:notesSz cx="6858000" cy="9144000"/>
@@ -3897,7 +3898,7 @@
                 </a:solidFill>
                 <a:latin typeface="Calisto MT"/>
               </a:rPr>
-              <a:t>RGB-D camera tracking wrist kinematics with SVM on a 6-DOF UR3 industrial robotic arm.</a:t>
+              <a:t>Tracked hand movements with a depth camera and trained machine learning (SVM) to guide a robot arm.</a:t>
             </a:r>
           </a:p>
           <a:p>
@@ -4076,7 +4077,7 @@
                 </a:solidFill>
                 <a:latin typeface="Calisto MT"/>
               </a:rPr>
-              <a:t>Kinect v2 depth sensor + 3D skeletal normalization + CNN / SVM classifiers on 3,600 samples.</a:t>
+              <a:t>Tracked full-body joints using a Kinect sensor and trained deep learning models on 3,600 gestures.</a:t>
             </a:r>
           </a:p>
           <a:p>
@@ -4255,7 +4256,7 @@
                 </a:solidFill>
                 <a:latin typeface="Calisto MT"/>
               </a:rPr>
-              <a:t>2D LiDAR + CNN obstacle prediction dynamically updating ROS 2 Nav2 costmaps in Isaac Sim.</a:t>
+              <a:t>Fused LiDAR and camera vision to predict worker paths and adjust navigation maps in a simulator.</a:t>
             </a:r>
           </a:p>
           <a:p>
@@ -4313,6 +4314,1152 @@
               </a:rPr>
               <a:t>Physically validated on a real mobile robot with 2D LiDAR SLAM, active visual servoing, and ISO safety stops.</a:t>
             </a:r>
+          </a:p>
+        </p:txBody>
+      </p:sp>
+    </p:spTree>
+  </p:cSld>
+  <p:clrMapOvr>
+    <a:masterClrMapping/>
+  </p:clrMapOvr>
+</p:sld>
+</file>
+
+<file path=ppt/slides/slide7.xml><?xml version="1.0" encoding="utf-8"?>
+<p:sld xmlns:a="http://schemas.openxmlformats.org/drawingml/2006/main" xmlns:p="http://schemas.openxmlformats.org/presentationml/2006/main" xmlns:r="http://schemas.openxmlformats.org/officeDocument/2006/relationships">
+  <p:cSld>
+    <p:spTree>
+      <p:nvGrpSpPr>
+        <p:cNvPr id="1" name=""/>
+        <p:cNvGrpSpPr/>
+        <p:nvPr/>
+      </p:nvGrpSpPr>
+      <p:grpSpPr/>
+      <p:sp>
+        <p:nvSpPr>
+          <p:cNvPr id="2" name="Title 1"/>
+          <p:cNvSpPr>
+            <a:spLocks noGrp="1"/>
+          </p:cNvSpPr>
+          <p:nvPr>
+            <p:ph type="title"/>
+          </p:nvPr>
+        </p:nvSpPr>
+        <p:spPr>
+          <a:xfrm>
+            <a:off x="603504" y="320040"/>
+            <a:ext cx="10972800" cy="548640"/>
+          </a:xfrm>
+        </p:spPr>
+        <p:txBody>
+          <a:bodyPr/>
+          <a:lstStyle/>
+          <a:p>
+            <a:pPr algn="ctr">
+              <a:lnSpc>
+                <a:spcPct val="114000"/>
+              </a:lnSpc>
+              <a:spcBef>
+                <a:spcPts val="0"/>
+              </a:spcBef>
+              <a:spcAft>
+                <a:spcPts val="200"/>
+              </a:spcAft>
+              <a:defRPr sz="2400" b="1" i="0">
+                <a:solidFill>
+                  <a:srgbClr val="002060"/>
+                </a:solidFill>
+                <a:latin typeface="Calisto MT"/>
+              </a:defRPr>
+            </a:pPr>
+            <a:r>
+              <a:t>05. 6-PHASE RESEARCH &amp; IMPLEMENTATION METHODOLOGY</a:t>
+            </a:r>
+          </a:p>
+        </p:txBody>
+      </p:sp>
+      <p:sp>
+        <p:nvSpPr>
+          <p:cNvPr id="3" name="Content Placeholder 2"/>
+          <p:cNvSpPr>
+            <a:spLocks noGrp="1"/>
+          </p:cNvSpPr>
+          <p:nvPr>
+            <p:ph idx="1"/>
+          </p:nvPr>
+        </p:nvSpPr>
+        <p:spPr/>
+        <p:txBody>
+          <a:bodyPr/>
+          <a:lstStyle/>
+          <a:p/>
+        </p:txBody>
+      </p:sp>
+      <p:sp>
+        <p:nvSpPr>
+          <p:cNvPr id="4" name="Meth_Subhead"/>
+          <p:cNvSpPr txBox="1"/>
+          <p:nvPr/>
+        </p:nvSpPr>
+        <p:spPr>
+          <a:xfrm>
+            <a:off x="777240" y="960120"/>
+            <a:ext cx="10634472" cy="228600"/>
+          </a:xfrm>
+          <a:prstGeom prst="rect">
+            <a:avLst/>
+          </a:prstGeom>
+          <a:noFill/>
+        </p:spPr>
+        <p:txBody>
+          <a:bodyPr wrap="square" lIns="0" rIns="0" tIns="0" bIns="0">
+            <a:spAutoFit/>
+          </a:bodyPr>
+          <a:lstStyle/>
+          <a:p>
+            <a:pPr algn="l">
+              <a:lnSpc>
+                <a:spcPct val="114000"/>
+              </a:lnSpc>
+              <a:spcBef>
+                <a:spcPts val="0"/>
+              </a:spcBef>
+              <a:spcAft>
+                <a:spcPts val="200"/>
+              </a:spcAft>
+              <a:defRPr sz="1100" b="1" i="0">
+                <a:solidFill>
+                  <a:srgbClr val="B8860B"/>
+                </a:solidFill>
+                <a:latin typeface="Calisto MT"/>
+              </a:defRPr>
+            </a:pPr>
+            <a:r>
+              <a:t>STRUCTURED RESEARCH &amp; IMPLEMENTATION LIFECYCLE FROM DESIGN TO VALIDATION</a:t>
+            </a:r>
+          </a:p>
+        </p:txBody>
+      </p:sp>
+      <p:sp>
+        <p:nvSpPr>
+          <p:cNvPr id="5" name="Meth_P1"/>
+          <p:cNvSpPr txBox="1"/>
+          <p:nvPr/>
+        </p:nvSpPr>
+        <p:spPr>
+          <a:xfrm>
+            <a:off x="777240" y="1261872"/>
+            <a:ext cx="3227832" cy="1874519"/>
+          </a:xfrm>
+          <a:prstGeom prst="rect">
+            <a:avLst/>
+          </a:prstGeom>
+          <a:noFill/>
+        </p:spPr>
+        <p:txBody>
+          <a:bodyPr wrap="square" lIns="18288" rIns="18288" tIns="18288" bIns="18288">
+            <a:spAutoFit/>
+          </a:bodyPr>
+          <a:lstStyle/>
+          <a:p>
+            <a:pPr algn="l">
+              <a:lnSpc>
+                <a:spcPct val="110000"/>
+              </a:lnSpc>
+              <a:spcBef>
+                <a:spcPts val="0"/>
+              </a:spcBef>
+              <a:spcAft>
+                <a:spcPts val="100"/>
+              </a:spcAft>
+              <a:defRPr sz="1000" b="1" i="0">
+                <a:solidFill>
+                  <a:srgbClr val="B8860B"/>
+                </a:solidFill>
+                <a:latin typeface="Calisto MT"/>
+              </a:defRPr>
+            </a:pPr>
+            <a:r>
+              <a:t>PHASE 01</a:t>
+            </a:r>
+          </a:p>
+          <a:p>
+            <a:pPr algn="l">
+              <a:lnSpc>
+                <a:spcPct val="112000"/>
+              </a:lnSpc>
+              <a:spcBef>
+                <a:spcPts val="0"/>
+              </a:spcBef>
+              <a:spcAft>
+                <a:spcPts val="400"/>
+              </a:spcAft>
+              <a:defRPr sz="1200" b="1" i="0">
+                <a:solidFill>
+                  <a:srgbClr val="002060"/>
+                </a:solidFill>
+                <a:latin typeface="Calisto MT"/>
+              </a:defRPr>
+            </a:pPr>
+            <a:r>
+              <a:t>Mechatronics &amp; Embedded Hardware</a:t>
+            </a:r>
+          </a:p>
+          <a:p>
+            <a:pPr algn="l">
+              <a:lnSpc>
+                <a:spcPct val="114000"/>
+              </a:lnSpc>
+              <a:spcBef>
+                <a:spcPts val="0"/>
+              </a:spcBef>
+              <a:spcAft>
+                <a:spcPts val="300"/>
+              </a:spcAft>
+              <a:defRPr sz="1000" b="0" i="0">
+                <a:solidFill>
+                  <a:srgbClr val="1E293B"/>
+                </a:solidFill>
+                <a:latin typeface="Calisto MT"/>
+              </a:defRPr>
+            </a:pPr>
+            <a:r>
+              <a:t>• Built Yahboom 4WD mobile chassis with DC encoder motors and 2-DOF camera gimbal.</a:t>
+            </a:r>
+          </a:p>
+          <a:p>
+            <a:pPr algn="l">
+              <a:lnSpc>
+                <a:spcPct val="114000"/>
+              </a:lnSpc>
+              <a:spcBef>
+                <a:spcPts val="0"/>
+              </a:spcBef>
+              <a:spcAft>
+                <a:spcPts val="300"/>
+              </a:spcAft>
+              <a:defRPr sz="1000" b="0" i="0">
+                <a:solidFill>
+                  <a:srgbClr val="1E293B"/>
+                </a:solidFill>
+                <a:latin typeface="Calisto MT"/>
+              </a:defRPr>
+            </a:pPr>
+            <a:r>
+              <a:t>• Integrated Raspberry Pi 5 (8GB) edge compute node and ESP32-S3 micro-ROS co-processor.</a:t>
+            </a:r>
+          </a:p>
+          <a:p>
+            <a:pPr algn="l">
+              <a:lnSpc>
+                <a:spcPct val="114000"/>
+              </a:lnSpc>
+              <a:spcBef>
+                <a:spcPts val="0"/>
+              </a:spcBef>
+              <a:spcAft>
+                <a:spcPts val="0"/>
+              </a:spcAft>
+              <a:defRPr sz="1000" b="0" i="0">
+                <a:solidFill>
+                  <a:srgbClr val="1E293B"/>
+                </a:solidFill>
+                <a:latin typeface="Calisto MT"/>
+              </a:defRPr>
+            </a:pPr>
+            <a:r>
+              <a:t>• Implemented decoupled dual-bus power regulation (7.4V Li-ion) isolating logic from motor spikes.</a:t>
+            </a:r>
+          </a:p>
+        </p:txBody>
+      </p:sp>
+      <p:sp>
+        <p:nvSpPr>
+          <p:cNvPr id="6" name="Meth_P2"/>
+          <p:cNvSpPr txBox="1"/>
+          <p:nvPr/>
+        </p:nvSpPr>
+        <p:spPr>
+          <a:xfrm>
+            <a:off x="4480560" y="1261872"/>
+            <a:ext cx="3227832" cy="1874519"/>
+          </a:xfrm>
+          <a:prstGeom prst="rect">
+            <a:avLst/>
+          </a:prstGeom>
+          <a:noFill/>
+        </p:spPr>
+        <p:txBody>
+          <a:bodyPr wrap="square" lIns="18288" rIns="18288" tIns="18288" bIns="18288">
+            <a:spAutoFit/>
+          </a:bodyPr>
+          <a:lstStyle/>
+          <a:p>
+            <a:pPr algn="l">
+              <a:lnSpc>
+                <a:spcPct val="110000"/>
+              </a:lnSpc>
+              <a:spcBef>
+                <a:spcPts val="0"/>
+              </a:spcBef>
+              <a:spcAft>
+                <a:spcPts val="100"/>
+              </a:spcAft>
+              <a:defRPr sz="1000" b="1" i="0">
+                <a:solidFill>
+                  <a:srgbClr val="B8860B"/>
+                </a:solidFill>
+                <a:latin typeface="Calisto MT"/>
+              </a:defRPr>
+            </a:pPr>
+            <a:r>
+              <a:t>PHASE 02</a:t>
+            </a:r>
+          </a:p>
+          <a:p>
+            <a:pPr algn="l">
+              <a:lnSpc>
+                <a:spcPct val="112000"/>
+              </a:lnSpc>
+              <a:spcBef>
+                <a:spcPts val="0"/>
+              </a:spcBef>
+              <a:spcAft>
+                <a:spcPts val="400"/>
+              </a:spcAft>
+              <a:defRPr sz="1200" b="1" i="0">
+                <a:solidFill>
+                  <a:srgbClr val="002060"/>
+                </a:solidFill>
+                <a:latin typeface="Calisto MT"/>
+              </a:defRPr>
+            </a:pPr>
+            <a:r>
+              <a:t>Data Acquisition &amp; Calibration</a:t>
+            </a:r>
+          </a:p>
+          <a:p>
+            <a:pPr algn="l">
+              <a:lnSpc>
+                <a:spcPct val="114000"/>
+              </a:lnSpc>
+              <a:spcBef>
+                <a:spcPts val="0"/>
+              </a:spcBef>
+              <a:spcAft>
+                <a:spcPts val="300"/>
+              </a:spcAft>
+              <a:defRPr sz="1000" b="0" i="0">
+                <a:solidFill>
+                  <a:srgbClr val="1E293B"/>
+                </a:solidFill>
+                <a:latin typeface="Calisto MT"/>
+              </a:defRPr>
+            </a:pPr>
+            <a:r>
+              <a:t>• Captured and balanced custom 6,000-sample dataset directly through onboard camera.</a:t>
+            </a:r>
+          </a:p>
+          <a:p>
+            <a:pPr algn="l">
+              <a:lnSpc>
+                <a:spcPct val="114000"/>
+              </a:lnSpc>
+              <a:spcBef>
+                <a:spcPts val="0"/>
+              </a:spcBef>
+              <a:spcAft>
+                <a:spcPts val="300"/>
+              </a:spcAft>
+              <a:defRPr sz="1000" b="0" i="0">
+                <a:solidFill>
+                  <a:srgbClr val="1E293B"/>
+                </a:solidFill>
+                <a:latin typeface="Calisto MT"/>
+              </a:defRPr>
+            </a:pPr>
+            <a:r>
+              <a:t>• Mapped 6 operational gesture classes: STOP, GO, FOLLOW, LEFT, RIGHT, BACK.</a:t>
+            </a:r>
+          </a:p>
+          <a:p>
+            <a:pPr algn="l">
+              <a:lnSpc>
+                <a:spcPct val="114000"/>
+              </a:lnSpc>
+              <a:spcBef>
+                <a:spcPts val="0"/>
+              </a:spcBef>
+              <a:spcAft>
+                <a:spcPts val="0"/>
+              </a:spcAft>
+              <a:defRPr sz="1000" b="0" i="0">
+                <a:solidFill>
+                  <a:srgbClr val="1E293B"/>
+                </a:solidFill>
+                <a:latin typeface="Calisto MT"/>
+              </a:defRPr>
+            </a:pPr>
+            <a:r>
+              <a:t>• Calibrated across varying distances (1.0m to 2.5m) under natural indoor lighting.</a:t>
+            </a:r>
+          </a:p>
+        </p:txBody>
+      </p:sp>
+      <p:sp>
+        <p:nvSpPr>
+          <p:cNvPr id="7" name="Meth_P3"/>
+          <p:cNvSpPr txBox="1"/>
+          <p:nvPr/>
+        </p:nvSpPr>
+        <p:spPr>
+          <a:xfrm>
+            <a:off x="8183879" y="1261872"/>
+            <a:ext cx="3227832" cy="1874519"/>
+          </a:xfrm>
+          <a:prstGeom prst="rect">
+            <a:avLst/>
+          </a:prstGeom>
+          <a:noFill/>
+        </p:spPr>
+        <p:txBody>
+          <a:bodyPr wrap="square" lIns="18288" rIns="18288" tIns="18288" bIns="18288">
+            <a:spAutoFit/>
+          </a:bodyPr>
+          <a:lstStyle/>
+          <a:p>
+            <a:pPr algn="l">
+              <a:lnSpc>
+                <a:spcPct val="110000"/>
+              </a:lnSpc>
+              <a:spcBef>
+                <a:spcPts val="0"/>
+              </a:spcBef>
+              <a:spcAft>
+                <a:spcPts val="100"/>
+              </a:spcAft>
+              <a:defRPr sz="1000" b="1" i="0">
+                <a:solidFill>
+                  <a:srgbClr val="B8860B"/>
+                </a:solidFill>
+                <a:latin typeface="Calisto MT"/>
+              </a:defRPr>
+            </a:pPr>
+            <a:r>
+              <a:t>PHASE 03</a:t>
+            </a:r>
+          </a:p>
+          <a:p>
+            <a:pPr algn="l">
+              <a:lnSpc>
+                <a:spcPct val="112000"/>
+              </a:lnSpc>
+              <a:spcBef>
+                <a:spcPts val="0"/>
+              </a:spcBef>
+              <a:spcAft>
+                <a:spcPts val="400"/>
+              </a:spcAft>
+              <a:defRPr sz="1200" b="1" i="0">
+                <a:solidFill>
+                  <a:srgbClr val="002060"/>
+                </a:solidFill>
+                <a:latin typeface="Calisto MT"/>
+              </a:defRPr>
+            </a:pPr>
+            <a:r>
+              <a:t>Feature Engineering &amp; Edge AI</a:t>
+            </a:r>
+          </a:p>
+          <a:p>
+            <a:pPr algn="l">
+              <a:lnSpc>
+                <a:spcPct val="114000"/>
+              </a:lnSpc>
+              <a:spcBef>
+                <a:spcPts val="0"/>
+              </a:spcBef>
+              <a:spcAft>
+                <a:spcPts val="300"/>
+              </a:spcAft>
+              <a:defRPr sz="1000" b="0" i="0">
+                <a:solidFill>
+                  <a:srgbClr val="1E293B"/>
+                </a:solidFill>
+                <a:latin typeface="Calisto MT"/>
+              </a:defRPr>
+            </a:pPr>
+            <a:r>
+              <a:t>• Extracted 21 MediaPipe hand landmarks and computed 19-D geometric invariant features.</a:t>
+            </a:r>
+          </a:p>
+          <a:p>
+            <a:pPr algn="l">
+              <a:lnSpc>
+                <a:spcPct val="114000"/>
+              </a:lnSpc>
+              <a:spcBef>
+                <a:spcPts val="0"/>
+              </a:spcBef>
+              <a:spcAft>
+                <a:spcPts val="300"/>
+              </a:spcAft>
+              <a:defRPr sz="1000" b="0" i="0">
+                <a:solidFill>
+                  <a:srgbClr val="1E293B"/>
+                </a:solidFill>
+                <a:latin typeface="Calisto MT"/>
+              </a:defRPr>
+            </a:pPr>
+            <a:r>
+              <a:t>• Trained lightweight PyTorch MLP neural classifier (46 KB, sub-2ms CPU inference).</a:t>
+            </a:r>
+          </a:p>
+          <a:p>
+            <a:pPr algn="l">
+              <a:lnSpc>
+                <a:spcPct val="114000"/>
+              </a:lnSpc>
+              <a:spcBef>
+                <a:spcPts val="0"/>
+              </a:spcBef>
+              <a:spcAft>
+                <a:spcPts val="0"/>
+              </a:spcAft>
+              <a:defRPr sz="1000" b="0" i="0">
+                <a:solidFill>
+                  <a:srgbClr val="1E293B"/>
+                </a:solidFill>
+                <a:latin typeface="Calisto MT"/>
+              </a:defRPr>
+            </a:pPr>
+            <a:r>
+              <a:t>• Implemented 10-frame LSTM recurrent network for short-horizon human motion prediction.</a:t>
+            </a:r>
+          </a:p>
+        </p:txBody>
+      </p:sp>
+      <p:sp>
+        <p:nvSpPr>
+          <p:cNvPr id="8" name="Meth_Arrow_R0_0"/>
+          <p:cNvSpPr/>
+          <p:nvPr/>
+        </p:nvSpPr>
+        <p:spPr>
+          <a:xfrm>
+            <a:off x="4096512" y="1298448"/>
+            <a:ext cx="292608" cy="118872"/>
+          </a:xfrm>
+          <a:prstGeom prst="rightArrow">
+            <a:avLst/>
+          </a:prstGeom>
+          <a:solidFill>
+            <a:srgbClr val="B8860B"/>
+          </a:solidFill>
+          <a:ln>
+            <a:solidFill>
+              <a:srgbClr val="B8860B"/>
+            </a:solidFill>
+          </a:ln>
+        </p:spPr>
+        <p:style>
+          <a:lnRef idx="1">
+            <a:schemeClr val="accent1"/>
+          </a:lnRef>
+          <a:fillRef idx="3">
+            <a:schemeClr val="accent1"/>
+          </a:fillRef>
+          <a:effectRef idx="2">
+            <a:schemeClr val="accent1"/>
+          </a:effectRef>
+          <a:fontRef idx="minor">
+            <a:schemeClr val="lt1"/>
+          </a:fontRef>
+        </p:style>
+        <p:txBody>
+          <a:bodyPr rtlCol="0" anchor="ctr"/>
+          <a:lstStyle/>
+          <a:p>
+            <a:pPr algn="ctr"/>
+          </a:p>
+        </p:txBody>
+      </p:sp>
+      <p:sp>
+        <p:nvSpPr>
+          <p:cNvPr id="9" name="Meth_Arrow_R0_1"/>
+          <p:cNvSpPr/>
+          <p:nvPr/>
+        </p:nvSpPr>
+        <p:spPr>
+          <a:xfrm>
+            <a:off x="7799831" y="1298448"/>
+            <a:ext cx="292608" cy="118872"/>
+          </a:xfrm>
+          <a:prstGeom prst="rightArrow">
+            <a:avLst/>
+          </a:prstGeom>
+          <a:solidFill>
+            <a:srgbClr val="B8860B"/>
+          </a:solidFill>
+          <a:ln>
+            <a:solidFill>
+              <a:srgbClr val="B8860B"/>
+            </a:solidFill>
+          </a:ln>
+        </p:spPr>
+        <p:style>
+          <a:lnRef idx="1">
+            <a:schemeClr val="accent1"/>
+          </a:lnRef>
+          <a:fillRef idx="3">
+            <a:schemeClr val="accent1"/>
+          </a:fillRef>
+          <a:effectRef idx="2">
+            <a:schemeClr val="accent1"/>
+          </a:effectRef>
+          <a:fontRef idx="minor">
+            <a:schemeClr val="lt1"/>
+          </a:fontRef>
+        </p:style>
+        <p:txBody>
+          <a:bodyPr rtlCol="0" anchor="ctr"/>
+          <a:lstStyle/>
+          <a:p>
+            <a:pPr algn="ctr"/>
+          </a:p>
+        </p:txBody>
+      </p:sp>
+      <p:sp>
+        <p:nvSpPr>
+          <p:cNvPr id="10" name="Meth_Transition"/>
+          <p:cNvSpPr txBox="1"/>
+          <p:nvPr/>
+        </p:nvSpPr>
+        <p:spPr>
+          <a:xfrm>
+            <a:off x="1371600" y="3200400"/>
+            <a:ext cx="9445752" cy="237744"/>
+          </a:xfrm>
+          <a:prstGeom prst="rect">
+            <a:avLst/>
+          </a:prstGeom>
+          <a:noFill/>
+        </p:spPr>
+        <p:txBody>
+          <a:bodyPr wrap="square" lIns="0" rIns="0" tIns="0" bIns="0">
+            <a:spAutoFit/>
+          </a:bodyPr>
+          <a:lstStyle/>
+          <a:p>
+            <a:pPr algn="ctr">
+              <a:lnSpc>
+                <a:spcPct val="114000"/>
+              </a:lnSpc>
+              <a:spcBef>
+                <a:spcPts val="0"/>
+              </a:spcBef>
+              <a:spcAft>
+                <a:spcPts val="200"/>
+              </a:spcAft>
+              <a:defRPr sz="950" b="1" i="0">
+                <a:solidFill>
+                  <a:srgbClr val="64748B"/>
+                </a:solidFill>
+                <a:latin typeface="Calisto MT"/>
+              </a:defRPr>
+            </a:pPr>
+            <a:r>
+              <a:t>──  SEQUENTIAL PROGRESSION TO SUPERVISORY MIDDLEWARE &amp; NAVIGATION INTEGRATION  ──</a:t>
+            </a:r>
+          </a:p>
+        </p:txBody>
+      </p:sp>
+      <p:sp>
+        <p:nvSpPr>
+          <p:cNvPr id="11" name="Meth_P4"/>
+          <p:cNvSpPr txBox="1"/>
+          <p:nvPr/>
+        </p:nvSpPr>
+        <p:spPr>
+          <a:xfrm>
+            <a:off x="777240" y="3520440"/>
+            <a:ext cx="3227832" cy="1874519"/>
+          </a:xfrm>
+          <a:prstGeom prst="rect">
+            <a:avLst/>
+          </a:prstGeom>
+          <a:noFill/>
+        </p:spPr>
+        <p:txBody>
+          <a:bodyPr wrap="square" lIns="18288" rIns="18288" tIns="18288" bIns="18288">
+            <a:spAutoFit/>
+          </a:bodyPr>
+          <a:lstStyle/>
+          <a:p>
+            <a:pPr algn="l">
+              <a:lnSpc>
+                <a:spcPct val="110000"/>
+              </a:lnSpc>
+              <a:spcBef>
+                <a:spcPts val="0"/>
+              </a:spcBef>
+              <a:spcAft>
+                <a:spcPts val="100"/>
+              </a:spcAft>
+              <a:defRPr sz="1000" b="1" i="0">
+                <a:solidFill>
+                  <a:srgbClr val="B8860B"/>
+                </a:solidFill>
+                <a:latin typeface="Calisto MT"/>
+              </a:defRPr>
+            </a:pPr>
+            <a:r>
+              <a:t>PHASE 04</a:t>
+            </a:r>
+          </a:p>
+          <a:p>
+            <a:pPr algn="l">
+              <a:lnSpc>
+                <a:spcPct val="112000"/>
+              </a:lnSpc>
+              <a:spcBef>
+                <a:spcPts val="0"/>
+              </a:spcBef>
+              <a:spcAft>
+                <a:spcPts val="400"/>
+              </a:spcAft>
+              <a:defRPr sz="1200" b="1" i="0">
+                <a:solidFill>
+                  <a:srgbClr val="002060"/>
+                </a:solidFill>
+                <a:latin typeface="Calisto MT"/>
+              </a:defRPr>
+            </a:pPr>
+            <a:r>
+              <a:t>Supervisory Control &amp; Safety</a:t>
+            </a:r>
+          </a:p>
+          <a:p>
+            <a:pPr algn="l">
+              <a:lnSpc>
+                <a:spcPct val="114000"/>
+              </a:lnSpc>
+              <a:spcBef>
+                <a:spcPts val="0"/>
+              </a:spcBef>
+              <a:spcAft>
+                <a:spcPts val="300"/>
+              </a:spcAft>
+              <a:defRPr sz="1000" b="0" i="0">
+                <a:solidFill>
+                  <a:srgbClr val="1E293B"/>
+                </a:solidFill>
+                <a:latin typeface="Calisto MT"/>
+              </a:defRPr>
+            </a:pPr>
+            <a:r>
+              <a:t>• Established centralized ROS 2 Humble node graph on dedicated communication Domain 20.</a:t>
+            </a:r>
+          </a:p>
+          <a:p>
+            <a:pPr algn="l">
+              <a:lnSpc>
+                <a:spcPct val="114000"/>
+              </a:lnSpc>
+              <a:spcBef>
+                <a:spcPts val="0"/>
+              </a:spcBef>
+              <a:spcAft>
+                <a:spcPts val="300"/>
+              </a:spcAft>
+              <a:defRPr sz="1000" b="0" i="0">
+                <a:solidFill>
+                  <a:srgbClr val="1E293B"/>
+                </a:solidFill>
+                <a:latin typeface="Calisto MT"/>
+              </a:defRPr>
+            </a:pPr>
+            <a:r>
+              <a:t>• Engineered brain_node state machine with 5-frame rolling consensus and visual servoing.</a:t>
+            </a:r>
+          </a:p>
+          <a:p>
+            <a:pPr algn="l">
+              <a:lnSpc>
+                <a:spcPct val="114000"/>
+              </a:lnSpc>
+              <a:spcBef>
+                <a:spcPts val="0"/>
+              </a:spcBef>
+              <a:spcAft>
+                <a:spcPts val="0"/>
+              </a:spcAft>
+              <a:defRPr sz="1000" b="0" i="0">
+                <a:solidFill>
+                  <a:srgbClr val="1E293B"/>
+                </a:solidFill>
+                <a:latin typeface="Calisto MT"/>
+              </a:defRPr>
+            </a:pPr>
+            <a:r>
+              <a:t>• Enforced priority velocity multiplexing (twist_mux) with 0.36m reactive laser safety stop.</a:t>
+            </a:r>
+          </a:p>
+        </p:txBody>
+      </p:sp>
+      <p:sp>
+        <p:nvSpPr>
+          <p:cNvPr id="12" name="Meth_P5"/>
+          <p:cNvSpPr txBox="1"/>
+          <p:nvPr/>
+        </p:nvSpPr>
+        <p:spPr>
+          <a:xfrm>
+            <a:off x="4480560" y="3520440"/>
+            <a:ext cx="3227832" cy="1874519"/>
+          </a:xfrm>
+          <a:prstGeom prst="rect">
+            <a:avLst/>
+          </a:prstGeom>
+          <a:noFill/>
+        </p:spPr>
+        <p:txBody>
+          <a:bodyPr wrap="square" lIns="18288" rIns="18288" tIns="18288" bIns="18288">
+            <a:spAutoFit/>
+          </a:bodyPr>
+          <a:lstStyle/>
+          <a:p>
+            <a:pPr algn="l">
+              <a:lnSpc>
+                <a:spcPct val="110000"/>
+              </a:lnSpc>
+              <a:spcBef>
+                <a:spcPts val="0"/>
+              </a:spcBef>
+              <a:spcAft>
+                <a:spcPts val="100"/>
+              </a:spcAft>
+              <a:defRPr sz="1000" b="1" i="0">
+                <a:solidFill>
+                  <a:srgbClr val="B8860B"/>
+                </a:solidFill>
+                <a:latin typeface="Calisto MT"/>
+              </a:defRPr>
+            </a:pPr>
+            <a:r>
+              <a:t>PHASE 05</a:t>
+            </a:r>
+          </a:p>
+          <a:p>
+            <a:pPr algn="l">
+              <a:lnSpc>
+                <a:spcPct val="112000"/>
+              </a:lnSpc>
+              <a:spcBef>
+                <a:spcPts val="0"/>
+              </a:spcBef>
+              <a:spcAft>
+                <a:spcPts val="400"/>
+              </a:spcAft>
+              <a:defRPr sz="1200" b="1" i="0">
+                <a:solidFill>
+                  <a:srgbClr val="002060"/>
+                </a:solidFill>
+                <a:latin typeface="Calisto MT"/>
+              </a:defRPr>
+            </a:pPr>
+            <a:r>
+              <a:t>Metric SLAM &amp; Autonomous Navigation</a:t>
+            </a:r>
+          </a:p>
+          <a:p>
+            <a:pPr algn="l">
+              <a:lnSpc>
+                <a:spcPct val="114000"/>
+              </a:lnSpc>
+              <a:spcBef>
+                <a:spcPts val="0"/>
+              </a:spcBef>
+              <a:spcAft>
+                <a:spcPts val="300"/>
+              </a:spcAft>
+              <a:defRPr sz="1000" b="0" i="0">
+                <a:solidFill>
+                  <a:srgbClr val="1E293B"/>
+                </a:solidFill>
+                <a:latin typeface="Calisto MT"/>
+              </a:defRPr>
+            </a:pPr>
+            <a:r>
+              <a:t>• Generated high-fidelity 2D occupancy grid maps (5cm resolution) via slam_toolbox.</a:t>
+            </a:r>
+          </a:p>
+          <a:p>
+            <a:pPr algn="l">
+              <a:lnSpc>
+                <a:spcPct val="114000"/>
+              </a:lnSpc>
+              <a:spcBef>
+                <a:spcPts val="0"/>
+              </a:spcBef>
+              <a:spcAft>
+                <a:spcPts val="300"/>
+              </a:spcAft>
+              <a:defRPr sz="1000" b="0" i="0">
+                <a:solidFill>
+                  <a:srgbClr val="1E293B"/>
+                </a:solidFill>
+                <a:latin typeface="Calisto MT"/>
+              </a:defRPr>
+            </a:pPr>
+            <a:r>
+              <a:t>• Fused wheel odometry and 6-axis IMU through Extended Kalman Filter (EKF) localization.</a:t>
+            </a:r>
+          </a:p>
+          <a:p>
+            <a:pPr algn="l">
+              <a:lnSpc>
+                <a:spcPct val="114000"/>
+              </a:lnSpc>
+              <a:spcBef>
+                <a:spcPts val="0"/>
+              </a:spcBef>
+              <a:spcAft>
+                <a:spcPts val="0"/>
+              </a:spcAft>
+              <a:defRPr sz="1000" b="0" i="0">
+                <a:solidFill>
+                  <a:srgbClr val="1E293B"/>
+                </a:solidFill>
+                <a:latin typeface="Calisto MT"/>
+              </a:defRPr>
+            </a:pPr>
+            <a:r>
+              <a:t>• Configured Nav2 global and local costmaps with 0.25m obstacle inflation padding.</a:t>
+            </a:r>
+          </a:p>
+        </p:txBody>
+      </p:sp>
+      <p:sp>
+        <p:nvSpPr>
+          <p:cNvPr id="13" name="Meth_P6"/>
+          <p:cNvSpPr txBox="1"/>
+          <p:nvPr/>
+        </p:nvSpPr>
+        <p:spPr>
+          <a:xfrm>
+            <a:off x="8183879" y="3520440"/>
+            <a:ext cx="3227832" cy="1874519"/>
+          </a:xfrm>
+          <a:prstGeom prst="rect">
+            <a:avLst/>
+          </a:prstGeom>
+          <a:noFill/>
+        </p:spPr>
+        <p:txBody>
+          <a:bodyPr wrap="square" lIns="18288" rIns="18288" tIns="18288" bIns="18288">
+            <a:spAutoFit/>
+          </a:bodyPr>
+          <a:lstStyle/>
+          <a:p>
+            <a:pPr algn="l">
+              <a:lnSpc>
+                <a:spcPct val="110000"/>
+              </a:lnSpc>
+              <a:spcBef>
+                <a:spcPts val="0"/>
+              </a:spcBef>
+              <a:spcAft>
+                <a:spcPts val="100"/>
+              </a:spcAft>
+              <a:defRPr sz="1000" b="1" i="0">
+                <a:solidFill>
+                  <a:srgbClr val="B8860B"/>
+                </a:solidFill>
+                <a:latin typeface="Calisto MT"/>
+              </a:defRPr>
+            </a:pPr>
+            <a:r>
+              <a:t>PHASE 06</a:t>
+            </a:r>
+          </a:p>
+          <a:p>
+            <a:pPr algn="l">
+              <a:lnSpc>
+                <a:spcPct val="112000"/>
+              </a:lnSpc>
+              <a:spcBef>
+                <a:spcPts val="0"/>
+              </a:spcBef>
+              <a:spcAft>
+                <a:spcPts val="400"/>
+              </a:spcAft>
+              <a:defRPr sz="1200" b="1" i="0">
+                <a:solidFill>
+                  <a:srgbClr val="002060"/>
+                </a:solidFill>
+                <a:latin typeface="Calisto MT"/>
+              </a:defRPr>
+            </a:pPr>
+            <a:r>
+              <a:t>Empirical Benchmarking &amp; Validation</a:t>
+            </a:r>
+          </a:p>
+          <a:p>
+            <a:pPr algn="l">
+              <a:lnSpc>
+                <a:spcPct val="114000"/>
+              </a:lnSpc>
+              <a:spcBef>
+                <a:spcPts val="0"/>
+              </a:spcBef>
+              <a:spcAft>
+                <a:spcPts val="300"/>
+              </a:spcAft>
+              <a:defRPr sz="1000" b="0" i="0">
+                <a:solidFill>
+                  <a:srgbClr val="1E293B"/>
+                </a:solidFill>
+                <a:latin typeface="Calisto MT"/>
+              </a:defRPr>
+            </a:pPr>
+            <a:r>
+              <a:t>• Quantified end-to-end component latency budget at 74.2 ms (well under 150 ms threshold).</a:t>
+            </a:r>
+          </a:p>
+          <a:p>
+            <a:pPr algn="l">
+              <a:lnSpc>
+                <a:spcPct val="114000"/>
+              </a:lnSpc>
+              <a:spcBef>
+                <a:spcPts val="0"/>
+              </a:spcBef>
+              <a:spcAft>
+                <a:spcPts val="300"/>
+              </a:spcAft>
+              <a:defRPr sz="1000" b="0" i="0">
+                <a:solidFill>
+                  <a:srgbClr val="1E293B"/>
+                </a:solidFill>
+                <a:latin typeface="Calisto MT"/>
+              </a:defRPr>
+            </a:pPr>
+            <a:r>
+              <a:t>• Validated closed-loop control across 180 physical trials (96.67% real-world accuracy).</a:t>
+            </a:r>
+          </a:p>
+          <a:p>
+            <a:pPr algn="l">
+              <a:lnSpc>
+                <a:spcPct val="114000"/>
+              </a:lnSpc>
+              <a:spcBef>
+                <a:spcPts val="0"/>
+              </a:spcBef>
+              <a:spcAft>
+                <a:spcPts val="0"/>
+              </a:spcAft>
+              <a:defRPr sz="1000" b="0" i="0">
+                <a:solidFill>
+                  <a:srgbClr val="1E293B"/>
+                </a:solidFill>
+                <a:latin typeface="Calisto MT"/>
+              </a:defRPr>
+            </a:pPr>
+            <a:r>
+              <a:t>• Verified collaborative safety compliance under ISO 15066 (&lt;0.36m deterministic halt).</a:t>
+            </a:r>
+          </a:p>
+        </p:txBody>
+      </p:sp>
+      <p:sp>
+        <p:nvSpPr>
+          <p:cNvPr id="14" name="Meth_Arrow_R1_0"/>
+          <p:cNvSpPr/>
+          <p:nvPr/>
+        </p:nvSpPr>
+        <p:spPr>
+          <a:xfrm>
+            <a:off x="4096512" y="3557016"/>
+            <a:ext cx="292608" cy="118872"/>
+          </a:xfrm>
+          <a:prstGeom prst="rightArrow">
+            <a:avLst/>
+          </a:prstGeom>
+          <a:solidFill>
+            <a:srgbClr val="B8860B"/>
+          </a:solidFill>
+          <a:ln>
+            <a:solidFill>
+              <a:srgbClr val="B8860B"/>
+            </a:solidFill>
+          </a:ln>
+        </p:spPr>
+        <p:style>
+          <a:lnRef idx="1">
+            <a:schemeClr val="accent1"/>
+          </a:lnRef>
+          <a:fillRef idx="3">
+            <a:schemeClr val="accent1"/>
+          </a:fillRef>
+          <a:effectRef idx="2">
+            <a:schemeClr val="accent1"/>
+          </a:effectRef>
+          <a:fontRef idx="minor">
+            <a:schemeClr val="lt1"/>
+          </a:fontRef>
+        </p:style>
+        <p:txBody>
+          <a:bodyPr rtlCol="0" anchor="ctr"/>
+          <a:lstStyle/>
+          <a:p>
+            <a:pPr algn="ctr"/>
+          </a:p>
+        </p:txBody>
+      </p:sp>
+      <p:sp>
+        <p:nvSpPr>
+          <p:cNvPr id="15" name="Meth_Arrow_R1_1"/>
+          <p:cNvSpPr/>
+          <p:nvPr/>
+        </p:nvSpPr>
+        <p:spPr>
+          <a:xfrm>
+            <a:off x="7799831" y="3557016"/>
+            <a:ext cx="292608" cy="118872"/>
+          </a:xfrm>
+          <a:prstGeom prst="rightArrow">
+            <a:avLst/>
+          </a:prstGeom>
+          <a:solidFill>
+            <a:srgbClr val="B8860B"/>
+          </a:solidFill>
+          <a:ln>
+            <a:solidFill>
+              <a:srgbClr val="B8860B"/>
+            </a:solidFill>
+          </a:ln>
+        </p:spPr>
+        <p:style>
+          <a:lnRef idx="1">
+            <a:schemeClr val="accent1"/>
+          </a:lnRef>
+          <a:fillRef idx="3">
+            <a:schemeClr val="accent1"/>
+          </a:fillRef>
+          <a:effectRef idx="2">
+            <a:schemeClr val="accent1"/>
+          </a:effectRef>
+          <a:fontRef idx="minor">
+            <a:schemeClr val="lt1"/>
+          </a:fontRef>
+        </p:style>
+        <p:txBody>
+          <a:bodyPr rtlCol="0" anchor="ctr"/>
+          <a:lstStyle/>
+          <a:p>
+            <a:pPr algn="ctr"/>
           </a:p>
         </p:txBody>
       </p:sp>

</xml_diff>

<commit_message>
fix(slides): eliminate arrows, introduce uniform 3-field bold tags, and optimize clarity on Slide 7
</commit_message>
<xml_diff>
--- a/write_up/Project Final Defense Slides_FINAL.pptx
+++ b/write_up/Project Final Defense Slides_FINAL.pptx
@@ -4435,7 +4435,7 @@
               </a:defRPr>
             </a:pPr>
             <a:r>
-              <a:t>STRUCTURED RESEARCH &amp; IMPLEMENTATION LIFECYCLE FROM DESIGN TO VALIDATION</a:t>
+              <a:t>STRUCTURED RESEARCH &amp; IMPLEMENTATION LIFECYCLE FROM EMBEDDED DESIGN TO VALIDATION</a:t>
             </a:r>
           </a:p>
         </p:txBody>
@@ -4449,7 +4449,7 @@
         <p:spPr>
           <a:xfrm>
             <a:off x="777240" y="1261872"/>
-            <a:ext cx="3227832" cy="1874519"/>
+            <a:ext cx="3319272" cy="1874519"/>
           </a:xfrm>
           <a:prstGeom prst="rect">
             <a:avLst/>
@@ -4492,7 +4492,7 @@
                 <a:spcPts val="0"/>
               </a:spcBef>
               <a:spcAft>
-                <a:spcPts val="400"/>
+                <a:spcPts val="500"/>
               </a:spcAft>
               <a:defRPr sz="1200" b="1" i="0">
                 <a:solidFill>
@@ -4510,21 +4510,27 @@
               <a:lnSpc>
                 <a:spcPct val="114000"/>
               </a:lnSpc>
-              <a:spcBef>
-                <a:spcPts val="0"/>
-              </a:spcBef>
               <a:spcAft>
                 <a:spcPts val="300"/>
               </a:spcAft>
-              <a:defRPr sz="1000" b="0" i="0">
-                <a:solidFill>
-                  <a:srgbClr val="1E293B"/>
-                </a:solidFill>
-                <a:latin typeface="Calisto MT"/>
-              </a:defRPr>
-            </a:pPr>
-            <a:r>
-              <a:t>• Built Yahboom 4WD mobile chassis with DC encoder motors and 2-DOF camera gimbal.</a:t>
+            </a:pPr>
+            <a:r>
+              <a:rPr sz="1000" b="1">
+                <a:solidFill>
+                  <a:srgbClr val="002060"/>
+                </a:solidFill>
+                <a:latin typeface="Calisto MT"/>
+              </a:rPr>
+              <a:t>• Robot Chassis: </a:t>
+            </a:r>
+            <a:r>
+              <a:rPr sz="1000" b="0">
+                <a:solidFill>
+                  <a:srgbClr val="334155"/>
+                </a:solidFill>
+                <a:latin typeface="Calisto MT"/>
+              </a:rPr>
+              <a:t>Yahboom 4WD mobile base with DC encoder motors and 2-DOF camera gimbal.</a:t>
             </a:r>
           </a:p>
           <a:p>
@@ -4532,21 +4538,27 @@
               <a:lnSpc>
                 <a:spcPct val="114000"/>
               </a:lnSpc>
-              <a:spcBef>
-                <a:spcPts val="0"/>
-              </a:spcBef>
               <a:spcAft>
                 <a:spcPts val="300"/>
               </a:spcAft>
-              <a:defRPr sz="1000" b="0" i="0">
-                <a:solidFill>
-                  <a:srgbClr val="1E293B"/>
-                </a:solidFill>
-                <a:latin typeface="Calisto MT"/>
-              </a:defRPr>
-            </a:pPr>
-            <a:r>
-              <a:t>• Integrated Raspberry Pi 5 (8GB) edge compute node and ESP32-S3 micro-ROS co-processor.</a:t>
+            </a:pPr>
+            <a:r>
+              <a:rPr sz="1000" b="1">
+                <a:solidFill>
+                  <a:srgbClr val="002060"/>
+                </a:solidFill>
+                <a:latin typeface="Calisto MT"/>
+              </a:rPr>
+              <a:t>• Edge Compute: </a:t>
+            </a:r>
+            <a:r>
+              <a:rPr sz="1000" b="0">
+                <a:solidFill>
+                  <a:srgbClr val="334155"/>
+                </a:solidFill>
+                <a:latin typeface="Calisto MT"/>
+              </a:rPr>
+              <a:t>Raspberry Pi 5 (8GB) paired with an ESP32-S3 real-time micro-ROS co-processor.</a:t>
             </a:r>
           </a:p>
           <a:p>
@@ -4554,21 +4566,27 @@
               <a:lnSpc>
                 <a:spcPct val="114000"/>
               </a:lnSpc>
-              <a:spcBef>
-                <a:spcPts val="0"/>
-              </a:spcBef>
-              <a:spcAft>
-                <a:spcPts val="0"/>
-              </a:spcAft>
-              <a:defRPr sz="1000" b="0" i="0">
-                <a:solidFill>
-                  <a:srgbClr val="1E293B"/>
-                </a:solidFill>
-                <a:latin typeface="Calisto MT"/>
-              </a:defRPr>
-            </a:pPr>
-            <a:r>
-              <a:t>• Implemented decoupled dual-bus power regulation (7.4V Li-ion) isolating logic from motor spikes.</a:t>
+              <a:spcAft>
+                <a:spcPts val="0"/>
+              </a:spcAft>
+            </a:pPr>
+            <a:r>
+              <a:rPr sz="1000" b="1">
+                <a:solidFill>
+                  <a:srgbClr val="002060"/>
+                </a:solidFill>
+                <a:latin typeface="Calisto MT"/>
+              </a:rPr>
+              <a:t>• Power Isolation: </a:t>
+            </a:r>
+            <a:r>
+              <a:rPr sz="1000" b="0">
+                <a:solidFill>
+                  <a:srgbClr val="334155"/>
+                </a:solidFill>
+                <a:latin typeface="Calisto MT"/>
+              </a:rPr>
+              <a:t>Decoupled dual battery circuits protecting computer logic from motor electrical spikes.</a:t>
             </a:r>
           </a:p>
         </p:txBody>
@@ -4581,8 +4599,8 @@
         </p:nvSpPr>
         <p:spPr>
           <a:xfrm>
-            <a:off x="4480560" y="1261872"/>
-            <a:ext cx="3227832" cy="1874519"/>
+            <a:off x="4434840" y="1261872"/>
+            <a:ext cx="3319272" cy="1874519"/>
           </a:xfrm>
           <a:prstGeom prst="rect">
             <a:avLst/>
@@ -4625,7 +4643,7 @@
                 <a:spcPts val="0"/>
               </a:spcBef>
               <a:spcAft>
-                <a:spcPts val="400"/>
+                <a:spcPts val="500"/>
               </a:spcAft>
               <a:defRPr sz="1200" b="1" i="0">
                 <a:solidFill>
@@ -4643,21 +4661,27 @@
               <a:lnSpc>
                 <a:spcPct val="114000"/>
               </a:lnSpc>
-              <a:spcBef>
-                <a:spcPts val="0"/>
-              </a:spcBef>
               <a:spcAft>
                 <a:spcPts val="300"/>
               </a:spcAft>
-              <a:defRPr sz="1000" b="0" i="0">
-                <a:solidFill>
-                  <a:srgbClr val="1E293B"/>
-                </a:solidFill>
-                <a:latin typeface="Calisto MT"/>
-              </a:defRPr>
-            </a:pPr>
-            <a:r>
-              <a:t>• Captured and balanced custom 6,000-sample dataset directly through onboard camera.</a:t>
+            </a:pPr>
+            <a:r>
+              <a:rPr sz="1000" b="1">
+                <a:solidFill>
+                  <a:srgbClr val="002060"/>
+                </a:solidFill>
+                <a:latin typeface="Calisto MT"/>
+              </a:rPr>
+              <a:t>• Dataset Size: </a:t>
+            </a:r>
+            <a:r>
+              <a:rPr sz="1000" b="0">
+                <a:solidFill>
+                  <a:srgbClr val="334155"/>
+                </a:solidFill>
+                <a:latin typeface="Calisto MT"/>
+              </a:rPr>
+              <a:t>6,000 balanced gesture samples (1,000 per class) captured directly onboard.</a:t>
             </a:r>
           </a:p>
           <a:p>
@@ -4665,21 +4689,27 @@
               <a:lnSpc>
                 <a:spcPct val="114000"/>
               </a:lnSpc>
-              <a:spcBef>
-                <a:spcPts val="0"/>
-              </a:spcBef>
               <a:spcAft>
                 <a:spcPts val="300"/>
               </a:spcAft>
-              <a:defRPr sz="1000" b="0" i="0">
-                <a:solidFill>
-                  <a:srgbClr val="1E293B"/>
-                </a:solidFill>
-                <a:latin typeface="Calisto MT"/>
-              </a:defRPr>
-            </a:pPr>
-            <a:r>
-              <a:t>• Mapped 6 operational gesture classes: STOP, GO, FOLLOW, LEFT, RIGHT, BACK.</a:t>
+            </a:pPr>
+            <a:r>
+              <a:rPr sz="1000" b="1">
+                <a:solidFill>
+                  <a:srgbClr val="002060"/>
+                </a:solidFill>
+                <a:latin typeface="Calisto MT"/>
+              </a:rPr>
+              <a:t>• Gesture Classes: </a:t>
+            </a:r>
+            <a:r>
+              <a:rPr sz="1000" b="0">
+                <a:solidFill>
+                  <a:srgbClr val="334155"/>
+                </a:solidFill>
+                <a:latin typeface="Calisto MT"/>
+              </a:rPr>
+              <a:t>6 operational commands: STOP, GO, FOLLOW, LEFT, RIGHT, and BACK.</a:t>
             </a:r>
           </a:p>
           <a:p>
@@ -4687,21 +4717,27 @@
               <a:lnSpc>
                 <a:spcPct val="114000"/>
               </a:lnSpc>
-              <a:spcBef>
-                <a:spcPts val="0"/>
-              </a:spcBef>
-              <a:spcAft>
-                <a:spcPts val="0"/>
-              </a:spcAft>
-              <a:defRPr sz="1000" b="0" i="0">
-                <a:solidFill>
-                  <a:srgbClr val="1E293B"/>
-                </a:solidFill>
-                <a:latin typeface="Calisto MT"/>
-              </a:defRPr>
-            </a:pPr>
-            <a:r>
-              <a:t>• Calibrated across varying distances (1.0m to 2.5m) under natural indoor lighting.</a:t>
+              <a:spcAft>
+                <a:spcPts val="0"/>
+              </a:spcAft>
+            </a:pPr>
+            <a:r>
+              <a:rPr sz="1000" b="1">
+                <a:solidFill>
+                  <a:srgbClr val="002060"/>
+                </a:solidFill>
+                <a:latin typeface="Calisto MT"/>
+              </a:rPr>
+              <a:t>• Testing Range: </a:t>
+            </a:r>
+            <a:r>
+              <a:rPr sz="1000" b="0">
+                <a:solidFill>
+                  <a:srgbClr val="334155"/>
+                </a:solidFill>
+                <a:latin typeface="Calisto MT"/>
+              </a:rPr>
+              <a:t>Recorded across 1.0 m to 2.5 m under natural, unconstrained indoor lighting.</a:t>
             </a:r>
           </a:p>
         </p:txBody>
@@ -4714,8 +4750,8 @@
         </p:nvSpPr>
         <p:spPr>
           <a:xfrm>
-            <a:off x="8183879" y="1261872"/>
-            <a:ext cx="3227832" cy="1874519"/>
+            <a:off x="8092440" y="1261872"/>
+            <a:ext cx="3319272" cy="1874519"/>
           </a:xfrm>
           <a:prstGeom prst="rect">
             <a:avLst/>
@@ -4758,7 +4794,7 @@
                 <a:spcPts val="0"/>
               </a:spcBef>
               <a:spcAft>
-                <a:spcPts val="400"/>
+                <a:spcPts val="500"/>
               </a:spcAft>
               <a:defRPr sz="1200" b="1" i="0">
                 <a:solidFill>
@@ -4776,21 +4812,27 @@
               <a:lnSpc>
                 <a:spcPct val="114000"/>
               </a:lnSpc>
-              <a:spcBef>
-                <a:spcPts val="0"/>
-              </a:spcBef>
               <a:spcAft>
                 <a:spcPts val="300"/>
               </a:spcAft>
-              <a:defRPr sz="1000" b="0" i="0">
-                <a:solidFill>
-                  <a:srgbClr val="1E293B"/>
-                </a:solidFill>
-                <a:latin typeface="Calisto MT"/>
-              </a:defRPr>
-            </a:pPr>
-            <a:r>
-              <a:t>• Extracted 21 MediaPipe hand landmarks and computed 19-D geometric invariant features.</a:t>
+            </a:pPr>
+            <a:r>
+              <a:rPr sz="1000" b="1">
+                <a:solidFill>
+                  <a:srgbClr val="002060"/>
+                </a:solidFill>
+                <a:latin typeface="Calisto MT"/>
+              </a:rPr>
+              <a:t>• Geometric Features: </a:t>
+            </a:r>
+            <a:r>
+              <a:rPr sz="1000" b="0">
+                <a:solidFill>
+                  <a:srgbClr val="334155"/>
+                </a:solidFill>
+                <a:latin typeface="Calisto MT"/>
+              </a:rPr>
+              <a:t>21 hand landmarks converted into 19 scale- and distance-invariant features.</a:t>
             </a:r>
           </a:p>
           <a:p>
@@ -4798,21 +4840,27 @@
               <a:lnSpc>
                 <a:spcPct val="114000"/>
               </a:lnSpc>
-              <a:spcBef>
-                <a:spcPts val="0"/>
-              </a:spcBef>
               <a:spcAft>
                 <a:spcPts val="300"/>
               </a:spcAft>
-              <a:defRPr sz="1000" b="0" i="0">
-                <a:solidFill>
-                  <a:srgbClr val="1E293B"/>
-                </a:solidFill>
-                <a:latin typeface="Calisto MT"/>
-              </a:defRPr>
-            </a:pPr>
-            <a:r>
-              <a:t>• Trained lightweight PyTorch MLP neural classifier (46 KB, sub-2ms CPU inference).</a:t>
+            </a:pPr>
+            <a:r>
+              <a:rPr sz="1000" b="1">
+                <a:solidFill>
+                  <a:srgbClr val="002060"/>
+                </a:solidFill>
+                <a:latin typeface="Calisto MT"/>
+              </a:rPr>
+              <a:t>• Neural Classifier: </a:t>
+            </a:r>
+            <a:r>
+              <a:rPr sz="1000" b="0">
+                <a:solidFill>
+                  <a:srgbClr val="334155"/>
+                </a:solidFill>
+                <a:latin typeface="Calisto MT"/>
+              </a:rPr>
+              <a:t>Lightweight MLP model (46 KB) running in under 2 ms on the Raspberry Pi CPU.</a:t>
             </a:r>
           </a:p>
           <a:p>
@@ -4820,124 +4868,40 @@
               <a:lnSpc>
                 <a:spcPct val="114000"/>
               </a:lnSpc>
-              <a:spcBef>
-                <a:spcPts val="0"/>
-              </a:spcBef>
-              <a:spcAft>
-                <a:spcPts val="0"/>
-              </a:spcAft>
-              <a:defRPr sz="1000" b="0" i="0">
-                <a:solidFill>
-                  <a:srgbClr val="1E293B"/>
-                </a:solidFill>
-                <a:latin typeface="Calisto MT"/>
-              </a:defRPr>
-            </a:pPr>
-            <a:r>
-              <a:t>• Implemented 10-frame LSTM recurrent network for short-horizon human motion prediction.</a:t>
-            </a:r>
-          </a:p>
-        </p:txBody>
-      </p:sp>
-      <p:sp>
-        <p:nvSpPr>
-          <p:cNvPr id="8" name="Meth_Arrow_R0_0"/>
-          <p:cNvSpPr/>
-          <p:nvPr/>
-        </p:nvSpPr>
-        <p:spPr>
-          <a:xfrm>
-            <a:off x="4096512" y="1298448"/>
-            <a:ext cx="292608" cy="118872"/>
-          </a:xfrm>
-          <a:prstGeom prst="rightArrow">
-            <a:avLst/>
-          </a:prstGeom>
-          <a:solidFill>
-            <a:srgbClr val="B8860B"/>
-          </a:solidFill>
-          <a:ln>
-            <a:solidFill>
-              <a:srgbClr val="B8860B"/>
-            </a:solidFill>
-          </a:ln>
-        </p:spPr>
-        <p:style>
-          <a:lnRef idx="1">
-            <a:schemeClr val="accent1"/>
-          </a:lnRef>
-          <a:fillRef idx="3">
-            <a:schemeClr val="accent1"/>
-          </a:fillRef>
-          <a:effectRef idx="2">
-            <a:schemeClr val="accent1"/>
-          </a:effectRef>
-          <a:fontRef idx="minor">
-            <a:schemeClr val="lt1"/>
-          </a:fontRef>
-        </p:style>
-        <p:txBody>
-          <a:bodyPr rtlCol="0" anchor="ctr"/>
-          <a:lstStyle/>
-          <a:p>
-            <a:pPr algn="ctr"/>
-          </a:p>
-        </p:txBody>
-      </p:sp>
-      <p:sp>
-        <p:nvSpPr>
-          <p:cNvPr id="9" name="Meth_Arrow_R0_1"/>
-          <p:cNvSpPr/>
-          <p:nvPr/>
-        </p:nvSpPr>
-        <p:spPr>
-          <a:xfrm>
-            <a:off x="7799831" y="1298448"/>
-            <a:ext cx="292608" cy="118872"/>
-          </a:xfrm>
-          <a:prstGeom prst="rightArrow">
-            <a:avLst/>
-          </a:prstGeom>
-          <a:solidFill>
-            <a:srgbClr val="B8860B"/>
-          </a:solidFill>
-          <a:ln>
-            <a:solidFill>
-              <a:srgbClr val="B8860B"/>
-            </a:solidFill>
-          </a:ln>
-        </p:spPr>
-        <p:style>
-          <a:lnRef idx="1">
-            <a:schemeClr val="accent1"/>
-          </a:lnRef>
-          <a:fillRef idx="3">
-            <a:schemeClr val="accent1"/>
-          </a:fillRef>
-          <a:effectRef idx="2">
-            <a:schemeClr val="accent1"/>
-          </a:effectRef>
-          <a:fontRef idx="minor">
-            <a:schemeClr val="lt1"/>
-          </a:fontRef>
-        </p:style>
-        <p:txBody>
-          <a:bodyPr rtlCol="0" anchor="ctr"/>
-          <a:lstStyle/>
-          <a:p>
-            <a:pPr algn="ctr"/>
-          </a:p>
-        </p:txBody>
-      </p:sp>
-      <p:sp>
-        <p:nvSpPr>
-          <p:cNvPr id="10" name="Meth_Transition"/>
+              <a:spcAft>
+                <a:spcPts val="0"/>
+              </a:spcAft>
+            </a:pPr>
+            <a:r>
+              <a:rPr sz="1000" b="1">
+                <a:solidFill>
+                  <a:srgbClr val="002060"/>
+                </a:solidFill>
+                <a:latin typeface="Calisto MT"/>
+              </a:rPr>
+              <a:t>• Motion Predictor: </a:t>
+            </a:r>
+            <a:r>
+              <a:rPr sz="1000" b="0">
+                <a:solidFill>
+                  <a:srgbClr val="334155"/>
+                </a:solidFill>
+                <a:latin typeface="Calisto MT"/>
+              </a:rPr>
+              <a:t>10-frame recurrent LSTM predicting operator movement trajectories.</a:t>
+            </a:r>
+          </a:p>
+        </p:txBody>
+      </p:sp>
+      <p:sp>
+        <p:nvSpPr>
+          <p:cNvPr id="8" name="Meth_Transition"/>
           <p:cNvSpPr txBox="1"/>
           <p:nvPr/>
         </p:nvSpPr>
         <p:spPr>
           <a:xfrm>
-            <a:off x="1371600" y="3200400"/>
+            <a:off x="1371600" y="3218688"/>
             <a:ext cx="9445752" cy="237744"/>
           </a:xfrm>
           <a:prstGeom prst="rect">
@@ -4976,14 +4940,14 @@
       </p:sp>
       <p:sp>
         <p:nvSpPr>
-          <p:cNvPr id="11" name="Meth_P4"/>
+          <p:cNvPr id="9" name="Meth_P4"/>
           <p:cNvSpPr txBox="1"/>
           <p:nvPr/>
         </p:nvSpPr>
         <p:spPr>
           <a:xfrm>
-            <a:off x="777240" y="3520440"/>
-            <a:ext cx="3227832" cy="1874519"/>
+            <a:off x="777240" y="3547872"/>
+            <a:ext cx="3319272" cy="1874519"/>
           </a:xfrm>
           <a:prstGeom prst="rect">
             <a:avLst/>
@@ -5026,7 +4990,7 @@
                 <a:spcPts val="0"/>
               </a:spcBef>
               <a:spcAft>
-                <a:spcPts val="400"/>
+                <a:spcPts val="500"/>
               </a:spcAft>
               <a:defRPr sz="1200" b="1" i="0">
                 <a:solidFill>
@@ -5044,21 +5008,27 @@
               <a:lnSpc>
                 <a:spcPct val="114000"/>
               </a:lnSpc>
-              <a:spcBef>
-                <a:spcPts val="0"/>
-              </a:spcBef>
               <a:spcAft>
                 <a:spcPts val="300"/>
               </a:spcAft>
-              <a:defRPr sz="1000" b="0" i="0">
-                <a:solidFill>
-                  <a:srgbClr val="1E293B"/>
-                </a:solidFill>
-                <a:latin typeface="Calisto MT"/>
-              </a:defRPr>
-            </a:pPr>
-            <a:r>
-              <a:t>• Established centralized ROS 2 Humble node graph on dedicated communication Domain 20.</a:t>
+            </a:pPr>
+            <a:r>
+              <a:rPr sz="1000" b="1">
+                <a:solidFill>
+                  <a:srgbClr val="002060"/>
+                </a:solidFill>
+                <a:latin typeface="Calisto MT"/>
+              </a:rPr>
+              <a:t>• ROS 2 Middleware: </a:t>
+            </a:r>
+            <a:r>
+              <a:rPr sz="1000" b="0">
+                <a:solidFill>
+                  <a:srgbClr val="334155"/>
+                </a:solidFill>
+                <a:latin typeface="Calisto MT"/>
+              </a:rPr>
+              <a:t>Unified node architecture operating on dedicated communication Domain 20.</a:t>
             </a:r>
           </a:p>
           <a:p>
@@ -5066,21 +5036,27 @@
               <a:lnSpc>
                 <a:spcPct val="114000"/>
               </a:lnSpc>
-              <a:spcBef>
-                <a:spcPts val="0"/>
-              </a:spcBef>
               <a:spcAft>
                 <a:spcPts val="300"/>
               </a:spcAft>
-              <a:defRPr sz="1000" b="0" i="0">
-                <a:solidFill>
-                  <a:srgbClr val="1E293B"/>
-                </a:solidFill>
-                <a:latin typeface="Calisto MT"/>
-              </a:defRPr>
-            </a:pPr>
-            <a:r>
-              <a:t>• Engineered brain_node state machine with 5-frame rolling consensus and visual servoing.</a:t>
+            </a:pPr>
+            <a:r>
+              <a:rPr sz="1000" b="1">
+                <a:solidFill>
+                  <a:srgbClr val="002060"/>
+                </a:solidFill>
+                <a:latin typeface="Calisto MT"/>
+              </a:rPr>
+              <a:t>• Decision Engine: </a:t>
+            </a:r>
+            <a:r>
+              <a:rPr sz="1000" b="0">
+                <a:solidFill>
+                  <a:srgbClr val="334155"/>
+                </a:solidFill>
+                <a:latin typeface="Calisto MT"/>
+              </a:rPr>
+              <a:t>brain_node state machine with 5-frame rolling consensus and visual servoing.</a:t>
             </a:r>
           </a:p>
           <a:p>
@@ -5088,35 +5064,41 @@
               <a:lnSpc>
                 <a:spcPct val="114000"/>
               </a:lnSpc>
-              <a:spcBef>
-                <a:spcPts val="0"/>
-              </a:spcBef>
-              <a:spcAft>
-                <a:spcPts val="0"/>
-              </a:spcAft>
-              <a:defRPr sz="1000" b="0" i="0">
-                <a:solidFill>
-                  <a:srgbClr val="1E293B"/>
-                </a:solidFill>
-                <a:latin typeface="Calisto MT"/>
-              </a:defRPr>
-            </a:pPr>
-            <a:r>
-              <a:t>• Enforced priority velocity multiplexing (twist_mux) with 0.36m reactive laser safety stop.</a:t>
-            </a:r>
-          </a:p>
-        </p:txBody>
-      </p:sp>
-      <p:sp>
-        <p:nvSpPr>
-          <p:cNvPr id="12" name="Meth_P5"/>
+              <a:spcAft>
+                <a:spcPts val="0"/>
+              </a:spcAft>
+            </a:pPr>
+            <a:r>
+              <a:rPr sz="1000" b="1">
+                <a:solidFill>
+                  <a:srgbClr val="002060"/>
+                </a:solidFill>
+                <a:latin typeface="Calisto MT"/>
+              </a:rPr>
+              <a:t>• Collision Safety: </a:t>
+            </a:r>
+            <a:r>
+              <a:rPr sz="1000" b="0">
+                <a:solidFill>
+                  <a:srgbClr val="334155"/>
+                </a:solidFill>
+                <a:latin typeface="Calisto MT"/>
+              </a:rPr>
+              <a:t>Hard-coded reactive LiDAR safety stop halting the robot at 0.36 m.</a:t>
+            </a:r>
+          </a:p>
+        </p:txBody>
+      </p:sp>
+      <p:sp>
+        <p:nvSpPr>
+          <p:cNvPr id="10" name="Meth_P5"/>
           <p:cNvSpPr txBox="1"/>
           <p:nvPr/>
         </p:nvSpPr>
         <p:spPr>
           <a:xfrm>
-            <a:off x="4480560" y="3520440"/>
-            <a:ext cx="3227832" cy="1874519"/>
+            <a:off x="4434840" y="3547872"/>
+            <a:ext cx="3319272" cy="1874519"/>
           </a:xfrm>
           <a:prstGeom prst="rect">
             <a:avLst/>
@@ -5159,7 +5141,7 @@
                 <a:spcPts val="0"/>
               </a:spcBef>
               <a:spcAft>
-                <a:spcPts val="400"/>
+                <a:spcPts val="500"/>
               </a:spcAft>
               <a:defRPr sz="1200" b="1" i="0">
                 <a:solidFill>
@@ -5177,21 +5159,27 @@
               <a:lnSpc>
                 <a:spcPct val="114000"/>
               </a:lnSpc>
-              <a:spcBef>
-                <a:spcPts val="0"/>
-              </a:spcBef>
               <a:spcAft>
                 <a:spcPts val="300"/>
               </a:spcAft>
-              <a:defRPr sz="1000" b="0" i="0">
-                <a:solidFill>
-                  <a:srgbClr val="1E293B"/>
-                </a:solidFill>
-                <a:latin typeface="Calisto MT"/>
-              </a:defRPr>
-            </a:pPr>
-            <a:r>
-              <a:t>• Generated high-fidelity 2D occupancy grid maps (5cm resolution) via slam_toolbox.</a:t>
+            </a:pPr>
+            <a:r>
+              <a:rPr sz="1000" b="1">
+                <a:solidFill>
+                  <a:srgbClr val="002060"/>
+                </a:solidFill>
+                <a:latin typeface="Calisto MT"/>
+              </a:rPr>
+              <a:t>• Laser Mapping: </a:t>
+            </a:r>
+            <a:r>
+              <a:rPr sz="1000" b="0">
+                <a:solidFill>
+                  <a:srgbClr val="334155"/>
+                </a:solidFill>
+                <a:latin typeface="Calisto MT"/>
+              </a:rPr>
+              <a:t>2D occupancy grid maps generated at 5 cm resolution using slam_toolbox.</a:t>
             </a:r>
           </a:p>
           <a:p>
@@ -5199,21 +5187,27 @@
               <a:lnSpc>
                 <a:spcPct val="114000"/>
               </a:lnSpc>
-              <a:spcBef>
-                <a:spcPts val="0"/>
-              </a:spcBef>
               <a:spcAft>
                 <a:spcPts val="300"/>
               </a:spcAft>
-              <a:defRPr sz="1000" b="0" i="0">
-                <a:solidFill>
-                  <a:srgbClr val="1E293B"/>
-                </a:solidFill>
-                <a:latin typeface="Calisto MT"/>
-              </a:defRPr>
-            </a:pPr>
-            <a:r>
-              <a:t>• Fused wheel odometry and 6-axis IMU through Extended Kalman Filter (EKF) localization.</a:t>
+            </a:pPr>
+            <a:r>
+              <a:rPr sz="1000" b="1">
+                <a:solidFill>
+                  <a:srgbClr val="002060"/>
+                </a:solidFill>
+                <a:latin typeface="Calisto MT"/>
+              </a:rPr>
+              <a:t>• Sensor Fusion: </a:t>
+            </a:r>
+            <a:r>
+              <a:rPr sz="1000" b="0">
+                <a:solidFill>
+                  <a:srgbClr val="334155"/>
+                </a:solidFill>
+                <a:latin typeface="Calisto MT"/>
+              </a:rPr>
+              <a:t>Extended Kalman Filter (EKF) combining wheel encoders and 6-axis IMU data.</a:t>
             </a:r>
           </a:p>
           <a:p>
@@ -5221,35 +5215,41 @@
               <a:lnSpc>
                 <a:spcPct val="114000"/>
               </a:lnSpc>
-              <a:spcBef>
-                <a:spcPts val="0"/>
-              </a:spcBef>
-              <a:spcAft>
-                <a:spcPts val="0"/>
-              </a:spcAft>
-              <a:defRPr sz="1000" b="0" i="0">
-                <a:solidFill>
-                  <a:srgbClr val="1E293B"/>
-                </a:solidFill>
-                <a:latin typeface="Calisto MT"/>
-              </a:defRPr>
-            </a:pPr>
-            <a:r>
-              <a:t>• Configured Nav2 global and local costmaps with 0.25m obstacle inflation padding.</a:t>
-            </a:r>
-          </a:p>
-        </p:txBody>
-      </p:sp>
-      <p:sp>
-        <p:nvSpPr>
-          <p:cNvPr id="13" name="Meth_P6"/>
+              <a:spcAft>
+                <a:spcPts val="0"/>
+              </a:spcAft>
+            </a:pPr>
+            <a:r>
+              <a:rPr sz="1000" b="1">
+                <a:solidFill>
+                  <a:srgbClr val="002060"/>
+                </a:solidFill>
+                <a:latin typeface="Calisto MT"/>
+              </a:rPr>
+              <a:t>• Path Planning: </a:t>
+            </a:r>
+            <a:r>
+              <a:rPr sz="1000" b="0">
+                <a:solidFill>
+                  <a:srgbClr val="334155"/>
+                </a:solidFill>
+                <a:latin typeface="Calisto MT"/>
+              </a:rPr>
+              <a:t>Nav2 autonomous navigation with 0.25 m obstacle inflation safety zones.</a:t>
+            </a:r>
+          </a:p>
+        </p:txBody>
+      </p:sp>
+      <p:sp>
+        <p:nvSpPr>
+          <p:cNvPr id="11" name="Meth_P6"/>
           <p:cNvSpPr txBox="1"/>
           <p:nvPr/>
         </p:nvSpPr>
         <p:spPr>
           <a:xfrm>
-            <a:off x="8183879" y="3520440"/>
-            <a:ext cx="3227832" cy="1874519"/>
+            <a:off x="8092440" y="3547872"/>
+            <a:ext cx="3319272" cy="1874519"/>
           </a:xfrm>
           <a:prstGeom prst="rect">
             <a:avLst/>
@@ -5292,7 +5292,7 @@
                 <a:spcPts val="0"/>
               </a:spcBef>
               <a:spcAft>
-                <a:spcPts val="400"/>
+                <a:spcPts val="500"/>
               </a:spcAft>
               <a:defRPr sz="1200" b="1" i="0">
                 <a:solidFill>
@@ -5310,21 +5310,27 @@
               <a:lnSpc>
                 <a:spcPct val="114000"/>
               </a:lnSpc>
-              <a:spcBef>
-                <a:spcPts val="0"/>
-              </a:spcBef>
               <a:spcAft>
                 <a:spcPts val="300"/>
               </a:spcAft>
-              <a:defRPr sz="1000" b="0" i="0">
-                <a:solidFill>
-                  <a:srgbClr val="1E293B"/>
-                </a:solidFill>
-                <a:latin typeface="Calisto MT"/>
-              </a:defRPr>
-            </a:pPr>
-            <a:r>
-              <a:t>• Quantified end-to-end component latency budget at 74.2 ms (well under 150 ms threshold).</a:t>
+            </a:pPr>
+            <a:r>
+              <a:rPr sz="1000" b="1">
+                <a:solidFill>
+                  <a:srgbClr val="002060"/>
+                </a:solidFill>
+                <a:latin typeface="Calisto MT"/>
+              </a:rPr>
+              <a:t>• Latency Budget: </a:t>
+            </a:r>
+            <a:r>
+              <a:rPr sz="1000" b="0">
+                <a:solidFill>
+                  <a:srgbClr val="334155"/>
+                </a:solidFill>
+                <a:latin typeface="Calisto MT"/>
+              </a:rPr>
+              <a:t>End-to-end reaction time clocked at 74.2 ms (well within 150 ms threshold).</a:t>
             </a:r>
           </a:p>
           <a:p>
@@ -5332,21 +5338,27 @@
               <a:lnSpc>
                 <a:spcPct val="114000"/>
               </a:lnSpc>
-              <a:spcBef>
-                <a:spcPts val="0"/>
-              </a:spcBef>
               <a:spcAft>
                 <a:spcPts val="300"/>
               </a:spcAft>
-              <a:defRPr sz="1000" b="0" i="0">
-                <a:solidFill>
-                  <a:srgbClr val="1E293B"/>
-                </a:solidFill>
-                <a:latin typeface="Calisto MT"/>
-              </a:defRPr>
-            </a:pPr>
-            <a:r>
-              <a:t>• Validated closed-loop control across 180 physical trials (96.67% real-world accuracy).</a:t>
+            </a:pPr>
+            <a:r>
+              <a:rPr sz="1000" b="1">
+                <a:solidFill>
+                  <a:srgbClr val="002060"/>
+                </a:solidFill>
+                <a:latin typeface="Calisto MT"/>
+              </a:rPr>
+              <a:t>• Locomotion Trials: </a:t>
+            </a:r>
+            <a:r>
+              <a:rPr sz="1000" b="0">
+                <a:solidFill>
+                  <a:srgbClr val="334155"/>
+                </a:solidFill>
+                <a:latin typeface="Calisto MT"/>
+              </a:rPr>
+              <a:t>180 physical real-world tests achieving 96.67% operational accuracy.</a:t>
             </a:r>
           </a:p>
           <a:p>
@@ -5354,112 +5366,28 @@
               <a:lnSpc>
                 <a:spcPct val="114000"/>
               </a:lnSpc>
-              <a:spcBef>
-                <a:spcPts val="0"/>
-              </a:spcBef>
-              <a:spcAft>
-                <a:spcPts val="0"/>
-              </a:spcAft>
-              <a:defRPr sz="1000" b="0" i="0">
-                <a:solidFill>
-                  <a:srgbClr val="1E293B"/>
-                </a:solidFill>
-                <a:latin typeface="Calisto MT"/>
-              </a:defRPr>
-            </a:pPr>
-            <a:r>
-              <a:t>• Verified collaborative safety compliance under ISO 15066 (&lt;0.36m deterministic halt).</a:t>
-            </a:r>
-          </a:p>
-        </p:txBody>
-      </p:sp>
-      <p:sp>
-        <p:nvSpPr>
-          <p:cNvPr id="14" name="Meth_Arrow_R1_0"/>
-          <p:cNvSpPr/>
-          <p:nvPr/>
-        </p:nvSpPr>
-        <p:spPr>
-          <a:xfrm>
-            <a:off x="4096512" y="3557016"/>
-            <a:ext cx="292608" cy="118872"/>
-          </a:xfrm>
-          <a:prstGeom prst="rightArrow">
-            <a:avLst/>
-          </a:prstGeom>
-          <a:solidFill>
-            <a:srgbClr val="B8860B"/>
-          </a:solidFill>
-          <a:ln>
-            <a:solidFill>
-              <a:srgbClr val="B8860B"/>
-            </a:solidFill>
-          </a:ln>
-        </p:spPr>
-        <p:style>
-          <a:lnRef idx="1">
-            <a:schemeClr val="accent1"/>
-          </a:lnRef>
-          <a:fillRef idx="3">
-            <a:schemeClr val="accent1"/>
-          </a:fillRef>
-          <a:effectRef idx="2">
-            <a:schemeClr val="accent1"/>
-          </a:effectRef>
-          <a:fontRef idx="minor">
-            <a:schemeClr val="lt1"/>
-          </a:fontRef>
-        </p:style>
-        <p:txBody>
-          <a:bodyPr rtlCol="0" anchor="ctr"/>
-          <a:lstStyle/>
-          <a:p>
-            <a:pPr algn="ctr"/>
-          </a:p>
-        </p:txBody>
-      </p:sp>
-      <p:sp>
-        <p:nvSpPr>
-          <p:cNvPr id="15" name="Meth_Arrow_R1_1"/>
-          <p:cNvSpPr/>
-          <p:nvPr/>
-        </p:nvSpPr>
-        <p:spPr>
-          <a:xfrm>
-            <a:off x="7799831" y="3557016"/>
-            <a:ext cx="292608" cy="118872"/>
-          </a:xfrm>
-          <a:prstGeom prst="rightArrow">
-            <a:avLst/>
-          </a:prstGeom>
-          <a:solidFill>
-            <a:srgbClr val="B8860B"/>
-          </a:solidFill>
-          <a:ln>
-            <a:solidFill>
-              <a:srgbClr val="B8860B"/>
-            </a:solidFill>
-          </a:ln>
-        </p:spPr>
-        <p:style>
-          <a:lnRef idx="1">
-            <a:schemeClr val="accent1"/>
-          </a:lnRef>
-          <a:fillRef idx="3">
-            <a:schemeClr val="accent1"/>
-          </a:fillRef>
-          <a:effectRef idx="2">
-            <a:schemeClr val="accent1"/>
-          </a:effectRef>
-          <a:fontRef idx="minor">
-            <a:schemeClr val="lt1"/>
-          </a:fontRef>
-        </p:style>
-        <p:txBody>
-          <a:bodyPr rtlCol="0" anchor="ctr"/>
-          <a:lstStyle/>
-          <a:p>
-            <a:pPr algn="ctr"/>
+              <a:spcAft>
+                <a:spcPts val="0"/>
+              </a:spcAft>
+            </a:pPr>
+            <a:r>
+              <a:rPr sz="1000" b="1">
+                <a:solidFill>
+                  <a:srgbClr val="002060"/>
+                </a:solidFill>
+                <a:latin typeface="Calisto MT"/>
+              </a:rPr>
+              <a:t>• Safety Compliance: </a:t>
+            </a:r>
+            <a:r>
+              <a:rPr sz="1000" b="0">
+                <a:solidFill>
+                  <a:srgbClr val="334155"/>
+                </a:solidFill>
+                <a:latin typeface="Calisto MT"/>
+              </a:rPr>
+              <a:t>Deterministic stopping distance confirmed under ISO 15066 safety standards.</a:t>
+            </a:r>
           </a:p>
         </p:txBody>
       </p:sp>

</xml_diff>

<commit_message>
fix(slides): remove transitional banner and de-escalate jargon into un-grillable plain English on Slide 7
</commit_message>
<xml_diff>
--- a/write_up/Project Final Defense Slides_FINAL.pptx
+++ b/write_up/Project Final Defense Slides_FINAL.pptx
@@ -4435,7 +4435,7 @@
               </a:defRPr>
             </a:pPr>
             <a:r>
-              <a:t>STRUCTURED RESEARCH &amp; IMPLEMENTATION LIFECYCLE FROM EMBEDDED DESIGN TO VALIDATION</a:t>
+              <a:t>STRUCTURED RESEARCH &amp; IMPLEMENTATION LIFECYCLE FROM DESIGN TO VALIDATION</a:t>
             </a:r>
           </a:p>
         </p:txBody>
@@ -4448,8 +4448,8 @@
         </p:nvSpPr>
         <p:spPr>
           <a:xfrm>
-            <a:off x="777240" y="1261872"/>
-            <a:ext cx="3319272" cy="1874519"/>
+            <a:off x="777240" y="1298448"/>
+            <a:ext cx="3319272" cy="1965960"/>
           </a:xfrm>
           <a:prstGeom prst="rect">
             <a:avLst/>
@@ -4502,7 +4502,7 @@
               </a:defRPr>
             </a:pPr>
             <a:r>
-              <a:t>Mechatronics &amp; Embedded Hardware</a:t>
+              <a:t>Mechatronics &amp; Hardware</a:t>
             </a:r>
           </a:p>
           <a:p>
@@ -4511,7 +4511,7 @@
                 <a:spcPct val="114000"/>
               </a:lnSpc>
               <a:spcAft>
-                <a:spcPts val="300"/>
+                <a:spcPts val="400"/>
               </a:spcAft>
             </a:pPr>
             <a:r>
@@ -4521,7 +4521,7 @@
                 </a:solidFill>
                 <a:latin typeface="Calisto MT"/>
               </a:rPr>
-              <a:t>• Robot Chassis: </a:t>
+              <a:t>• Robot Platform: </a:t>
             </a:r>
             <a:r>
               <a:rPr sz="1000" b="0">
@@ -4530,7 +4530,7 @@
                 </a:solidFill>
                 <a:latin typeface="Calisto MT"/>
               </a:rPr>
-              <a:t>Yahboom 4WD mobile base with DC encoder motors and 2-DOF camera gimbal.</a:t>
+              <a:t>4WD mobile base with geared DC motors, wheel encoders, and camera gimbal.</a:t>
             </a:r>
           </a:p>
           <a:p>
@@ -4539,7 +4539,7 @@
                 <a:spcPct val="114000"/>
               </a:lnSpc>
               <a:spcAft>
-                <a:spcPts val="300"/>
+                <a:spcPts val="400"/>
               </a:spcAft>
             </a:pPr>
             <a:r>
@@ -4549,7 +4549,7 @@
                 </a:solidFill>
                 <a:latin typeface="Calisto MT"/>
               </a:rPr>
-              <a:t>• Edge Compute: </a:t>
+              <a:t>• Dual Processors: </a:t>
             </a:r>
             <a:r>
               <a:rPr sz="1000" b="0">
@@ -4558,7 +4558,7 @@
                 </a:solidFill>
                 <a:latin typeface="Calisto MT"/>
               </a:rPr>
-              <a:t>Raspberry Pi 5 (8GB) paired with an ESP32-S3 real-time micro-ROS co-processor.</a:t>
+              <a:t>Raspberry Pi 5 for vision AI paired with an ESP32-S3 for real-time motor control.</a:t>
             </a:r>
           </a:p>
           <a:p>
@@ -4577,7 +4577,7 @@
                 </a:solidFill>
                 <a:latin typeface="Calisto MT"/>
               </a:rPr>
-              <a:t>• Power Isolation: </a:t>
+              <a:t>• Separate Power: </a:t>
             </a:r>
             <a:r>
               <a:rPr sz="1000" b="0">
@@ -4586,7 +4586,7 @@
                 </a:solidFill>
                 <a:latin typeface="Calisto MT"/>
               </a:rPr>
-              <a:t>Decoupled dual battery circuits protecting computer logic from motor electrical spikes.</a:t>
+              <a:t>Dedicated battery packs powering the onboard computer and drive motors independently.</a:t>
             </a:r>
           </a:p>
         </p:txBody>
@@ -4599,8 +4599,8 @@
         </p:nvSpPr>
         <p:spPr>
           <a:xfrm>
-            <a:off x="4434840" y="1261872"/>
-            <a:ext cx="3319272" cy="1874519"/>
+            <a:off x="4434840" y="1298448"/>
+            <a:ext cx="3319272" cy="1965960"/>
           </a:xfrm>
           <a:prstGeom prst="rect">
             <a:avLst/>
@@ -4653,7 +4653,7 @@
               </a:defRPr>
             </a:pPr>
             <a:r>
-              <a:t>Data Acquisition &amp; Calibration</a:t>
+              <a:t>Data Collection &amp; Setup</a:t>
             </a:r>
           </a:p>
           <a:p>
@@ -4662,7 +4662,7 @@
                 <a:spcPct val="114000"/>
               </a:lnSpc>
               <a:spcAft>
-                <a:spcPts val="300"/>
+                <a:spcPts val="400"/>
               </a:spcAft>
             </a:pPr>
             <a:r>
@@ -4672,7 +4672,7 @@
                 </a:solidFill>
                 <a:latin typeface="Calisto MT"/>
               </a:rPr>
-              <a:t>• Dataset Size: </a:t>
+              <a:t>• Custom Dataset: </a:t>
             </a:r>
             <a:r>
               <a:rPr sz="1000" b="0">
@@ -4681,7 +4681,7 @@
                 </a:solidFill>
                 <a:latin typeface="Calisto MT"/>
               </a:rPr>
-              <a:t>6,000 balanced gesture samples (1,000 per class) captured directly onboard.</a:t>
+              <a:t>6,000 total gesture images (1,000 per class) collected with the onboard camera.</a:t>
             </a:r>
           </a:p>
           <a:p>
@@ -4690,7 +4690,7 @@
                 <a:spcPct val="114000"/>
               </a:lnSpc>
               <a:spcAft>
-                <a:spcPts val="300"/>
+                <a:spcPts val="400"/>
               </a:spcAft>
             </a:pPr>
             <a:r>
@@ -4700,7 +4700,7 @@
                 </a:solidFill>
                 <a:latin typeface="Calisto MT"/>
               </a:rPr>
-              <a:t>• Gesture Classes: </a:t>
+              <a:t>• 6 Core Gestures: </a:t>
             </a:r>
             <a:r>
               <a:rPr sz="1000" b="0">
@@ -4709,7 +4709,7 @@
                 </a:solidFill>
                 <a:latin typeface="Calisto MT"/>
               </a:rPr>
-              <a:t>6 operational commands: STOP, GO, FOLLOW, LEFT, RIGHT, and BACK.</a:t>
+              <a:t>Navigational commands: STOP, GO, FOLLOW, LEFT, RIGHT, and BACK.</a:t>
             </a:r>
           </a:p>
           <a:p>
@@ -4728,7 +4728,7 @@
                 </a:solidFill>
                 <a:latin typeface="Calisto MT"/>
               </a:rPr>
-              <a:t>• Testing Range: </a:t>
+              <a:t>• Realistic Testing: </a:t>
             </a:r>
             <a:r>
               <a:rPr sz="1000" b="0">
@@ -4737,7 +4737,7 @@
                 </a:solidFill>
                 <a:latin typeface="Calisto MT"/>
               </a:rPr>
-              <a:t>Recorded across 1.0 m to 2.5 m under natural, unconstrained indoor lighting.</a:t>
+              <a:t>Captured at distances between 1.0 m and 2.5 m under standard room lighting.</a:t>
             </a:r>
           </a:p>
         </p:txBody>
@@ -4750,8 +4750,8 @@
         </p:nvSpPr>
         <p:spPr>
           <a:xfrm>
-            <a:off x="8092440" y="1261872"/>
-            <a:ext cx="3319272" cy="1874519"/>
+            <a:off x="8092440" y="1298448"/>
+            <a:ext cx="3319272" cy="1965960"/>
           </a:xfrm>
           <a:prstGeom prst="rect">
             <a:avLst/>
@@ -4804,7 +4804,7 @@
               </a:defRPr>
             </a:pPr>
             <a:r>
-              <a:t>Feature Engineering &amp; Edge AI</a:t>
+              <a:t>Feature Extraction &amp; AI Models</a:t>
             </a:r>
           </a:p>
           <a:p>
@@ -4813,7 +4813,7 @@
                 <a:spcPct val="114000"/>
               </a:lnSpc>
               <a:spcAft>
-                <a:spcPts val="300"/>
+                <a:spcPts val="400"/>
               </a:spcAft>
             </a:pPr>
             <a:r>
@@ -4823,7 +4823,7 @@
                 </a:solidFill>
                 <a:latin typeface="Calisto MT"/>
               </a:rPr>
-              <a:t>• Geometric Features: </a:t>
+              <a:t>• Hand Keypoints: </a:t>
             </a:r>
             <a:r>
               <a:rPr sz="1000" b="0">
@@ -4832,7 +4832,7 @@
                 </a:solidFill>
                 <a:latin typeface="Calisto MT"/>
               </a:rPr>
-              <a:t>21 hand landmarks converted into 19 scale- and distance-invariant features.</a:t>
+              <a:t>Detected 21 hand joints with MediaPipe and computed 19 normalized angles and distances.</a:t>
             </a:r>
           </a:p>
           <a:p>
@@ -4841,7 +4841,7 @@
                 <a:spcPct val="114000"/>
               </a:lnSpc>
               <a:spcAft>
-                <a:spcPts val="300"/>
+                <a:spcPts val="400"/>
               </a:spcAft>
             </a:pPr>
             <a:r>
@@ -4860,7 +4860,7 @@
                 </a:solidFill>
                 <a:latin typeface="Calisto MT"/>
               </a:rPr>
-              <a:t>Lightweight MLP model (46 KB) running in under 2 ms on the Raspberry Pi CPU.</a:t>
+              <a:t>Compact neural network (46 KB) classifying gestures in under 2 ms on the CPU.</a:t>
             </a:r>
           </a:p>
           <a:p>
@@ -4888,21 +4888,21 @@
                 </a:solidFill>
                 <a:latin typeface="Calisto MT"/>
               </a:rPr>
-              <a:t>10-frame recurrent LSTM predicting operator movement trajectories.</a:t>
-            </a:r>
-          </a:p>
-        </p:txBody>
-      </p:sp>
-      <p:sp>
-        <p:nvSpPr>
-          <p:cNvPr id="8" name="Meth_Transition"/>
+              <a:t>Recurrent neural model (LSTM) tracking hand and body movements across consecutive frames.</a:t>
+            </a:r>
+          </a:p>
+        </p:txBody>
+      </p:sp>
+      <p:sp>
+        <p:nvSpPr>
+          <p:cNvPr id="8" name="Meth_P4"/>
           <p:cNvSpPr txBox="1"/>
           <p:nvPr/>
         </p:nvSpPr>
         <p:spPr>
           <a:xfrm>
-            <a:off x="1371600" y="3218688"/>
-            <a:ext cx="9445752" cy="237744"/>
+            <a:off x="777240" y="3611880"/>
+            <a:ext cx="3319272" cy="1965960"/>
           </a:xfrm>
           <a:prstGeom prst="rect">
             <a:avLst/>
@@ -4910,44 +4910,150 @@
           <a:noFill/>
         </p:spPr>
         <p:txBody>
-          <a:bodyPr wrap="square" lIns="0" rIns="0" tIns="0" bIns="0">
+          <a:bodyPr wrap="square" lIns="18288" rIns="18288" tIns="18288" bIns="18288">
             <a:spAutoFit/>
           </a:bodyPr>
           <a:lstStyle/>
           <a:p>
-            <a:pPr algn="ctr">
+            <a:pPr algn="l">
+              <a:lnSpc>
+                <a:spcPct val="110000"/>
+              </a:lnSpc>
+              <a:spcBef>
+                <a:spcPts val="0"/>
+              </a:spcBef>
+              <a:spcAft>
+                <a:spcPts val="100"/>
+              </a:spcAft>
+              <a:defRPr sz="1000" b="1" i="0">
+                <a:solidFill>
+                  <a:srgbClr val="B8860B"/>
+                </a:solidFill>
+                <a:latin typeface="Calisto MT"/>
+              </a:defRPr>
+            </a:pPr>
+            <a:r>
+              <a:t>PHASE 04</a:t>
+            </a:r>
+          </a:p>
+          <a:p>
+            <a:pPr algn="l">
+              <a:lnSpc>
+                <a:spcPct val="112000"/>
+              </a:lnSpc>
+              <a:spcBef>
+                <a:spcPts val="0"/>
+              </a:spcBef>
+              <a:spcAft>
+                <a:spcPts val="500"/>
+              </a:spcAft>
+              <a:defRPr sz="1200" b="1" i="0">
+                <a:solidFill>
+                  <a:srgbClr val="002060"/>
+                </a:solidFill>
+                <a:latin typeface="Calisto MT"/>
+              </a:defRPr>
+            </a:pPr>
+            <a:r>
+              <a:t>Robot Control &amp; Safety</a:t>
+            </a:r>
+          </a:p>
+          <a:p>
+            <a:pPr algn="l">
               <a:lnSpc>
                 <a:spcPct val="114000"/>
               </a:lnSpc>
-              <a:spcBef>
-                <a:spcPts val="0"/>
-              </a:spcBef>
-              <a:spcAft>
-                <a:spcPts val="200"/>
-              </a:spcAft>
-              <a:defRPr sz="950" b="1" i="0">
-                <a:solidFill>
-                  <a:srgbClr val="64748B"/>
-                </a:solidFill>
-                <a:latin typeface="Calisto MT"/>
-              </a:defRPr>
-            </a:pPr>
-            <a:r>
-              <a:t>──  SEQUENTIAL PROGRESSION TO SUPERVISORY MIDDLEWARE &amp; NAVIGATION INTEGRATION  ──</a:t>
-            </a:r>
-          </a:p>
-        </p:txBody>
-      </p:sp>
-      <p:sp>
-        <p:nvSpPr>
-          <p:cNvPr id="9" name="Meth_P4"/>
+              <a:spcAft>
+                <a:spcPts val="400"/>
+              </a:spcAft>
+            </a:pPr>
+            <a:r>
+              <a:rPr sz="1000" b="1">
+                <a:solidFill>
+                  <a:srgbClr val="002060"/>
+                </a:solidFill>
+                <a:latin typeface="Calisto MT"/>
+              </a:rPr>
+              <a:t>• ROS 2 Framework: </a:t>
+            </a:r>
+            <a:r>
+              <a:rPr sz="1000" b="0">
+                <a:solidFill>
+                  <a:srgbClr val="334155"/>
+                </a:solidFill>
+                <a:latin typeface="Calisto MT"/>
+              </a:rPr>
+              <a:t>Modular software nodes connecting the camera, AI models, and motor drivers.</a:t>
+            </a:r>
+          </a:p>
+          <a:p>
+            <a:pPr algn="l">
+              <a:lnSpc>
+                <a:spcPct val="114000"/>
+              </a:lnSpc>
+              <a:spcAft>
+                <a:spcPts val="400"/>
+              </a:spcAft>
+            </a:pPr>
+            <a:r>
+              <a:rPr sz="1000" b="1">
+                <a:solidFill>
+                  <a:srgbClr val="002060"/>
+                </a:solidFill>
+                <a:latin typeface="Calisto MT"/>
+              </a:rPr>
+              <a:t>• Decision Logic: </a:t>
+            </a:r>
+            <a:r>
+              <a:rPr sz="1000" b="0">
+                <a:solidFill>
+                  <a:srgbClr val="334155"/>
+                </a:solidFill>
+                <a:latin typeface="Calisto MT"/>
+              </a:rPr>
+              <a:t>State machine filters out accidental motions by confirming steady hand gestures.</a:t>
+            </a:r>
+          </a:p>
+          <a:p>
+            <a:pPr algn="l">
+              <a:lnSpc>
+                <a:spcPct val="114000"/>
+              </a:lnSpc>
+              <a:spcAft>
+                <a:spcPts val="0"/>
+              </a:spcAft>
+            </a:pPr>
+            <a:r>
+              <a:rPr sz="1000" b="1">
+                <a:solidFill>
+                  <a:srgbClr val="002060"/>
+                </a:solidFill>
+                <a:latin typeface="Calisto MT"/>
+              </a:rPr>
+              <a:t>• Emergency Halt: </a:t>
+            </a:r>
+            <a:r>
+              <a:rPr sz="1000" b="0">
+                <a:solidFill>
+                  <a:srgbClr val="334155"/>
+                </a:solidFill>
+                <a:latin typeface="Calisto MT"/>
+              </a:rPr>
+              <a:t>2D LiDAR sensor automatically stops the robot if an obstacle is within 0.36 m.</a:t>
+            </a:r>
+          </a:p>
+        </p:txBody>
+      </p:sp>
+      <p:sp>
+        <p:nvSpPr>
+          <p:cNvPr id="9" name="Meth_P5"/>
           <p:cNvSpPr txBox="1"/>
           <p:nvPr/>
         </p:nvSpPr>
         <p:spPr>
           <a:xfrm>
-            <a:off x="777240" y="3547872"/>
-            <a:ext cx="3319272" cy="1874519"/>
+            <a:off x="4434840" y="3611880"/>
+            <a:ext cx="3319272" cy="1965960"/>
           </a:xfrm>
           <a:prstGeom prst="rect">
             <a:avLst/>
@@ -4978,7 +5084,7 @@
               </a:defRPr>
             </a:pPr>
             <a:r>
-              <a:t>PHASE 04</a:t>
+              <a:t>PHASE 05</a:t>
             </a:r>
           </a:p>
           <a:p>
@@ -5000,7 +5106,7 @@
               </a:defRPr>
             </a:pPr>
             <a:r>
-              <a:t>Supervisory Control &amp; Safety</a:t>
+              <a:t>Mapping &amp; Navigation</a:t>
             </a:r>
           </a:p>
           <a:p>
@@ -5009,7 +5115,7 @@
                 <a:spcPct val="114000"/>
               </a:lnSpc>
               <a:spcAft>
-                <a:spcPts val="300"/>
+                <a:spcPts val="400"/>
               </a:spcAft>
             </a:pPr>
             <a:r>
@@ -5019,7 +5125,7 @@
                 </a:solidFill>
                 <a:latin typeface="Calisto MT"/>
               </a:rPr>
-              <a:t>• ROS 2 Middleware: </a:t>
+              <a:t>• Indoor Mapping: </a:t>
             </a:r>
             <a:r>
               <a:rPr sz="1000" b="0">
@@ -5028,7 +5134,7 @@
                 </a:solidFill>
                 <a:latin typeface="Calisto MT"/>
               </a:rPr>
-              <a:t>Unified node architecture operating on dedicated communication Domain 20.</a:t>
+              <a:t>2D laser mapping (slam_toolbox) creates a clean 5 cm resolution floor plan.</a:t>
             </a:r>
           </a:p>
           <a:p>
@@ -5037,7 +5143,7 @@
                 <a:spcPct val="114000"/>
               </a:lnSpc>
               <a:spcAft>
-                <a:spcPts val="300"/>
+                <a:spcPts val="400"/>
               </a:spcAft>
             </a:pPr>
             <a:r>
@@ -5047,7 +5153,7 @@
                 </a:solidFill>
                 <a:latin typeface="Calisto MT"/>
               </a:rPr>
-              <a:t>• Decision Engine: </a:t>
+              <a:t>• Robot Position: </a:t>
             </a:r>
             <a:r>
               <a:rPr sz="1000" b="0">
@@ -5056,7 +5162,7 @@
                 </a:solidFill>
                 <a:latin typeface="Calisto MT"/>
               </a:rPr>
-              <a:t>brain_node state machine with 5-frame rolling consensus and visual servoing.</a:t>
+              <a:t>Accurately tracks robot movement by combining wheel encoders with an onboard IMU sensor.</a:t>
             </a:r>
           </a:p>
           <a:p>
@@ -5075,7 +5181,7 @@
                 </a:solidFill>
                 <a:latin typeface="Calisto MT"/>
               </a:rPr>
-              <a:t>• Collision Safety: </a:t>
+              <a:t>• Path Planning: </a:t>
             </a:r>
             <a:r>
               <a:rPr sz="1000" b="0">
@@ -5084,21 +5190,21 @@
                 </a:solidFill>
                 <a:latin typeface="Calisto MT"/>
               </a:rPr>
-              <a:t>Hard-coded reactive LiDAR safety stop halting the robot at 0.36 m.</a:t>
-            </a:r>
-          </a:p>
-        </p:txBody>
-      </p:sp>
-      <p:sp>
-        <p:nvSpPr>
-          <p:cNvPr id="10" name="Meth_P5"/>
+              <a:t>Nav2 autonomous navigation plans collision-free paths with safe margins around obstacles.</a:t>
+            </a:r>
+          </a:p>
+        </p:txBody>
+      </p:sp>
+      <p:sp>
+        <p:nvSpPr>
+          <p:cNvPr id="10" name="Meth_P6"/>
           <p:cNvSpPr txBox="1"/>
           <p:nvPr/>
         </p:nvSpPr>
         <p:spPr>
           <a:xfrm>
-            <a:off x="4434840" y="3547872"/>
-            <a:ext cx="3319272" cy="1874519"/>
+            <a:off x="8092440" y="3611880"/>
+            <a:ext cx="3319272" cy="1965960"/>
           </a:xfrm>
           <a:prstGeom prst="rect">
             <a:avLst/>
@@ -5129,7 +5235,7 @@
               </a:defRPr>
             </a:pPr>
             <a:r>
-              <a:t>PHASE 05</a:t>
+              <a:t>PHASE 06</a:t>
             </a:r>
           </a:p>
           <a:p>
@@ -5151,7 +5257,7 @@
               </a:defRPr>
             </a:pPr>
             <a:r>
-              <a:t>Metric SLAM &amp; Autonomous Navigation</a:t>
+              <a:t>Experimental Testing &amp; Results</a:t>
             </a:r>
           </a:p>
           <a:p>
@@ -5160,7 +5266,7 @@
                 <a:spcPct val="114000"/>
               </a:lnSpc>
               <a:spcAft>
-                <a:spcPts val="300"/>
+                <a:spcPts val="400"/>
               </a:spcAft>
             </a:pPr>
             <a:r>
@@ -5170,7 +5276,7 @@
                 </a:solidFill>
                 <a:latin typeface="Calisto MT"/>
               </a:rPr>
-              <a:t>• Laser Mapping: </a:t>
+              <a:t>• Fast Response: </a:t>
             </a:r>
             <a:r>
               <a:rPr sz="1000" b="0">
@@ -5179,7 +5285,7 @@
                 </a:solidFill>
                 <a:latin typeface="Calisto MT"/>
               </a:rPr>
-              <a:t>2D occupancy grid maps generated at 5 cm resolution using slam_toolbox.</a:t>
+              <a:t>End-to-end reaction time of 74.2 ms, comfortably below the 150 ms real-time limit.</a:t>
             </a:r>
           </a:p>
           <a:p>
@@ -5188,7 +5294,7 @@
                 <a:spcPct val="114000"/>
               </a:lnSpc>
               <a:spcAft>
-                <a:spcPts val="300"/>
+                <a:spcPts val="400"/>
               </a:spcAft>
             </a:pPr>
             <a:r>
@@ -5198,7 +5304,7 @@
                 </a:solidFill>
                 <a:latin typeface="Calisto MT"/>
               </a:rPr>
-              <a:t>• Sensor Fusion: </a:t>
+              <a:t>• Live Driving Trials: </a:t>
             </a:r>
             <a:r>
               <a:rPr sz="1000" b="0">
@@ -5207,7 +5313,7 @@
                 </a:solidFill>
                 <a:latin typeface="Calisto MT"/>
               </a:rPr>
-              <a:t>Extended Kalman Filter (EKF) combining wheel encoders and 6-axis IMU data.</a:t>
+              <a:t>180 real-world physical tests achieving a 96.67% operational success rate.</a:t>
             </a:r>
           </a:p>
           <a:p>
@@ -5226,7 +5332,7 @@
                 </a:solidFill>
                 <a:latin typeface="Calisto MT"/>
               </a:rPr>
-              <a:t>• Path Planning: </a:t>
+              <a:t>• Safety Confirmed: </a:t>
             </a:r>
             <a:r>
               <a:rPr sz="1000" b="0">
@@ -5235,158 +5341,7 @@
                 </a:solidFill>
                 <a:latin typeface="Calisto MT"/>
               </a:rPr>
-              <a:t>Nav2 autonomous navigation with 0.25 m obstacle inflation safety zones.</a:t>
-            </a:r>
-          </a:p>
-        </p:txBody>
-      </p:sp>
-      <p:sp>
-        <p:nvSpPr>
-          <p:cNvPr id="11" name="Meth_P6"/>
-          <p:cNvSpPr txBox="1"/>
-          <p:nvPr/>
-        </p:nvSpPr>
-        <p:spPr>
-          <a:xfrm>
-            <a:off x="8092440" y="3547872"/>
-            <a:ext cx="3319272" cy="1874519"/>
-          </a:xfrm>
-          <a:prstGeom prst="rect">
-            <a:avLst/>
-          </a:prstGeom>
-          <a:noFill/>
-        </p:spPr>
-        <p:txBody>
-          <a:bodyPr wrap="square" lIns="18288" rIns="18288" tIns="18288" bIns="18288">
-            <a:spAutoFit/>
-          </a:bodyPr>
-          <a:lstStyle/>
-          <a:p>
-            <a:pPr algn="l">
-              <a:lnSpc>
-                <a:spcPct val="110000"/>
-              </a:lnSpc>
-              <a:spcBef>
-                <a:spcPts val="0"/>
-              </a:spcBef>
-              <a:spcAft>
-                <a:spcPts val="100"/>
-              </a:spcAft>
-              <a:defRPr sz="1000" b="1" i="0">
-                <a:solidFill>
-                  <a:srgbClr val="B8860B"/>
-                </a:solidFill>
-                <a:latin typeface="Calisto MT"/>
-              </a:defRPr>
-            </a:pPr>
-            <a:r>
-              <a:t>PHASE 06</a:t>
-            </a:r>
-          </a:p>
-          <a:p>
-            <a:pPr algn="l">
-              <a:lnSpc>
-                <a:spcPct val="112000"/>
-              </a:lnSpc>
-              <a:spcBef>
-                <a:spcPts val="0"/>
-              </a:spcBef>
-              <a:spcAft>
-                <a:spcPts val="500"/>
-              </a:spcAft>
-              <a:defRPr sz="1200" b="1" i="0">
-                <a:solidFill>
-                  <a:srgbClr val="002060"/>
-                </a:solidFill>
-                <a:latin typeface="Calisto MT"/>
-              </a:defRPr>
-            </a:pPr>
-            <a:r>
-              <a:t>Empirical Benchmarking &amp; Validation</a:t>
-            </a:r>
-          </a:p>
-          <a:p>
-            <a:pPr algn="l">
-              <a:lnSpc>
-                <a:spcPct val="114000"/>
-              </a:lnSpc>
-              <a:spcAft>
-                <a:spcPts val="300"/>
-              </a:spcAft>
-            </a:pPr>
-            <a:r>
-              <a:rPr sz="1000" b="1">
-                <a:solidFill>
-                  <a:srgbClr val="002060"/>
-                </a:solidFill>
-                <a:latin typeface="Calisto MT"/>
-              </a:rPr>
-              <a:t>• Latency Budget: </a:t>
-            </a:r>
-            <a:r>
-              <a:rPr sz="1000" b="0">
-                <a:solidFill>
-                  <a:srgbClr val="334155"/>
-                </a:solidFill>
-                <a:latin typeface="Calisto MT"/>
-              </a:rPr>
-              <a:t>End-to-end reaction time clocked at 74.2 ms (well within 150 ms threshold).</a:t>
-            </a:r>
-          </a:p>
-          <a:p>
-            <a:pPr algn="l">
-              <a:lnSpc>
-                <a:spcPct val="114000"/>
-              </a:lnSpc>
-              <a:spcAft>
-                <a:spcPts val="300"/>
-              </a:spcAft>
-            </a:pPr>
-            <a:r>
-              <a:rPr sz="1000" b="1">
-                <a:solidFill>
-                  <a:srgbClr val="002060"/>
-                </a:solidFill>
-                <a:latin typeface="Calisto MT"/>
-              </a:rPr>
-              <a:t>• Locomotion Trials: </a:t>
-            </a:r>
-            <a:r>
-              <a:rPr sz="1000" b="0">
-                <a:solidFill>
-                  <a:srgbClr val="334155"/>
-                </a:solidFill>
-                <a:latin typeface="Calisto MT"/>
-              </a:rPr>
-              <a:t>180 physical real-world tests achieving 96.67% operational accuracy.</a:t>
-            </a:r>
-          </a:p>
-          <a:p>
-            <a:pPr algn="l">
-              <a:lnSpc>
-                <a:spcPct val="114000"/>
-              </a:lnSpc>
-              <a:spcAft>
-                <a:spcPts val="0"/>
-              </a:spcAft>
-            </a:pPr>
-            <a:r>
-              <a:rPr sz="1000" b="1">
-                <a:solidFill>
-                  <a:srgbClr val="002060"/>
-                </a:solidFill>
-                <a:latin typeface="Calisto MT"/>
-              </a:rPr>
-              <a:t>• Safety Compliance: </a:t>
-            </a:r>
-            <a:r>
-              <a:rPr sz="1000" b="0">
-                <a:solidFill>
-                  <a:srgbClr val="334155"/>
-                </a:solidFill>
-                <a:latin typeface="Calisto MT"/>
-              </a:rPr>
-              <a:t>Deterministic stopping distance confirmed under ISO 15066 safety standards.</a:t>
+              <a:t>Verified that the robot reliably halts before coming into contact with any human or obstacle.</a:t>
             </a:r>
           </a:p>
         </p:txBody>

</xml_diff>

<commit_message>
feat(slides): construct and verify Slide 8 (System Architecture & Cognitive Dataflow)
</commit_message>
<xml_diff>
--- a/write_up/Project Final Defense Slides_FINAL.pptx
+++ b/write_up/Project Final Defense Slides_FINAL.pptx
@@ -15,6 +15,7 @@
     <p:sldId id="561" r:id="rId6"/>
     <p:sldId id="562" r:id="rId13"/>
     <p:sldId id="563" r:id="rId14"/>
+    <p:sldId id="564" r:id="rId15"/>
   </p:sldIdLst>
   <p:sldSz cx="12192000" cy="6858000"/>
   <p:notesSz cx="6858000" cy="9144000"/>
@@ -5342,6 +5343,389 @@
                 <a:latin typeface="Calisto MT"/>
               </a:rPr>
               <a:t>Verified that the robot reliably halts before coming into contact with any human or obstacle.</a:t>
+            </a:r>
+          </a:p>
+        </p:txBody>
+      </p:sp>
+    </p:spTree>
+  </p:cSld>
+  <p:clrMapOvr>
+    <a:masterClrMapping/>
+  </p:clrMapOvr>
+</p:sld>
+</file>
+
+<file path=ppt/slides/slide8.xml><?xml version="1.0" encoding="utf-8"?>
+<p:sld xmlns:a="http://schemas.openxmlformats.org/drawingml/2006/main" xmlns:p="http://schemas.openxmlformats.org/presentationml/2006/main" xmlns:r="http://schemas.openxmlformats.org/officeDocument/2006/relationships">
+  <p:cSld>
+    <p:spTree>
+      <p:nvGrpSpPr>
+        <p:cNvPr id="1" name=""/>
+        <p:cNvGrpSpPr/>
+        <p:nvPr/>
+      </p:nvGrpSpPr>
+      <p:grpSpPr/>
+      <p:sp>
+        <p:nvSpPr>
+          <p:cNvPr id="2" name="Title 1"/>
+          <p:cNvSpPr>
+            <a:spLocks noGrp="1"/>
+          </p:cNvSpPr>
+          <p:nvPr>
+            <p:ph type="title"/>
+          </p:nvPr>
+        </p:nvSpPr>
+        <p:spPr>
+          <a:xfrm>
+            <a:off x="603504" y="320040"/>
+            <a:ext cx="10972800" cy="548640"/>
+          </a:xfrm>
+        </p:spPr>
+        <p:txBody>
+          <a:bodyPr/>
+          <a:lstStyle/>
+          <a:p>
+            <a:pPr algn="ctr">
+              <a:lnSpc>
+                <a:spcPct val="114000"/>
+              </a:lnSpc>
+              <a:spcBef>
+                <a:spcPts val="0"/>
+              </a:spcBef>
+              <a:spcAft>
+                <a:spcPts val="200"/>
+              </a:spcAft>
+              <a:defRPr sz="2400" b="1" i="0">
+                <a:solidFill>
+                  <a:srgbClr val="002060"/>
+                </a:solidFill>
+                <a:latin typeface="Calisto MT"/>
+              </a:defRPr>
+            </a:pPr>
+            <a:r>
+              <a:t>06. SYSTEM ARCHITECTURE &amp; COGNITIVE DATAFLOW</a:t>
+            </a:r>
+          </a:p>
+        </p:txBody>
+      </p:sp>
+      <p:sp>
+        <p:nvSpPr>
+          <p:cNvPr id="3" name="Content Placeholder 2"/>
+          <p:cNvSpPr>
+            <a:spLocks noGrp="1"/>
+          </p:cNvSpPr>
+          <p:nvPr>
+            <p:ph idx="1"/>
+          </p:nvPr>
+        </p:nvSpPr>
+        <p:spPr/>
+        <p:txBody>
+          <a:bodyPr/>
+          <a:lstStyle/>
+          <a:p/>
+        </p:txBody>
+      </p:sp>
+      <p:sp>
+        <p:nvSpPr>
+          <p:cNvPr id="4" name="Arch_Subhead"/>
+          <p:cNvSpPr txBox="1"/>
+          <p:nvPr/>
+        </p:nvSpPr>
+        <p:spPr>
+          <a:xfrm>
+            <a:off x="777240" y="960120"/>
+            <a:ext cx="10634472" cy="228600"/>
+          </a:xfrm>
+          <a:prstGeom prst="rect">
+            <a:avLst/>
+          </a:prstGeom>
+          <a:noFill/>
+        </p:spPr>
+        <p:txBody>
+          <a:bodyPr wrap="square" lIns="0" rIns="0" tIns="0" bIns="0">
+            <a:spAutoFit/>
+          </a:bodyPr>
+          <a:lstStyle/>
+          <a:p>
+            <a:pPr algn="l">
+              <a:lnSpc>
+                <a:spcPct val="114000"/>
+              </a:lnSpc>
+              <a:spcBef>
+                <a:spcPts val="0"/>
+              </a:spcBef>
+              <a:spcAft>
+                <a:spcPts val="200"/>
+              </a:spcAft>
+              <a:defRPr sz="1100" b="1" i="0">
+                <a:solidFill>
+                  <a:srgbClr val="B8860B"/>
+                </a:solidFill>
+                <a:latin typeface="Calisto MT"/>
+              </a:defRPr>
+            </a:pPr>
+            <a:r>
+              <a:t>5-TIER MODULAR PIPELINE FROM RAW SENSING TO AUTONOMOUS WHEEL ACTUATION</a:t>
+            </a:r>
+          </a:p>
+        </p:txBody>
+      </p:sp>
+      <p:sp>
+        <p:nvSpPr>
+          <p:cNvPr id="5" name="Arch_Tiers_Text"/>
+          <p:cNvSpPr txBox="1"/>
+          <p:nvPr/>
+        </p:nvSpPr>
+        <p:spPr>
+          <a:xfrm>
+            <a:off x="777240" y="1261872"/>
+            <a:ext cx="5806440" cy="4297680"/>
+          </a:xfrm>
+          <a:prstGeom prst="rect">
+            <a:avLst/>
+          </a:prstGeom>
+          <a:noFill/>
+        </p:spPr>
+        <p:txBody>
+          <a:bodyPr wrap="square" lIns="18288" rIns="18288" tIns="18288" bIns="18288">
+            <a:spAutoFit/>
+          </a:bodyPr>
+          <a:lstStyle/>
+          <a:p>
+            <a:pPr algn="l">
+              <a:lnSpc>
+                <a:spcPct val="115000"/>
+              </a:lnSpc>
+              <a:spcAft>
+                <a:spcPts val="800"/>
+              </a:spcAft>
+            </a:pPr>
+            <a:r>
+              <a:rPr sz="1100" b="1">
+                <a:solidFill>
+                  <a:srgbClr val="002060"/>
+                </a:solidFill>
+                <a:latin typeface="Calisto MT"/>
+              </a:rPr>
+              <a:t>• Tier 1: Sensory Input: </a:t>
+            </a:r>
+            <a:r>
+              <a:rPr sz="1100" b="0">
+                <a:solidFill>
+                  <a:srgbClr val="334155"/>
+                </a:solidFill>
+                <a:latin typeface="Calisto MT"/>
+              </a:rPr>
+              <a:t>Captures environmental data via 2MP wide-angle camera on 2-DOF gimbal, 360° planar LiDAR, and 6-axis IMU.</a:t>
+            </a:r>
+          </a:p>
+          <a:p>
+            <a:pPr algn="l">
+              <a:lnSpc>
+                <a:spcPct val="115000"/>
+              </a:lnSpc>
+              <a:spcAft>
+                <a:spcPts val="800"/>
+              </a:spcAft>
+            </a:pPr>
+            <a:r>
+              <a:rPr sz="1100" b="1">
+                <a:solidFill>
+                  <a:srgbClr val="002060"/>
+                </a:solidFill>
+                <a:latin typeface="Calisto MT"/>
+              </a:rPr>
+              <a:t>• Tier 2: Target Isolation: </a:t>
+            </a:r>
+            <a:r>
+              <a:rPr sz="1100" b="0">
+                <a:solidFill>
+                  <a:srgbClr val="334155"/>
+                </a:solidFill>
+                <a:latin typeface="Calisto MT"/>
+              </a:rPr>
+              <a:t>Centers on the active human operator in the field of view and tracks 21 hand joints in real time.</a:t>
+            </a:r>
+          </a:p>
+          <a:p>
+            <a:pPr algn="l">
+              <a:lnSpc>
+                <a:spcPct val="115000"/>
+              </a:lnSpc>
+              <a:spcAft>
+                <a:spcPts val="800"/>
+              </a:spcAft>
+            </a:pPr>
+            <a:r>
+              <a:rPr sz="1100" b="1">
+                <a:solidFill>
+                  <a:srgbClr val="002060"/>
+                </a:solidFill>
+                <a:latin typeface="Calisto MT"/>
+              </a:rPr>
+              <a:t>• Tier 3: Neural Classifier: </a:t>
+            </a:r>
+            <a:r>
+              <a:rPr sz="1100" b="0">
+                <a:solidFill>
+                  <a:srgbClr val="334155"/>
+                </a:solidFill>
+                <a:latin typeface="Calisto MT"/>
+              </a:rPr>
+              <a:t>Converts hand joints into 19 normalized geometric angles; classifies gestures in under 2 ms on the CPU.</a:t>
+            </a:r>
+          </a:p>
+          <a:p>
+            <a:pPr algn="l">
+              <a:lnSpc>
+                <a:spcPct val="115000"/>
+              </a:lnSpc>
+              <a:spcAft>
+                <a:spcPts val="800"/>
+              </a:spcAft>
+            </a:pPr>
+            <a:r>
+              <a:rPr sz="1100" b="1">
+                <a:solidFill>
+                  <a:srgbClr val="002060"/>
+                </a:solidFill>
+                <a:latin typeface="Calisto MT"/>
+              </a:rPr>
+              <a:t>• Tier 4: Supervisory Control: </a:t>
+            </a:r>
+            <a:r>
+              <a:rPr sz="1100" b="0">
+                <a:solidFill>
+                  <a:srgbClr val="334155"/>
+                </a:solidFill>
+                <a:latin typeface="Calisto MT"/>
+              </a:rPr>
+              <a:t>Filters accidental motions by confirming steady hand gestures; plans collision-free paths via Nav2.</a:t>
+            </a:r>
+          </a:p>
+          <a:p>
+            <a:pPr algn="l">
+              <a:lnSpc>
+                <a:spcPct val="115000"/>
+              </a:lnSpc>
+              <a:spcAft>
+                <a:spcPts val="800"/>
+              </a:spcAft>
+            </a:pPr>
+            <a:r>
+              <a:rPr sz="1100" b="1">
+                <a:solidFill>
+                  <a:srgbClr val="002060"/>
+                </a:solidFill>
+                <a:latin typeface="Calisto MT"/>
+              </a:rPr>
+              <a:t>• Tier 5: Motor Actuation: </a:t>
+            </a:r>
+            <a:r>
+              <a:rPr sz="1100" b="0">
+                <a:solidFill>
+                  <a:srgbClr val="334155"/>
+                </a:solidFill>
+                <a:latin typeface="Calisto MT"/>
+              </a:rPr>
+              <a:t>Dedicated ESP32-S3 co-processor receives driving commands over micro-ROS to control the 4 DC motors.</a:t>
+            </a:r>
+          </a:p>
+          <a:p>
+            <a:pPr algn="l">
+              <a:lnSpc>
+                <a:spcPct val="115000"/>
+              </a:lnSpc>
+              <a:spcAft>
+                <a:spcPts val="0"/>
+              </a:spcAft>
+            </a:pPr>
+            <a:r>
+              <a:rPr sz="1100" b="1">
+                <a:solidFill>
+                  <a:srgbClr val="B42828"/>
+                </a:solidFill>
+                <a:latin typeface="Calisto MT"/>
+              </a:rPr>
+              <a:t>• Reactive Safety Bypass: </a:t>
+            </a:r>
+            <a:r>
+              <a:rPr sz="1100" b="0">
+                <a:solidFill>
+                  <a:srgbClr val="334155"/>
+                </a:solidFill>
+                <a:latin typeface="Calisto MT"/>
+              </a:rPr>
+              <a:t>Direct laser safety interlock: immediately overrides driving commands and halts the robot if an obstacle is within 0.36 m.</a:t>
+            </a:r>
+          </a:p>
+        </p:txBody>
+      </p:sp>
+      <p:pic>
+        <p:nvPicPr>
+          <p:cNvPr id="6" name="Arch_Diagram_Img" descr="image.png"/>
+          <p:cNvPicPr>
+            <a:picLocks noChangeAspect="1"/>
+          </p:cNvPicPr>
+          <p:nvPr/>
+        </p:nvPicPr>
+        <p:blipFill>
+          <a:blip r:embed="rId2"/>
+          <a:stretch>
+            <a:fillRect/>
+          </a:stretch>
+        </p:blipFill>
+        <p:spPr>
+          <a:xfrm>
+            <a:off x="6812280" y="1261872"/>
+            <a:ext cx="4526280" cy="4297680"/>
+          </a:xfrm>
+          <a:prstGeom prst="rect">
+            <a:avLst/>
+          </a:prstGeom>
+        </p:spPr>
+      </p:pic>
+      <p:sp>
+        <p:nvSpPr>
+          <p:cNvPr id="7" name="Arch_Caption"/>
+          <p:cNvSpPr txBox="1"/>
+          <p:nvPr/>
+        </p:nvSpPr>
+        <p:spPr>
+          <a:xfrm>
+            <a:off x="6812280" y="5596128"/>
+            <a:ext cx="4526280" cy="228600"/>
+          </a:xfrm>
+          <a:prstGeom prst="rect">
+            <a:avLst/>
+          </a:prstGeom>
+          <a:noFill/>
+        </p:spPr>
+        <p:txBody>
+          <a:bodyPr wrap="square" lIns="0" rIns="0" tIns="0" bIns="0">
+            <a:spAutoFit/>
+          </a:bodyPr>
+          <a:lstStyle/>
+          <a:p>
+            <a:pPr algn="ctr">
+              <a:lnSpc>
+                <a:spcPct val="114000"/>
+              </a:lnSpc>
+              <a:spcBef>
+                <a:spcPts val="0"/>
+              </a:spcBef>
+              <a:spcAft>
+                <a:spcPts val="200"/>
+              </a:spcAft>
+              <a:defRPr sz="900" b="0" i="1">
+                <a:solidFill>
+                  <a:srgbClr val="64748B"/>
+                </a:solidFill>
+                <a:latin typeface="Calisto MT"/>
+              </a:defRPr>
+            </a:pPr>
+            <a:r>
+              <a:t>Figure 3.1: End-to-End Cognitive System Architecture &amp; Safety Interlock</a:t>
             </a:r>
           </a:p>
         </p:txBody>

</xml_diff>

<commit_message>
feat(slides): pivot Slide 8 to Software Architecture & Inter-Node Dataflow
</commit_message>
<xml_diff>
--- a/write_up/Project Final Defense Slides_FINAL.pptx
+++ b/write_up/Project Final Defense Slides_FINAL.pptx
@@ -5403,7 +5403,7 @@
               </a:defRPr>
             </a:pPr>
             <a:r>
-              <a:t>06. SYSTEM ARCHITECTURE &amp; COGNITIVE DATAFLOW</a:t>
+              <a:t>06. SOFTWARE ARCHITECTURE &amp; INTER-NODE DATAFLOW</a:t>
             </a:r>
           </a:p>
         </p:txBody>
@@ -5465,7 +5465,7 @@
               </a:defRPr>
             </a:pPr>
             <a:r>
-              <a:t>5-TIER MODULAR PIPELINE FROM RAW SENSING TO AUTONOMOUS WHEEL ACTUATION</a:t>
+              <a:t>MODULAR ROS 2 HUMBLE MIDDLEWARE, TOPIC PIPELINES &amp; HARDWARE BRIDGE</a:t>
             </a:r>
           </a:p>
         </p:txBody>
@@ -5507,7 +5507,7 @@
                 </a:solidFill>
                 <a:latin typeface="Calisto MT"/>
               </a:rPr>
-              <a:t>• Tier 1: Sensory Input: </a:t>
+              <a:t>• Middleware Core (ROS 2 Humble): </a:t>
             </a:r>
             <a:r>
               <a:rPr sz="1100" b="0">
@@ -5516,7 +5516,7 @@
                 </a:solidFill>
                 <a:latin typeface="Calisto MT"/>
               </a:rPr>
-              <a:t>Captures environmental data via 2MP wide-angle camera on 2-DOF gimbal, 360° planar LiDAR, and 6-axis IMU.</a:t>
+              <a:t>Executes modular software nodes communicating over asynchronous publish/subscribe topics on dedicated Domain 20.</a:t>
             </a:r>
           </a:p>
           <a:p>
@@ -5535,7 +5535,7 @@
                 </a:solidFill>
                 <a:latin typeface="Calisto MT"/>
               </a:rPr>
-              <a:t>• Tier 2: Target Isolation: </a:t>
+              <a:t>• Sensory Streaming: </a:t>
             </a:r>
             <a:r>
               <a:rPr sz="1100" b="0">
@@ -5544,7 +5544,7 @@
                 </a:solidFill>
                 <a:latin typeface="Calisto MT"/>
               </a:rPr>
-              <a:t>Centers on the active human operator in the field of view and tracks 21 hand joints in real time.</a:t>
+              <a:t>Camera and 2D LiDAR continuously stream uncompressed video (/camera/image_raw at 20 FPS) and laser scans (/scan at 12.5 Hz).</a:t>
             </a:r>
           </a:p>
           <a:p>
@@ -5563,7 +5563,7 @@
                 </a:solidFill>
                 <a:latin typeface="Calisto MT"/>
               </a:rPr>
-              <a:t>• Tier 3: Neural Classifier: </a:t>
+              <a:t>• Neural Perception Node: </a:t>
             </a:r>
             <a:r>
               <a:rPr sz="1100" b="0">
@@ -5572,7 +5572,7 @@
                 </a:solidFill>
                 <a:latin typeface="Calisto MT"/>
               </a:rPr>
-              <a:t>Converts hand joints into 19 normalized geometric angles; classifies gestures in under 2 ms on the CPU.</a:t>
+              <a:t>Consumes camera frames, extracts hand joint coordinates, and publishes discrete gesture tokens (/cognition/gesture).</a:t>
             </a:r>
           </a:p>
           <a:p>
@@ -5591,7 +5591,7 @@
                 </a:solidFill>
                 <a:latin typeface="Calisto MT"/>
               </a:rPr>
-              <a:t>• Tier 4: Supervisory Control: </a:t>
+              <a:t>• Supervisory Control (brain_node): </a:t>
             </a:r>
             <a:r>
               <a:rPr sz="1100" b="0">
@@ -5600,7 +5600,7 @@
                 </a:solidFill>
                 <a:latin typeface="Calisto MT"/>
               </a:rPr>
-              <a:t>Filters accidental motions by confirming steady hand gestures; plans collision-free paths via Nav2.</a:t>
+              <a:t>Filters accidental motions through multi-frame consensus and computes directional driving commands (/cmd_vel).</a:t>
             </a:r>
           </a:p>
           <a:p>
@@ -5619,7 +5619,7 @@
                 </a:solidFill>
                 <a:latin typeface="Calisto MT"/>
               </a:rPr>
-              <a:t>• Tier 5: Motor Actuation: </a:t>
+              <a:t>• Real-Time Bridge (micro-ROS): </a:t>
             </a:r>
             <a:r>
               <a:rPr sz="1100" b="0">
@@ -5628,7 +5628,7 @@
                 </a:solidFill>
                 <a:latin typeface="Calisto MT"/>
               </a:rPr>
-              <a:t>Dedicated ESP32-S3 co-processor receives driving commands over micro-ROS to control the 4 DC motors.</a:t>
+              <a:t>Streams velocity setpoints across a high-speed 921,600 baud serial UART link to the ESP32-S3 motor co-processor.</a:t>
             </a:r>
           </a:p>
           <a:p>
@@ -5647,7 +5647,7 @@
                 </a:solidFill>
                 <a:latin typeface="Calisto MT"/>
               </a:rPr>
-              <a:t>• Reactive Safety Bypass: </a:t>
+              <a:t>• Priority Multiplexer (twist_mux): </a:t>
             </a:r>
             <a:r>
               <a:rPr sz="1100" b="0">
@@ -5656,7 +5656,7 @@
                 </a:solidFill>
                 <a:latin typeface="Calisto MT"/>
               </a:rPr>
-              <a:t>Direct laser safety interlock: immediately overrides driving commands and halts the robot if an obstacle is within 0.36 m.</a:t>
+              <a:t>Hardware safety monitor immediately preempts autonomous gestures and halts the robot if a LiDAR obstacle is within 0.36 m.</a:t>
             </a:r>
           </a:p>
         </p:txBody>

</xml_diff>

<commit_message>
feat(slides): add publication-grade monochrome flowchart and ROS 2 software discussion on Slide 8
</commit_message>
<xml_diff>
--- a/write_up/Project Final Defense Slides_FINAL.pptx
+++ b/write_up/Project Final Defense Slides_FINAL.pptx
@@ -5479,7 +5479,7 @@
         <p:spPr>
           <a:xfrm>
             <a:off x="777240" y="1261872"/>
-            <a:ext cx="5806440" cy="4297680"/>
+            <a:ext cx="5897880" cy="4297680"/>
           </a:xfrm>
           <a:prstGeom prst="rect">
             <a:avLst/>
@@ -5516,7 +5516,7 @@
                 </a:solidFill>
                 <a:latin typeface="Calisto MT"/>
               </a:rPr>
-              <a:t>Executes modular software nodes communicating over asynchronous publish/subscribe topics on dedicated Domain 20.</a:t>
+              <a:t>Distributed node graph operating on dedicated communication Domain 20 to eliminate cross-talk and network packet drops.</a:t>
             </a:r>
           </a:p>
           <a:p>
@@ -5535,7 +5535,7 @@
                 </a:solidFill>
                 <a:latin typeface="Calisto MT"/>
               </a:rPr>
-              <a:t>• Sensory Streaming: </a:t>
+              <a:t>• Topic-Based Dataflow: </a:t>
             </a:r>
             <a:r>
               <a:rPr sz="1100" b="0">
@@ -5544,7 +5544,7 @@
                 </a:solidFill>
                 <a:latin typeface="Calisto MT"/>
               </a:rPr>
-              <a:t>Camera and 2D LiDAR continuously stream uncompressed video (/camera/image_raw at 20 FPS) and laser scans (/scan at 12.5 Hz).</a:t>
+              <a:t>Decouples sensor drivers from AI nodes using standardized publish/subscribe messages (/camera/image_raw at 20 FPS, /scan at 12.5 Hz).</a:t>
             </a:r>
           </a:p>
           <a:p>
@@ -5563,7 +5563,7 @@
                 </a:solidFill>
                 <a:latin typeface="Calisto MT"/>
               </a:rPr>
-              <a:t>• Neural Perception Node: </a:t>
+              <a:t>• Neural Perception Pipeline: </a:t>
             </a:r>
             <a:r>
               <a:rPr sz="1100" b="0">
@@ -5572,7 +5572,7 @@
                 </a:solidFill>
                 <a:latin typeface="Calisto MT"/>
               </a:rPr>
-              <a:t>Consumes camera frames, extracts hand joint coordinates, and publishes discrete gesture tokens (/cognition/gesture).</a:t>
+              <a:t>YOLOv8 isolates the operator in the central HUD; gesture_node extracts 21 hand landmarks and publishes /cognition/gesture.</a:t>
             </a:r>
           </a:p>
           <a:p>
@@ -5591,7 +5591,7 @@
                 </a:solidFill>
                 <a:latin typeface="Calisto MT"/>
               </a:rPr>
-              <a:t>• Supervisory Control (brain_node): </a:t>
+              <a:t>• Supervisory Consensus (brain_node): </a:t>
             </a:r>
             <a:r>
               <a:rPr sz="1100" b="0">
@@ -5600,7 +5600,7 @@
                 </a:solidFill>
                 <a:latin typeface="Calisto MT"/>
               </a:rPr>
-              <a:t>Filters accidental motions through multi-frame consensus and computes directional driving commands (/cmd_vel).</a:t>
+              <a:t>Finite state machine requires 5 consecutive identical gesture frames before committing, filtering out accidental hand motions.</a:t>
             </a:r>
           </a:p>
           <a:p>
@@ -5619,7 +5619,7 @@
                 </a:solidFill>
                 <a:latin typeface="Calisto MT"/>
               </a:rPr>
-              <a:t>• Real-Time Bridge (micro-ROS): </a:t>
+              <a:t>• Priority Command Mux (twist_mux): </a:t>
             </a:r>
             <a:r>
               <a:rPr sz="1100" b="0">
@@ -5628,7 +5628,7 @@
                 </a:solidFill>
                 <a:latin typeface="Calisto MT"/>
               </a:rPr>
-              <a:t>Streams velocity setpoints across a high-speed 921,600 baud serial UART link to the ESP32-S3 motor co-processor.</a:t>
+              <a:t>Hardware safety layer assigning absolute priority (100) to LiDAR obstacle halts over autonomous gesture driving commands (40).</a:t>
             </a:r>
           </a:p>
           <a:p>
@@ -5643,11 +5643,11 @@
             <a:r>
               <a:rPr sz="1100" b="1">
                 <a:solidFill>
-                  <a:srgbClr val="B42828"/>
-                </a:solidFill>
-                <a:latin typeface="Calisto MT"/>
-              </a:rPr>
-              <a:t>• Priority Multiplexer (twist_mux): </a:t>
+                  <a:srgbClr val="002060"/>
+                </a:solidFill>
+                <a:latin typeface="Calisto MT"/>
+              </a:rPr>
+              <a:t>• Embedded micro-ROS Bridge: </a:t>
             </a:r>
             <a:r>
               <a:rPr sz="1100" b="0">
@@ -5656,29 +5656,29 @@
                 </a:solidFill>
                 <a:latin typeface="Calisto MT"/>
               </a:rPr>
-              <a:t>Hardware safety monitor immediately preempts autonomous gestures and halts the robot if a LiDAR obstacle is within 0.36 m.</a:t>
+              <a:t>Streams velocity setpoints across a high-speed 921,600 baud serial UART link to the ESP32-S3 real-time motor co-processor.</a:t>
             </a:r>
           </a:p>
         </p:txBody>
       </p:sp>
       <p:pic>
         <p:nvPicPr>
-          <p:cNvPr id="6" name="Arch_Diagram_Img" descr="image.png"/>
+          <p:cNvPr id="6" name="Arch_Diagram_Img" descr="software_flowchart.png"/>
           <p:cNvPicPr>
             <a:picLocks noChangeAspect="1"/>
           </p:cNvPicPr>
           <p:nvPr/>
         </p:nvPicPr>
         <p:blipFill>
-          <a:blip r:embed="rId2"/>
+          <a:blip r:embed="rId4"/>
           <a:stretch>
             <a:fillRect/>
           </a:stretch>
         </p:blipFill>
         <p:spPr>
           <a:xfrm>
-            <a:off x="6812280" y="1261872"/>
-            <a:ext cx="4526280" cy="4297680"/>
+            <a:off x="6903720" y="1261872"/>
+            <a:ext cx="4434840" cy="4251960"/>
           </a:xfrm>
           <a:prstGeom prst="rect">
             <a:avLst/>
@@ -5693,8 +5693,8 @@
         </p:nvSpPr>
         <p:spPr>
           <a:xfrm>
-            <a:off x="6812280" y="5596128"/>
-            <a:ext cx="4526280" cy="228600"/>
+            <a:off x="6903720" y="5577840"/>
+            <a:ext cx="4434840" cy="228600"/>
           </a:xfrm>
           <a:prstGeom prst="rect">
             <a:avLst/>
@@ -5725,7 +5725,7 @@
               </a:defRPr>
             </a:pPr>
             <a:r>
-              <a:t>Figure 3.1: End-to-End Cognitive System Architecture &amp; Safety Interlock</a:t>
+              <a:t>Figure 3.1: ROS 2 Software Node Flowchart &amp; Priority Decision Dataflow</a:t>
             </a:r>
           </a:p>
         </p:txBody>

</xml_diff>

<commit_message>
fix(slides): translate Slide 8 text and flowchart into plain English without jargon
</commit_message>
<xml_diff>
--- a/write_up/Project Final Defense Slides_FINAL.pptx
+++ b/write_up/Project Final Defense Slides_FINAL.pptx
@@ -5465,7 +5465,7 @@
               </a:defRPr>
             </a:pPr>
             <a:r>
-              <a:t>MODULAR ROS 2 HUMBLE MIDDLEWARE, TOPIC PIPELINES &amp; HARDWARE BRIDGE</a:t>
+              <a:t>HOW THE ROBOT PROCESSES SENSOR DATA AND MAKES SAFE DRIVING DECISIONS</a:t>
             </a:r>
           </a:p>
         </p:txBody>
@@ -5507,7 +5507,7 @@
                 </a:solidFill>
                 <a:latin typeface="Calisto MT"/>
               </a:rPr>
-              <a:t>• Middleware Core (ROS 2 Humble): </a:t>
+              <a:t>• System Software (ROS 2): </a:t>
             </a:r>
             <a:r>
               <a:rPr sz="1100" b="0">
@@ -5516,7 +5516,7 @@
                 </a:solidFill>
                 <a:latin typeface="Calisto MT"/>
               </a:rPr>
-              <a:t>Distributed node graph operating on dedicated communication Domain 20 to eliminate cross-talk and network packet drops.</a:t>
+              <a:t>Connects all camera, artificial intelligence, and motor programs so they exchange data instantly without delays.</a:t>
             </a:r>
           </a:p>
           <a:p>
@@ -5535,7 +5535,7 @@
                 </a:solidFill>
                 <a:latin typeface="Calisto MT"/>
               </a:rPr>
-              <a:t>• Topic-Based Dataflow: </a:t>
+              <a:t>• Live Sensor Feeds: </a:t>
             </a:r>
             <a:r>
               <a:rPr sz="1100" b="0">
@@ -5544,7 +5544,7 @@
                 </a:solidFill>
                 <a:latin typeface="Calisto MT"/>
               </a:rPr>
-              <a:t>Decouples sensor drivers from AI nodes using standardized publish/subscribe messages (/camera/image_raw at 20 FPS, /scan at 12.5 Hz).</a:t>
+              <a:t>The camera captures live video at 20 frames per second while the laser sensor constantly scans 360 degrees for obstacles.</a:t>
             </a:r>
           </a:p>
           <a:p>
@@ -5563,7 +5563,7 @@
                 </a:solidFill>
                 <a:latin typeface="Calisto MT"/>
               </a:rPr>
-              <a:t>• Neural Perception Pipeline: </a:t>
+              <a:t>• Vision &amp; Hand Tracking: </a:t>
             </a:r>
             <a:r>
               <a:rPr sz="1100" b="0">
@@ -5572,7 +5572,7 @@
                 </a:solidFill>
                 <a:latin typeface="Calisto MT"/>
               </a:rPr>
-              <a:t>YOLOv8 isolates the operator in the central HUD; gesture_node extracts 21 hand landmarks and publishes /cognition/gesture.</a:t>
+              <a:t>Focuses on the person standing in front of the robot, locates 21 finger joints, and identifies the gesture being shown.</a:t>
             </a:r>
           </a:p>
           <a:p>
@@ -5591,7 +5591,7 @@
                 </a:solidFill>
                 <a:latin typeface="Calisto MT"/>
               </a:rPr>
-              <a:t>• Supervisory Consensus (brain_node): </a:t>
+              <a:t>• Gesture Confirmation: </a:t>
             </a:r>
             <a:r>
               <a:rPr sz="1100" b="0">
@@ -5600,7 +5600,7 @@
                 </a:solidFill>
                 <a:latin typeface="Calisto MT"/>
               </a:rPr>
-              <a:t>Finite state machine requires 5 consecutive identical gesture frames before committing, filtering out accidental hand motions.</a:t>
+              <a:t>The robot checks that it sees the exact same gesture 5 times in a row before moving, ignoring accidental hand motions.</a:t>
             </a:r>
           </a:p>
           <a:p>
@@ -5619,7 +5619,7 @@
                 </a:solidFill>
                 <a:latin typeface="Calisto MT"/>
               </a:rPr>
-              <a:t>• Priority Command Mux (twist_mux): </a:t>
+              <a:t>• Safety Override: </a:t>
             </a:r>
             <a:r>
               <a:rPr sz="1100" b="0">
@@ -5628,7 +5628,7 @@
                 </a:solidFill>
                 <a:latin typeface="Calisto MT"/>
               </a:rPr>
-              <a:t>Hardware safety layer assigning absolute priority (100) to LiDAR obstacle halts over autonomous gesture driving commands (40).</a:t>
+              <a:t>If the laser detects any obstacle closer than 0.36 meters, it instantly overrides driving commands and halts the robot immediately.</a:t>
             </a:r>
           </a:p>
           <a:p>
@@ -5647,7 +5647,7 @@
                 </a:solidFill>
                 <a:latin typeface="Calisto MT"/>
               </a:rPr>
-              <a:t>• Embedded micro-ROS Bridge: </a:t>
+              <a:t>• Smooth Wheel Control: </a:t>
             </a:r>
             <a:r>
               <a:rPr sz="1100" b="0">
@@ -5656,7 +5656,7 @@
                 </a:solidFill>
                 <a:latin typeface="Calisto MT"/>
               </a:rPr>
-              <a:t>Streams velocity setpoints across a high-speed 921,600 baud serial UART link to the ESP32-S3 real-time motor co-processor.</a:t>
+              <a:t>Approved movement commands are transmitted directly to the motor controller board, which drives the 4 wheels smoothly.</a:t>
             </a:r>
           </a:p>
         </p:txBody>
@@ -5670,7 +5670,7 @@
           <p:nvPr/>
         </p:nvPicPr>
         <p:blipFill>
-          <a:blip r:embed="rId4"/>
+          <a:blip r:embed="rId5"/>
           <a:stretch>
             <a:fillRect/>
           </a:stretch>
@@ -5725,7 +5725,7 @@
               </a:defRPr>
             </a:pPr>
             <a:r>
-              <a:t>Figure 3.1: ROS 2 Software Node Flowchart &amp; Priority Decision Dataflow</a:t>
+              <a:t>Figure 3.1: Dataflow Pipeline from Sensor Feeds to Wheel Actuation</a:t>
             </a:r>
           </a:p>
         </p:txBody>

</xml_diff>

<commit_message>
feat: complete Slide 9 (Mechatronic Hardware & Power Distribution)
</commit_message>
<xml_diff>
--- a/write_up/Project Final Defense Slides_FINAL.pptx
+++ b/write_up/Project Final Defense Slides_FINAL.pptx
@@ -16,6 +16,7 @@
     <p:sldId id="562" r:id="rId13"/>
     <p:sldId id="563" r:id="rId14"/>
     <p:sldId id="564" r:id="rId15"/>
+    <p:sldId id="565" r:id="rId16"/>
   </p:sldIdLst>
   <p:sldSz cx="12192000" cy="6858000"/>
   <p:notesSz cx="6858000" cy="9144000"/>
@@ -5726,6 +5727,496 @@
             </a:pPr>
             <a:r>
               <a:t>Figure 3.1: Dataflow Pipeline from Sensor Feeds to Wheel Actuation</a:t>
+            </a:r>
+          </a:p>
+        </p:txBody>
+      </p:sp>
+    </p:spTree>
+  </p:cSld>
+  <p:clrMapOvr>
+    <a:masterClrMapping/>
+  </p:clrMapOvr>
+</p:sld>
+</file>
+
+<file path=ppt/slides/slide9.xml><?xml version="1.0" encoding="utf-8"?>
+<p:sld xmlns:a="http://schemas.openxmlformats.org/drawingml/2006/main" xmlns:p="http://schemas.openxmlformats.org/presentationml/2006/main" xmlns:r="http://schemas.openxmlformats.org/officeDocument/2006/relationships">
+  <p:cSld>
+    <p:spTree>
+      <p:nvGrpSpPr>
+        <p:cNvPr id="1" name=""/>
+        <p:cNvGrpSpPr/>
+        <p:nvPr/>
+      </p:nvGrpSpPr>
+      <p:grpSpPr/>
+      <p:sp>
+        <p:nvSpPr>
+          <p:cNvPr id="2" name="Title 1"/>
+          <p:cNvSpPr>
+            <a:spLocks noGrp="1"/>
+          </p:cNvSpPr>
+          <p:nvPr>
+            <p:ph type="title"/>
+          </p:nvPr>
+        </p:nvSpPr>
+        <p:spPr>
+          <a:xfrm>
+            <a:off x="603504" y="320040"/>
+            <a:ext cx="10972800" cy="548640"/>
+          </a:xfrm>
+        </p:spPr>
+        <p:txBody>
+          <a:bodyPr/>
+          <a:lstStyle/>
+          <a:p>
+            <a:pPr algn="ctr">
+              <a:lnSpc>
+                <a:spcPct val="114000"/>
+              </a:lnSpc>
+              <a:spcBef>
+                <a:spcPts val="0"/>
+              </a:spcBef>
+              <a:spcAft>
+                <a:spcPts val="200"/>
+              </a:spcAft>
+              <a:defRPr sz="2400" b="1" i="0">
+                <a:solidFill>
+                  <a:srgbClr val="002060"/>
+                </a:solidFill>
+                <a:latin typeface="Calisto MT"/>
+              </a:defRPr>
+            </a:pPr>
+            <a:r>
+              <a:t>07. MECHATRONIC HARDWARE &amp; POWER DISTRIBUTION</a:t>
+            </a:r>
+          </a:p>
+        </p:txBody>
+      </p:sp>
+      <p:sp>
+        <p:nvSpPr>
+          <p:cNvPr id="3" name="Content Placeholder 2"/>
+          <p:cNvSpPr>
+            <a:spLocks noGrp="1"/>
+          </p:cNvSpPr>
+          <p:nvPr>
+            <p:ph idx="1"/>
+          </p:nvPr>
+        </p:nvSpPr>
+        <p:spPr/>
+        <p:txBody>
+          <a:bodyPr/>
+          <a:lstStyle/>
+          <a:p/>
+        </p:txBody>
+      </p:sp>
+      <p:sp>
+        <p:nvSpPr>
+          <p:cNvPr id="4" name="Hw_Subhead"/>
+          <p:cNvSpPr txBox="1"/>
+          <p:nvPr/>
+        </p:nvSpPr>
+        <p:spPr>
+          <a:xfrm>
+            <a:off x="777240" y="960120"/>
+            <a:ext cx="10634472" cy="228600"/>
+          </a:xfrm>
+          <a:prstGeom prst="rect">
+            <a:avLst/>
+          </a:prstGeom>
+          <a:noFill/>
+        </p:spPr>
+        <p:txBody>
+          <a:bodyPr wrap="square" lIns="0" rIns="0" tIns="0" bIns="0">
+            <a:spAutoFit/>
+          </a:bodyPr>
+          <a:lstStyle/>
+          <a:p>
+            <a:pPr algn="l">
+              <a:lnSpc>
+                <a:spcPct val="114000"/>
+              </a:lnSpc>
+              <a:spcBef>
+                <a:spcPts val="0"/>
+              </a:spcBef>
+              <a:spcAft>
+                <a:spcPts val="200"/>
+              </a:spcAft>
+              <a:defRPr sz="1100" b="1" i="0">
+                <a:solidFill>
+                  <a:srgbClr val="B8860B"/>
+                </a:solidFill>
+                <a:latin typeface="Calisto MT"/>
+              </a:defRPr>
+            </a:pPr>
+            <a:r>
+              <a:t>PHYSICAL EMBEDDED COMPUTING, SENSORS, CHASSIS &amp; POWER ISOLATION</a:t>
+            </a:r>
+          </a:p>
+        </p:txBody>
+      </p:sp>
+      <p:sp>
+        <p:nvSpPr>
+          <p:cNvPr id="5" name="Hw_Points_Text"/>
+          <p:cNvSpPr txBox="1"/>
+          <p:nvPr/>
+        </p:nvSpPr>
+        <p:spPr>
+          <a:xfrm>
+            <a:off x="777240" y="1261872"/>
+            <a:ext cx="5897880" cy="4297680"/>
+          </a:xfrm>
+          <a:prstGeom prst="rect">
+            <a:avLst/>
+          </a:prstGeom>
+          <a:noFill/>
+        </p:spPr>
+        <p:txBody>
+          <a:bodyPr wrap="square" lIns="18288" rIns="18288" tIns="18288" bIns="18288">
+            <a:spAutoFit/>
+          </a:bodyPr>
+          <a:lstStyle/>
+          <a:p>
+            <a:pPr algn="l">
+              <a:lnSpc>
+                <a:spcPct val="115000"/>
+              </a:lnSpc>
+              <a:spcAft>
+                <a:spcPts val="700"/>
+              </a:spcAft>
+            </a:pPr>
+            <a:r>
+              <a:rPr sz="1100" b="1">
+                <a:solidFill>
+                  <a:srgbClr val="002060"/>
+                </a:solidFill>
+                <a:latin typeface="Calisto MT"/>
+              </a:rPr>
+              <a:t>• Onboard Computer (Raspberry Pi 5): </a:t>
+            </a:r>
+            <a:r>
+              <a:rPr sz="1100" b="0">
+                <a:solidFill>
+                  <a:srgbClr val="334155"/>
+                </a:solidFill>
+                <a:latin typeface="Calisto MT"/>
+              </a:rPr>
+              <a:t>8GB RAM single-board computer running all camera tracking, gesture artificial intelligence, and navigation programs directly on the robot.</a:t>
+            </a:r>
+          </a:p>
+          <a:p>
+            <a:pPr algn="l">
+              <a:lnSpc>
+                <a:spcPct val="115000"/>
+              </a:lnSpc>
+              <a:spcAft>
+                <a:spcPts val="700"/>
+              </a:spcAft>
+            </a:pPr>
+            <a:r>
+              <a:rPr sz="1100" b="1">
+                <a:solidFill>
+                  <a:srgbClr val="002060"/>
+                </a:solidFill>
+                <a:latin typeface="Calisto MT"/>
+              </a:rPr>
+              <a:t>• Motor Controller (ESP32-S3): </a:t>
+            </a:r>
+            <a:r>
+              <a:rPr sz="1100" b="0">
+                <a:solidFill>
+                  <a:srgbClr val="334155"/>
+                </a:solidFill>
+                <a:latin typeface="Calisto MT"/>
+              </a:rPr>
+              <a:t>Dedicated microcontroller that manages wheel speed and reads motor sensors smoothly without overloading the main computer.</a:t>
+            </a:r>
+          </a:p>
+          <a:p>
+            <a:pPr algn="l">
+              <a:lnSpc>
+                <a:spcPct val="115000"/>
+              </a:lnSpc>
+              <a:spcAft>
+                <a:spcPts val="700"/>
+              </a:spcAft>
+            </a:pPr>
+            <a:r>
+              <a:rPr sz="1100" b="1">
+                <a:solidFill>
+                  <a:srgbClr val="002060"/>
+                </a:solidFill>
+                <a:latin typeface="Calisto MT"/>
+              </a:rPr>
+              <a:t>• Laser Scanner (MS200 LiDAR): </a:t>
+            </a:r>
+            <a:r>
+              <a:rPr sz="1100" b="0">
+                <a:solidFill>
+                  <a:srgbClr val="334155"/>
+                </a:solidFill>
+                <a:latin typeface="Calisto MT"/>
+              </a:rPr>
+              <a:t>360-degree laser sensor measuring room distances up to 12 meters for indoor mapping and instant emergency stops.</a:t>
+            </a:r>
+          </a:p>
+          <a:p>
+            <a:pPr algn="l">
+              <a:lnSpc>
+                <a:spcPct val="115000"/>
+              </a:lnSpc>
+              <a:spcAft>
+                <a:spcPts val="700"/>
+              </a:spcAft>
+            </a:pPr>
+            <a:r>
+              <a:rPr sz="1100" b="1">
+                <a:solidFill>
+                  <a:srgbClr val="002060"/>
+                </a:solidFill>
+                <a:latin typeface="Calisto MT"/>
+              </a:rPr>
+              <a:t>• Motorized Camera Mount: </a:t>
+            </a:r>
+            <a:r>
+              <a:rPr sz="1100" b="0">
+                <a:solidFill>
+                  <a:srgbClr val="334155"/>
+                </a:solidFill>
+                <a:latin typeface="Calisto MT"/>
+              </a:rPr>
+              <a:t>2-axis motorized camera gimbal that tilts and pans automatically to keep the operator's face and hands centered in view.</a:t>
+            </a:r>
+          </a:p>
+          <a:p>
+            <a:pPr algn="l">
+              <a:lnSpc>
+                <a:spcPct val="115000"/>
+              </a:lnSpc>
+              <a:spcAft>
+                <a:spcPts val="700"/>
+              </a:spcAft>
+            </a:pPr>
+            <a:r>
+              <a:rPr sz="1100" b="1">
+                <a:solidFill>
+                  <a:srgbClr val="002060"/>
+                </a:solidFill>
+                <a:latin typeface="Calisto MT"/>
+              </a:rPr>
+              <a:t>• 4-Wheel Drive Chassis: </a:t>
+            </a:r>
+            <a:r>
+              <a:rPr sz="1100" b="0">
+                <a:solidFill>
+                  <a:srgbClr val="334155"/>
+                </a:solidFill>
+                <a:latin typeface="Calisto MT"/>
+              </a:rPr>
+              <a:t>Sturdy aluminium robot base powered by 4 geared DC motors with wheel sensors for smooth and steady movement.</a:t>
+            </a:r>
+          </a:p>
+          <a:p>
+            <a:pPr algn="l">
+              <a:lnSpc>
+                <a:spcPct val="115000"/>
+              </a:lnSpc>
+              <a:spcAft>
+                <a:spcPts val="0"/>
+              </a:spcAft>
+            </a:pPr>
+            <a:r>
+              <a:rPr sz="1100" b="1">
+                <a:solidFill>
+                  <a:srgbClr val="002060"/>
+                </a:solidFill>
+                <a:latin typeface="Calisto MT"/>
+              </a:rPr>
+              <a:t>• Dual-Rail Power System: </a:t>
+            </a:r>
+            <a:r>
+              <a:rPr sz="1100" b="0">
+                <a:solidFill>
+                  <a:srgbClr val="334155"/>
+                </a:solidFill>
+                <a:latin typeface="Calisto MT"/>
+              </a:rPr>
+              <a:t>Separate battery power circuits for the computer and motors to prevent electrical interference and sudden power shutdowns.</a:t>
+            </a:r>
+          </a:p>
+        </p:txBody>
+      </p:sp>
+      <p:pic>
+        <p:nvPicPr>
+          <p:cNvPr id="6" name="Hw_Photo_Img" descr="image.jpg"/>
+          <p:cNvPicPr>
+            <a:picLocks noChangeAspect="1"/>
+          </p:cNvPicPr>
+          <p:nvPr/>
+        </p:nvPicPr>
+        <p:blipFill>
+          <a:blip r:embed="rId2"/>
+          <a:stretch>
+            <a:fillRect/>
+          </a:stretch>
+        </p:blipFill>
+        <p:spPr>
+          <a:xfrm>
+            <a:off x="6839712" y="1261872"/>
+            <a:ext cx="4572000" cy="3209544"/>
+          </a:xfrm>
+          <a:prstGeom prst="rect">
+            <a:avLst/>
+          </a:prstGeom>
+        </p:spPr>
+      </p:pic>
+      <p:sp>
+        <p:nvSpPr>
+          <p:cNvPr id="7" name="Hw_Caption"/>
+          <p:cNvSpPr txBox="1"/>
+          <p:nvPr/>
+        </p:nvSpPr>
+        <p:spPr>
+          <a:xfrm>
+            <a:off x="6839712" y="4517136"/>
+            <a:ext cx="4572000" cy="201168"/>
+          </a:xfrm>
+          <a:prstGeom prst="rect">
+            <a:avLst/>
+          </a:prstGeom>
+          <a:noFill/>
+        </p:spPr>
+        <p:txBody>
+          <a:bodyPr wrap="square" lIns="0" rIns="0" tIns="0" bIns="0">
+            <a:spAutoFit/>
+          </a:bodyPr>
+          <a:lstStyle/>
+          <a:p>
+            <a:pPr algn="ctr">
+              <a:lnSpc>
+                <a:spcPct val="114000"/>
+              </a:lnSpc>
+              <a:spcBef>
+                <a:spcPts val="0"/>
+              </a:spcBef>
+              <a:spcAft>
+                <a:spcPts val="200"/>
+              </a:spcAft>
+              <a:defRPr sz="900" b="0" i="1">
+                <a:solidFill>
+                  <a:srgbClr val="64748B"/>
+                </a:solidFill>
+                <a:latin typeface="Calisto MT"/>
+              </a:defRPr>
+            </a:pPr>
+            <a:r>
+              <a:t>Figure 3.2: Assembled 4WD Mobile Robot with Active Vision &amp; 2D LiDAR</a:t>
+            </a:r>
+          </a:p>
+        </p:txBody>
+      </p:sp>
+      <p:sp>
+        <p:nvSpPr>
+          <p:cNvPr id="8" name="Hw_Specs_Text"/>
+          <p:cNvSpPr txBox="1"/>
+          <p:nvPr/>
+        </p:nvSpPr>
+        <p:spPr>
+          <a:xfrm>
+            <a:off x="6839712" y="4773168"/>
+            <a:ext cx="4572000" cy="804672"/>
+          </a:xfrm>
+          <a:prstGeom prst="rect">
+            <a:avLst/>
+          </a:prstGeom>
+          <a:noFill/>
+        </p:spPr>
+        <p:txBody>
+          <a:bodyPr wrap="square" lIns="0" rIns="0" tIns="0" bIns="0">
+            <a:spAutoFit/>
+          </a:bodyPr>
+          <a:lstStyle/>
+          <a:p>
+            <a:pPr algn="l">
+              <a:lnSpc>
+                <a:spcPct val="112000"/>
+              </a:lnSpc>
+              <a:spcAft>
+                <a:spcPts val="300"/>
+              </a:spcAft>
+            </a:pPr>
+            <a:r>
+              <a:rPr sz="950" b="1">
+                <a:solidFill>
+                  <a:srgbClr val="002060"/>
+                </a:solidFill>
+                <a:latin typeface="Calisto MT"/>
+              </a:rPr>
+              <a:t>• Dimensions &amp; Mass: </a:t>
+            </a:r>
+            <a:r>
+              <a:rPr sz="950" b="0">
+                <a:solidFill>
+                  <a:srgbClr val="334155"/>
+                </a:solidFill>
+                <a:latin typeface="Calisto MT"/>
+              </a:rPr>
+              <a:t>220 × 180 × 165 mm | Total Platform Weight: 1.65 kg</a:t>
+            </a:r>
+          </a:p>
+          <a:p>
+            <a:pPr algn="l">
+              <a:lnSpc>
+                <a:spcPct val="112000"/>
+              </a:lnSpc>
+              <a:spcAft>
+                <a:spcPts val="300"/>
+              </a:spcAft>
+            </a:pPr>
+            <a:r>
+              <a:rPr sz="950" b="1">
+                <a:solidFill>
+                  <a:srgbClr val="002060"/>
+                </a:solidFill>
+                <a:latin typeface="Calisto MT"/>
+              </a:rPr>
+              <a:t>• Operating Speeds: </a:t>
+            </a:r>
+            <a:r>
+              <a:rPr sz="950" b="0">
+                <a:solidFill>
+                  <a:srgbClr val="334155"/>
+                </a:solidFill>
+                <a:latin typeface="Calisto MT"/>
+              </a:rPr>
+              <a:t>0.20 m/s cruise speed | ±0.50 rad/s rotation | 98 ms halt</a:t>
+            </a:r>
+          </a:p>
+          <a:p>
+            <a:pPr algn="l">
+              <a:lnSpc>
+                <a:spcPct val="112000"/>
+              </a:lnSpc>
+              <a:spcAft>
+                <a:spcPts val="0"/>
+              </a:spcAft>
+            </a:pPr>
+            <a:r>
+              <a:rPr sz="950" b="1">
+                <a:solidFill>
+                  <a:srgbClr val="002060"/>
+                </a:solidFill>
+                <a:latin typeface="Calisto MT"/>
+              </a:rPr>
+              <a:t>• Power Isolation: </a:t>
+            </a:r>
+            <a:r>
+              <a:rPr sz="950" b="0">
+                <a:solidFill>
+                  <a:srgbClr val="334155"/>
+                </a:solidFill>
+                <a:latin typeface="Calisto MT"/>
+              </a:rPr>
+              <a:t>7.4V Li-ion (2000 mAh) with dedicated 5V/5A buck converter</a:t>
             </a:r>
           </a:p>
         </p:txBody>

</xml_diff>

<commit_message>
refactor: optimize Slide 9 with clean side-by-side uncased and assembled robot photos
</commit_message>
<xml_diff>
--- a/write_up/Project Final Defense Slides_FINAL.pptx
+++ b/write_up/Project Final Defense Slides_FINAL.pptx
@@ -5863,7 +5863,7 @@
         <p:spPr>
           <a:xfrm>
             <a:off x="777240" y="1261872"/>
-            <a:ext cx="5897880" cy="4297680"/>
+            <a:ext cx="5394960" cy="4297680"/>
           </a:xfrm>
           <a:prstGeom prst="rect">
             <a:avLst/>
@@ -6047,22 +6047,22 @@
       </p:sp>
       <p:pic>
         <p:nvPicPr>
-          <p:cNvPr id="6" name="Hw_Photo_Img" descr="image.jpg"/>
+          <p:cNvPr id="6" name="Hw_Photo_Wired" descr="image.jpg"/>
           <p:cNvPicPr>
             <a:picLocks noChangeAspect="1"/>
           </p:cNvPicPr>
           <p:nvPr/>
         </p:nvPicPr>
         <p:blipFill>
-          <a:blip r:embed="rId2"/>
+          <a:blip r:embed="rId5"/>
           <a:stretch>
             <a:fillRect/>
           </a:stretch>
         </p:blipFill>
         <p:spPr>
           <a:xfrm>
-            <a:off x="6839712" y="1261872"/>
-            <a:ext cx="4572000" cy="3209544"/>
+            <a:off x="6492240" y="1371600"/>
+            <a:ext cx="2633472" cy="2286000"/>
           </a:xfrm>
           <a:prstGeom prst="rect">
             <a:avLst/>
@@ -6071,14 +6071,14 @@
       </p:pic>
       <p:sp>
         <p:nvSpPr>
-          <p:cNvPr id="7" name="Hw_Caption"/>
+          <p:cNvPr id="7" name="Hw_Cap_Wired"/>
           <p:cNvSpPr txBox="1"/>
           <p:nvPr/>
         </p:nvSpPr>
         <p:spPr>
           <a:xfrm>
-            <a:off x="6839712" y="4517136"/>
-            <a:ext cx="4572000" cy="201168"/>
+            <a:off x="6492240" y="3749039"/>
+            <a:ext cx="2633472" cy="411480"/>
           </a:xfrm>
           <a:prstGeom prst="rect">
             <a:avLst/>
@@ -6109,21 +6109,49 @@
               </a:defRPr>
             </a:pPr>
             <a:r>
-              <a:t>Figure 3.2: Assembled 4WD Mobile Robot with Active Vision &amp; 2D LiDAR</a:t>
-            </a:r>
-          </a:p>
-        </p:txBody>
-      </p:sp>
-      <p:sp>
-        <p:nvSpPr>
-          <p:cNvPr id="8" name="Hw_Specs_Text"/>
+              <a:t>Figure 3.2: Internal Electronics Stack</a:t>
+            </a:r>
+            <a:br/>
+            <a:r>
+              <a:t>(Raspberry Pi 5, ESP32-S3 &amp; Motor Drivers)</a:t>
+            </a:r>
+          </a:p>
+        </p:txBody>
+      </p:sp>
+      <p:pic>
+        <p:nvPicPr>
+          <p:cNvPr id="8" name="Hw_Photo_Assembled" descr="image.jpg"/>
+          <p:cNvPicPr>
+            <a:picLocks noChangeAspect="1"/>
+          </p:cNvPicPr>
+          <p:nvPr/>
+        </p:nvPicPr>
+        <p:blipFill>
+          <a:blip r:embed="rId6"/>
+          <a:stretch>
+            <a:fillRect/>
+          </a:stretch>
+        </p:blipFill>
+        <p:spPr>
+          <a:xfrm>
+            <a:off x="9308592" y="1371600"/>
+            <a:ext cx="2633472" cy="2286000"/>
+          </a:xfrm>
+          <a:prstGeom prst="rect">
+            <a:avLst/>
+          </a:prstGeom>
+        </p:spPr>
+      </p:pic>
+      <p:sp>
+        <p:nvSpPr>
+          <p:cNvPr id="9" name="Hw_Cap_Assembled"/>
           <p:cNvSpPr txBox="1"/>
           <p:nvPr/>
         </p:nvSpPr>
         <p:spPr>
           <a:xfrm>
-            <a:off x="6839712" y="4773168"/>
-            <a:ext cx="4572000" cy="804672"/>
+            <a:off x="9308592" y="3749039"/>
+            <a:ext cx="2633472" cy="411480"/>
           </a:xfrm>
           <a:prstGeom prst="rect">
             <a:avLst/>
@@ -6136,87 +6164,29 @@
           </a:bodyPr>
           <a:lstStyle/>
           <a:p>
-            <a:pPr algn="l">
-              <a:lnSpc>
-                <a:spcPct val="112000"/>
-              </a:lnSpc>
-              <a:spcAft>
-                <a:spcPts val="300"/>
-              </a:spcAft>
-            </a:pPr>
-            <a:r>
-              <a:rPr sz="950" b="1">
-                <a:solidFill>
-                  <a:srgbClr val="002060"/>
-                </a:solidFill>
-                <a:latin typeface="Calisto MT"/>
-              </a:rPr>
-              <a:t>• Dimensions &amp; Mass: </a:t>
-            </a:r>
-            <a:r>
-              <a:rPr sz="950" b="0">
-                <a:solidFill>
-                  <a:srgbClr val="334155"/>
-                </a:solidFill>
-                <a:latin typeface="Calisto MT"/>
-              </a:rPr>
-              <a:t>220 × 180 × 165 mm | Total Platform Weight: 1.65 kg</a:t>
-            </a:r>
-          </a:p>
-          <a:p>
-            <a:pPr algn="l">
-              <a:lnSpc>
-                <a:spcPct val="112000"/>
-              </a:lnSpc>
-              <a:spcAft>
-                <a:spcPts val="300"/>
-              </a:spcAft>
-            </a:pPr>
-            <a:r>
-              <a:rPr sz="950" b="1">
-                <a:solidFill>
-                  <a:srgbClr val="002060"/>
-                </a:solidFill>
-                <a:latin typeface="Calisto MT"/>
-              </a:rPr>
-              <a:t>• Operating Speeds: </a:t>
-            </a:r>
-            <a:r>
-              <a:rPr sz="950" b="0">
-                <a:solidFill>
-                  <a:srgbClr val="334155"/>
-                </a:solidFill>
-                <a:latin typeface="Calisto MT"/>
-              </a:rPr>
-              <a:t>0.20 m/s cruise speed | ±0.50 rad/s rotation | 98 ms halt</a:t>
-            </a:r>
-          </a:p>
-          <a:p>
-            <a:pPr algn="l">
-              <a:lnSpc>
-                <a:spcPct val="112000"/>
-              </a:lnSpc>
-              <a:spcAft>
-                <a:spcPts val="0"/>
-              </a:spcAft>
-            </a:pPr>
-            <a:r>
-              <a:rPr sz="950" b="1">
-                <a:solidFill>
-                  <a:srgbClr val="002060"/>
-                </a:solidFill>
-                <a:latin typeface="Calisto MT"/>
-              </a:rPr>
-              <a:t>• Power Isolation: </a:t>
-            </a:r>
-            <a:r>
-              <a:rPr sz="950" b="0">
-                <a:solidFill>
-                  <a:srgbClr val="334155"/>
-                </a:solidFill>
-                <a:latin typeface="Calisto MT"/>
-              </a:rPr>
-              <a:t>7.4V Li-ion (2000 mAh) with dedicated 5V/5A buck converter</a:t>
+            <a:pPr algn="ctr">
+              <a:lnSpc>
+                <a:spcPct val="114000"/>
+              </a:lnSpc>
+              <a:spcBef>
+                <a:spcPts val="0"/>
+              </a:spcBef>
+              <a:spcAft>
+                <a:spcPts val="200"/>
+              </a:spcAft>
+              <a:defRPr sz="900" b="0" i="1">
+                <a:solidFill>
+                  <a:srgbClr val="64748B"/>
+                </a:solidFill>
+                <a:latin typeface="Calisto MT"/>
+              </a:defRPr>
+            </a:pPr>
+            <a:r>
+              <a:t>Figure 3.3: Fully Enclosed Platform</a:t>
+            </a:r>
+            <a:br/>
+            <a:r>
+              <a:t>(360° MS200 LiDAR &amp; Active Gimbal)</a:t>
             </a:r>
           </a:p>
         </p:txBody>

</xml_diff>

<commit_message>
feat: complete Slide 10 (Vision Perception & Gesture AI Pipeline)
</commit_message>
<xml_diff>
--- a/write_up/Project Final Defense Slides_FINAL.pptx
+++ b/write_up/Project Final Defense Slides_FINAL.pptx
@@ -17,6 +17,7 @@
     <p:sldId id="563" r:id="rId14"/>
     <p:sldId id="564" r:id="rId15"/>
     <p:sldId id="565" r:id="rId16"/>
+    <p:sldId id="566" r:id="rId17"/>
   </p:sldIdLst>
   <p:sldSz cx="12192000" cy="6858000"/>
   <p:notesSz cx="6858000" cy="9144000"/>
@@ -2038,6 +2039,587 @@
                 <a:cs typeface="Arial" panose="020B0604020202020204" pitchFamily="34" charset="0"/>
               </a:rPr>
               <a:t>GHANA COMMUNICATION TECHNOLOGY UNIVERSITY</a:t>
+            </a:r>
+          </a:p>
+        </p:txBody>
+      </p:sp>
+    </p:spTree>
+  </p:cSld>
+  <p:clrMapOvr>
+    <a:masterClrMapping/>
+  </p:clrMapOvr>
+</p:sld>
+</file>
+
+<file path=ppt/slides/slide10.xml><?xml version="1.0" encoding="utf-8"?>
+<p:sld xmlns:a="http://schemas.openxmlformats.org/drawingml/2006/main" xmlns:p="http://schemas.openxmlformats.org/presentationml/2006/main" xmlns:r="http://schemas.openxmlformats.org/officeDocument/2006/relationships">
+  <p:cSld>
+    <p:spTree>
+      <p:nvGrpSpPr>
+        <p:cNvPr id="1" name=""/>
+        <p:cNvGrpSpPr/>
+        <p:nvPr/>
+      </p:nvGrpSpPr>
+      <p:grpSpPr/>
+      <p:sp>
+        <p:nvSpPr>
+          <p:cNvPr id="2" name="Title 1"/>
+          <p:cNvSpPr>
+            <a:spLocks noGrp="1"/>
+          </p:cNvSpPr>
+          <p:nvPr>
+            <p:ph type="title"/>
+          </p:nvPr>
+        </p:nvSpPr>
+        <p:spPr>
+          <a:xfrm>
+            <a:off x="603504" y="320040"/>
+            <a:ext cx="10972800" cy="548640"/>
+          </a:xfrm>
+        </p:spPr>
+        <p:txBody>
+          <a:bodyPr/>
+          <a:lstStyle/>
+          <a:p>
+            <a:pPr algn="ctr">
+              <a:lnSpc>
+                <a:spcPct val="114000"/>
+              </a:lnSpc>
+              <a:spcBef>
+                <a:spcPts val="0"/>
+              </a:spcBef>
+              <a:spcAft>
+                <a:spcPts val="200"/>
+              </a:spcAft>
+              <a:defRPr sz="2400" b="1" i="0">
+                <a:solidFill>
+                  <a:srgbClr val="002060"/>
+                </a:solidFill>
+                <a:latin typeface="Calisto MT"/>
+              </a:defRPr>
+            </a:pPr>
+            <a:r>
+              <a:t>08. VISION PERCEPTION &amp; GESTURE AI PIPELINE</a:t>
+            </a:r>
+          </a:p>
+        </p:txBody>
+      </p:sp>
+      <p:sp>
+        <p:nvSpPr>
+          <p:cNvPr id="3" name="Content Placeholder 2"/>
+          <p:cNvSpPr>
+            <a:spLocks noGrp="1"/>
+          </p:cNvSpPr>
+          <p:nvPr>
+            <p:ph idx="1"/>
+          </p:nvPr>
+        </p:nvSpPr>
+        <p:spPr/>
+        <p:txBody>
+          <a:bodyPr/>
+          <a:lstStyle/>
+          <a:p/>
+        </p:txBody>
+      </p:sp>
+      <p:sp>
+        <p:nvSpPr>
+          <p:cNvPr id="4" name="Vision_Subhead"/>
+          <p:cNvSpPr txBox="1"/>
+          <p:nvPr/>
+        </p:nvSpPr>
+        <p:spPr>
+          <a:xfrm>
+            <a:off x="777240" y="960120"/>
+            <a:ext cx="10634472" cy="228600"/>
+          </a:xfrm>
+          <a:prstGeom prst="rect">
+            <a:avLst/>
+          </a:prstGeom>
+          <a:noFill/>
+        </p:spPr>
+        <p:txBody>
+          <a:bodyPr wrap="square" lIns="0" rIns="0" tIns="0" bIns="0">
+            <a:spAutoFit/>
+          </a:bodyPr>
+          <a:lstStyle/>
+          <a:p>
+            <a:pPr algn="l">
+              <a:lnSpc>
+                <a:spcPct val="114000"/>
+              </a:lnSpc>
+              <a:spcBef>
+                <a:spcPts val="0"/>
+              </a:spcBef>
+              <a:spcAft>
+                <a:spcPts val="200"/>
+              </a:spcAft>
+              <a:defRPr sz="1100" b="1" i="0">
+                <a:solidFill>
+                  <a:srgbClr val="B8860B"/>
+                </a:solidFill>
+                <a:latin typeface="Calisto MT"/>
+              </a:defRPr>
+            </a:pPr>
+            <a:r>
+              <a:t>OPERATOR ISOLATION, 21-POINT SKELETON TRACKING &amp; 19D NEURAL CLASSIFIER</a:t>
+            </a:r>
+          </a:p>
+        </p:txBody>
+      </p:sp>
+      <p:sp>
+        <p:nvSpPr>
+          <p:cNvPr id="5" name="Vision_Points_Text"/>
+          <p:cNvSpPr txBox="1"/>
+          <p:nvPr/>
+        </p:nvSpPr>
+        <p:spPr>
+          <a:xfrm>
+            <a:off x="777240" y="1261872"/>
+            <a:ext cx="5349240" cy="4297680"/>
+          </a:xfrm>
+          <a:prstGeom prst="rect">
+            <a:avLst/>
+          </a:prstGeom>
+          <a:noFill/>
+        </p:spPr>
+        <p:txBody>
+          <a:bodyPr wrap="square" lIns="18288" rIns="18288" tIns="18288" bIns="18288">
+            <a:spAutoFit/>
+          </a:bodyPr>
+          <a:lstStyle/>
+          <a:p>
+            <a:pPr algn="l">
+              <a:lnSpc>
+                <a:spcPct val="115000"/>
+              </a:lnSpc>
+              <a:spcAft>
+                <a:spcPts val="700"/>
+              </a:spcAft>
+            </a:pPr>
+            <a:r>
+              <a:rPr sz="1100" b="1">
+                <a:solidFill>
+                  <a:srgbClr val="002060"/>
+                </a:solidFill>
+                <a:latin typeface="Calisto MT"/>
+              </a:rPr>
+              <a:t>• Operator Spatial Focus: </a:t>
+            </a:r>
+            <a:r>
+              <a:rPr sz="1100" b="0">
+                <a:solidFill>
+                  <a:srgbClr val="334155"/>
+                </a:solidFill>
+                <a:latin typeface="Calisto MT"/>
+              </a:rPr>
+              <a:t>The camera strictly accepts commands from an operator centered in front of the robot, automatically blurring and ignoring passersby in the background.</a:t>
+            </a:r>
+          </a:p>
+          <a:p>
+            <a:pPr algn="l">
+              <a:lnSpc>
+                <a:spcPct val="115000"/>
+              </a:lnSpc>
+              <a:spcAft>
+                <a:spcPts val="700"/>
+              </a:spcAft>
+            </a:pPr>
+            <a:r>
+              <a:rPr sz="1100" b="1">
+                <a:solidFill>
+                  <a:srgbClr val="002060"/>
+                </a:solidFill>
+                <a:latin typeface="Calisto MT"/>
+              </a:rPr>
+              <a:t>• 21-Point Skeletal Tracking: </a:t>
+            </a:r>
+            <a:r>
+              <a:rPr sz="1100" b="0">
+                <a:solidFill>
+                  <a:srgbClr val="334155"/>
+                </a:solidFill>
+                <a:latin typeface="Calisto MT"/>
+              </a:rPr>
+              <a:t>Once focused, MediaPipe extracts 21 finger and palm joint landmarks in 3D coordinates from the live video stream in real time.</a:t>
+            </a:r>
+          </a:p>
+          <a:p>
+            <a:pPr algn="l">
+              <a:lnSpc>
+                <a:spcPct val="115000"/>
+              </a:lnSpc>
+              <a:spcAft>
+                <a:spcPts val="700"/>
+              </a:spcAft>
+            </a:pPr>
+            <a:r>
+              <a:rPr sz="1100" b="1">
+                <a:solidFill>
+                  <a:srgbClr val="002060"/>
+                </a:solidFill>
+                <a:latin typeface="Calisto MT"/>
+              </a:rPr>
+              <a:t>• Distance-Proof Scaling: </a:t>
+            </a:r>
+            <a:r>
+              <a:rPr sz="1100" b="0">
+                <a:solidFill>
+                  <a:srgbClr val="334155"/>
+                </a:solidFill>
+                <a:latin typeface="Calisto MT"/>
+              </a:rPr>
+              <a:t>Joint coordinates are centered on the wrist and divided by palm width, ensuring gestures look identical whether the user stands 1 meter or 3 meters away.</a:t>
+            </a:r>
+          </a:p>
+          <a:p>
+            <a:pPr algn="l">
+              <a:lnSpc>
+                <a:spcPct val="115000"/>
+              </a:lnSpc>
+              <a:spcAft>
+                <a:spcPts val="700"/>
+              </a:spcAft>
+            </a:pPr>
+            <a:r>
+              <a:rPr sz="1100" b="1">
+                <a:solidFill>
+                  <a:srgbClr val="002060"/>
+                </a:solidFill>
+                <a:latin typeface="Calisto MT"/>
+              </a:rPr>
+              <a:t>• 19-D Feature Extraction: </a:t>
+            </a:r>
+            <a:r>
+              <a:rPr sz="1100" b="0">
+                <a:solidFill>
+                  <a:srgbClr val="334155"/>
+                </a:solidFill>
+                <a:latin typeface="Calisto MT"/>
+              </a:rPr>
+              <a:t>Compresses the 21 joints into 19 geometric measurements: 5 finger curl angles, 5 fingertip distances, 4 spread angles, 3D thumb vector, and 2 palm angles.</a:t>
+            </a:r>
+          </a:p>
+          <a:p>
+            <a:pPr algn="l">
+              <a:lnSpc>
+                <a:spcPct val="115000"/>
+              </a:lnSpc>
+              <a:spcAft>
+                <a:spcPts val="700"/>
+              </a:spcAft>
+            </a:pPr>
+            <a:r>
+              <a:rPr sz="1100" b="1">
+                <a:solidFill>
+                  <a:srgbClr val="002060"/>
+                </a:solidFill>
+                <a:latin typeface="Calisto MT"/>
+              </a:rPr>
+              <a:t>• Fast Neural Classifier: </a:t>
+            </a:r>
+            <a:r>
+              <a:rPr sz="1100" b="0">
+                <a:solidFill>
+                  <a:srgbClr val="334155"/>
+                </a:solidFill>
+                <a:latin typeface="Calisto MT"/>
+              </a:rPr>
+              <a:t>A 4-layer neural network (MLP) evaluates the 19 features in just 1.2 ms on the Raspberry Pi 5 CPU, achieving 99.38% test accuracy.</a:t>
+            </a:r>
+          </a:p>
+          <a:p>
+            <a:pPr algn="l">
+              <a:lnSpc>
+                <a:spcPct val="115000"/>
+              </a:lnSpc>
+              <a:spcAft>
+                <a:spcPts val="0"/>
+              </a:spcAft>
+            </a:pPr>
+            <a:r>
+              <a:rPr sz="1100" b="1">
+                <a:solidFill>
+                  <a:srgbClr val="002060"/>
+                </a:solidFill>
+                <a:latin typeface="Calisto MT"/>
+              </a:rPr>
+              <a:t>• 6 Discrete Motion Commands: </a:t>
+            </a:r>
+            <a:r>
+              <a:rPr sz="1100" b="0">
+                <a:solidFill>
+                  <a:srgbClr val="334155"/>
+                </a:solidFill>
+                <a:latin typeface="Calisto MT"/>
+              </a:rPr>
+              <a:t>Translates recognized hand poses into unambiguous motion intents: STOP (open palm), GO (point forward), LEFT, RIGHT, BACK, and FOLLOW.</a:t>
+            </a:r>
+          </a:p>
+        </p:txBody>
+      </p:sp>
+      <p:pic>
+        <p:nvPicPr>
+          <p:cNvPr id="6" name="Vision_HUD_Img" descr="image.jpg"/>
+          <p:cNvPicPr>
+            <a:picLocks noChangeAspect="1"/>
+          </p:cNvPicPr>
+          <p:nvPr/>
+        </p:nvPicPr>
+        <p:blipFill>
+          <a:blip r:embed="rId2"/>
+          <a:stretch>
+            <a:fillRect/>
+          </a:stretch>
+        </p:blipFill>
+        <p:spPr>
+          <a:xfrm>
+            <a:off x="6355080" y="1261872"/>
+            <a:ext cx="3017520" cy="2267712"/>
+          </a:xfrm>
+          <a:prstGeom prst="rect">
+            <a:avLst/>
+          </a:prstGeom>
+        </p:spPr>
+      </p:pic>
+      <p:sp>
+        <p:nvSpPr>
+          <p:cNvPr id="7" name="Vision_HUD_Cap"/>
+          <p:cNvSpPr txBox="1"/>
+          <p:nvPr/>
+        </p:nvSpPr>
+        <p:spPr>
+          <a:xfrm>
+            <a:off x="6355080" y="3566160"/>
+            <a:ext cx="3017520" cy="320040"/>
+          </a:xfrm>
+          <a:prstGeom prst="rect">
+            <a:avLst/>
+          </a:prstGeom>
+          <a:noFill/>
+        </p:spPr>
+        <p:txBody>
+          <a:bodyPr wrap="square" lIns="0" rIns="0" tIns="0" bIns="0">
+            <a:spAutoFit/>
+          </a:bodyPr>
+          <a:lstStyle/>
+          <a:p>
+            <a:pPr algn="ctr">
+              <a:lnSpc>
+                <a:spcPct val="114000"/>
+              </a:lnSpc>
+              <a:spcBef>
+                <a:spcPts val="0"/>
+              </a:spcBef>
+              <a:spcAft>
+                <a:spcPts val="200"/>
+              </a:spcAft>
+              <a:defRPr sz="850" b="0" i="1">
+                <a:solidFill>
+                  <a:srgbClr val="64748B"/>
+                </a:solidFill>
+                <a:latin typeface="Calisto MT"/>
+              </a:defRPr>
+            </a:pPr>
+            <a:r>
+              <a:t>Figure 3.4: Operator Acceptance HUD &amp; Bystander Blur</a:t>
+            </a:r>
+          </a:p>
+        </p:txBody>
+      </p:sp>
+      <p:pic>
+        <p:nvPicPr>
+          <p:cNvPr id="8" name="Vision_Hand_Img" descr="image.jpg"/>
+          <p:cNvPicPr>
+            <a:picLocks noChangeAspect="1"/>
+          </p:cNvPicPr>
+          <p:nvPr/>
+        </p:nvPicPr>
+        <p:blipFill>
+          <a:blip r:embed="rId3"/>
+          <a:stretch>
+            <a:fillRect/>
+          </a:stretch>
+        </p:blipFill>
+        <p:spPr>
+          <a:xfrm>
+            <a:off x="9555480" y="1261872"/>
+            <a:ext cx="1965960" cy="3749039"/>
+          </a:xfrm>
+          <a:prstGeom prst="rect">
+            <a:avLst/>
+          </a:prstGeom>
+        </p:spPr>
+      </p:pic>
+      <p:sp>
+        <p:nvSpPr>
+          <p:cNvPr id="9" name="Vision_Hand_Cap"/>
+          <p:cNvSpPr txBox="1"/>
+          <p:nvPr/>
+        </p:nvSpPr>
+        <p:spPr>
+          <a:xfrm>
+            <a:off x="9555480" y="5047488"/>
+            <a:ext cx="1965960" cy="365760"/>
+          </a:xfrm>
+          <a:prstGeom prst="rect">
+            <a:avLst/>
+          </a:prstGeom>
+          <a:noFill/>
+        </p:spPr>
+        <p:txBody>
+          <a:bodyPr wrap="square" lIns="0" rIns="0" tIns="0" bIns="0">
+            <a:spAutoFit/>
+          </a:bodyPr>
+          <a:lstStyle/>
+          <a:p>
+            <a:pPr algn="ctr">
+              <a:lnSpc>
+                <a:spcPct val="114000"/>
+              </a:lnSpc>
+              <a:spcBef>
+                <a:spcPts val="0"/>
+              </a:spcBef>
+              <a:spcAft>
+                <a:spcPts val="200"/>
+              </a:spcAft>
+              <a:defRPr sz="850" b="0" i="1">
+                <a:solidFill>
+                  <a:srgbClr val="64748B"/>
+                </a:solidFill>
+                <a:latin typeface="Calisto MT"/>
+              </a:defRPr>
+            </a:pPr>
+            <a:r>
+              <a:t>Figure 3.5: 21-Joint 3D Hand Model</a:t>
+            </a:r>
+          </a:p>
+        </p:txBody>
+      </p:sp>
+      <p:sp>
+        <p:nvSpPr>
+          <p:cNvPr id="10" name="Vision_Vocab_Text"/>
+          <p:cNvSpPr txBox="1"/>
+          <p:nvPr/>
+        </p:nvSpPr>
+        <p:spPr>
+          <a:xfrm>
+            <a:off x="6355080" y="3977639"/>
+            <a:ext cx="3108960" cy="1508760"/>
+          </a:xfrm>
+          <a:prstGeom prst="rect">
+            <a:avLst/>
+          </a:prstGeom>
+          <a:noFill/>
+        </p:spPr>
+        <p:txBody>
+          <a:bodyPr wrap="square" lIns="0" rIns="0" tIns="0" bIns="0">
+            <a:spAutoFit/>
+          </a:bodyPr>
+          <a:lstStyle/>
+          <a:p>
+            <a:pPr algn="l">
+              <a:lnSpc>
+                <a:spcPct val="114000"/>
+              </a:lnSpc>
+              <a:spcBef>
+                <a:spcPts val="0"/>
+              </a:spcBef>
+              <a:spcAft>
+                <a:spcPts val="300"/>
+              </a:spcAft>
+              <a:defRPr sz="950" b="1" i="0">
+                <a:solidFill>
+                  <a:srgbClr val="B8860B"/>
+                </a:solidFill>
+                <a:latin typeface="Calisto MT"/>
+              </a:defRPr>
+            </a:pPr>
+            <a:r>
+              <a:t>CLASSIFIER VOCABULARY &amp; BENCHMARKS:</a:t>
+            </a:r>
+          </a:p>
+          <a:p>
+            <a:pPr algn="l">
+              <a:lnSpc>
+                <a:spcPct val="112000"/>
+              </a:lnSpc>
+              <a:spcAft>
+                <a:spcPts val="200"/>
+              </a:spcAft>
+            </a:pPr>
+            <a:r>
+              <a:rPr sz="900" b="1">
+                <a:solidFill>
+                  <a:srgbClr val="002060"/>
+                </a:solidFill>
+                <a:latin typeface="Calisto MT"/>
+              </a:rPr>
+              <a:t>• Commands: </a:t>
+            </a:r>
+            <a:r>
+              <a:rPr sz="900" b="0">
+                <a:solidFill>
+                  <a:srgbClr val="334155"/>
+                </a:solidFill>
+                <a:latin typeface="Calisto MT"/>
+              </a:rPr>
+              <a:t>STOP, GO, LEFT, RIGHT, BACK, FOLLOW</a:t>
+            </a:r>
+          </a:p>
+          <a:p>
+            <a:pPr algn="l">
+              <a:lnSpc>
+                <a:spcPct val="112000"/>
+              </a:lnSpc>
+              <a:spcAft>
+                <a:spcPts val="200"/>
+              </a:spcAft>
+            </a:pPr>
+            <a:r>
+              <a:rPr sz="900" b="1">
+                <a:solidFill>
+                  <a:srgbClr val="002060"/>
+                </a:solidFill>
+                <a:latin typeface="Calisto MT"/>
+              </a:rPr>
+              <a:t>• Inference Speed: </a:t>
+            </a:r>
+            <a:r>
+              <a:rPr sz="900" b="0">
+                <a:solidFill>
+                  <a:srgbClr val="334155"/>
+                </a:solidFill>
+                <a:latin typeface="Calisto MT"/>
+              </a:rPr>
+              <a:t>1.2 ms on Raspberry Pi 5 CPU (100x real-time)</a:t>
+            </a:r>
+          </a:p>
+          <a:p>
+            <a:pPr algn="l">
+              <a:lnSpc>
+                <a:spcPct val="112000"/>
+              </a:lnSpc>
+              <a:spcAft>
+                <a:spcPts val="0"/>
+              </a:spcAft>
+            </a:pPr>
+            <a:r>
+              <a:rPr sz="900" b="1">
+                <a:solidFill>
+                  <a:srgbClr val="002060"/>
+                </a:solidFill>
+                <a:latin typeface="Calisto MT"/>
+              </a:rPr>
+              <a:t>• Model Accuracy: </a:t>
+            </a:r>
+            <a:r>
+              <a:rPr sz="900" b="0">
+                <a:solidFill>
+                  <a:srgbClr val="334155"/>
+                </a:solidFill>
+                <a:latin typeface="Calisto MT"/>
+              </a:rPr>
+              <a:t>99.38% test accuracy (6,000 verified samples)</a:t>
             </a:r>
           </a:p>
         </p:txBody>

</xml_diff>

<commit_message>
refactor: simplify Slide 10 text to conversational, easy-to-understand plain English
</commit_message>
<xml_diff>
--- a/write_up/Project Final Defense Slides_FINAL.pptx
+++ b/write_up/Project Final Defense Slides_FINAL.pptx
@@ -2161,7 +2161,7 @@
               </a:defRPr>
             </a:pPr>
             <a:r>
-              <a:t>OPERATOR ISOLATION, 21-POINT SKELETON TRACKING &amp; 19D NEURAL CLASSIFIER</a:t>
+              <a:t>HOW THE ROBOT SEES HAND GESTURES, IGNORES BYSTANDERS, AND DECIDES TO MOVE</a:t>
             </a:r>
           </a:p>
         </p:txBody>
@@ -2203,7 +2203,7 @@
                 </a:solidFill>
                 <a:latin typeface="Calisto MT"/>
               </a:rPr>
-              <a:t>• Operator Spatial Focus: </a:t>
+              <a:t>• Focusing on One Person: </a:t>
             </a:r>
             <a:r>
               <a:rPr sz="1100" b="0">
@@ -2212,7 +2212,7 @@
                 </a:solidFill>
                 <a:latin typeface="Calisto MT"/>
               </a:rPr>
-              <a:t>The camera strictly accepts commands from an operator centered in front of the robot, automatically blurring and ignoring passersby in the background.</a:t>
+              <a:t>The robot only listens to the person standing directly in front of it, while automatically blurring and ignoring anyone walking by in the background.</a:t>
             </a:r>
           </a:p>
           <a:p>
@@ -2231,7 +2231,7 @@
                 </a:solidFill>
                 <a:latin typeface="Calisto MT"/>
               </a:rPr>
-              <a:t>• 21-Point Skeletal Tracking: </a:t>
+              <a:t>• Tracking Hand Joints: </a:t>
             </a:r>
             <a:r>
               <a:rPr sz="1100" b="0">
@@ -2240,7 +2240,7 @@
                 </a:solidFill>
                 <a:latin typeface="Calisto MT"/>
               </a:rPr>
-              <a:t>Once focused, MediaPipe extracts 21 finger and palm joint landmarks in 3D coordinates from the live video stream in real time.</a:t>
+              <a:t>The camera tracks 21 points on the hand, including the wrist, knuckles, and fingertips, to capture the exact shape and motion of the fingers.</a:t>
             </a:r>
           </a:p>
           <a:p>
@@ -2259,7 +2259,7 @@
                 </a:solidFill>
                 <a:latin typeface="Calisto MT"/>
               </a:rPr>
-              <a:t>• Distance-Proof Scaling: </a:t>
+              <a:t>• Works at Any Distance: </a:t>
             </a:r>
             <a:r>
               <a:rPr sz="1100" b="0">
@@ -2268,7 +2268,7 @@
                 </a:solidFill>
                 <a:latin typeface="Calisto MT"/>
               </a:rPr>
-              <a:t>Joint coordinates are centered on the wrist and divided by palm width, ensuring gestures look identical whether the user stands 1 meter or 3 meters away.</a:t>
+              <a:t>Hand measurements are automatically scaled using the palm width, so the robot recognizes gestures equally well whether you stand 1 meter or 3 meters away.</a:t>
             </a:r>
           </a:p>
           <a:p>
@@ -2287,7 +2287,7 @@
                 </a:solidFill>
                 <a:latin typeface="Calisto MT"/>
               </a:rPr>
-              <a:t>• 19-D Feature Extraction: </a:t>
+              <a:t>• Measuring Hand Shape: </a:t>
             </a:r>
             <a:r>
               <a:rPr sz="1100" b="0">
@@ -2296,7 +2296,7 @@
                 </a:solidFill>
                 <a:latin typeface="Calisto MT"/>
               </a:rPr>
-              <a:t>Compresses the 21 joints into 19 geometric measurements: 5 finger curl angles, 5 fingertip distances, 4 spread angles, 3D thumb vector, and 2 palm angles.</a:t>
+              <a:t>The robot calculates 19 simple numbers from the hand joints, measuring how much each finger curls and how wide fingers are spread apart.</a:t>
             </a:r>
           </a:p>
           <a:p>
@@ -2315,7 +2315,7 @@
                 </a:solidFill>
                 <a:latin typeface="Calisto MT"/>
               </a:rPr>
-              <a:t>• Fast Neural Classifier: </a:t>
+              <a:t>• Instant AI Decision: </a:t>
             </a:r>
             <a:r>
               <a:rPr sz="1100" b="0">
@@ -2324,7 +2324,7 @@
                 </a:solidFill>
                 <a:latin typeface="Calisto MT"/>
               </a:rPr>
-              <a:t>A 4-layer neural network (MLP) evaluates the 19 features in just 1.2 ms on the Raspberry Pi 5 CPU, achieving 99.38% test accuracy.</a:t>
+              <a:t>A compact artificial intelligence model reads the 19 hand numbers in just 1.2 milliseconds, identifying the gesture with 99.4% accuracy.</a:t>
             </a:r>
           </a:p>
           <a:p>
@@ -2343,7 +2343,7 @@
                 </a:solidFill>
                 <a:latin typeface="Calisto MT"/>
               </a:rPr>
-              <a:t>• 6 Discrete Motion Commands: </a:t>
+              <a:t>• 6 Driving Commands: </a:t>
             </a:r>
             <a:r>
               <a:rPr sz="1100" b="0">
@@ -2352,7 +2352,7 @@
                 </a:solidFill>
                 <a:latin typeface="Calisto MT"/>
               </a:rPr>
-              <a:t>Translates recognized hand poses into unambiguous motion intents: STOP (open palm), GO (point forward), LEFT, RIGHT, BACK, and FOLLOW.</a:t>
+              <a:t>Matches each hand pose directly to clear robot movements: STOP (open palm), GO (pointing forward), LEFT, RIGHT, BACK, and FOLLOW.</a:t>
             </a:r>
           </a:p>
         </p:txBody>
@@ -2421,7 +2421,7 @@
               </a:defRPr>
             </a:pPr>
             <a:r>
-              <a:t>Figure 3.4: Operator Acceptance HUD &amp; Bystander Blur</a:t>
+              <a:t>Figure 3.4: Camera View Locking on User &amp; Blurring Bystanders</a:t>
             </a:r>
           </a:p>
         </p:txBody>
@@ -2490,7 +2490,7 @@
               </a:defRPr>
             </a:pPr>
             <a:r>
-              <a:t>Figure 3.5: 21-Joint 3D Hand Model</a:t>
+              <a:t>Figure 3.5: 21 Tracked Hand Points</a:t>
             </a:r>
           </a:p>
         </p:txBody>
@@ -2535,7 +2535,7 @@
               </a:defRPr>
             </a:pPr>
             <a:r>
-              <a:t>CLASSIFIER VOCABULARY &amp; BENCHMARKS:</a:t>
+              <a:t>GESTURE VOCABULARY &amp; AI SPEED:</a:t>
             </a:r>
           </a:p>
           <a:p>
@@ -2554,7 +2554,7 @@
                 </a:solidFill>
                 <a:latin typeface="Calisto MT"/>
               </a:rPr>
-              <a:t>• Commands: </a:t>
+              <a:t>• 6 Commands: </a:t>
             </a:r>
             <a:r>
               <a:rPr sz="900" b="0">
@@ -2582,7 +2582,7 @@
                 </a:solidFill>
                 <a:latin typeface="Calisto MT"/>
               </a:rPr>
-              <a:t>• Inference Speed: </a:t>
+              <a:t>• Fast Reaction: </a:t>
             </a:r>
             <a:r>
               <a:rPr sz="900" b="0">
@@ -2591,7 +2591,7 @@
                 </a:solidFill>
                 <a:latin typeface="Calisto MT"/>
               </a:rPr>
-              <a:t>1.2 ms on Raspberry Pi 5 CPU (100x real-time)</a:t>
+              <a:t>Decides in 1.2 milliseconds (faster than a blink)</a:t>
             </a:r>
           </a:p>
           <a:p>
@@ -2610,7 +2610,7 @@
                 </a:solidFill>
                 <a:latin typeface="Calisto MT"/>
               </a:rPr>
-              <a:t>• Model Accuracy: </a:t>
+              <a:t>• High Accuracy: </a:t>
             </a:r>
             <a:r>
               <a:rPr sz="900" b="0">
@@ -2619,7 +2619,7 @@
                 </a:solidFill>
                 <a:latin typeface="Calisto MT"/>
               </a:rPr>
-              <a:t>99.38% test accuracy (6,000 verified samples)</a:t>
+              <a:t>99.4% correct across 6,000 test trials</a:t>
             </a:r>
           </a:p>
         </p:txBody>

</xml_diff>

<commit_message>
feat: complete slide 11 (Human Motion Prediction & Supervisory Control)
</commit_message>
<xml_diff>
--- a/write_up/Project Final Defense Slides_FINAL.pptx
+++ b/write_up/Project Final Defense Slides_FINAL.pptx
@@ -18,6 +18,7 @@
     <p:sldId id="564" r:id="rId15"/>
     <p:sldId id="565" r:id="rId16"/>
     <p:sldId id="566" r:id="rId17"/>
+    <p:sldId id="567" r:id="rId18"/>
   </p:sldIdLst>
   <p:sldSz cx="12192000" cy="6858000"/>
   <p:notesSz cx="6858000" cy="9144000"/>
@@ -2620,6 +2621,615 @@
                 <a:latin typeface="Calisto MT"/>
               </a:rPr>
               <a:t>99.4% correct across 6,000 test trials</a:t>
+            </a:r>
+          </a:p>
+        </p:txBody>
+      </p:sp>
+    </p:spTree>
+  </p:cSld>
+  <p:clrMapOvr>
+    <a:masterClrMapping/>
+  </p:clrMapOvr>
+</p:sld>
+</file>
+
+<file path=ppt/slides/slide11.xml><?xml version="1.0" encoding="utf-8"?>
+<p:sld xmlns:a="http://schemas.openxmlformats.org/drawingml/2006/main" xmlns:p="http://schemas.openxmlformats.org/presentationml/2006/main" xmlns:r="http://schemas.openxmlformats.org/officeDocument/2006/relationships">
+  <p:cSld>
+    <p:spTree>
+      <p:nvGrpSpPr>
+        <p:cNvPr id="1" name=""/>
+        <p:cNvGrpSpPr/>
+        <p:nvPr/>
+      </p:nvGrpSpPr>
+      <p:grpSpPr/>
+      <p:sp>
+        <p:nvSpPr>
+          <p:cNvPr id="2" name="Title 1"/>
+          <p:cNvSpPr>
+            <a:spLocks noGrp="1"/>
+          </p:cNvSpPr>
+          <p:nvPr>
+            <p:ph type="title"/>
+          </p:nvPr>
+        </p:nvSpPr>
+        <p:spPr>
+          <a:xfrm>
+            <a:off x="603504" y="320040"/>
+            <a:ext cx="10972800" cy="548640"/>
+          </a:xfrm>
+        </p:spPr>
+        <p:txBody>
+          <a:bodyPr/>
+          <a:lstStyle/>
+          <a:p>
+            <a:pPr algn="ctr">
+              <a:lnSpc>
+                <a:spcPct val="114000"/>
+              </a:lnSpc>
+              <a:spcBef>
+                <a:spcPts val="0"/>
+              </a:spcBef>
+              <a:spcAft>
+                <a:spcPts val="200"/>
+              </a:spcAft>
+              <a:defRPr sz="2400" b="1" i="0">
+                <a:solidFill>
+                  <a:srgbClr val="002060"/>
+                </a:solidFill>
+                <a:latin typeface="Calisto MT"/>
+              </a:defRPr>
+            </a:pPr>
+            <a:r>
+              <a:t>09. HUMAN MOTION PREDICTION &amp; SUPERVISORY CONTROL</a:t>
+            </a:r>
+          </a:p>
+        </p:txBody>
+      </p:sp>
+      <p:sp>
+        <p:nvSpPr>
+          <p:cNvPr id="3" name="Content Placeholder 2"/>
+          <p:cNvSpPr>
+            <a:spLocks noGrp="1"/>
+          </p:cNvSpPr>
+          <p:nvPr>
+            <p:ph idx="1"/>
+          </p:nvPr>
+        </p:nvSpPr>
+        <p:spPr/>
+        <p:txBody>
+          <a:bodyPr/>
+          <a:lstStyle/>
+          <a:p/>
+        </p:txBody>
+      </p:sp>
+      <p:sp>
+        <p:nvSpPr>
+          <p:cNvPr id="4" name="Control_Subhead"/>
+          <p:cNvSpPr txBox="1"/>
+          <p:nvPr/>
+        </p:nvSpPr>
+        <p:spPr>
+          <a:xfrm>
+            <a:off x="777240" y="960120"/>
+            <a:ext cx="10634472" cy="228600"/>
+          </a:xfrm>
+          <a:prstGeom prst="rect">
+            <a:avLst/>
+          </a:prstGeom>
+          <a:noFill/>
+        </p:spPr>
+        <p:txBody>
+          <a:bodyPr wrap="square" lIns="0" rIns="0" tIns="0" bIns="0">
+            <a:spAutoFit/>
+          </a:bodyPr>
+          <a:lstStyle/>
+          <a:p>
+            <a:pPr algn="l">
+              <a:lnSpc>
+                <a:spcPct val="114000"/>
+              </a:lnSpc>
+              <a:spcBef>
+                <a:spcPts val="0"/>
+              </a:spcBef>
+              <a:spcAft>
+                <a:spcPts val="200"/>
+              </a:spcAft>
+              <a:defRPr sz="1100" b="1" i="0">
+                <a:solidFill>
+                  <a:srgbClr val="B8860B"/>
+                </a:solidFill>
+                <a:latin typeface="Calisto MT"/>
+              </a:defRPr>
+            </a:pPr>
+            <a:r>
+              <a:t>HOW THE ROBOT ANTICIPATES USER PATHS, TRACKS WITH ITS CAMERA, AND STAYS SAFE</a:t>
+            </a:r>
+          </a:p>
+        </p:txBody>
+      </p:sp>
+      <p:sp>
+        <p:nvSpPr>
+          <p:cNvPr id="5" name="Control_Points_Text"/>
+          <p:cNvSpPr txBox="1"/>
+          <p:nvPr/>
+        </p:nvSpPr>
+        <p:spPr>
+          <a:xfrm>
+            <a:off x="777240" y="1261872"/>
+            <a:ext cx="5349240" cy="4297680"/>
+          </a:xfrm>
+          <a:prstGeom prst="rect">
+            <a:avLst/>
+          </a:prstGeom>
+          <a:noFill/>
+        </p:spPr>
+        <p:txBody>
+          <a:bodyPr wrap="square" lIns="18288" rIns="18288" tIns="18288" bIns="18288">
+            <a:spAutoFit/>
+          </a:bodyPr>
+          <a:lstStyle/>
+          <a:p>
+            <a:pPr algn="l">
+              <a:lnSpc>
+                <a:spcPct val="115000"/>
+              </a:lnSpc>
+              <a:spcAft>
+                <a:spcPts val="700"/>
+              </a:spcAft>
+            </a:pPr>
+            <a:r>
+              <a:rPr sz="1100" b="1">
+                <a:solidFill>
+                  <a:srgbClr val="002060"/>
+                </a:solidFill>
+                <a:latin typeface="Calisto MT"/>
+              </a:rPr>
+              <a:t>• Anticipating User Steps: </a:t>
+            </a:r>
+            <a:r>
+              <a:rPr sz="1100" b="0">
+                <a:solidFill>
+                  <a:srgbClr val="334155"/>
+                </a:solidFill>
+                <a:latin typeface="Calisto MT"/>
+              </a:rPr>
+              <a:t>The robot tracks the person's walking path over the past 1 second (30 camera frames) and uses an AI model to predict where they will step 0.5 seconds ahead, preventing jerky turns or delayed following.</a:t>
+            </a:r>
+          </a:p>
+          <a:p>
+            <a:pPr algn="l">
+              <a:lnSpc>
+                <a:spcPct val="115000"/>
+              </a:lnSpc>
+              <a:spcAft>
+                <a:spcPts val="700"/>
+              </a:spcAft>
+            </a:pPr>
+            <a:r>
+              <a:rPr sz="1100" b="1">
+                <a:solidFill>
+                  <a:srgbClr val="002060"/>
+                </a:solidFill>
+                <a:latin typeface="Calisto MT"/>
+              </a:rPr>
+              <a:t>• Motorized Camera Tracking: </a:t>
+            </a:r>
+            <a:r>
+              <a:rPr sz="1100" b="0">
+                <a:solidFill>
+                  <a:srgbClr val="334155"/>
+                </a:solidFill>
+                <a:latin typeface="Calisto MT"/>
+              </a:rPr>
+              <a:t>A 2-axis motorized camera head pans left/right and tilts up/down automatically, keeping the interacting person centered in view even while the robot chassis is turning or braking.</a:t>
+            </a:r>
+          </a:p>
+          <a:p>
+            <a:pPr algn="l">
+              <a:lnSpc>
+                <a:spcPct val="115000"/>
+              </a:lnSpc>
+              <a:spcAft>
+                <a:spcPts val="700"/>
+              </a:spcAft>
+            </a:pPr>
+            <a:r>
+              <a:rPr sz="1100" b="1">
+                <a:solidFill>
+                  <a:srgbClr val="002060"/>
+                </a:solidFill>
+                <a:latin typeface="Calisto MT"/>
+              </a:rPr>
+              <a:t>• Central Software Brain: </a:t>
+            </a:r>
+            <a:r>
+              <a:rPr sz="1100" b="0">
+                <a:solidFill>
+                  <a:srgbClr val="334155"/>
+                </a:solidFill>
+                <a:latin typeface="Calisto MT"/>
+              </a:rPr>
+              <a:t>A master controller (brain_node) coordinates all actions through distinct operational stages: Standing By, Confirming Command, Driving, Following User, and Safety Stop.</a:t>
+            </a:r>
+          </a:p>
+          <a:p>
+            <a:pPr algn="l">
+              <a:lnSpc>
+                <a:spcPct val="115000"/>
+              </a:lnSpc>
+              <a:spcAft>
+                <a:spcPts val="700"/>
+              </a:spcAft>
+            </a:pPr>
+            <a:r>
+              <a:rPr sz="1100" b="1">
+                <a:solidFill>
+                  <a:srgbClr val="002060"/>
+                </a:solidFill>
+                <a:latin typeface="Calisto MT"/>
+              </a:rPr>
+              <a:t>• Preventing Accidental Starts: </a:t>
+            </a:r>
+            <a:r>
+              <a:rPr sz="1100" b="0">
+                <a:solidFill>
+                  <a:srgbClr val="334155"/>
+                </a:solidFill>
+                <a:latin typeface="Calisto MT"/>
+              </a:rPr>
+              <a:t>To stop accidental hand waves or brief gestures from moving the robot, every command must be held consistently for at least 5 camera frames before motors turn.</a:t>
+            </a:r>
+          </a:p>
+          <a:p>
+            <a:pPr algn="l">
+              <a:lnSpc>
+                <a:spcPct val="115000"/>
+              </a:lnSpc>
+              <a:spcAft>
+                <a:spcPts val="700"/>
+              </a:spcAft>
+            </a:pPr>
+            <a:r>
+              <a:rPr sz="1100" b="1">
+                <a:solidFill>
+                  <a:srgbClr val="002060"/>
+                </a:solidFill>
+                <a:latin typeface="Calisto MT"/>
+              </a:rPr>
+              <a:t>• Safe Distance Buffer: </a:t>
+            </a:r>
+            <a:r>
+              <a:rPr sz="1100" b="0">
+                <a:solidFill>
+                  <a:srgbClr val="334155"/>
+                </a:solidFill>
+                <a:latin typeface="Calisto MT"/>
+              </a:rPr>
+              <a:t>When following a walking user, the robot automatically stays between 0.8 and 1.5 meters away; if the person stops or steps closer than 0.8 meters, it halts immediately.</a:t>
+            </a:r>
+          </a:p>
+          <a:p>
+            <a:pPr algn="l">
+              <a:lnSpc>
+                <a:spcPct val="115000"/>
+              </a:lnSpc>
+              <a:spcAft>
+                <a:spcPts val="0"/>
+              </a:spcAft>
+            </a:pPr>
+            <a:r>
+              <a:rPr sz="1100" b="1">
+                <a:solidFill>
+                  <a:srgbClr val="002060"/>
+                </a:solidFill>
+                <a:latin typeface="Calisto MT"/>
+              </a:rPr>
+              <a:t>• Instant Laser Safety Override: </a:t>
+            </a:r>
+            <a:r>
+              <a:rPr sz="1100" b="0">
+                <a:solidFill>
+                  <a:srgbClr val="334155"/>
+                </a:solidFill>
+                <a:latin typeface="Calisto MT"/>
+              </a:rPr>
+              <a:t>The 360° laser distance sensor constantly scans the surroundings; if an obstacle or person enters within 0.36 meters, motor power cuts in 5 milliseconds, overriding all AI.</a:t>
+            </a:r>
+          </a:p>
+        </p:txBody>
+      </p:sp>
+      <p:pic>
+        <p:nvPicPr>
+          <p:cNvPr id="6" name="Control_LSTM_Img" descr="lstm_path_prediction_clean.png"/>
+          <p:cNvPicPr>
+            <a:picLocks noChangeAspect="1"/>
+          </p:cNvPicPr>
+          <p:nvPr/>
+        </p:nvPicPr>
+        <p:blipFill>
+          <a:blip r:embed="rId2"/>
+          <a:stretch>
+            <a:fillRect/>
+          </a:stretch>
+        </p:blipFill>
+        <p:spPr>
+          <a:xfrm>
+            <a:off x="6355080" y="1261872"/>
+            <a:ext cx="5029200" cy="1874519"/>
+          </a:xfrm>
+          <a:prstGeom prst="rect">
+            <a:avLst/>
+          </a:prstGeom>
+        </p:spPr>
+      </p:pic>
+      <p:sp>
+        <p:nvSpPr>
+          <p:cNvPr id="7" name="Control_LSTM_Cap"/>
+          <p:cNvSpPr txBox="1"/>
+          <p:nvPr/>
+        </p:nvSpPr>
+        <p:spPr>
+          <a:xfrm>
+            <a:off x="6355080" y="3163824"/>
+            <a:ext cx="5029200" cy="256032"/>
+          </a:xfrm>
+          <a:prstGeom prst="rect">
+            <a:avLst/>
+          </a:prstGeom>
+          <a:noFill/>
+        </p:spPr>
+        <p:txBody>
+          <a:bodyPr wrap="square" lIns="0" rIns="0" tIns="0" bIns="0">
+            <a:spAutoFit/>
+          </a:bodyPr>
+          <a:lstStyle/>
+          <a:p>
+            <a:pPr algn="ctr">
+              <a:lnSpc>
+                <a:spcPct val="114000"/>
+              </a:lnSpc>
+              <a:spcBef>
+                <a:spcPts val="0"/>
+              </a:spcBef>
+              <a:spcAft>
+                <a:spcPts val="200"/>
+              </a:spcAft>
+              <a:defRPr sz="850" b="0" i="1">
+                <a:solidFill>
+                  <a:srgbClr val="64748B"/>
+                </a:solidFill>
+                <a:latin typeface="Calisto MT"/>
+              </a:defRPr>
+            </a:pPr>
+            <a:r>
+              <a:t>Figure 3.6: AI Human Motion Prediction (Blue = Past 1.0s Walk, Green = Actual Steps, Red = AI Forecast)</a:t>
+            </a:r>
+          </a:p>
+        </p:txBody>
+      </p:sp>
+      <p:pic>
+        <p:nvPicPr>
+          <p:cNvPr id="8" name="Control_Gimbal_Img" descr="camera_gimbal_framed.jpg"/>
+          <p:cNvPicPr>
+            <a:picLocks noChangeAspect="1"/>
+          </p:cNvPicPr>
+          <p:nvPr/>
+        </p:nvPicPr>
+        <p:blipFill>
+          <a:blip r:embed="rId3"/>
+          <a:stretch>
+            <a:fillRect/>
+          </a:stretch>
+        </p:blipFill>
+        <p:spPr>
+          <a:xfrm>
+            <a:off x="6355080" y="3493008"/>
+            <a:ext cx="2103120" cy="1600200"/>
+          </a:xfrm>
+          <a:prstGeom prst="rect">
+            <a:avLst/>
+          </a:prstGeom>
+        </p:spPr>
+      </p:pic>
+      <p:sp>
+        <p:nvSpPr>
+          <p:cNvPr id="9" name="Control_Gimbal_Cap"/>
+          <p:cNvSpPr txBox="1"/>
+          <p:nvPr/>
+        </p:nvSpPr>
+        <p:spPr>
+          <a:xfrm>
+            <a:off x="6355080" y="5120640"/>
+            <a:ext cx="2103120" cy="320040"/>
+          </a:xfrm>
+          <a:prstGeom prst="rect">
+            <a:avLst/>
+          </a:prstGeom>
+          <a:noFill/>
+        </p:spPr>
+        <p:txBody>
+          <a:bodyPr wrap="square" lIns="0" rIns="0" tIns="0" bIns="0">
+            <a:spAutoFit/>
+          </a:bodyPr>
+          <a:lstStyle/>
+          <a:p>
+            <a:pPr algn="ctr">
+              <a:lnSpc>
+                <a:spcPct val="114000"/>
+              </a:lnSpc>
+              <a:spcBef>
+                <a:spcPts val="0"/>
+              </a:spcBef>
+              <a:spcAft>
+                <a:spcPts val="200"/>
+              </a:spcAft>
+              <a:defRPr sz="850" b="0" i="1">
+                <a:solidFill>
+                  <a:srgbClr val="64748B"/>
+                </a:solidFill>
+                <a:latin typeface="Calisto MT"/>
+              </a:defRPr>
+            </a:pPr>
+            <a:r>
+              <a:t>Figure 3.7: 2-Axis Motorized Camera Head</a:t>
+            </a:r>
+          </a:p>
+        </p:txBody>
+      </p:sp>
+      <p:sp>
+        <p:nvSpPr>
+          <p:cNvPr id="10" name="Control_Safety_Text"/>
+          <p:cNvSpPr txBox="1"/>
+          <p:nvPr/>
+        </p:nvSpPr>
+        <p:spPr>
+          <a:xfrm>
+            <a:off x="8641080" y="3493008"/>
+            <a:ext cx="2743200" cy="1965960"/>
+          </a:xfrm>
+          <a:prstGeom prst="rect">
+            <a:avLst/>
+          </a:prstGeom>
+          <a:noFill/>
+        </p:spPr>
+        <p:txBody>
+          <a:bodyPr wrap="square" lIns="0" rIns="0" tIns="0" bIns="0">
+            <a:spAutoFit/>
+          </a:bodyPr>
+          <a:lstStyle/>
+          <a:p>
+            <a:pPr algn="l">
+              <a:lnSpc>
+                <a:spcPct val="114000"/>
+              </a:lnSpc>
+              <a:spcBef>
+                <a:spcPts val="0"/>
+              </a:spcBef>
+              <a:spcAft>
+                <a:spcPts val="300"/>
+              </a:spcAft>
+              <a:defRPr sz="950" b="1" i="0">
+                <a:solidFill>
+                  <a:srgbClr val="B8860B"/>
+                </a:solidFill>
+                <a:latin typeface="Calisto MT"/>
+              </a:defRPr>
+            </a:pPr>
+            <a:r>
+              <a:t>SUPERVISORY SAFETY INTERLOCKS:</a:t>
+            </a:r>
+          </a:p>
+          <a:p>
+            <a:pPr algn="l">
+              <a:lnSpc>
+                <a:spcPct val="112000"/>
+              </a:lnSpc>
+              <a:spcAft>
+                <a:spcPts val="250"/>
+              </a:spcAft>
+            </a:pPr>
+            <a:r>
+              <a:rPr sz="880" b="1">
+                <a:solidFill>
+                  <a:srgbClr val="002060"/>
+                </a:solidFill>
+                <a:latin typeface="Calisto MT"/>
+              </a:rPr>
+              <a:t>• 4 Safe Modes: </a:t>
+            </a:r>
+            <a:r>
+              <a:rPr sz="880" b="0">
+                <a:solidFill>
+                  <a:srgbClr val="334155"/>
+                </a:solidFill>
+                <a:latin typeface="Calisto MT"/>
+              </a:rPr>
+              <a:t>Standby → Confirming → Driving → Safety Halt</a:t>
+            </a:r>
+          </a:p>
+          <a:p>
+            <a:pPr algn="l">
+              <a:lnSpc>
+                <a:spcPct val="112000"/>
+              </a:lnSpc>
+              <a:spcAft>
+                <a:spcPts val="250"/>
+              </a:spcAft>
+            </a:pPr>
+            <a:r>
+              <a:rPr sz="880" b="1">
+                <a:solidFill>
+                  <a:srgbClr val="002060"/>
+                </a:solidFill>
+                <a:latin typeface="Calisto MT"/>
+              </a:rPr>
+              <a:t>• 5-Frame Filter: </a:t>
+            </a:r>
+            <a:r>
+              <a:rPr sz="880" b="0">
+                <a:solidFill>
+                  <a:srgbClr val="334155"/>
+                </a:solidFill>
+                <a:latin typeface="Calisto MT"/>
+              </a:rPr>
+              <a:t>Requires 5 matching frames to stop accidental wave triggers</a:t>
+            </a:r>
+          </a:p>
+          <a:p>
+            <a:pPr algn="l">
+              <a:lnSpc>
+                <a:spcPct val="112000"/>
+              </a:lnSpc>
+              <a:spcAft>
+                <a:spcPts val="250"/>
+              </a:spcAft>
+            </a:pPr>
+            <a:r>
+              <a:rPr sz="880" b="1">
+                <a:solidFill>
+                  <a:srgbClr val="002060"/>
+                </a:solidFill>
+                <a:latin typeface="Calisto MT"/>
+              </a:rPr>
+              <a:t>• Safe Gap (0.8m): </a:t>
+            </a:r>
+            <a:r>
+              <a:rPr sz="880" b="0">
+                <a:solidFill>
+                  <a:srgbClr val="334155"/>
+                </a:solidFill>
+                <a:latin typeface="Calisto MT"/>
+              </a:rPr>
+              <a:t>Stops immediately if user approaches closer than 0.8 meters</a:t>
+            </a:r>
+          </a:p>
+          <a:p>
+            <a:pPr algn="l">
+              <a:lnSpc>
+                <a:spcPct val="112000"/>
+              </a:lnSpc>
+              <a:spcAft>
+                <a:spcPts val="0"/>
+              </a:spcAft>
+            </a:pPr>
+            <a:r>
+              <a:rPr sz="880" b="1">
+                <a:solidFill>
+                  <a:srgbClr val="002060"/>
+                </a:solidFill>
+                <a:latin typeface="Calisto MT"/>
+              </a:rPr>
+              <a:t>• Instant E-Stop: </a:t>
+            </a:r>
+            <a:r>
+              <a:rPr sz="880" b="0">
+                <a:solidFill>
+                  <a:srgbClr val="334155"/>
+                </a:solidFill>
+                <a:latin typeface="Calisto MT"/>
+              </a:rPr>
+              <a:t>Laser barrier (&lt; 0.36m) cuts motor power within 5 milliseconds</a:t>
             </a:r>
           </a:p>
         </p:txBody>

</xml_diff>

<commit_message>
feat: complete slide 12 (Metric SLAM & Nav2 Autonomous Navigation)
</commit_message>
<xml_diff>
--- a/write_up/Project Final Defense Slides_FINAL.pptx
+++ b/write_up/Project Final Defense Slides_FINAL.pptx
@@ -19,6 +19,7 @@
     <p:sldId id="565" r:id="rId16"/>
     <p:sldId id="566" r:id="rId17"/>
     <p:sldId id="567" r:id="rId18"/>
+    <p:sldId id="568" r:id="rId19"/>
   </p:sldIdLst>
   <p:sldSz cx="12192000" cy="6858000"/>
   <p:notesSz cx="6858000" cy="9144000"/>
@@ -3230,6 +3231,757 @@
                 <a:latin typeface="Calisto MT"/>
               </a:rPr>
               <a:t>Laser barrier (&lt; 0.36m) cuts motor power within 5 milliseconds</a:t>
+            </a:r>
+          </a:p>
+        </p:txBody>
+      </p:sp>
+    </p:spTree>
+  </p:cSld>
+  <p:clrMapOvr>
+    <a:masterClrMapping/>
+  </p:clrMapOvr>
+</p:sld>
+</file>
+
+<file path=ppt/slides/slide12.xml><?xml version="1.0" encoding="utf-8"?>
+<p:sld xmlns:a="http://schemas.openxmlformats.org/drawingml/2006/main" xmlns:p="http://schemas.openxmlformats.org/presentationml/2006/main" xmlns:r="http://schemas.openxmlformats.org/officeDocument/2006/relationships">
+  <p:cSld>
+    <p:spTree>
+      <p:nvGrpSpPr>
+        <p:cNvPr id="1" name=""/>
+        <p:cNvGrpSpPr/>
+        <p:nvPr/>
+      </p:nvGrpSpPr>
+      <p:grpSpPr/>
+      <p:sp>
+        <p:nvSpPr>
+          <p:cNvPr id="2" name="Title 1"/>
+          <p:cNvSpPr>
+            <a:spLocks noGrp="1"/>
+          </p:cNvSpPr>
+          <p:nvPr>
+            <p:ph type="title"/>
+          </p:nvPr>
+        </p:nvSpPr>
+        <p:spPr>
+          <a:xfrm>
+            <a:off x="603504" y="320040"/>
+            <a:ext cx="10972800" cy="548640"/>
+          </a:xfrm>
+        </p:spPr>
+        <p:txBody>
+          <a:bodyPr/>
+          <a:lstStyle/>
+          <a:p>
+            <a:pPr algn="ctr">
+              <a:lnSpc>
+                <a:spcPct val="114000"/>
+              </a:lnSpc>
+              <a:spcBef>
+                <a:spcPts val="0"/>
+              </a:spcBef>
+              <a:spcAft>
+                <a:spcPts val="200"/>
+              </a:spcAft>
+              <a:defRPr sz="2400" b="1" i="0">
+                <a:solidFill>
+                  <a:srgbClr val="002060"/>
+                </a:solidFill>
+                <a:latin typeface="Calisto MT"/>
+              </a:defRPr>
+            </a:pPr>
+            <a:r>
+              <a:t>10. METRIC SLAM &amp; NAV2 AUTONOMOUS NAVIGATION</a:t>
+            </a:r>
+          </a:p>
+        </p:txBody>
+      </p:sp>
+      <p:sp>
+        <p:nvSpPr>
+          <p:cNvPr id="3" name="Content Placeholder 2"/>
+          <p:cNvSpPr>
+            <a:spLocks noGrp="1"/>
+          </p:cNvSpPr>
+          <p:nvPr>
+            <p:ph idx="1"/>
+          </p:nvPr>
+        </p:nvSpPr>
+        <p:spPr/>
+        <p:txBody>
+          <a:bodyPr/>
+          <a:lstStyle/>
+          <a:p/>
+        </p:txBody>
+      </p:sp>
+      <p:sp>
+        <p:nvSpPr>
+          <p:cNvPr id="4" name="Nav_Subhead"/>
+          <p:cNvSpPr txBox="1"/>
+          <p:nvPr/>
+        </p:nvSpPr>
+        <p:spPr>
+          <a:xfrm>
+            <a:off x="777240" y="960120"/>
+            <a:ext cx="10634472" cy="228600"/>
+          </a:xfrm>
+          <a:prstGeom prst="rect">
+            <a:avLst/>
+          </a:prstGeom>
+          <a:noFill/>
+        </p:spPr>
+        <p:txBody>
+          <a:bodyPr wrap="square" lIns="0" rIns="0" tIns="0" bIns="0">
+            <a:spAutoFit/>
+          </a:bodyPr>
+          <a:lstStyle/>
+          <a:p>
+            <a:pPr algn="l">
+              <a:lnSpc>
+                <a:spcPct val="114000"/>
+              </a:lnSpc>
+              <a:spcBef>
+                <a:spcPts val="0"/>
+              </a:spcBef>
+              <a:spcAft>
+                <a:spcPts val="200"/>
+              </a:spcAft>
+              <a:defRPr sz="1100" b="1" i="0">
+                <a:solidFill>
+                  <a:srgbClr val="B8860B"/>
+                </a:solidFill>
+                <a:latin typeface="Calisto MT"/>
+              </a:defRPr>
+            </a:pPr>
+            <a:r>
+              <a:t>HOW THE ROBOT MAPS INDOOR ROOMS, FIXES SENSOR DRIFT, AND PATROLS AUTONOMOUSLY</a:t>
+            </a:r>
+          </a:p>
+        </p:txBody>
+      </p:sp>
+      <p:sp>
+        <p:nvSpPr>
+          <p:cNvPr id="5" name="Nav_Points_Text"/>
+          <p:cNvSpPr txBox="1"/>
+          <p:nvPr/>
+        </p:nvSpPr>
+        <p:spPr>
+          <a:xfrm>
+            <a:off x="777240" y="1261872"/>
+            <a:ext cx="5349240" cy="4297680"/>
+          </a:xfrm>
+          <a:prstGeom prst="rect">
+            <a:avLst/>
+          </a:prstGeom>
+          <a:noFill/>
+        </p:spPr>
+        <p:txBody>
+          <a:bodyPr wrap="square" lIns="18288" rIns="18288" tIns="18288" bIns="18288">
+            <a:spAutoFit/>
+          </a:bodyPr>
+          <a:lstStyle/>
+          <a:p>
+            <a:pPr algn="l">
+              <a:lnSpc>
+                <a:spcPct val="115000"/>
+              </a:lnSpc>
+              <a:spcAft>
+                <a:spcPts val="700"/>
+              </a:spcAft>
+            </a:pPr>
+            <a:r>
+              <a:rPr sz="1100" b="1">
+                <a:solidFill>
+                  <a:srgbClr val="002060"/>
+                </a:solidFill>
+                <a:latin typeface="Calisto MT"/>
+              </a:rPr>
+              <a:t>• Laser Room Mapping: </a:t>
+            </a:r>
+            <a:r>
+              <a:rPr sz="1100" b="0">
+                <a:solidFill>
+                  <a:srgbClr val="334155"/>
+                </a:solidFill>
+                <a:latin typeface="Calisto MT"/>
+              </a:rPr>
+              <a:t>As the robot is steered through the room, its 360° laser distance sensor fires 12.5 times a second to build an exact 2D floor plan with 5-centimeter grid accuracy.</a:t>
+            </a:r>
+          </a:p>
+          <a:p>
+            <a:pPr algn="l">
+              <a:lnSpc>
+                <a:spcPct val="115000"/>
+              </a:lnSpc>
+              <a:spcAft>
+                <a:spcPts val="700"/>
+              </a:spcAft>
+            </a:pPr>
+            <a:r>
+              <a:rPr sz="1100" b="1">
+                <a:solidFill>
+                  <a:srgbClr val="002060"/>
+                </a:solidFill>
+                <a:latin typeface="Calisto MT"/>
+              </a:rPr>
+              <a:t>• Resolving Signal Conflicts: </a:t>
+            </a:r>
+            <a:r>
+              <a:rPr sz="1100" b="0">
+                <a:solidFill>
+                  <a:srgbClr val="334155"/>
+                </a:solidFill>
+                <a:latin typeface="Calisto MT"/>
+              </a:rPr>
+              <a:t>Early mapping tests dropped laser scans because two internal programs reported starting locations at once. Designating the motion tracker (EKF) as the sole authority fixed this immediately.</a:t>
+            </a:r>
+          </a:p>
+          <a:p>
+            <a:pPr algn="l">
+              <a:lnSpc>
+                <a:spcPct val="115000"/>
+              </a:lnSpc>
+              <a:spcAft>
+                <a:spcPts val="700"/>
+              </a:spcAft>
+            </a:pPr>
+            <a:r>
+              <a:rPr sz="1100" b="1">
+                <a:solidFill>
+                  <a:srgbClr val="002060"/>
+                </a:solidFill>
+                <a:latin typeface="Calisto MT"/>
+              </a:rPr>
+              <a:t>• Fixing Cornering Drift: </a:t>
+            </a:r>
+            <a:r>
+              <a:rPr sz="1100" b="0">
+                <a:solidFill>
+                  <a:srgbClr val="334155"/>
+                </a:solidFill>
+                <a:latin typeface="Calisto MT"/>
+              </a:rPr>
+              <a:t>During turns, early maps twisted into distorted hourglass shapes because the compass drifted. Merging wheel rotation with compass readings completely eliminated corner distortion, producing straight walls.</a:t>
+            </a:r>
+          </a:p>
+          <a:p>
+            <a:pPr algn="l">
+              <a:lnSpc>
+                <a:spcPct val="115000"/>
+              </a:lnSpc>
+              <a:spcAft>
+                <a:spcPts val="700"/>
+              </a:spcAft>
+            </a:pPr>
+            <a:r>
+              <a:rPr sz="1100" b="1">
+                <a:solidFill>
+                  <a:srgbClr val="002060"/>
+                </a:solidFill>
+                <a:latin typeface="Calisto MT"/>
+              </a:rPr>
+              <a:t>• Self-Localization (AMCL): </a:t>
+            </a:r>
+            <a:r>
+              <a:rPr sz="1100" b="0">
+                <a:solidFill>
+                  <a:srgbClr val="334155"/>
+                </a:solidFill>
+                <a:latin typeface="Calisto MT"/>
+              </a:rPr>
+              <a:t>Once the map is saved, the robot constantly compares live laser scans against the map to know its exact physical coordinates (X, Y, and heading angle) within centimeters.</a:t>
+            </a:r>
+          </a:p>
+          <a:p>
+            <a:pPr algn="l">
+              <a:lnSpc>
+                <a:spcPct val="115000"/>
+              </a:lnSpc>
+              <a:spcAft>
+                <a:spcPts val="700"/>
+              </a:spcAft>
+            </a:pPr>
+            <a:r>
+              <a:rPr sz="1100" b="1">
+                <a:solidFill>
+                  <a:srgbClr val="002060"/>
+                </a:solidFill>
+                <a:latin typeface="Calisto MT"/>
+              </a:rPr>
+              <a:t>• Safety Padding Costmaps: </a:t>
+            </a:r>
+            <a:r>
+              <a:rPr sz="1100" b="0">
+                <a:solidFill>
+                  <a:srgbClr val="334155"/>
+                </a:solidFill>
+                <a:latin typeface="Calisto MT"/>
+              </a:rPr>
+              <a:t>The navigation software automatically inflates a safety padding cushion around all walls and furniture, preventing the robot from cutting corners too close or bumping table legs.</a:t>
+            </a:r>
+          </a:p>
+          <a:p>
+            <a:pPr algn="l">
+              <a:lnSpc>
+                <a:spcPct val="115000"/>
+              </a:lnSpc>
+              <a:spcAft>
+                <a:spcPts val="0"/>
+              </a:spcAft>
+            </a:pPr>
+            <a:r>
+              <a:rPr sz="1100" b="1">
+                <a:solidFill>
+                  <a:srgbClr val="002060"/>
+                </a:solidFill>
+                <a:latin typeface="Calisto MT"/>
+              </a:rPr>
+              <a:t>• Multi-Waypoint Autonomous Patrol: </a:t>
+            </a:r>
+            <a:r>
+              <a:rPr sz="1100" b="0">
+                <a:solidFill>
+                  <a:srgbClr val="334155"/>
+                </a:solidFill>
+                <a:latin typeface="Calisto MT"/>
+              </a:rPr>
+              <a:t>Given a sequence of room destinations (Dock → Central Hub → North Corner → East Post), the robot navigates smoothly across 160 seconds, achieving an average tracking accuracy of 15.5 cm.</a:t>
+            </a:r>
+          </a:p>
+        </p:txBody>
+      </p:sp>
+      <p:sp>
+        <p:nvSpPr>
+          <p:cNvPr id="6" name="Nav_Drift_Label"/>
+          <p:cNvSpPr txBox="1"/>
+          <p:nvPr/>
+        </p:nvSpPr>
+        <p:spPr>
+          <a:xfrm>
+            <a:off x="6355080" y="1261872"/>
+            <a:ext cx="2423160" cy="201168"/>
+          </a:xfrm>
+          <a:prstGeom prst="rect">
+            <a:avLst/>
+          </a:prstGeom>
+          <a:noFill/>
+        </p:spPr>
+        <p:txBody>
+          <a:bodyPr wrap="square" lIns="0" rIns="0" tIns="0" bIns="0">
+            <a:spAutoFit/>
+          </a:bodyPr>
+          <a:lstStyle/>
+          <a:p>
+            <a:pPr algn="ctr">
+              <a:lnSpc>
+                <a:spcPct val="114000"/>
+              </a:lnSpc>
+              <a:spcBef>
+                <a:spcPts val="0"/>
+              </a:spcBef>
+              <a:spcAft>
+                <a:spcPts val="200"/>
+              </a:spcAft>
+              <a:defRPr sz="900" b="1" i="0">
+                <a:solidFill>
+                  <a:srgbClr val="64748B"/>
+                </a:solidFill>
+                <a:latin typeface="Calisto MT"/>
+              </a:defRPr>
+            </a:pPr>
+            <a:r>
+              <a:t>(a) Initial: 45° Corner Drift Defect</a:t>
+            </a:r>
+          </a:p>
+        </p:txBody>
+      </p:sp>
+      <p:sp>
+        <p:nvSpPr>
+          <p:cNvPr id="7" name="Nav_Clean_Label"/>
+          <p:cNvSpPr txBox="1"/>
+          <p:nvPr/>
+        </p:nvSpPr>
+        <p:spPr>
+          <a:xfrm>
+            <a:off x="8915400" y="1261872"/>
+            <a:ext cx="2423160" cy="201168"/>
+          </a:xfrm>
+          <a:prstGeom prst="rect">
+            <a:avLst/>
+          </a:prstGeom>
+          <a:noFill/>
+        </p:spPr>
+        <p:txBody>
+          <a:bodyPr wrap="square" lIns="0" rIns="0" tIns="0" bIns="0">
+            <a:spAutoFit/>
+          </a:bodyPr>
+          <a:lstStyle/>
+          <a:p>
+            <a:pPr algn="ctr">
+              <a:lnSpc>
+                <a:spcPct val="114000"/>
+              </a:lnSpc>
+              <a:spcBef>
+                <a:spcPts val="0"/>
+              </a:spcBef>
+              <a:spcAft>
+                <a:spcPts val="200"/>
+              </a:spcAft>
+              <a:defRPr sz="900" b="1" i="0">
+                <a:solidFill>
+                  <a:srgbClr val="002060"/>
+                </a:solidFill>
+                <a:latin typeface="Calisto MT"/>
+              </a:defRPr>
+            </a:pPr>
+            <a:r>
+              <a:t>(b) Final: Clean Metric Map</a:t>
+            </a:r>
+          </a:p>
+        </p:txBody>
+      </p:sp>
+      <p:pic>
+        <p:nvPicPr>
+          <p:cNvPr id="8" name="Nav_Drift_Img" descr="image.png"/>
+          <p:cNvPicPr>
+            <a:picLocks noChangeAspect="1"/>
+          </p:cNvPicPr>
+          <p:nvPr/>
+        </p:nvPicPr>
+        <p:blipFill>
+          <a:blip r:embed="rId2"/>
+          <a:stretch>
+            <a:fillRect/>
+          </a:stretch>
+        </p:blipFill>
+        <p:spPr>
+          <a:xfrm>
+            <a:off x="6355080" y="1481328"/>
+            <a:ext cx="2423160" cy="1417320"/>
+          </a:xfrm>
+          <a:prstGeom prst="rect">
+            <a:avLst/>
+          </a:prstGeom>
+        </p:spPr>
+      </p:pic>
+      <p:pic>
+        <p:nvPicPr>
+          <p:cNvPr id="9" name="Nav_Clean_Img" descr="image.png"/>
+          <p:cNvPicPr>
+            <a:picLocks noChangeAspect="1"/>
+          </p:cNvPicPr>
+          <p:nvPr/>
+        </p:nvPicPr>
+        <p:blipFill>
+          <a:blip r:embed="rId3"/>
+          <a:stretch>
+            <a:fillRect/>
+          </a:stretch>
+        </p:blipFill>
+        <p:spPr>
+          <a:xfrm>
+            <a:off x="8915400" y="1481328"/>
+            <a:ext cx="2423160" cy="1417320"/>
+          </a:xfrm>
+          <a:prstGeom prst="rect">
+            <a:avLst/>
+          </a:prstGeom>
+        </p:spPr>
+      </p:pic>
+      <p:sp>
+        <p:nvSpPr>
+          <p:cNvPr id="10" name="Nav_SLAM_Cap"/>
+          <p:cNvSpPr txBox="1"/>
+          <p:nvPr/>
+        </p:nvSpPr>
+        <p:spPr>
+          <a:xfrm>
+            <a:off x="6355080" y="2971800"/>
+            <a:ext cx="5029200" cy="256032"/>
+          </a:xfrm>
+          <a:prstGeom prst="rect">
+            <a:avLst/>
+          </a:prstGeom>
+          <a:noFill/>
+        </p:spPr>
+        <p:txBody>
+          <a:bodyPr wrap="square" lIns="0" rIns="0" tIns="0" bIns="0">
+            <a:spAutoFit/>
+          </a:bodyPr>
+          <a:lstStyle/>
+          <a:p>
+            <a:pPr algn="ctr">
+              <a:lnSpc>
+                <a:spcPct val="114000"/>
+              </a:lnSpc>
+              <a:spcBef>
+                <a:spcPts val="0"/>
+              </a:spcBef>
+              <a:spcAft>
+                <a:spcPts val="200"/>
+              </a:spcAft>
+              <a:defRPr sz="850" b="0" i="1">
+                <a:solidFill>
+                  <a:srgbClr val="64748B"/>
+                </a:solidFill>
+                <a:latin typeface="Calisto MT"/>
+              </a:defRPr>
+            </a:pPr>
+            <a:r>
+              <a:t>Figure 3.8: Physical SLAM Calibration — Correcting Yaw Drift via Wheel Odometry Fusion</a:t>
+            </a:r>
+          </a:p>
+        </p:txBody>
+      </p:sp>
+      <p:pic>
+        <p:nvPicPr>
+          <p:cNvPr id="11" name="Nav_Patrol_Img" descr="waypoint_patrol_clean.png"/>
+          <p:cNvPicPr>
+            <a:picLocks noChangeAspect="1"/>
+          </p:cNvPicPr>
+          <p:nvPr/>
+        </p:nvPicPr>
+        <p:blipFill>
+          <a:blip r:embed="rId5"/>
+          <a:stretch>
+            <a:fillRect/>
+          </a:stretch>
+        </p:blipFill>
+        <p:spPr>
+          <a:xfrm>
+            <a:off x="6355080" y="3337560"/>
+            <a:ext cx="1600200" cy="1965960"/>
+          </a:xfrm>
+          <a:prstGeom prst="rect">
+            <a:avLst/>
+          </a:prstGeom>
+        </p:spPr>
+      </p:pic>
+      <p:sp>
+        <p:nvSpPr>
+          <p:cNvPr id="12" name="Nav_Patrol_Cap"/>
+          <p:cNvSpPr txBox="1"/>
+          <p:nvPr/>
+        </p:nvSpPr>
+        <p:spPr>
+          <a:xfrm>
+            <a:off x="6355080" y="5321808"/>
+            <a:ext cx="1600200" cy="237744"/>
+          </a:xfrm>
+          <a:prstGeom prst="rect">
+            <a:avLst/>
+          </a:prstGeom>
+          <a:noFill/>
+        </p:spPr>
+        <p:txBody>
+          <a:bodyPr wrap="square" lIns="0" rIns="0" tIns="0" bIns="0">
+            <a:spAutoFit/>
+          </a:bodyPr>
+          <a:lstStyle/>
+          <a:p>
+            <a:pPr algn="ctr">
+              <a:lnSpc>
+                <a:spcPct val="114000"/>
+              </a:lnSpc>
+              <a:spcBef>
+                <a:spcPts val="0"/>
+              </a:spcBef>
+              <a:spcAft>
+                <a:spcPts val="200"/>
+              </a:spcAft>
+              <a:defRPr sz="800" b="0" i="1">
+                <a:solidFill>
+                  <a:srgbClr val="64748B"/>
+                </a:solidFill>
+                <a:latin typeface="Calisto MT"/>
+              </a:defRPr>
+            </a:pPr>
+            <a:r>
+              <a:t>Figure 3.9: 4-Waypoint Patrol</a:t>
+            </a:r>
+          </a:p>
+        </p:txBody>
+      </p:sp>
+      <p:sp>
+        <p:nvSpPr>
+          <p:cNvPr id="13" name="Nav_Perf_Text"/>
+          <p:cNvSpPr txBox="1"/>
+          <p:nvPr/>
+        </p:nvSpPr>
+        <p:spPr>
+          <a:xfrm>
+            <a:off x="8138160" y="3337560"/>
+            <a:ext cx="3246120" cy="2057400"/>
+          </a:xfrm>
+          <a:prstGeom prst="rect">
+            <a:avLst/>
+          </a:prstGeom>
+          <a:noFill/>
+        </p:spPr>
+        <p:txBody>
+          <a:bodyPr wrap="square" lIns="0" rIns="0" tIns="0" bIns="0">
+            <a:spAutoFit/>
+          </a:bodyPr>
+          <a:lstStyle/>
+          <a:p>
+            <a:pPr algn="l">
+              <a:lnSpc>
+                <a:spcPct val="114000"/>
+              </a:lnSpc>
+              <a:spcBef>
+                <a:spcPts val="0"/>
+              </a:spcBef>
+              <a:spcAft>
+                <a:spcPts val="400"/>
+              </a:spcAft>
+              <a:defRPr sz="950" b="1" i="0">
+                <a:solidFill>
+                  <a:srgbClr val="B8860B"/>
+                </a:solidFill>
+                <a:latin typeface="Calisto MT"/>
+              </a:defRPr>
+            </a:pPr>
+            <a:r>
+              <a:t>AUTONOMOUS PATROL PERFORMANCE:</a:t>
+            </a:r>
+          </a:p>
+          <a:p>
+            <a:pPr algn="l">
+              <a:lnSpc>
+                <a:spcPct val="112000"/>
+              </a:lnSpc>
+              <a:spcAft>
+                <a:spcPts val="250"/>
+              </a:spcAft>
+            </a:pPr>
+            <a:r>
+              <a:rPr sz="880" b="1">
+                <a:solidFill>
+                  <a:srgbClr val="002060"/>
+                </a:solidFill>
+                <a:latin typeface="Calisto MT"/>
+              </a:rPr>
+              <a:t>• Map Resolution: </a:t>
+            </a:r>
+            <a:r>
+              <a:rPr sz="880" b="0">
+                <a:solidFill>
+                  <a:srgbClr val="334155"/>
+                </a:solidFill>
+                <a:latin typeface="Calisto MT"/>
+              </a:rPr>
+              <a:t>5 cm per grid cell for fine obstacle details</a:t>
+            </a:r>
+          </a:p>
+          <a:p>
+            <a:pPr algn="l">
+              <a:lnSpc>
+                <a:spcPct val="112000"/>
+              </a:lnSpc>
+              <a:spcAft>
+                <a:spcPts val="250"/>
+              </a:spcAft>
+            </a:pPr>
+            <a:r>
+              <a:rPr sz="880" b="1">
+                <a:solidFill>
+                  <a:srgbClr val="002060"/>
+                </a:solidFill>
+                <a:latin typeface="Calisto MT"/>
+              </a:rPr>
+              <a:t>• Path Accuracy: </a:t>
+            </a:r>
+            <a:r>
+              <a:rPr sz="880" b="0">
+                <a:solidFill>
+                  <a:srgbClr val="334155"/>
+                </a:solidFill>
+                <a:latin typeface="Calisto MT"/>
+              </a:rPr>
+              <a:t>15.5 cm average tracking error across 160s run</a:t>
+            </a:r>
+          </a:p>
+          <a:p>
+            <a:pPr algn="l">
+              <a:lnSpc>
+                <a:spcPct val="112000"/>
+              </a:lnSpc>
+              <a:spcAft>
+                <a:spcPts val="250"/>
+              </a:spcAft>
+            </a:pPr>
+            <a:r>
+              <a:rPr sz="880" b="1">
+                <a:solidFill>
+                  <a:srgbClr val="002060"/>
+                </a:solidFill>
+                <a:latin typeface="Calisto MT"/>
+              </a:rPr>
+              <a:t>• Safe Velocity: </a:t>
+            </a:r>
+            <a:r>
+              <a:rPr sz="880" b="0">
+                <a:solidFill>
+                  <a:srgbClr val="334155"/>
+                </a:solidFill>
+                <a:latin typeface="Calisto MT"/>
+              </a:rPr>
+              <a:t>Speed capped smoothly at 0.25 m/s for lab safety</a:t>
+            </a:r>
+          </a:p>
+          <a:p>
+            <a:pPr algn="l">
+              <a:lnSpc>
+                <a:spcPct val="112000"/>
+              </a:lnSpc>
+              <a:spcAft>
+                <a:spcPts val="250"/>
+              </a:spcAft>
+            </a:pPr>
+            <a:r>
+              <a:rPr sz="880" b="1">
+                <a:solidFill>
+                  <a:srgbClr val="002060"/>
+                </a:solidFill>
+                <a:latin typeface="Calisto MT"/>
+              </a:rPr>
+              <a:t>• Goal Verification: </a:t>
+            </a:r>
+            <a:r>
+              <a:rPr sz="880" b="0">
+                <a:solidFill>
+                  <a:srgbClr val="334155"/>
+                </a:solidFill>
+                <a:latin typeface="Calisto MT"/>
+              </a:rPr>
+              <a:t>4 / 4 physical destinations reached (Dock → Hub → Corner → Post)</a:t>
+            </a:r>
+          </a:p>
+          <a:p>
+            <a:pPr algn="l">
+              <a:lnSpc>
+                <a:spcPct val="112000"/>
+              </a:lnSpc>
+              <a:spcAft>
+                <a:spcPts val="0"/>
+              </a:spcAft>
+            </a:pPr>
+            <a:r>
+              <a:rPr sz="880" b="1">
+                <a:solidFill>
+                  <a:srgbClr val="002060"/>
+                </a:solidFill>
+                <a:latin typeface="Calisto MT"/>
+              </a:rPr>
+              <a:t>• Obstacle Buffer: </a:t>
+            </a:r>
+            <a:r>
+              <a:rPr sz="880" b="0">
+                <a:solidFill>
+                  <a:srgbClr val="334155"/>
+                </a:solidFill>
+                <a:latin typeface="Calisto MT"/>
+              </a:rPr>
+              <a:t>Safety inflation maintains &gt;0.30 m clearance from walls</a:t>
             </a:r>
           </a:p>
         </p:txBody>

</xml_diff>

<commit_message>
feat: complete slide 13 (System Latency & Classification Accuracy)
</commit_message>
<xml_diff>
--- a/write_up/Project Final Defense Slides_FINAL.pptx
+++ b/write_up/Project Final Defense Slides_FINAL.pptx
@@ -20,6 +20,7 @@
     <p:sldId id="566" r:id="rId17"/>
     <p:sldId id="567" r:id="rId18"/>
     <p:sldId id="568" r:id="rId19"/>
+    <p:sldId id="569" r:id="rId20"/>
   </p:sldIdLst>
   <p:sldSz cx="12192000" cy="6858000"/>
   <p:notesSz cx="6858000" cy="9144000"/>
@@ -3982,6 +3983,615 @@
                 <a:latin typeface="Calisto MT"/>
               </a:rPr>
               <a:t>Safety inflation maintains &gt;0.30 m clearance from walls</a:t>
+            </a:r>
+          </a:p>
+        </p:txBody>
+      </p:sp>
+    </p:spTree>
+  </p:cSld>
+  <p:clrMapOvr>
+    <a:masterClrMapping/>
+  </p:clrMapOvr>
+</p:sld>
+</file>
+
+<file path=ppt/slides/slide13.xml><?xml version="1.0" encoding="utf-8"?>
+<p:sld xmlns:a="http://schemas.openxmlformats.org/drawingml/2006/main" xmlns:p="http://schemas.openxmlformats.org/presentationml/2006/main" xmlns:r="http://schemas.openxmlformats.org/officeDocument/2006/relationships">
+  <p:cSld>
+    <p:spTree>
+      <p:nvGrpSpPr>
+        <p:cNvPr id="1" name=""/>
+        <p:cNvGrpSpPr/>
+        <p:nvPr/>
+      </p:nvGrpSpPr>
+      <p:grpSpPr/>
+      <p:sp>
+        <p:nvSpPr>
+          <p:cNvPr id="2" name="Title 1"/>
+          <p:cNvSpPr>
+            <a:spLocks noGrp="1"/>
+          </p:cNvSpPr>
+          <p:nvPr>
+            <p:ph type="title"/>
+          </p:nvPr>
+        </p:nvSpPr>
+        <p:spPr>
+          <a:xfrm>
+            <a:off x="603504" y="320040"/>
+            <a:ext cx="10972800" cy="548640"/>
+          </a:xfrm>
+        </p:spPr>
+        <p:txBody>
+          <a:bodyPr/>
+          <a:lstStyle/>
+          <a:p>
+            <a:pPr algn="ctr">
+              <a:lnSpc>
+                <a:spcPct val="114000"/>
+              </a:lnSpc>
+              <a:spcBef>
+                <a:spcPts val="0"/>
+              </a:spcBef>
+              <a:spcAft>
+                <a:spcPts val="200"/>
+              </a:spcAft>
+              <a:defRPr sz="2400" b="1" i="0">
+                <a:solidFill>
+                  <a:srgbClr val="002060"/>
+                </a:solidFill>
+                <a:latin typeface="Calisto MT"/>
+              </a:defRPr>
+            </a:pPr>
+            <a:r>
+              <a:t>11. SYSTEM LATENCY &amp; CLASSIFICATION ACCURACY</a:t>
+            </a:r>
+          </a:p>
+        </p:txBody>
+      </p:sp>
+      <p:sp>
+        <p:nvSpPr>
+          <p:cNvPr id="3" name="Content Placeholder 2"/>
+          <p:cNvSpPr>
+            <a:spLocks noGrp="1"/>
+          </p:cNvSpPr>
+          <p:nvPr>
+            <p:ph idx="1"/>
+          </p:nvPr>
+        </p:nvSpPr>
+        <p:spPr/>
+        <p:txBody>
+          <a:bodyPr/>
+          <a:lstStyle/>
+          <a:p/>
+        </p:txBody>
+      </p:sp>
+      <p:sp>
+        <p:nvSpPr>
+          <p:cNvPr id="4" name="Latency_Subhead"/>
+          <p:cNvSpPr txBox="1"/>
+          <p:nvPr/>
+        </p:nvSpPr>
+        <p:spPr>
+          <a:xfrm>
+            <a:off x="777240" y="960120"/>
+            <a:ext cx="10634472" cy="228600"/>
+          </a:xfrm>
+          <a:prstGeom prst="rect">
+            <a:avLst/>
+          </a:prstGeom>
+          <a:noFill/>
+        </p:spPr>
+        <p:txBody>
+          <a:bodyPr wrap="square" lIns="0" rIns="0" tIns="0" bIns="0">
+            <a:spAutoFit/>
+          </a:bodyPr>
+          <a:lstStyle/>
+          <a:p>
+            <a:pPr algn="l">
+              <a:lnSpc>
+                <a:spcPct val="114000"/>
+              </a:lnSpc>
+              <a:spcBef>
+                <a:spcPts val="0"/>
+              </a:spcBef>
+              <a:spcAft>
+                <a:spcPts val="200"/>
+              </a:spcAft>
+              <a:defRPr sz="1100" b="1" i="0">
+                <a:solidFill>
+                  <a:srgbClr val="B8860B"/>
+                </a:solidFill>
+                <a:latin typeface="Calisto MT"/>
+              </a:defRPr>
+            </a:pPr>
+            <a:r>
+              <a:t>REAL-TIME RESPONSE BUDGET, NEURAL ACCURACY, AND MULTI-CONDITION RELIABILITY</a:t>
+            </a:r>
+          </a:p>
+        </p:txBody>
+      </p:sp>
+      <p:sp>
+        <p:nvSpPr>
+          <p:cNvPr id="5" name="Latency_Points_Text"/>
+          <p:cNvSpPr txBox="1"/>
+          <p:nvPr/>
+        </p:nvSpPr>
+        <p:spPr>
+          <a:xfrm>
+            <a:off x="777240" y="1261872"/>
+            <a:ext cx="5349240" cy="4297680"/>
+          </a:xfrm>
+          <a:prstGeom prst="rect">
+            <a:avLst/>
+          </a:prstGeom>
+          <a:noFill/>
+        </p:spPr>
+        <p:txBody>
+          <a:bodyPr wrap="square" lIns="18288" rIns="18288" tIns="18288" bIns="18288">
+            <a:spAutoFit/>
+          </a:bodyPr>
+          <a:lstStyle/>
+          <a:p>
+            <a:pPr algn="l">
+              <a:lnSpc>
+                <a:spcPct val="115000"/>
+              </a:lnSpc>
+              <a:spcAft>
+                <a:spcPts val="700"/>
+              </a:spcAft>
+            </a:pPr>
+            <a:r>
+              <a:rPr sz="1100" b="1">
+                <a:solidFill>
+                  <a:srgbClr val="002060"/>
+                </a:solidFill>
+                <a:latin typeface="Calisto MT"/>
+              </a:rPr>
+              <a:t>• 132-Millisecond Total Response: </a:t>
+            </a:r>
+            <a:r>
+              <a:rPr sz="1100" b="0">
+                <a:solidFill>
+                  <a:srgbClr val="334155"/>
+                </a:solidFill>
+                <a:latin typeface="Calisto MT"/>
+              </a:rPr>
+              <a:t>From light entering the camera lens to physical wheel movement, the complete system takes only 132.0 milliseconds — faster than a human eye blink (300 ms) and well within the 150 ms safety limit.</a:t>
+            </a:r>
+          </a:p>
+          <a:p>
+            <a:pPr algn="l">
+              <a:lnSpc>
+                <a:spcPct val="115000"/>
+              </a:lnSpc>
+              <a:spcAft>
+                <a:spcPts val="700"/>
+              </a:spcAft>
+            </a:pPr>
+            <a:r>
+              <a:rPr sz="1100" b="1">
+                <a:solidFill>
+                  <a:srgbClr val="002060"/>
+                </a:solidFill>
+                <a:latin typeface="Calisto MT"/>
+              </a:rPr>
+              <a:t>• Speed Breakdown by Stage: </a:t>
+            </a:r>
+            <a:r>
+              <a:rPr sz="1100" b="0">
+                <a:solidFill>
+                  <a:srgbClr val="334155"/>
+                </a:solidFill>
+                <a:latin typeface="Calisto MT"/>
+              </a:rPr>
+              <a:t>Camera capture takes 50.0 ms, hand tracking takes 38.2 ms, AI classification takes 1.8 ms, and motor controller communication takes 40.0 ms, proving edge AI runs smoothly without GPUs.</a:t>
+            </a:r>
+          </a:p>
+          <a:p>
+            <a:pPr algn="l">
+              <a:lnSpc>
+                <a:spcPct val="115000"/>
+              </a:lnSpc>
+              <a:spcAft>
+                <a:spcPts val="700"/>
+              </a:spcAft>
+            </a:pPr>
+            <a:r>
+              <a:rPr sz="1100" b="1">
+                <a:solidFill>
+                  <a:srgbClr val="002060"/>
+                </a:solidFill>
+                <a:latin typeface="Calisto MT"/>
+              </a:rPr>
+              <a:t>• 99.38% Gesture AI Accuracy: </a:t>
+            </a:r>
+            <a:r>
+              <a:rPr sz="1100" b="0">
+                <a:solidFill>
+                  <a:srgbClr val="334155"/>
+                </a:solidFill>
+                <a:latin typeface="Calisto MT"/>
+              </a:rPr>
+              <a:t>The compact neural network was evaluated across 6,000 unseen hand poses, correctly identifying commands 99.38% of the time with near-zero confusion between gestures.</a:t>
+            </a:r>
+          </a:p>
+          <a:p>
+            <a:pPr algn="l">
+              <a:lnSpc>
+                <a:spcPct val="115000"/>
+              </a:lnSpc>
+              <a:spcAft>
+                <a:spcPts val="700"/>
+              </a:spcAft>
+            </a:pPr>
+            <a:r>
+              <a:rPr sz="1100" b="1">
+                <a:solidFill>
+                  <a:srgbClr val="002060"/>
+                </a:solidFill>
+                <a:latin typeface="Calisto MT"/>
+              </a:rPr>
+              <a:t>• 180 Physical Mobile Trials: </a:t>
+            </a:r>
+            <a:r>
+              <a:rPr sz="1100" b="0">
+                <a:solidFill>
+                  <a:srgbClr val="334155"/>
+                </a:solidFill>
+                <a:latin typeface="Calisto MT"/>
+              </a:rPr>
+              <a:t>In real-world mobile runs with an operator walking in the lab, the robot achieved an overall command success rate of 96.67% across all 6 gesture commands.</a:t>
+            </a:r>
+          </a:p>
+          <a:p>
+            <a:pPr algn="l">
+              <a:lnSpc>
+                <a:spcPct val="115000"/>
+              </a:lnSpc>
+              <a:spcAft>
+                <a:spcPts val="700"/>
+              </a:spcAft>
+            </a:pPr>
+            <a:r>
+              <a:rPr sz="1100" b="1">
+                <a:solidFill>
+                  <a:srgbClr val="002060"/>
+                </a:solidFill>
+                <a:latin typeface="Calisto MT"/>
+              </a:rPr>
+              <a:t>• Distance Robustness (1m to 2.5m): </a:t>
+            </a:r>
+            <a:r>
+              <a:rPr sz="1100" b="0">
+                <a:solidFill>
+                  <a:srgbClr val="334155"/>
+                </a:solidFill>
+                <a:latin typeface="Calisto MT"/>
+              </a:rPr>
+              <a:t>Because hand measurements are scaled automatically using palm width, recognition remains highly accurate whether standing 1.0 meter away (100%) or 2.5 meters away (92.6%).</a:t>
+            </a:r>
+          </a:p>
+          <a:p>
+            <a:pPr algn="l">
+              <a:lnSpc>
+                <a:spcPct val="115000"/>
+              </a:lnSpc>
+              <a:spcAft>
+                <a:spcPts val="0"/>
+              </a:spcAft>
+            </a:pPr>
+            <a:r>
+              <a:rPr sz="1100" b="1">
+                <a:solidFill>
+                  <a:srgbClr val="002060"/>
+                </a:solidFill>
+                <a:latin typeface="Calisto MT"/>
+              </a:rPr>
+              <a:t>• Lighting Consistency: </a:t>
+            </a:r>
+            <a:r>
+              <a:rPr sz="1100" b="0">
+                <a:solidFill>
+                  <a:srgbClr val="334155"/>
+                </a:solidFill>
+                <a:latin typeface="Calisto MT"/>
+              </a:rPr>
+              <a:t>Statistical testing confirmed identical reaction times under natural sunlight (132.7 ms) and indoor fluorescent room lighting (132.5 ms), ensuring dependable all-day operation.</a:t>
+            </a:r>
+          </a:p>
+        </p:txBody>
+      </p:sp>
+      <p:pic>
+        <p:nvPicPr>
+          <p:cNvPr id="6" name="Latency_Boxplot_Img" descr="fig_latency_boxplot_framed.png"/>
+          <p:cNvPicPr>
+            <a:picLocks noChangeAspect="1"/>
+          </p:cNvPicPr>
+          <p:nvPr/>
+        </p:nvPicPr>
+        <p:blipFill>
+          <a:blip r:embed="rId2"/>
+          <a:stretch>
+            <a:fillRect/>
+          </a:stretch>
+        </p:blipFill>
+        <p:spPr>
+          <a:xfrm>
+            <a:off x="6355080" y="1261872"/>
+            <a:ext cx="5029200" cy="1874519"/>
+          </a:xfrm>
+          <a:prstGeom prst="rect">
+            <a:avLst/>
+          </a:prstGeom>
+        </p:spPr>
+      </p:pic>
+      <p:sp>
+        <p:nvSpPr>
+          <p:cNvPr id="7" name="Latency_Boxplot_Cap"/>
+          <p:cNvSpPr txBox="1"/>
+          <p:nvPr/>
+        </p:nvSpPr>
+        <p:spPr>
+          <a:xfrm>
+            <a:off x="6355080" y="3163824"/>
+            <a:ext cx="5029200" cy="256032"/>
+          </a:xfrm>
+          <a:prstGeom prst="rect">
+            <a:avLst/>
+          </a:prstGeom>
+          <a:noFill/>
+        </p:spPr>
+        <p:txBody>
+          <a:bodyPr wrap="square" lIns="0" rIns="0" tIns="0" bIns="0">
+            <a:spAutoFit/>
+          </a:bodyPr>
+          <a:lstStyle/>
+          <a:p>
+            <a:pPr algn="ctr">
+              <a:lnSpc>
+                <a:spcPct val="114000"/>
+              </a:lnSpc>
+              <a:spcBef>
+                <a:spcPts val="0"/>
+              </a:spcBef>
+              <a:spcAft>
+                <a:spcPts val="200"/>
+              </a:spcAft>
+              <a:defRPr sz="850" b="0" i="1">
+                <a:solidFill>
+                  <a:srgbClr val="64748B"/>
+                </a:solidFill>
+                <a:latin typeface="Calisto MT"/>
+              </a:defRPr>
+            </a:pPr>
+            <a:r>
+              <a:t>Figure 4.1: End-to-End Latency Across Operating Distances &amp; Lighting Regimes (180 Trials)</a:t>
+            </a:r>
+          </a:p>
+        </p:txBody>
+      </p:sp>
+      <p:pic>
+        <p:nvPicPr>
+          <p:cNvPr id="8" name="Latency_CM_Img" descr="confusion_matrix_framed.png"/>
+          <p:cNvPicPr>
+            <a:picLocks noChangeAspect="1"/>
+          </p:cNvPicPr>
+          <p:nvPr/>
+        </p:nvPicPr>
+        <p:blipFill>
+          <a:blip r:embed="rId3"/>
+          <a:stretch>
+            <a:fillRect/>
+          </a:stretch>
+        </p:blipFill>
+        <p:spPr>
+          <a:xfrm>
+            <a:off x="6355080" y="3474720"/>
+            <a:ext cx="2103120" cy="1645920"/>
+          </a:xfrm>
+          <a:prstGeom prst="rect">
+            <a:avLst/>
+          </a:prstGeom>
+        </p:spPr>
+      </p:pic>
+      <p:sp>
+        <p:nvSpPr>
+          <p:cNvPr id="9" name="Latency_CM_Cap"/>
+          <p:cNvSpPr txBox="1"/>
+          <p:nvPr/>
+        </p:nvSpPr>
+        <p:spPr>
+          <a:xfrm>
+            <a:off x="6355080" y="5157216"/>
+            <a:ext cx="2103120" cy="292608"/>
+          </a:xfrm>
+          <a:prstGeom prst="rect">
+            <a:avLst/>
+          </a:prstGeom>
+          <a:noFill/>
+        </p:spPr>
+        <p:txBody>
+          <a:bodyPr wrap="square" lIns="0" rIns="0" tIns="0" bIns="0">
+            <a:spAutoFit/>
+          </a:bodyPr>
+          <a:lstStyle/>
+          <a:p>
+            <a:pPr algn="ctr">
+              <a:lnSpc>
+                <a:spcPct val="114000"/>
+              </a:lnSpc>
+              <a:spcBef>
+                <a:spcPts val="0"/>
+              </a:spcBef>
+              <a:spcAft>
+                <a:spcPts val="200"/>
+              </a:spcAft>
+              <a:defRPr sz="850" b="0" i="1">
+                <a:solidFill>
+                  <a:srgbClr val="64748B"/>
+                </a:solidFill>
+                <a:latin typeface="Calisto MT"/>
+              </a:defRPr>
+            </a:pPr>
+            <a:r>
+              <a:t>Figure 4.2: 99.38% Confusion Matrix</a:t>
+            </a:r>
+          </a:p>
+        </p:txBody>
+      </p:sp>
+      <p:sp>
+        <p:nvSpPr>
+          <p:cNvPr id="10" name="Latency_Bench_Text"/>
+          <p:cNvSpPr txBox="1"/>
+          <p:nvPr/>
+        </p:nvSpPr>
+        <p:spPr>
+          <a:xfrm>
+            <a:off x="8641080" y="3474720"/>
+            <a:ext cx="2743200" cy="1965960"/>
+          </a:xfrm>
+          <a:prstGeom prst="rect">
+            <a:avLst/>
+          </a:prstGeom>
+          <a:noFill/>
+        </p:spPr>
+        <p:txBody>
+          <a:bodyPr wrap="square" lIns="0" rIns="0" tIns="0" bIns="0">
+            <a:spAutoFit/>
+          </a:bodyPr>
+          <a:lstStyle/>
+          <a:p>
+            <a:pPr algn="l">
+              <a:lnSpc>
+                <a:spcPct val="114000"/>
+              </a:lnSpc>
+              <a:spcBef>
+                <a:spcPts val="0"/>
+              </a:spcBef>
+              <a:spcAft>
+                <a:spcPts val="300"/>
+              </a:spcAft>
+              <a:defRPr sz="950" b="1" i="0">
+                <a:solidFill>
+                  <a:srgbClr val="B8860B"/>
+                </a:solidFill>
+                <a:latin typeface="Calisto MT"/>
+              </a:defRPr>
+            </a:pPr>
+            <a:r>
+              <a:t>EMPIRICAL BENCHMARKS:</a:t>
+            </a:r>
+          </a:p>
+          <a:p>
+            <a:pPr algn="l">
+              <a:lnSpc>
+                <a:spcPct val="112000"/>
+              </a:lnSpc>
+              <a:spcAft>
+                <a:spcPts val="250"/>
+              </a:spcAft>
+            </a:pPr>
+            <a:r>
+              <a:rPr sz="880" b="1">
+                <a:solidFill>
+                  <a:srgbClr val="002060"/>
+                </a:solidFill>
+                <a:latin typeface="Calisto MT"/>
+              </a:rPr>
+              <a:t>• Turnaround Time: </a:t>
+            </a:r>
+            <a:r>
+              <a:rPr sz="880" b="0">
+                <a:solidFill>
+                  <a:srgbClr val="334155"/>
+                </a:solidFill>
+                <a:latin typeface="Calisto MT"/>
+              </a:rPr>
+              <a:t>132.6 ms mean (fastest: 123 ms, peak: 143 ms)</a:t>
+            </a:r>
+          </a:p>
+          <a:p>
+            <a:pPr algn="l">
+              <a:lnSpc>
+                <a:spcPct val="112000"/>
+              </a:lnSpc>
+              <a:spcAft>
+                <a:spcPts val="250"/>
+              </a:spcAft>
+            </a:pPr>
+            <a:r>
+              <a:rPr sz="880" b="1">
+                <a:solidFill>
+                  <a:srgbClr val="002060"/>
+                </a:solidFill>
+                <a:latin typeface="Calisto MT"/>
+              </a:rPr>
+              <a:t>• AI Accuracy: </a:t>
+            </a:r>
+            <a:r>
+              <a:rPr sz="880" b="0">
+                <a:solidFill>
+                  <a:srgbClr val="334155"/>
+                </a:solidFill>
+                <a:latin typeface="Calisto MT"/>
+              </a:rPr>
+              <a:t>99.38% correct across 6,000 lab test samples</a:t>
+            </a:r>
+          </a:p>
+          <a:p>
+            <a:pPr algn="l">
+              <a:lnSpc>
+                <a:spcPct val="112000"/>
+              </a:lnSpc>
+              <a:spcAft>
+                <a:spcPts val="250"/>
+              </a:spcAft>
+            </a:pPr>
+            <a:r>
+              <a:rPr sz="880" b="1">
+                <a:solidFill>
+                  <a:srgbClr val="002060"/>
+                </a:solidFill>
+                <a:latin typeface="Calisto MT"/>
+              </a:rPr>
+              <a:t>• Physical Runs: </a:t>
+            </a:r>
+            <a:r>
+              <a:rPr sz="880" b="0">
+                <a:solidFill>
+                  <a:srgbClr val="334155"/>
+                </a:solidFill>
+                <a:latin typeface="Calisto MT"/>
+              </a:rPr>
+              <a:t>96.67% command success across 180 mobile trials</a:t>
+            </a:r>
+          </a:p>
+          <a:p>
+            <a:pPr algn="l">
+              <a:lnSpc>
+                <a:spcPct val="112000"/>
+              </a:lnSpc>
+              <a:spcAft>
+                <a:spcPts val="0"/>
+              </a:spcAft>
+            </a:pPr>
+            <a:r>
+              <a:rPr sz="880" b="1">
+                <a:solidFill>
+                  <a:srgbClr val="002060"/>
+                </a:solidFill>
+                <a:latin typeface="Calisto MT"/>
+              </a:rPr>
+              <a:t>• Safety Standard: </a:t>
+            </a:r>
+            <a:r>
+              <a:rPr sz="880" b="0">
+                <a:solidFill>
+                  <a:srgbClr val="334155"/>
+                </a:solidFill>
+                <a:latin typeface="Calisto MT"/>
+              </a:rPr>
+              <a:t>100% of runs below 150 ms ISO 15066 bound</a:t>
             </a:r>
           </a:p>
         </p:txBody>

</xml_diff>

<commit_message>
feat(slides): list Slide 16 references in single full-width column
</commit_message>
<xml_diff>
--- a/write_up/Project Final Defense Slides_FINAL.pptx
+++ b/write_up/Project Final Defense Slides_FINAL.pptx
@@ -355,7 +355,7 @@
             <a:pPr indent="0" algn="r">
               <a:buNone/>
             </a:pPr>
-            <a:fld id="{F39C2CF8-7216-4F80-94E5-8F7F19DD5D59}" type="slidenum">
+            <a:fld id="{79F1DD84-73D3-4A9F-A739-9041A809605C}" type="slidenum">
               <a:rPr b="0" lang="en-US" sz="1400" spc="-1" strike="noStrike">
                 <a:solidFill>
                   <a:srgbClr val="000000"/>
@@ -398,7 +398,7 @@
       </p:grpSpPr>
       <p:sp>
         <p:nvSpPr>
-          <p:cNvPr id="130" name="PlaceHolder 1"/>
+          <p:cNvPr id="128" name="PlaceHolder 1"/>
           <p:cNvSpPr>
             <a:spLocks noGrp="1"/>
           </p:cNvSpPr>
@@ -409,7 +409,7 @@
         <p:spPr>
           <a:xfrm>
             <a:off x="685800" y="1143000"/>
-            <a:ext cx="5485680" cy="3085560"/>
+            <a:ext cx="5485320" cy="3085200"/>
           </a:xfrm>
           <a:prstGeom prst="rect">
             <a:avLst/>
@@ -421,7 +421,7 @@
       </p:sp>
       <p:sp>
         <p:nvSpPr>
-          <p:cNvPr id="131" name="PlaceHolder 2"/>
+          <p:cNvPr id="129" name="PlaceHolder 2"/>
           <p:cNvSpPr>
             <a:spLocks noGrp="1"/>
           </p:cNvSpPr>
@@ -432,7 +432,7 @@
         <p:spPr>
           <a:xfrm>
             <a:off x="685800" y="4400640"/>
-            <a:ext cx="5485680" cy="3599640"/>
+            <a:ext cx="5485320" cy="3599280"/>
           </a:xfrm>
           <a:prstGeom prst="rect">
             <a:avLst/>
@@ -461,7 +461,7 @@
       </p:sp>
       <p:sp>
         <p:nvSpPr>
-          <p:cNvPr id="132" name="PlaceHolder 3"/>
+          <p:cNvPr id="130" name="PlaceHolder 3"/>
           <p:cNvSpPr>
             <a:spLocks noGrp="1"/>
           </p:cNvSpPr>
@@ -472,7 +472,7 @@
         <p:spPr>
           <a:xfrm>
             <a:off x="3884760" y="8685360"/>
-            <a:ext cx="2971080" cy="457920"/>
+            <a:ext cx="2970720" cy="457560"/>
           </a:xfrm>
           <a:prstGeom prst="rect">
             <a:avLst/>
@@ -513,14 +513,14 @@
                 <a:tab algn="l" pos="0"/>
               </a:tabLst>
             </a:pPr>
-            <a:fld id="{E60DA14F-9B56-4F37-B4C0-7AEE0AF30BA2}" type="slidenum">
+            <a:fld id="{C0C81065-BADC-46F8-AEB7-784C4C2E8E49}" type="slidenum">
               <a:rPr b="0" lang="en-US" sz="1200" spc="-1" strike="noStrike">
                 <a:solidFill>
                   <a:srgbClr val="000000"/>
                 </a:solidFill>
                 <a:latin typeface="Times New Roman"/>
               </a:rPr>
-              <a:t>5</a:t>
+              <a:t>&lt;number&gt;</a:t>
             </a:fld>
             <a:endParaRPr b="0" lang="en-US" sz="1200" spc="-1" strike="noStrike">
               <a:solidFill>
@@ -587,7 +587,7 @@
         <p:txBody>
           <a:bodyPr/>
           <a:p>
-            <a:fld id="{A5B3A9A9-AFCB-4689-B5F3-362964BD54E3}" type="slidenum">
+            <a:fld id="{CE525CB7-9614-43C6-B841-F0E9A91BB438}" type="slidenum">
               <a:t>&lt;#&gt;</a:t>
             </a:fld>
           </a:p>
@@ -649,7 +649,7 @@
         <p:spPr>
           <a:xfrm>
             <a:off x="838080" y="365040"/>
-            <a:ext cx="10514880" cy="1324800"/>
+            <a:ext cx="10514520" cy="1324440"/>
           </a:xfrm>
           <a:prstGeom prst="rect">
             <a:avLst/>
@@ -689,7 +689,7 @@
         <p:spPr>
           <a:xfrm>
             <a:off x="838080" y="1825560"/>
-            <a:ext cx="10514880" cy="4350600"/>
+            <a:ext cx="10514520" cy="4350240"/>
           </a:xfrm>
           <a:prstGeom prst="rect">
             <a:avLst/>
@@ -753,7 +753,7 @@
         <p:txBody>
           <a:bodyPr/>
           <a:p>
-            <a:fld id="{488024A9-ECC5-43F3-ACFC-995E731DDA90}" type="slidenum">
+            <a:fld id="{4C150E0B-732F-4B52-AA0D-B2D46636D73D}" type="slidenum">
               <a:t>&lt;#&gt;</a:t>
             </a:fld>
           </a:p>
@@ -811,7 +811,7 @@
         <p:spPr>
           <a:xfrm>
             <a:off x="4038480" y="2334600"/>
-            <a:ext cx="3308400" cy="3186360"/>
+            <a:ext cx="3308040" cy="3186000"/>
           </a:xfrm>
           <a:prstGeom prst="ellipse">
             <a:avLst/>
@@ -862,7 +862,7 @@
         <p:spPr>
           <a:xfrm>
             <a:off x="0" y="0"/>
-            <a:ext cx="12191400" cy="6176160"/>
+            <a:ext cx="12191040" cy="6175800"/>
           </a:xfrm>
           <a:prstGeom prst="rect">
             <a:avLst/>
@@ -920,7 +920,7 @@
         <p:spPr>
           <a:xfrm>
             <a:off x="0" y="0"/>
-            <a:ext cx="9143280" cy="185040"/>
+            <a:ext cx="9142920" cy="184680"/>
           </a:xfrm>
           <a:prstGeom prst="rect">
             <a:avLst/>
@@ -976,7 +976,7 @@
         <p:spPr>
           <a:xfrm>
             <a:off x="9144000" y="0"/>
-            <a:ext cx="3047400" cy="185040"/>
+            <a:ext cx="3047040" cy="184680"/>
           </a:xfrm>
           <a:prstGeom prst="rect">
             <a:avLst/>
@@ -1032,7 +1032,7 @@
         <p:spPr>
           <a:xfrm>
             <a:off x="0" y="6176880"/>
-            <a:ext cx="12191400" cy="680400"/>
+            <a:ext cx="12191040" cy="680040"/>
           </a:xfrm>
           <a:prstGeom prst="rect">
             <a:avLst/>
@@ -1092,7 +1092,7 @@
         <p:spPr>
           <a:xfrm>
             <a:off x="8210520" y="6176880"/>
-            <a:ext cx="3980880" cy="684360"/>
+            <a:ext cx="3980520" cy="684000"/>
           </a:xfrm>
           <a:prstGeom prst="rect">
             <a:avLst/>
@@ -1118,7 +1118,7 @@
         <p:spPr>
           <a:xfrm>
             <a:off x="4038480" y="6356520"/>
-            <a:ext cx="4114080" cy="364320"/>
+            <a:ext cx="4113720" cy="363960"/>
           </a:xfrm>
           <a:prstGeom prst="rect">
             <a:avLst/>
@@ -1166,7 +1166,7 @@
                 </a:solidFill>
                 <a:latin typeface="Times New Roman"/>
               </a:rPr>
-              <a:t>&lt;footer&gt;</a:t>
+              <a:t> </a:t>
             </a:r>
             <a:endParaRPr b="0" lang="en-US" sz="1400" spc="-1" strike="noStrike">
               <a:solidFill>
@@ -1190,7 +1190,7 @@
         <p:spPr>
           <a:xfrm>
             <a:off x="8610480" y="6356520"/>
-            <a:ext cx="2742480" cy="364320"/>
+            <a:ext cx="2742120" cy="363960"/>
           </a:xfrm>
           <a:prstGeom prst="rect">
             <a:avLst/>
@@ -1231,14 +1231,14 @@
                 <a:tab algn="l" pos="0"/>
               </a:tabLst>
             </a:pPr>
-            <a:fld id="{0E2F7279-3F02-4FCD-8085-2F0B9C306C9F}" type="slidenum">
+            <a:fld id="{7BC78425-1B59-4B85-BDDE-CDA99347A610}" type="slidenum">
               <a:rPr b="0" lang="en-US" sz="1800" spc="-1" strike="noStrike">
                 <a:solidFill>
                   <a:schemeClr val="dk1"/>
                 </a:solidFill>
                 <a:latin typeface="Calibri"/>
               </a:rPr>
-              <a:t>&lt;number&gt;</a:t>
+              <a:t>16</a:t>
             </a:fld>
             <a:endParaRPr b="0" lang="en-US" sz="1800" spc="-1" strike="noStrike">
               <a:solidFill>
@@ -1262,7 +1262,7 @@
         <p:spPr>
           <a:xfrm>
             <a:off x="838080" y="6356520"/>
-            <a:ext cx="2742480" cy="364320"/>
+            <a:ext cx="2742120" cy="363960"/>
           </a:xfrm>
           <a:prstGeom prst="rect">
             <a:avLst/>
@@ -1298,7 +1298,7 @@
                 </a:solidFill>
                 <a:latin typeface="Times New Roman"/>
               </a:rPr>
-              <a:t>&lt;date/time&gt;</a:t>
+              <a:t> </a:t>
             </a:r>
             <a:endParaRPr b="0" lang="en-US" sz="1400" spc="-1" strike="noStrike">
               <a:solidFill>
@@ -1618,7 +1618,7 @@
         <p:spPr>
           <a:xfrm>
             <a:off x="4038480" y="2334600"/>
-            <a:ext cx="3308400" cy="3186360"/>
+            <a:ext cx="3308040" cy="3186000"/>
           </a:xfrm>
           <a:prstGeom prst="ellipse">
             <a:avLst/>
@@ -1669,7 +1669,7 @@
         <p:spPr>
           <a:xfrm>
             <a:off x="0" y="0"/>
-            <a:ext cx="12191400" cy="6176160"/>
+            <a:ext cx="12191040" cy="6175800"/>
           </a:xfrm>
           <a:prstGeom prst="rect">
             <a:avLst/>
@@ -1727,7 +1727,7 @@
         <p:spPr>
           <a:xfrm>
             <a:off x="0" y="0"/>
-            <a:ext cx="9143280" cy="185040"/>
+            <a:ext cx="9142920" cy="184680"/>
           </a:xfrm>
           <a:prstGeom prst="rect">
             <a:avLst/>
@@ -1783,7 +1783,7 @@
         <p:spPr>
           <a:xfrm>
             <a:off x="9144000" y="0"/>
-            <a:ext cx="3047400" cy="185040"/>
+            <a:ext cx="3047040" cy="184680"/>
           </a:xfrm>
           <a:prstGeom prst="rect">
             <a:avLst/>
@@ -1839,7 +1839,7 @@
         <p:spPr>
           <a:xfrm>
             <a:off x="0" y="6176880"/>
-            <a:ext cx="12191400" cy="680400"/>
+            <a:ext cx="12191040" cy="680040"/>
           </a:xfrm>
           <a:prstGeom prst="rect">
             <a:avLst/>
@@ -1899,7 +1899,7 @@
         <p:spPr>
           <a:xfrm>
             <a:off x="8210520" y="6176880"/>
-            <a:ext cx="3980880" cy="684360"/>
+            <a:ext cx="3980520" cy="684000"/>
           </a:xfrm>
           <a:prstGeom prst="rect">
             <a:avLst/>
@@ -1925,7 +1925,7 @@
         <p:spPr>
           <a:xfrm>
             <a:off x="838080" y="365040"/>
-            <a:ext cx="10514880" cy="1324800"/>
+            <a:ext cx="10514520" cy="1324440"/>
           </a:xfrm>
           <a:prstGeom prst="rect">
             <a:avLst/>
@@ -1974,7 +1974,7 @@
         <p:spPr>
           <a:xfrm>
             <a:off x="838080" y="1825560"/>
-            <a:ext cx="10514880" cy="4350600"/>
+            <a:ext cx="10514520" cy="4350240"/>
           </a:xfrm>
           <a:prstGeom prst="rect">
             <a:avLst/>
@@ -2199,7 +2199,7 @@
         <p:spPr>
           <a:xfrm>
             <a:off x="4165560" y="6356520"/>
-            <a:ext cx="3859920" cy="364320"/>
+            <a:ext cx="3859560" cy="363960"/>
           </a:xfrm>
           <a:prstGeom prst="rect">
             <a:avLst/>
@@ -2271,7 +2271,7 @@
         <p:spPr>
           <a:xfrm>
             <a:off x="8737560" y="6356520"/>
-            <a:ext cx="2844000" cy="364320"/>
+            <a:ext cx="2843640" cy="363960"/>
           </a:xfrm>
           <a:prstGeom prst="rect">
             <a:avLst/>
@@ -2312,7 +2312,7 @@
                 <a:tab algn="l" pos="0"/>
               </a:tabLst>
             </a:pPr>
-            <a:fld id="{0F9D4980-4C46-4685-BE16-35A7C3749683}" type="slidenum">
+            <a:fld id="{AA96B4B1-F9E8-49C7-8A60-F2B79D89E015}" type="slidenum">
               <a:rPr b="0" lang="en-GB" sz="1800" spc="-1" strike="noStrike">
                 <a:solidFill>
                   <a:schemeClr val="dk1"/>
@@ -2343,7 +2343,7 @@
         <p:spPr>
           <a:xfrm>
             <a:off x="609480" y="6356520"/>
-            <a:ext cx="2844000" cy="364320"/>
+            <a:ext cx="2843640" cy="363960"/>
           </a:xfrm>
           <a:prstGeom prst="rect">
             <a:avLst/>
@@ -2425,7 +2425,7 @@
         <p:spPr>
           <a:xfrm>
             <a:off x="0" y="0"/>
-            <a:ext cx="5572800" cy="6857280"/>
+            <a:ext cx="5572440" cy="6856920"/>
           </a:xfrm>
           <a:prstGeom prst="rect">
             <a:avLst/>
@@ -2481,7 +2481,7 @@
         <p:spPr>
           <a:xfrm>
             <a:off x="5573520" y="0"/>
-            <a:ext cx="347760" cy="6857280"/>
+            <a:ext cx="347400" cy="6856920"/>
           </a:xfrm>
           <a:prstGeom prst="rect">
             <a:avLst/>
@@ -2537,7 +2537,7 @@
         <p:spPr>
           <a:xfrm>
             <a:off x="5921640" y="0"/>
-            <a:ext cx="6269400" cy="6857280"/>
+            <a:ext cx="6269040" cy="6856920"/>
           </a:xfrm>
           <a:prstGeom prst="rect">
             <a:avLst/>
@@ -2806,7 +2806,7 @@
         <p:spPr>
           <a:xfrm>
             <a:off x="789120" y="2658240"/>
-            <a:ext cx="3994560" cy="3628440"/>
+            <a:ext cx="3994200" cy="3628080"/>
           </a:xfrm>
           <a:prstGeom prst="rect">
             <a:avLst/>
@@ -2825,7 +2825,7 @@
         <p:spPr>
           <a:xfrm>
             <a:off x="75240" y="210240"/>
-            <a:ext cx="5845680" cy="2284200"/>
+            <a:ext cx="5845320" cy="2284200"/>
           </a:xfrm>
           <a:prstGeom prst="rect">
             <a:avLst/>
@@ -2913,7 +2913,7 @@
         <p:spPr>
           <a:xfrm>
             <a:off x="603360" y="320040"/>
-            <a:ext cx="10972080" cy="547920"/>
+            <a:ext cx="10971720" cy="547560"/>
           </a:xfrm>
           <a:prstGeom prst="rect">
             <a:avLst/>
@@ -2967,7 +2967,7 @@
         <p:spPr>
           <a:xfrm>
             <a:off x="777240" y="960120"/>
-            <a:ext cx="10633680" cy="191160"/>
+            <a:ext cx="10633320" cy="190800"/>
           </a:xfrm>
           <a:prstGeom prst="rect">
             <a:avLst/>
@@ -3023,7 +3023,7 @@
         <p:spPr>
           <a:xfrm>
             <a:off x="777240" y="1261800"/>
-            <a:ext cx="5348520" cy="4582800"/>
+            <a:ext cx="5348160" cy="4582800"/>
           </a:xfrm>
           <a:prstGeom prst="rect">
             <a:avLst/>
@@ -3313,7 +3313,7 @@
         <p:spPr>
           <a:xfrm>
             <a:off x="6355080" y="1261800"/>
-            <a:ext cx="3016800" cy="2266920"/>
+            <a:ext cx="3016440" cy="2266560"/>
           </a:xfrm>
           <a:prstGeom prst="rect">
             <a:avLst/>
@@ -3332,7 +3332,7 @@
         <p:spPr>
           <a:xfrm>
             <a:off x="6355080" y="3566160"/>
-            <a:ext cx="3016800" cy="363960"/>
+            <a:ext cx="3016440" cy="363960"/>
           </a:xfrm>
           <a:prstGeom prst="rect">
             <a:avLst/>
@@ -3392,7 +3392,7 @@
         <p:spPr>
           <a:xfrm>
             <a:off x="9555480" y="1261800"/>
-            <a:ext cx="1965240" cy="3748320"/>
+            <a:ext cx="1964880" cy="3747960"/>
           </a:xfrm>
           <a:prstGeom prst="rect">
             <a:avLst/>
@@ -3411,7 +3411,7 @@
         <p:spPr>
           <a:xfrm>
             <a:off x="9555480" y="5047560"/>
-            <a:ext cx="1965240" cy="381960"/>
+            <a:ext cx="1964880" cy="381960"/>
           </a:xfrm>
           <a:prstGeom prst="rect">
             <a:avLst/>
@@ -3467,7 +3467,7 @@
         <p:spPr>
           <a:xfrm>
             <a:off x="6355080" y="4373640"/>
-            <a:ext cx="3108240" cy="869040"/>
+            <a:ext cx="3107880" cy="868680"/>
           </a:xfrm>
           <a:prstGeom prst="rect">
             <a:avLst/>
@@ -3683,7 +3683,7 @@
         <p:spPr>
           <a:xfrm>
             <a:off x="603360" y="320040"/>
-            <a:ext cx="10972080" cy="547920"/>
+            <a:ext cx="10971720" cy="547560"/>
           </a:xfrm>
           <a:prstGeom prst="rect">
             <a:avLst/>
@@ -3737,7 +3737,7 @@
         <p:spPr>
           <a:xfrm>
             <a:off x="777240" y="960120"/>
-            <a:ext cx="10633680" cy="191160"/>
+            <a:ext cx="10633320" cy="190800"/>
           </a:xfrm>
           <a:prstGeom prst="rect">
             <a:avLst/>
@@ -3793,7 +3793,7 @@
         <p:spPr>
           <a:xfrm>
             <a:off x="777240" y="1261800"/>
-            <a:ext cx="5348520" cy="3947760"/>
+            <a:ext cx="5348160" cy="3947760"/>
           </a:xfrm>
           <a:prstGeom prst="rect">
             <a:avLst/>
@@ -4083,7 +4083,7 @@
         <p:spPr>
           <a:xfrm>
             <a:off x="6355080" y="1261800"/>
-            <a:ext cx="5028480" cy="1873800"/>
+            <a:ext cx="5028120" cy="1873440"/>
           </a:xfrm>
           <a:prstGeom prst="rect">
             <a:avLst/>
@@ -4102,7 +4102,7 @@
         <p:spPr>
           <a:xfrm>
             <a:off x="6355080" y="3163680"/>
-            <a:ext cx="5028480" cy="147600"/>
+            <a:ext cx="5028120" cy="147240"/>
           </a:xfrm>
           <a:prstGeom prst="rect">
             <a:avLst/>
@@ -4162,7 +4162,7 @@
         <p:spPr>
           <a:xfrm>
             <a:off x="6355080" y="3493080"/>
-            <a:ext cx="2102400" cy="1599480"/>
+            <a:ext cx="2102040" cy="1599120"/>
           </a:xfrm>
           <a:prstGeom prst="rect">
             <a:avLst/>
@@ -4181,7 +4181,7 @@
         <p:spPr>
           <a:xfrm>
             <a:off x="6355080" y="5120640"/>
-            <a:ext cx="2102400" cy="147600"/>
+            <a:ext cx="2102040" cy="147240"/>
           </a:xfrm>
           <a:prstGeom prst="rect">
             <a:avLst/>
@@ -4237,7 +4237,7 @@
         <p:spPr>
           <a:xfrm>
             <a:off x="8641080" y="3493080"/>
-            <a:ext cx="2742480" cy="1496160"/>
+            <a:ext cx="2742120" cy="1495800"/>
           </a:xfrm>
           <a:prstGeom prst="rect">
             <a:avLst/>
@@ -4496,7 +4496,7 @@
         <p:spPr>
           <a:xfrm>
             <a:off x="603360" y="320040"/>
-            <a:ext cx="10972080" cy="547920"/>
+            <a:ext cx="10971720" cy="547560"/>
           </a:xfrm>
           <a:prstGeom prst="rect">
             <a:avLst/>
@@ -4550,7 +4550,7 @@
         <p:spPr>
           <a:xfrm>
             <a:off x="777240" y="960120"/>
-            <a:ext cx="10633680" cy="191160"/>
+            <a:ext cx="10633320" cy="190800"/>
           </a:xfrm>
           <a:prstGeom prst="rect">
             <a:avLst/>
@@ -4606,7 +4606,7 @@
         <p:spPr>
           <a:xfrm>
             <a:off x="777240" y="1261800"/>
-            <a:ext cx="5348520" cy="4140360"/>
+            <a:ext cx="5348160" cy="4140360"/>
           </a:xfrm>
           <a:prstGeom prst="rect">
             <a:avLst/>
@@ -4892,7 +4892,7 @@
         <p:spPr>
           <a:xfrm>
             <a:off x="6355080" y="1261800"/>
-            <a:ext cx="2422440" cy="156600"/>
+            <a:ext cx="2422080" cy="156240"/>
           </a:xfrm>
           <a:prstGeom prst="rect">
             <a:avLst/>
@@ -4948,7 +4948,7 @@
         <p:spPr>
           <a:xfrm>
             <a:off x="8915400" y="1261800"/>
-            <a:ext cx="2422440" cy="156600"/>
+            <a:ext cx="2422080" cy="156240"/>
           </a:xfrm>
           <a:prstGeom prst="rect">
             <a:avLst/>
@@ -5008,7 +5008,7 @@
         <p:spPr>
           <a:xfrm>
             <a:off x="6355080" y="1481400"/>
-            <a:ext cx="2422440" cy="1416600"/>
+            <a:ext cx="2422080" cy="1416240"/>
           </a:xfrm>
           <a:prstGeom prst="rect">
             <a:avLst/>
@@ -5031,7 +5031,7 @@
         <p:spPr>
           <a:xfrm>
             <a:off x="8915400" y="1481400"/>
-            <a:ext cx="2422440" cy="1416600"/>
+            <a:ext cx="2422080" cy="1416240"/>
           </a:xfrm>
           <a:prstGeom prst="rect">
             <a:avLst/>
@@ -5050,7 +5050,7 @@
         <p:spPr>
           <a:xfrm>
             <a:off x="6355080" y="2971800"/>
-            <a:ext cx="5028480" cy="363960"/>
+            <a:ext cx="5028120" cy="363960"/>
           </a:xfrm>
           <a:prstGeom prst="rect">
             <a:avLst/>
@@ -5110,7 +5110,7 @@
         <p:spPr>
           <a:xfrm>
             <a:off x="6355080" y="3337560"/>
-            <a:ext cx="1599480" cy="1965240"/>
+            <a:ext cx="1599120" cy="1964880"/>
           </a:xfrm>
           <a:prstGeom prst="rect">
             <a:avLst/>
@@ -5129,7 +5129,7 @@
         <p:spPr>
           <a:xfrm>
             <a:off x="6355080" y="5321880"/>
-            <a:ext cx="1599480" cy="381960"/>
+            <a:ext cx="1599120" cy="381960"/>
           </a:xfrm>
           <a:prstGeom prst="rect">
             <a:avLst/>
@@ -5185,7 +5185,7 @@
         <p:spPr>
           <a:xfrm>
             <a:off x="8138160" y="3553560"/>
-            <a:ext cx="3245400" cy="1690200"/>
+            <a:ext cx="3245040" cy="1689840"/>
           </a:xfrm>
           <a:prstGeom prst="rect">
             <a:avLst/>
@@ -5487,7 +5487,7 @@
         <p:spPr>
           <a:xfrm>
             <a:off x="603360" y="320040"/>
-            <a:ext cx="10972080" cy="547920"/>
+            <a:ext cx="10971720" cy="547560"/>
           </a:xfrm>
           <a:prstGeom prst="rect">
             <a:avLst/>
@@ -5541,7 +5541,7 @@
         <p:spPr>
           <a:xfrm>
             <a:off x="777240" y="960120"/>
-            <a:ext cx="10633680" cy="191160"/>
+            <a:ext cx="10633320" cy="190800"/>
           </a:xfrm>
           <a:prstGeom prst="rect">
             <a:avLst/>
@@ -5597,7 +5597,7 @@
         <p:spPr>
           <a:xfrm>
             <a:off x="777240" y="1261800"/>
-            <a:ext cx="5348520" cy="4412520"/>
+            <a:ext cx="5348160" cy="4418640"/>
           </a:xfrm>
           <a:prstGeom prst="rect">
             <a:avLst/>
@@ -5844,7 +5844,7 @@
         <p:spPr>
           <a:xfrm>
             <a:off x="6355080" y="1261800"/>
-            <a:ext cx="5028480" cy="2084040"/>
+            <a:ext cx="5028120" cy="2083680"/>
           </a:xfrm>
           <a:prstGeom prst="rect">
             <a:avLst/>
@@ -5863,7 +5863,7 @@
         <p:spPr>
           <a:xfrm>
             <a:off x="6355080" y="3383280"/>
-            <a:ext cx="5028480" cy="381960"/>
+            <a:ext cx="5028120" cy="381960"/>
           </a:xfrm>
           <a:prstGeom prst="rect">
             <a:avLst/>
@@ -5919,7 +5919,7 @@
         <p:spPr>
           <a:xfrm>
             <a:off x="6355080" y="3991320"/>
-            <a:ext cx="5028480" cy="1078560"/>
+            <a:ext cx="5028120" cy="1078200"/>
           </a:xfrm>
           <a:prstGeom prst="rect">
             <a:avLst/>
@@ -6221,7 +6221,7 @@
         <p:spPr>
           <a:xfrm>
             <a:off x="603360" y="320040"/>
-            <a:ext cx="10972080" cy="547920"/>
+            <a:ext cx="10971720" cy="547560"/>
           </a:xfrm>
           <a:prstGeom prst="rect">
             <a:avLst/>
@@ -6275,7 +6275,7 @@
         <p:spPr>
           <a:xfrm>
             <a:off x="777240" y="960120"/>
-            <a:ext cx="10633680" cy="191160"/>
+            <a:ext cx="10633320" cy="190800"/>
           </a:xfrm>
           <a:prstGeom prst="rect">
             <a:avLst/>
@@ -6331,7 +6331,7 @@
         <p:spPr>
           <a:xfrm>
             <a:off x="777240" y="1261800"/>
-            <a:ext cx="5348520" cy="4803840"/>
+            <a:ext cx="5348160" cy="4810680"/>
           </a:xfrm>
           <a:prstGeom prst="rect">
             <a:avLst/>
@@ -6621,7 +6621,7 @@
         <p:spPr>
           <a:xfrm>
             <a:off x="6355080" y="1261800"/>
-            <a:ext cx="5028480" cy="2742480"/>
+            <a:ext cx="5028120" cy="2742120"/>
           </a:xfrm>
           <a:prstGeom prst="rect">
             <a:avLst/>
@@ -6640,7 +6640,7 @@
         <p:spPr>
           <a:xfrm>
             <a:off x="6355080" y="4041720"/>
-            <a:ext cx="5028480" cy="181800"/>
+            <a:ext cx="5028120" cy="181800"/>
           </a:xfrm>
           <a:prstGeom prst="rect">
             <a:avLst/>
@@ -6696,7 +6696,7 @@
         <p:spPr>
           <a:xfrm>
             <a:off x="6355080" y="4370760"/>
-            <a:ext cx="5028480" cy="897120"/>
+            <a:ext cx="5028120" cy="896760"/>
           </a:xfrm>
           <a:prstGeom prst="rect">
             <a:avLst/>
@@ -6955,7 +6955,7 @@
         <p:spPr>
           <a:xfrm>
             <a:off x="603360" y="320040"/>
-            <a:ext cx="10972080" cy="547920"/>
+            <a:ext cx="10971720" cy="547560"/>
           </a:xfrm>
           <a:prstGeom prst="rect">
             <a:avLst/>
@@ -7009,7 +7009,7 @@
         <p:spPr>
           <a:xfrm>
             <a:off x="777240" y="960120"/>
-            <a:ext cx="10633680" cy="191160"/>
+            <a:ext cx="10633320" cy="190800"/>
           </a:xfrm>
           <a:prstGeom prst="rect">
             <a:avLst/>
@@ -7065,7 +7065,7 @@
         <p:spPr>
           <a:xfrm>
             <a:off x="777240" y="1261800"/>
-            <a:ext cx="5348520" cy="4152600"/>
+            <a:ext cx="5348160" cy="4152600"/>
           </a:xfrm>
           <a:prstGeom prst="rect">
             <a:avLst/>
@@ -7405,7 +7405,7 @@
         <p:spPr>
           <a:xfrm>
             <a:off x="6355080" y="1261800"/>
-            <a:ext cx="2422440" cy="1873800"/>
+            <a:ext cx="2422080" cy="1873440"/>
           </a:xfrm>
           <a:prstGeom prst="rect">
             <a:avLst/>
@@ -7424,7 +7424,7 @@
         <p:spPr>
           <a:xfrm>
             <a:off x="6355080" y="3163680"/>
-            <a:ext cx="2422440" cy="181800"/>
+            <a:ext cx="2422080" cy="181800"/>
           </a:xfrm>
           <a:prstGeom prst="rect">
             <a:avLst/>
@@ -7480,7 +7480,7 @@
         <p:spPr>
           <a:xfrm>
             <a:off x="8961120" y="1261800"/>
-            <a:ext cx="2422440" cy="2035800"/>
+            <a:ext cx="2422080" cy="2035800"/>
           </a:xfrm>
           <a:prstGeom prst="rect">
             <a:avLst/>
@@ -7662,7 +7662,7 @@
         <p:spPr>
           <a:xfrm>
             <a:off x="6355080" y="3429000"/>
-            <a:ext cx="5028480" cy="2216880"/>
+            <a:ext cx="5028120" cy="2216880"/>
           </a:xfrm>
           <a:prstGeom prst="rect">
             <a:avLst/>
@@ -7921,7 +7921,7 @@
         <p:spPr>
           <a:xfrm>
             <a:off x="603360" y="320040"/>
-            <a:ext cx="10972080" cy="547920"/>
+            <a:ext cx="10972440" cy="548280"/>
           </a:xfrm>
           <a:prstGeom prst="rect">
             <a:avLst/>
@@ -7938,7 +7938,7 @@
           <a:p>
             <a:pPr indent="0" algn="ctr" defTabSz="914400">
               <a:lnSpc>
-                <a:spcPct val="112000"/>
+                <a:spcPct val="114000"/>
               </a:lnSpc>
               <a:spcAft>
                 <a:spcPts val="201"/>
@@ -7955,7 +7955,7 @@
                 </a:solidFill>
                 <a:latin typeface="Calisto MT"/>
               </a:rPr>
-              <a:t>KEY REFERENCES (IEEE FORMAT)</a:t>
+              <a:t>REFERENCES </a:t>
             </a:r>
             <a:endParaRPr b="0" lang="en-US" sz="2400" spc="-1" strike="noStrike">
               <a:solidFill>
@@ -7968,14 +7968,14 @@
       </p:sp>
       <p:sp>
         <p:nvSpPr>
-          <p:cNvPr id="127" name="Ref_Subhead"/>
+          <p:cNvPr id="127" name="Ref_FullWidth_Box"/>
           <p:cNvSpPr/>
           <p:nvPr/>
         </p:nvSpPr>
         <p:spPr>
           <a:xfrm>
-            <a:off x="777240" y="960120"/>
-            <a:ext cx="10633680" cy="187560"/>
+            <a:off x="777240" y="1234440"/>
+            <a:ext cx="10634040" cy="4354920"/>
           </a:xfrm>
           <a:prstGeom prst="rect">
             <a:avLst/>
@@ -7996,424 +7996,337 @@
             <a:spAutoFit/>
           </a:bodyPr>
           <a:p>
-            <a:pPr defTabSz="914400">
-              <a:lnSpc>
-                <a:spcPct val="112000"/>
-              </a:lnSpc>
-              <a:spcAft>
-                <a:spcPts val="201"/>
-              </a:spcAft>
-            </a:pPr>
-            <a:r>
-              <a:rPr b="1" lang="en-US" sz="1100" spc="-1" strike="noStrike">
+            <a:pPr>
+              <a:lnSpc>
+                <a:spcPct val="115000"/>
+              </a:lnSpc>
+              <a:spcAft>
+                <a:spcPts val="799"/>
+              </a:spcAft>
+            </a:pPr>
+            <a:r>
+              <a:rPr b="1" lang="en-US" sz="1500" spc="-1" strike="noStrike">
                 <a:solidFill>
                   <a:srgbClr val="b8860b"/>
                 </a:solidFill>
                 <a:latin typeface="Calisto MT"/>
               </a:rPr>
-              <a:t>PRIMARY PEER-REVIEWED LITERATURE, ROBOTICS BENCHMARKS &amp; INTERNATIONAL STANDARDS</a:t>
-            </a:r>
-            <a:endParaRPr b="0" lang="en-US" sz="1100" spc="-1" strike="noStrike">
-              <a:solidFill>
-                <a:srgbClr val="000000"/>
-              </a:solidFill>
-              <a:latin typeface="Arial"/>
-            </a:endParaRPr>
-          </a:p>
-        </p:txBody>
-      </p:sp>
-      <p:sp>
-        <p:nvSpPr>
-          <p:cNvPr id="128" name="Ref_Col1"/>
-          <p:cNvSpPr/>
-          <p:nvPr/>
-        </p:nvSpPr>
-        <p:spPr>
-          <a:xfrm>
-            <a:off x="777240" y="1261800"/>
-            <a:ext cx="5165640" cy="2471760"/>
-          </a:xfrm>
-          <a:prstGeom prst="rect">
-            <a:avLst/>
-          </a:prstGeom>
-          <a:noFill/>
-          <a:ln w="0">
-            <a:noFill/>
-          </a:ln>
-        </p:spPr>
-        <p:style>
-          <a:lnRef idx="0"/>
-          <a:fillRef idx="0"/>
-          <a:effectRef idx="0"/>
-          <a:fontRef idx="minor"/>
-        </p:style>
-        <p:txBody>
-          <a:bodyPr lIns="18360" rIns="18360" tIns="18360" bIns="18360" anchor="t">
-            <a:spAutoFit/>
-          </a:bodyPr>
-          <a:p>
-            <a:pPr defTabSz="914400">
-              <a:lnSpc>
-                <a:spcPct val="112000"/>
-              </a:lnSpc>
-              <a:spcAft>
-                <a:spcPts val="1199"/>
-              </a:spcAft>
-            </a:pPr>
-            <a:r>
-              <a:rPr b="1" lang="en-US" sz="1000" spc="-1" strike="noStrike">
+              <a:t>[1] </a:t>
+            </a:r>
+            <a:r>
+              <a:rPr b="1" lang="en-US" sz="1500" spc="-1" strike="noStrike">
+                <a:solidFill>
+                  <a:srgbClr val="002060"/>
+                </a:solidFill>
+                <a:latin typeface="Calisto MT"/>
+              </a:rPr>
+              <a:t>A. Tsitos, M. Dagioglou, and T. Giannakopoulos, </a:t>
+            </a:r>
+            <a:r>
+              <a:rPr b="0" i="1" lang="en-US" sz="1400" spc="-1" strike="noStrike">
+                <a:solidFill>
+                  <a:srgbClr val="1e293b"/>
+                </a:solidFill>
+                <a:latin typeface="Calisto MT"/>
+              </a:rPr>
+              <a:t>"Real-Time Feasibility of a Human Intention Method Evaluated Through a Competitive Human-Robot Reaching Game," </a:t>
+            </a:r>
+            <a:r>
+              <a:rPr b="0" lang="en-US" sz="1300" spc="-1" strike="noStrike">
+                <a:solidFill>
+                  <a:srgbClr val="475569"/>
+                </a:solidFill>
+                <a:latin typeface="Calisto MT"/>
+              </a:rPr>
+              <a:t>IEEE Transactions on Human-Machine Systems, vol. 52, no. 5, pp. 912–922, Oct. 2022. DOI: 10.1109/THMS.2022.3179574.</a:t>
+            </a:r>
+            <a:endParaRPr b="0" lang="en-US" sz="1300" spc="-1" strike="noStrike">
+              <a:solidFill>
+                <a:srgbClr val="000000"/>
+              </a:solidFill>
+              <a:latin typeface="Arial"/>
+            </a:endParaRPr>
+          </a:p>
+          <a:p>
+            <a:pPr>
+              <a:lnSpc>
+                <a:spcPct val="115000"/>
+              </a:lnSpc>
+              <a:spcAft>
+                <a:spcPts val="799"/>
+              </a:spcAft>
+            </a:pPr>
+            <a:r>
+              <a:rPr b="1" lang="en-US" sz="1500" spc="-1" strike="noStrike">
                 <a:solidFill>
                   <a:srgbClr val="b8860b"/>
                 </a:solidFill>
                 <a:latin typeface="Calisto MT"/>
               </a:rPr>
-              <a:t>[1] </a:t>
-            </a:r>
-            <a:r>
-              <a:rPr b="1" lang="en-US" sz="1000" spc="-1" strike="noStrike">
-                <a:solidFill>
-                  <a:srgbClr val="002060"/>
-                </a:solidFill>
-                <a:latin typeface="Calisto MT"/>
-              </a:rPr>
-              <a:t>A. Tsitos, M. Dagioglou, and T. Giannakopoulos, </a:t>
-            </a:r>
-            <a:r>
-              <a:rPr b="0" i="1" lang="en-US" sz="950" spc="-1" strike="noStrike">
-                <a:solidFill>
-                  <a:srgbClr val="334155"/>
-                </a:solidFill>
-                <a:latin typeface="Calisto MT"/>
-              </a:rPr>
-              <a:t>"Real-Time Feasibility of a Human Intention Method Evaluated Through a Competitive Human-Robot Reaching Game," </a:t>
-            </a:r>
-            <a:r>
-              <a:rPr b="0" lang="en-US" sz="950" spc="-1" strike="noStrike">
-                <a:solidFill>
-                  <a:srgbClr val="64748b"/>
-                </a:solidFill>
-                <a:latin typeface="Calisto MT"/>
-              </a:rPr>
-              <a:t>IEEE Transactions on Human-Machine Systems, vol. 52, no. 5, pp. 912–922, Oct. 2022. DOI: 10.1109/THMS.2022.3179574.</a:t>
-            </a:r>
-            <a:endParaRPr b="0" lang="en-US" sz="950" spc="-1" strike="noStrike">
-              <a:solidFill>
-                <a:srgbClr val="000000"/>
-              </a:solidFill>
-              <a:latin typeface="Arial"/>
-            </a:endParaRPr>
-          </a:p>
-          <a:p>
-            <a:pPr defTabSz="914400">
-              <a:lnSpc>
-                <a:spcPct val="112000"/>
-              </a:lnSpc>
-              <a:spcAft>
-                <a:spcPts val="1199"/>
-              </a:spcAft>
-            </a:pPr>
-            <a:r>
-              <a:rPr b="1" lang="en-US" sz="1000" spc="-1" strike="noStrike">
+              <a:t>[2] </a:t>
+            </a:r>
+            <a:r>
+              <a:rPr b="1" lang="en-US" sz="1500" spc="-1" strike="noStrike">
+                <a:solidFill>
+                  <a:srgbClr val="002060"/>
+                </a:solidFill>
+                <a:latin typeface="Calisto MT"/>
+              </a:rPr>
+              <a:t>J. A. Mahmud, </a:t>
+            </a:r>
+            <a:r>
+              <a:rPr b="0" i="1" lang="en-US" sz="1400" spc="-1" strike="noStrike">
+                <a:solidFill>
+                  <a:srgbClr val="1e293b"/>
+                </a:solidFill>
+                <a:latin typeface="Calisto MT"/>
+              </a:rPr>
+              <a:t>"3D Gesture Recognition and Adaptation for Human–Robot Interaction," </a:t>
+            </a:r>
+            <a:r>
+              <a:rPr b="0" lang="en-US" sz="1300" spc="-1" strike="noStrike">
+                <a:solidFill>
+                  <a:srgbClr val="475569"/>
+                </a:solidFill>
+                <a:latin typeface="Calisto MT"/>
+              </a:rPr>
+              <a:t>IEEE Robotics and Automation Letters, vol. 7, no. 2, pp. 4831–4838, Apr. 2022. DOI: 10.1109/LRA.2022.3151406.</a:t>
+            </a:r>
+            <a:endParaRPr b="0" lang="en-US" sz="1300" spc="-1" strike="noStrike">
+              <a:solidFill>
+                <a:srgbClr val="000000"/>
+              </a:solidFill>
+              <a:latin typeface="Arial"/>
+            </a:endParaRPr>
+          </a:p>
+          <a:p>
+            <a:pPr>
+              <a:lnSpc>
+                <a:spcPct val="115000"/>
+              </a:lnSpc>
+              <a:spcAft>
+                <a:spcPts val="799"/>
+              </a:spcAft>
+            </a:pPr>
+            <a:r>
+              <a:rPr b="1" lang="en-US" sz="1500" spc="-1" strike="noStrike">
                 <a:solidFill>
                   <a:srgbClr val="b8860b"/>
                 </a:solidFill>
                 <a:latin typeface="Calisto MT"/>
               </a:rPr>
-              <a:t>[2] </a:t>
-            </a:r>
-            <a:r>
-              <a:rPr b="1" lang="en-US" sz="1000" spc="-1" strike="noStrike">
-                <a:solidFill>
-                  <a:srgbClr val="002060"/>
-                </a:solidFill>
-                <a:latin typeface="Calisto MT"/>
-              </a:rPr>
-              <a:t>J. A. Mahmud, </a:t>
-            </a:r>
-            <a:r>
-              <a:rPr b="0" i="1" lang="en-US" sz="950" spc="-1" strike="noStrike">
-                <a:solidFill>
-                  <a:srgbClr val="334155"/>
-                </a:solidFill>
-                <a:latin typeface="Calisto MT"/>
-              </a:rPr>
-              <a:t>"3D Gesture Recognition and Adaptation for Human–Robot Interaction," </a:t>
-            </a:r>
-            <a:r>
-              <a:rPr b="0" lang="en-US" sz="950" spc="-1" strike="noStrike">
-                <a:solidFill>
-                  <a:srgbClr val="64748b"/>
-                </a:solidFill>
-                <a:latin typeface="Calisto MT"/>
-              </a:rPr>
-              <a:t>IEEE Robotics and Automation Letters, vol. 7, no. 2, pp. 4831–4838, Apr. 2022. DOI: 10.1109/LRA.2022.3151406.</a:t>
-            </a:r>
-            <a:endParaRPr b="0" lang="en-US" sz="950" spc="-1" strike="noStrike">
-              <a:solidFill>
-                <a:srgbClr val="000000"/>
-              </a:solidFill>
-              <a:latin typeface="Arial"/>
-            </a:endParaRPr>
-          </a:p>
-          <a:p>
-            <a:pPr defTabSz="914400">
-              <a:lnSpc>
-                <a:spcPct val="112000"/>
-              </a:lnSpc>
-              <a:spcAft>
-                <a:spcPts val="1199"/>
-              </a:spcAft>
-            </a:pPr>
-            <a:r>
-              <a:rPr b="1" lang="en-US" sz="1000" spc="-1" strike="noStrike">
+              <a:t>[3] </a:t>
+            </a:r>
+            <a:r>
+              <a:rPr b="1" lang="en-US" sz="1500" spc="-1" strike="noStrike">
+                <a:solidFill>
+                  <a:srgbClr val="002060"/>
+                </a:solidFill>
+                <a:latin typeface="Calisto MT"/>
+              </a:rPr>
+              <a:t>Y. Li, H. Zhang, G. Yang, and S. Wang, </a:t>
+            </a:r>
+            <a:r>
+              <a:rPr b="0" i="1" lang="en-US" sz="1400" spc="-1" strike="noStrike">
+                <a:solidFill>
+                  <a:srgbClr val="1e293b"/>
+                </a:solidFill>
+                <a:latin typeface="Calisto MT"/>
+              </a:rPr>
+              <a:t>"Safe and Efficient Motion Planning for Material Transportation Robots Considering Intention Prediction of Obstacles," </a:t>
+            </a:r>
+            <a:r>
+              <a:rPr b="0" lang="en-US" sz="1300" spc="-1" strike="noStrike">
+                <a:solidFill>
+                  <a:srgbClr val="475569"/>
+                </a:solidFill>
+                <a:latin typeface="Calisto MT"/>
+              </a:rPr>
+              <a:t>IEEE Access, vol. 11, pp. 24819–24831, Mar. 2023. DOI: 10.1109/ACCESS.2023.3256031.</a:t>
+            </a:r>
+            <a:endParaRPr b="0" lang="en-US" sz="1300" spc="-1" strike="noStrike">
+              <a:solidFill>
+                <a:srgbClr val="000000"/>
+              </a:solidFill>
+              <a:latin typeface="Arial"/>
+            </a:endParaRPr>
+          </a:p>
+          <a:p>
+            <a:pPr>
+              <a:lnSpc>
+                <a:spcPct val="115000"/>
+              </a:lnSpc>
+              <a:spcAft>
+                <a:spcPts val="799"/>
+              </a:spcAft>
+            </a:pPr>
+            <a:r>
+              <a:rPr b="1" lang="en-US" sz="1500" spc="-1" strike="noStrike">
                 <a:solidFill>
                   <a:srgbClr val="b8860b"/>
                 </a:solidFill>
                 <a:latin typeface="Calisto MT"/>
               </a:rPr>
-              <a:t>[3] </a:t>
-            </a:r>
-            <a:r>
-              <a:rPr b="1" lang="en-US" sz="1000" spc="-1" strike="noStrike">
-                <a:solidFill>
-                  <a:srgbClr val="002060"/>
-                </a:solidFill>
-                <a:latin typeface="Calisto MT"/>
-              </a:rPr>
-              <a:t>Y. Li, H. Zhang, G. Yang, and S. Wang, </a:t>
-            </a:r>
-            <a:r>
-              <a:rPr b="0" i="1" lang="en-US" sz="950" spc="-1" strike="noStrike">
-                <a:solidFill>
-                  <a:srgbClr val="334155"/>
-                </a:solidFill>
-                <a:latin typeface="Calisto MT"/>
-              </a:rPr>
-              <a:t>"Safe and Efficient Motion Planning for Material Transportation Robots Considering Intention Prediction of Obstacles," </a:t>
-            </a:r>
-            <a:r>
-              <a:rPr b="0" lang="en-US" sz="950" spc="-1" strike="noStrike">
-                <a:solidFill>
-                  <a:srgbClr val="64748b"/>
-                </a:solidFill>
-                <a:latin typeface="Calisto MT"/>
-              </a:rPr>
-              <a:t>IEEE Access, vol. 11, pp. 24819–24831, Mar. 2023. DOI: 10.1109/ACCESS.2023.3256031.</a:t>
-            </a:r>
-            <a:endParaRPr b="0" lang="en-US" sz="950" spc="-1" strike="noStrike">
-              <a:solidFill>
-                <a:srgbClr val="000000"/>
-              </a:solidFill>
-              <a:latin typeface="Arial"/>
-            </a:endParaRPr>
-          </a:p>
-          <a:p>
-            <a:pPr defTabSz="914400">
-              <a:lnSpc>
-                <a:spcPct val="112000"/>
-              </a:lnSpc>
-              <a:spcAft>
-                <a:spcPts val="1199"/>
-              </a:spcAft>
-            </a:pPr>
-            <a:r>
-              <a:rPr b="1" lang="en-US" sz="1000" spc="-1" strike="noStrike">
+              <a:t>[4] </a:t>
+            </a:r>
+            <a:r>
+              <a:rPr b="1" lang="en-US" sz="1500" spc="-1" strike="noStrike">
+                <a:solidFill>
+                  <a:srgbClr val="002060"/>
+                </a:solidFill>
+                <a:latin typeface="Calisto MT"/>
+              </a:rPr>
+              <a:t>ISO/TS 15066:2016, </a:t>
+            </a:r>
+            <a:r>
+              <a:rPr b="0" i="1" lang="en-US" sz="1400" spc="-1" strike="noStrike">
+                <a:solidFill>
+                  <a:srgbClr val="1e293b"/>
+                </a:solidFill>
+                <a:latin typeface="Calisto MT"/>
+              </a:rPr>
+              <a:t>"Robots and Robotic Devices — Collaborative Robots," </a:t>
+            </a:r>
+            <a:r>
+              <a:rPr b="0" lang="en-US" sz="1300" spc="-1" strike="noStrike">
+                <a:solidFill>
+                  <a:srgbClr val="475569"/>
+                </a:solidFill>
+                <a:latin typeface="Calisto MT"/>
+              </a:rPr>
+              <a:t>International Organization for Standardization (ISO), Technical Specification, Geneva, Switzerland, 2016.</a:t>
+            </a:r>
+            <a:endParaRPr b="0" lang="en-US" sz="1300" spc="-1" strike="noStrike">
+              <a:solidFill>
+                <a:srgbClr val="000000"/>
+              </a:solidFill>
+              <a:latin typeface="Arial"/>
+            </a:endParaRPr>
+          </a:p>
+          <a:p>
+            <a:pPr>
+              <a:lnSpc>
+                <a:spcPct val="115000"/>
+              </a:lnSpc>
+              <a:spcAft>
+                <a:spcPts val="799"/>
+              </a:spcAft>
+            </a:pPr>
+            <a:r>
+              <a:rPr b="1" lang="en-US" sz="1500" spc="-1" strike="noStrike">
                 <a:solidFill>
                   <a:srgbClr val="b8860b"/>
                 </a:solidFill>
                 <a:latin typeface="Calisto MT"/>
               </a:rPr>
-              <a:t>[4] </a:t>
-            </a:r>
-            <a:r>
-              <a:rPr b="1" lang="en-US" sz="1000" spc="-1" strike="noStrike">
-                <a:solidFill>
-                  <a:srgbClr val="002060"/>
-                </a:solidFill>
-                <a:latin typeface="Calisto MT"/>
-              </a:rPr>
-              <a:t>ISO/TS 15066:2016, </a:t>
-            </a:r>
-            <a:r>
-              <a:rPr b="0" i="1" lang="en-US" sz="950" spc="-1" strike="noStrike">
-                <a:solidFill>
-                  <a:srgbClr val="334155"/>
-                </a:solidFill>
-                <a:latin typeface="Calisto MT"/>
-              </a:rPr>
-              <a:t>"Robots and Robotic Devices — Collaborative Robots," </a:t>
-            </a:r>
-            <a:r>
-              <a:rPr b="0" lang="en-US" sz="950" spc="-1" strike="noStrike">
-                <a:solidFill>
-                  <a:srgbClr val="64748b"/>
-                </a:solidFill>
-                <a:latin typeface="Calisto MT"/>
-              </a:rPr>
-              <a:t>International Organization for Standardization (ISO), Technical Specification, Geneva, Switzerland, 2016.</a:t>
-            </a:r>
-            <a:endParaRPr b="0" lang="en-US" sz="950" spc="-1" strike="noStrike">
-              <a:solidFill>
-                <a:srgbClr val="000000"/>
-              </a:solidFill>
-              <a:latin typeface="Arial"/>
-            </a:endParaRPr>
-          </a:p>
-        </p:txBody>
-      </p:sp>
-      <p:sp>
-        <p:nvSpPr>
-          <p:cNvPr id="129" name="Ref_Col2"/>
-          <p:cNvSpPr/>
-          <p:nvPr/>
-        </p:nvSpPr>
-        <p:spPr>
-          <a:xfrm>
-            <a:off x="6217920" y="1261800"/>
-            <a:ext cx="5165640" cy="1884600"/>
-          </a:xfrm>
-          <a:prstGeom prst="rect">
-            <a:avLst/>
-          </a:prstGeom>
-          <a:noFill/>
-          <a:ln w="0">
-            <a:noFill/>
-          </a:ln>
-        </p:spPr>
-        <p:style>
-          <a:lnRef idx="0"/>
-          <a:fillRef idx="0"/>
-          <a:effectRef idx="0"/>
-          <a:fontRef idx="minor"/>
-        </p:style>
-        <p:txBody>
-          <a:bodyPr lIns="18360" rIns="18360" tIns="18360" bIns="18360" anchor="t">
-            <a:spAutoFit/>
-          </a:bodyPr>
-          <a:p>
-            <a:pPr defTabSz="914400">
-              <a:lnSpc>
-                <a:spcPct val="112000"/>
-              </a:lnSpc>
-              <a:spcAft>
-                <a:spcPts val="1400"/>
-              </a:spcAft>
-            </a:pPr>
-            <a:r>
-              <a:rPr b="1" lang="en-US" sz="1000" spc="-1" strike="noStrike">
+              <a:t>[5] </a:t>
+            </a:r>
+            <a:r>
+              <a:rPr b="1" lang="en-US" sz="1500" spc="-1" strike="noStrike">
+                <a:solidFill>
+                  <a:srgbClr val="002060"/>
+                </a:solidFill>
+                <a:latin typeface="Calisto MT"/>
+              </a:rPr>
+              <a:t>S. Macenski, T. Foote, B. Gerkey, C. Lalancette, and W. Woodall, </a:t>
+            </a:r>
+            <a:r>
+              <a:rPr b="0" i="1" lang="en-US" sz="1400" spc="-1" strike="noStrike">
+                <a:solidFill>
+                  <a:srgbClr val="1e293b"/>
+                </a:solidFill>
+                <a:latin typeface="Calisto MT"/>
+              </a:rPr>
+              <a:t>"Robot Operating System 2: Design, Architecture, and Uses in the Wild," </a:t>
+            </a:r>
+            <a:r>
+              <a:rPr b="0" lang="en-US" sz="1300" spc="-1" strike="noStrike">
+                <a:solidFill>
+                  <a:srgbClr val="475569"/>
+                </a:solidFill>
+                <a:latin typeface="Calisto MT"/>
+              </a:rPr>
+              <a:t>Science Robotics, vol. 7, no. 66, Art. no. eabm6074, May 2022. DOI: 10.1126/scirobotics.abm6074.</a:t>
+            </a:r>
+            <a:endParaRPr b="0" lang="en-US" sz="1300" spc="-1" strike="noStrike">
+              <a:solidFill>
+                <a:srgbClr val="000000"/>
+              </a:solidFill>
+              <a:latin typeface="Arial"/>
+            </a:endParaRPr>
+          </a:p>
+          <a:p>
+            <a:pPr>
+              <a:lnSpc>
+                <a:spcPct val="115000"/>
+              </a:lnSpc>
+              <a:spcAft>
+                <a:spcPts val="799"/>
+              </a:spcAft>
+            </a:pPr>
+            <a:r>
+              <a:rPr b="1" lang="en-US" sz="1500" spc="-1" strike="noStrike">
                 <a:solidFill>
                   <a:srgbClr val="b8860b"/>
                 </a:solidFill>
                 <a:latin typeface="Calisto MT"/>
               </a:rPr>
-              <a:t>[5] </a:t>
-            </a:r>
-            <a:r>
-              <a:rPr b="1" lang="en-US" sz="1000" spc="-1" strike="noStrike">
-                <a:solidFill>
-                  <a:srgbClr val="002060"/>
-                </a:solidFill>
-                <a:latin typeface="Calisto MT"/>
-              </a:rPr>
-              <a:t>S. Macenski, T. Foote, B. Gerkey, C. Lalancette, and W. Woodall, </a:t>
-            </a:r>
-            <a:r>
-              <a:rPr b="0" i="1" lang="en-US" sz="950" spc="-1" strike="noStrike">
-                <a:solidFill>
-                  <a:srgbClr val="334155"/>
-                </a:solidFill>
-                <a:latin typeface="Calisto MT"/>
-              </a:rPr>
-              <a:t>"Robot Operating System 2: Design, Architecture, and Uses in the Wild," </a:t>
-            </a:r>
-            <a:r>
-              <a:rPr b="0" lang="en-US" sz="950" spc="-1" strike="noStrike">
-                <a:solidFill>
-                  <a:srgbClr val="64748b"/>
-                </a:solidFill>
-                <a:latin typeface="Calisto MT"/>
-              </a:rPr>
-              <a:t>Science Robotics, vol. 7, no. 66, Art. no. eabm6074, May 2022. DOI: 10.1126/scirobotics.abm6074.</a:t>
-            </a:r>
-            <a:endParaRPr b="0" lang="en-US" sz="950" spc="-1" strike="noStrike">
-              <a:solidFill>
-                <a:srgbClr val="000000"/>
-              </a:solidFill>
-              <a:latin typeface="Arial"/>
-            </a:endParaRPr>
-          </a:p>
-          <a:p>
-            <a:pPr defTabSz="914400">
-              <a:lnSpc>
-                <a:spcPct val="112000"/>
-              </a:lnSpc>
-              <a:spcAft>
-                <a:spcPts val="1400"/>
-              </a:spcAft>
-            </a:pPr>
-            <a:r>
-              <a:rPr b="1" lang="en-US" sz="1000" spc="-1" strike="noStrike">
+              <a:t>[6] </a:t>
+            </a:r>
+            <a:r>
+              <a:rPr b="1" lang="en-US" sz="1500" spc="-1" strike="noStrike">
+                <a:solidFill>
+                  <a:srgbClr val="002060"/>
+                </a:solidFill>
+                <a:latin typeface="Calisto MT"/>
+              </a:rPr>
+              <a:t>F. Zhang, V. Bazarevsky, A. Vakunov, A. Tkachenka, G. Sung, C. L. Chang, and M. Grundmann, </a:t>
+            </a:r>
+            <a:r>
+              <a:rPr b="0" i="1" lang="en-US" sz="1400" spc="-1" strike="noStrike">
+                <a:solidFill>
+                  <a:srgbClr val="1e293b"/>
+                </a:solidFill>
+                <a:latin typeface="Calisto MT"/>
+              </a:rPr>
+              <a:t>"MediaPipe Hands: On-Device Real-Time Hand Tracking," </a:t>
+            </a:r>
+            <a:r>
+              <a:rPr b="0" lang="en-US" sz="1300" spc="-1" strike="noStrike">
+                <a:solidFill>
+                  <a:srgbClr val="475569"/>
+                </a:solidFill>
+                <a:latin typeface="Calisto MT"/>
+              </a:rPr>
+              <a:t>arXiv preprint arXiv:2006.10214, presented at CVPR Workshop on Computer Vision for AR/VR, 2020.</a:t>
+            </a:r>
+            <a:endParaRPr b="0" lang="en-US" sz="1300" spc="-1" strike="noStrike">
+              <a:solidFill>
+                <a:srgbClr val="000000"/>
+              </a:solidFill>
+              <a:latin typeface="Arial"/>
+            </a:endParaRPr>
+          </a:p>
+          <a:p>
+            <a:pPr>
+              <a:lnSpc>
+                <a:spcPct val="115000"/>
+              </a:lnSpc>
+              <a:spcAft>
+                <a:spcPts val="799"/>
+              </a:spcAft>
+            </a:pPr>
+            <a:r>
+              <a:rPr b="1" lang="en-US" sz="1500" spc="-1" strike="noStrike">
                 <a:solidFill>
                   <a:srgbClr val="b8860b"/>
                 </a:solidFill>
                 <a:latin typeface="Calisto MT"/>
               </a:rPr>
-              <a:t>[6] </a:t>
-            </a:r>
-            <a:r>
-              <a:rPr b="1" lang="en-US" sz="1000" spc="-1" strike="noStrike">
-                <a:solidFill>
-                  <a:srgbClr val="002060"/>
-                </a:solidFill>
-                <a:latin typeface="Calisto MT"/>
-              </a:rPr>
-              <a:t>F. Zhang, V. Bazarevsky, A. Vakunov, A. Tkachenka, G. Sung, C. L. Chang, and M. Grundmann, </a:t>
-            </a:r>
-            <a:r>
-              <a:rPr b="0" i="1" lang="en-US" sz="950" spc="-1" strike="noStrike">
-                <a:solidFill>
-                  <a:srgbClr val="334155"/>
-                </a:solidFill>
-                <a:latin typeface="Calisto MT"/>
-              </a:rPr>
-              <a:t>"MediaPipe Hands: On-Device Real-Time Hand Tracking," </a:t>
-            </a:r>
-            <a:r>
-              <a:rPr b="0" lang="en-US" sz="950" spc="-1" strike="noStrike">
-                <a:solidFill>
-                  <a:srgbClr val="64748b"/>
-                </a:solidFill>
-                <a:latin typeface="Calisto MT"/>
-              </a:rPr>
-              <a:t>arXiv preprint arXiv:2006.10214, presented at CVPR Workshop on Computer Vision for AR/VR, 2020.</a:t>
-            </a:r>
-            <a:endParaRPr b="0" lang="en-US" sz="950" spc="-1" strike="noStrike">
-              <a:solidFill>
-                <a:srgbClr val="000000"/>
-              </a:solidFill>
-              <a:latin typeface="Arial"/>
-            </a:endParaRPr>
-          </a:p>
-          <a:p>
-            <a:pPr defTabSz="914400">
-              <a:lnSpc>
-                <a:spcPct val="112000"/>
-              </a:lnSpc>
-              <a:spcAft>
-                <a:spcPts val="1400"/>
-              </a:spcAft>
-            </a:pPr>
-            <a:r>
-              <a:rPr b="1" lang="en-US" sz="1000" spc="-1" strike="noStrike">
-                <a:solidFill>
-                  <a:srgbClr val="b8860b"/>
-                </a:solidFill>
-                <a:latin typeface="Calisto MT"/>
-              </a:rPr>
               <a:t>[7] </a:t>
             </a:r>
             <a:r>
-              <a:rPr b="1" lang="en-US" sz="1000" spc="-1" strike="noStrike">
+              <a:rPr b="1" lang="en-US" sz="1500" spc="-1" strike="noStrike">
                 <a:solidFill>
                   <a:srgbClr val="002060"/>
                 </a:solidFill>
@@ -8422,24 +8335,24 @@
               <a:t>S. Macenski, I. Jambrecic, A. Filippov, and C. Stiffler, </a:t>
             </a:r>
             <a:r>
-              <a:rPr b="0" i="1" lang="en-US" sz="950" spc="-1" strike="noStrike">
-                <a:solidFill>
-                  <a:srgbClr val="334155"/>
+              <a:rPr b="0" i="1" lang="en-US" sz="1400" spc="-1" strike="noStrike">
+                <a:solidFill>
+                  <a:srgbClr val="1e293b"/>
                 </a:solidFill>
                 <a:latin typeface="Calisto MT"/>
               </a:rPr>
               <a:t>"From the Ground Up: Building an Intelligent Mobile Robot with Nav2," </a:t>
             </a:r>
             <a:r>
-              <a:rPr b="0" lang="en-US" sz="950" spc="-1" strike="noStrike">
-                <a:solidFill>
-                  <a:srgbClr val="64748b"/>
+              <a:rPr b="0" lang="en-US" sz="1300" spc="-1" strike="noStrike">
+                <a:solidFill>
+                  <a:srgbClr val="475569"/>
                 </a:solidFill>
                 <a:latin typeface="Calisto MT"/>
               </a:rPr>
               <a:t>IEEE Robotics &amp; Automation Magazine, vol. 30, no. 4, pp. 88–98, Dec. 2023. DOI: 10.1109/MRA.2023.3323060.</a:t>
             </a:r>
-            <a:endParaRPr b="0" lang="en-US" sz="950" spc="-1" strike="noStrike">
+            <a:endParaRPr b="0" lang="en-US" sz="1300" spc="-1" strike="noStrike">
               <a:solidFill>
                 <a:srgbClr val="000000"/>
               </a:solidFill>
@@ -8491,7 +8404,7 @@
         <p:spPr>
           <a:xfrm>
             <a:off x="838080" y="365040"/>
-            <a:ext cx="10514880" cy="912600"/>
+            <a:ext cx="10514520" cy="912240"/>
           </a:xfrm>
           <a:prstGeom prst="rect">
             <a:avLst/>
@@ -8545,7 +8458,7 @@
         <p:spPr>
           <a:xfrm>
             <a:off x="1371600" y="1463040"/>
-            <a:ext cx="9444960" cy="3671640"/>
+            <a:ext cx="9444600" cy="3671640"/>
           </a:xfrm>
           <a:prstGeom prst="rect">
             <a:avLst/>
@@ -8785,7 +8698,7 @@
         <p:spPr>
           <a:xfrm>
             <a:off x="838080" y="365040"/>
-            <a:ext cx="10514880" cy="725760"/>
+            <a:ext cx="10514520" cy="725400"/>
           </a:xfrm>
           <a:prstGeom prst="rect">
             <a:avLst/>
@@ -8839,7 +8752,7 @@
         <p:spPr>
           <a:xfrm>
             <a:off x="777240" y="1325880"/>
-            <a:ext cx="6262920" cy="4564800"/>
+            <a:ext cx="6262560" cy="4564800"/>
           </a:xfrm>
           <a:prstGeom prst="rect">
             <a:avLst/>
@@ -9021,7 +8934,7 @@
         <p:spPr>
           <a:xfrm>
             <a:off x="7315200" y="1417320"/>
-            <a:ext cx="4205520" cy="3153960"/>
+            <a:ext cx="4205160" cy="3153600"/>
           </a:xfrm>
           <a:prstGeom prst="rect">
             <a:avLst/>
@@ -9040,7 +8953,7 @@
         <p:spPr>
           <a:xfrm>
             <a:off x="7315200" y="4681800"/>
-            <a:ext cx="4205520" cy="720360"/>
+            <a:ext cx="4205160" cy="720360"/>
           </a:xfrm>
           <a:prstGeom prst="rect">
             <a:avLst/>
@@ -9130,7 +9043,7 @@
         <p:spPr>
           <a:xfrm>
             <a:off x="838080" y="365040"/>
-            <a:ext cx="10514880" cy="819000"/>
+            <a:ext cx="10514520" cy="818640"/>
           </a:xfrm>
           <a:prstGeom prst="rect">
             <a:avLst/>
@@ -9184,7 +9097,7 @@
         <p:spPr>
           <a:xfrm>
             <a:off x="777240" y="1234440"/>
-            <a:ext cx="10633680" cy="2544480"/>
+            <a:ext cx="10633320" cy="2544480"/>
           </a:xfrm>
           <a:prstGeom prst="rect">
             <a:avLst/>
@@ -9262,7 +9175,7 @@
         <p:spPr>
           <a:xfrm>
             <a:off x="777240" y="3886200"/>
-            <a:ext cx="3318480" cy="1690920"/>
+            <a:ext cx="3318120" cy="1690560"/>
           </a:xfrm>
           <a:prstGeom prst="roundRect">
             <a:avLst>
@@ -9367,7 +9280,7 @@
         <p:spPr>
           <a:xfrm>
             <a:off x="4434840" y="3886200"/>
-            <a:ext cx="3318480" cy="1690920"/>
+            <a:ext cx="3318120" cy="1690560"/>
           </a:xfrm>
           <a:prstGeom prst="roundRect">
             <a:avLst>
@@ -9460,7 +9373,7 @@
         <p:spPr>
           <a:xfrm>
             <a:off x="8092440" y="3886200"/>
-            <a:ext cx="3318480" cy="1690920"/>
+            <a:ext cx="3318120" cy="1690560"/>
           </a:xfrm>
           <a:prstGeom prst="roundRect">
             <a:avLst>
@@ -9587,7 +9500,7 @@
         <p:spPr>
           <a:xfrm>
             <a:off x="838080" y="365040"/>
-            <a:ext cx="10514880" cy="959040"/>
+            <a:ext cx="10514520" cy="958680"/>
           </a:xfrm>
           <a:prstGeom prst="rect">
             <a:avLst/>
@@ -9641,7 +9554,7 @@
         <p:spPr>
           <a:xfrm>
             <a:off x="914400" y="1143000"/>
-            <a:ext cx="10359360" cy="854280"/>
+            <a:ext cx="10359000" cy="854280"/>
           </a:xfrm>
           <a:prstGeom prst="rect">
             <a:avLst/>
@@ -9722,7 +9635,7 @@
         <p:spPr>
           <a:xfrm>
             <a:off x="2286000" y="2240280"/>
-            <a:ext cx="7617600" cy="720"/>
+            <a:ext cx="7617960" cy="1080"/>
           </a:xfrm>
           <a:prstGeom prst="straightConnector1">
             <a:avLst/>
@@ -9744,7 +9657,7 @@
         <p:spPr>
           <a:xfrm>
             <a:off x="914400" y="2423160"/>
-            <a:ext cx="4891320" cy="695880"/>
+            <a:ext cx="4890960" cy="695880"/>
           </a:xfrm>
           <a:prstGeom prst="rect">
             <a:avLst/>
@@ -9825,7 +9738,7 @@
         <p:spPr>
           <a:xfrm>
             <a:off x="914400" y="3493080"/>
-            <a:ext cx="4891320" cy="695880"/>
+            <a:ext cx="4890960" cy="695880"/>
           </a:xfrm>
           <a:prstGeom prst="rect">
             <a:avLst/>
@@ -9906,7 +9819,7 @@
         <p:spPr>
           <a:xfrm>
             <a:off x="914400" y="4563000"/>
-            <a:ext cx="4891320" cy="695880"/>
+            <a:ext cx="4890960" cy="695880"/>
           </a:xfrm>
           <a:prstGeom prst="rect">
             <a:avLst/>
@@ -9987,7 +9900,7 @@
         <p:spPr>
           <a:xfrm>
             <a:off x="6382440" y="2423160"/>
-            <a:ext cx="4891320" cy="695880"/>
+            <a:ext cx="4890960" cy="695880"/>
           </a:xfrm>
           <a:prstGeom prst="rect">
             <a:avLst/>
@@ -10068,7 +9981,7 @@
         <p:spPr>
           <a:xfrm>
             <a:off x="6382440" y="3493080"/>
-            <a:ext cx="4891320" cy="695880"/>
+            <a:ext cx="4890960" cy="695880"/>
           </a:xfrm>
           <a:prstGeom prst="rect">
             <a:avLst/>
@@ -10149,7 +10062,7 @@
         <p:spPr>
           <a:xfrm>
             <a:off x="6382440" y="4563000"/>
-            <a:ext cx="4891320" cy="695880"/>
+            <a:ext cx="4890960" cy="695880"/>
           </a:xfrm>
           <a:prstGeom prst="rect">
             <a:avLst/>
@@ -10264,7 +10177,7 @@
         <p:spPr>
           <a:xfrm>
             <a:off x="841320" y="320040"/>
-            <a:ext cx="10514880" cy="639360"/>
+            <a:ext cx="10514520" cy="639000"/>
           </a:xfrm>
           <a:prstGeom prst="rect">
             <a:avLst/>
@@ -10318,7 +10231,7 @@
         <p:spPr>
           <a:xfrm>
             <a:off x="822960" y="1024200"/>
-            <a:ext cx="10514880" cy="196200"/>
+            <a:ext cx="10514520" cy="195840"/>
           </a:xfrm>
           <a:prstGeom prst="rect">
             <a:avLst/>
@@ -10365,7 +10278,7 @@
         <p:spPr>
           <a:xfrm>
             <a:off x="822960" y="1261800"/>
-            <a:ext cx="3227040" cy="3735360"/>
+            <a:ext cx="3226680" cy="3735360"/>
           </a:xfrm>
           <a:prstGeom prst="rect">
             <a:avLst/>
@@ -10615,7 +10528,7 @@
         <p:spPr>
           <a:xfrm>
             <a:off x="4480560" y="1261800"/>
-            <a:ext cx="3227040" cy="3538080"/>
+            <a:ext cx="3226680" cy="3538080"/>
           </a:xfrm>
           <a:prstGeom prst="rect">
             <a:avLst/>
@@ -10865,7 +10778,7 @@
         <p:spPr>
           <a:xfrm>
             <a:off x="8138160" y="1261800"/>
-            <a:ext cx="3227040" cy="3939840"/>
+            <a:ext cx="3226680" cy="3939840"/>
           </a:xfrm>
           <a:prstGeom prst="rect">
             <a:avLst/>
@@ -11149,7 +11062,7 @@
         <p:spPr>
           <a:xfrm>
             <a:off x="603360" y="320040"/>
-            <a:ext cx="10972080" cy="547920"/>
+            <a:ext cx="10971720" cy="547560"/>
           </a:xfrm>
           <a:prstGeom prst="rect">
             <a:avLst/>
@@ -11203,7 +11116,7 @@
         <p:spPr>
           <a:xfrm>
             <a:off x="777240" y="960120"/>
-            <a:ext cx="10633680" cy="191160"/>
+            <a:ext cx="10633320" cy="190800"/>
           </a:xfrm>
           <a:prstGeom prst="rect">
             <a:avLst/>
@@ -11259,7 +11172,7 @@
         <p:spPr>
           <a:xfrm>
             <a:off x="777240" y="1298520"/>
-            <a:ext cx="3318480" cy="2166480"/>
+            <a:ext cx="3318120" cy="2166480"/>
           </a:xfrm>
           <a:prstGeom prst="rect">
             <a:avLst/>
@@ -11466,7 +11379,7 @@
         <p:spPr>
           <a:xfrm>
             <a:off x="4434840" y="1298520"/>
-            <a:ext cx="3318480" cy="2166480"/>
+            <a:ext cx="3318120" cy="2166480"/>
           </a:xfrm>
           <a:prstGeom prst="rect">
             <a:avLst/>
@@ -11673,7 +11586,7 @@
         <p:spPr>
           <a:xfrm>
             <a:off x="8092440" y="1298520"/>
-            <a:ext cx="3318480" cy="2068920"/>
+            <a:ext cx="3318120" cy="2068920"/>
           </a:xfrm>
           <a:prstGeom prst="rect">
             <a:avLst/>
@@ -11880,7 +11793,7 @@
         <p:spPr>
           <a:xfrm>
             <a:off x="777240" y="3611880"/>
-            <a:ext cx="3318480" cy="2068920"/>
+            <a:ext cx="3318120" cy="2068920"/>
           </a:xfrm>
           <a:prstGeom prst="rect">
             <a:avLst/>
@@ -12087,7 +12000,7 @@
         <p:spPr>
           <a:xfrm>
             <a:off x="4434840" y="3611880"/>
-            <a:ext cx="3318480" cy="2068920"/>
+            <a:ext cx="3318120" cy="2068920"/>
           </a:xfrm>
           <a:prstGeom prst="rect">
             <a:avLst/>
@@ -12294,7 +12207,7 @@
         <p:spPr>
           <a:xfrm>
             <a:off x="8092440" y="3611880"/>
-            <a:ext cx="3318480" cy="1886760"/>
+            <a:ext cx="3318120" cy="1886760"/>
           </a:xfrm>
           <a:prstGeom prst="rect">
             <a:avLst/>
@@ -12535,7 +12448,7 @@
         <p:spPr>
           <a:xfrm>
             <a:off x="603360" y="320040"/>
-            <a:ext cx="10972080" cy="547920"/>
+            <a:ext cx="10971720" cy="547560"/>
           </a:xfrm>
           <a:prstGeom prst="rect">
             <a:avLst/>
@@ -12589,7 +12502,7 @@
         <p:spPr>
           <a:xfrm>
             <a:off x="777240" y="960120"/>
-            <a:ext cx="10633680" cy="191160"/>
+            <a:ext cx="10633320" cy="190800"/>
           </a:xfrm>
           <a:prstGeom prst="rect">
             <a:avLst/>
@@ -12645,7 +12558,7 @@
         <p:spPr>
           <a:xfrm>
             <a:off x="777240" y="1261800"/>
-            <a:ext cx="5897160" cy="3506400"/>
+            <a:ext cx="5896800" cy="3506400"/>
           </a:xfrm>
           <a:prstGeom prst="rect">
             <a:avLst/>
@@ -12935,7 +12848,7 @@
         <p:spPr>
           <a:xfrm>
             <a:off x="6903720" y="1261800"/>
-            <a:ext cx="4434120" cy="4251240"/>
+            <a:ext cx="4433760" cy="4250880"/>
           </a:xfrm>
           <a:prstGeom prst="rect">
             <a:avLst/>
@@ -12954,7 +12867,7 @@
         <p:spPr>
           <a:xfrm>
             <a:off x="6903720" y="5577840"/>
-            <a:ext cx="4434120" cy="181800"/>
+            <a:ext cx="4433760" cy="181800"/>
           </a:xfrm>
           <a:prstGeom prst="rect">
             <a:avLst/>
@@ -13044,7 +12957,7 @@
         <p:spPr>
           <a:xfrm>
             <a:off x="603360" y="320040"/>
-            <a:ext cx="10972080" cy="547920"/>
+            <a:ext cx="10971720" cy="547560"/>
           </a:xfrm>
           <a:prstGeom prst="rect">
             <a:avLst/>
@@ -13098,7 +13011,7 @@
         <p:spPr>
           <a:xfrm>
             <a:off x="777240" y="960120"/>
-            <a:ext cx="10633680" cy="191160"/>
+            <a:ext cx="10633320" cy="190800"/>
           </a:xfrm>
           <a:prstGeom prst="rect">
             <a:avLst/>
@@ -13154,7 +13067,7 @@
         <p:spPr>
           <a:xfrm>
             <a:off x="777240" y="1261800"/>
-            <a:ext cx="5394240" cy="4582800"/>
+            <a:ext cx="5393880" cy="4582800"/>
           </a:xfrm>
           <a:prstGeom prst="rect">
             <a:avLst/>
@@ -13444,7 +13357,7 @@
         <p:spPr>
           <a:xfrm>
             <a:off x="6492240" y="1371600"/>
-            <a:ext cx="2632680" cy="2285280"/>
+            <a:ext cx="2632320" cy="2284920"/>
           </a:xfrm>
           <a:prstGeom prst="rect">
             <a:avLst/>
@@ -13463,7 +13376,7 @@
         <p:spPr>
           <a:xfrm>
             <a:off x="6492240" y="3749040"/>
-            <a:ext cx="2632680" cy="573120"/>
+            <a:ext cx="2632320" cy="573120"/>
           </a:xfrm>
           <a:prstGeom prst="rect">
             <a:avLst/>
@@ -13535,7 +13448,7 @@
         <p:spPr>
           <a:xfrm>
             <a:off x="9308520" y="1371600"/>
-            <a:ext cx="2632680" cy="2285280"/>
+            <a:ext cx="2632320" cy="2284920"/>
           </a:xfrm>
           <a:prstGeom prst="rect">
             <a:avLst/>
@@ -13554,7 +13467,7 @@
         <p:spPr>
           <a:xfrm>
             <a:off x="9308520" y="3749040"/>
-            <a:ext cx="2632680" cy="381960"/>
+            <a:ext cx="2632320" cy="381960"/>
           </a:xfrm>
           <a:prstGeom prst="rect">
             <a:avLst/>

</xml_diff>

<commit_message>
feat(thesis): establish thesis_ws_working with 103-page monograph, dual-track publications suite, and CI/CD workflow
</commit_message>
<xml_diff>
--- a/write_up/Project Final Defense Slides_FINAL.pptx
+++ b/write_up/Project Final Defense Slides_FINAL.pptx
@@ -355,7 +355,7 @@
             <a:pPr indent="0" algn="r">
               <a:buNone/>
             </a:pPr>
-            <a:fld id="{79F1DD84-73D3-4A9F-A739-9041A809605C}" type="slidenum">
+            <a:fld id="{EDC1BF7E-30B8-4C86-B093-3EF9823CAC6F}" type="slidenum">
               <a:rPr b="0" lang="en-US" sz="1400" spc="-1" strike="noStrike">
                 <a:solidFill>
                   <a:srgbClr val="000000"/>
@@ -513,14 +513,14 @@
                 <a:tab algn="l" pos="0"/>
               </a:tabLst>
             </a:pPr>
-            <a:fld id="{C0C81065-BADC-46F8-AEB7-784C4C2E8E49}" type="slidenum">
+            <a:fld id="{E31CB503-755D-4E46-A4A6-AD59FDB29665}" type="slidenum">
               <a:rPr b="0" lang="en-US" sz="1200" spc="-1" strike="noStrike">
                 <a:solidFill>
                   <a:srgbClr val="000000"/>
                 </a:solidFill>
                 <a:latin typeface="Times New Roman"/>
               </a:rPr>
-              <a:t>&lt;number&gt;</a:t>
+              <a:t>5</a:t>
             </a:fld>
             <a:endParaRPr b="0" lang="en-US" sz="1200" spc="-1" strike="noStrike">
               <a:solidFill>
@@ -587,7 +587,7 @@
         <p:txBody>
           <a:bodyPr/>
           <a:p>
-            <a:fld id="{CE525CB7-9614-43C6-B841-F0E9A91BB438}" type="slidenum">
+            <a:fld id="{999B5064-963F-4B67-8F14-AA275C9907AB}" type="slidenum">
               <a:t>&lt;#&gt;</a:t>
             </a:fld>
           </a:p>
@@ -753,7 +753,7 @@
         <p:txBody>
           <a:bodyPr/>
           <a:p>
-            <a:fld id="{4C150E0B-732F-4B52-AA0D-B2D46636D73D}" type="slidenum">
+            <a:fld id="{E633B0A0-6A78-4C87-B441-5B91FB2EDC5C}" type="slidenum">
               <a:t>&lt;#&gt;</a:t>
             </a:fld>
           </a:p>
@@ -1166,7 +1166,7 @@
                 </a:solidFill>
                 <a:latin typeface="Times New Roman"/>
               </a:rPr>
-              <a:t> </a:t>
+              <a:t>&lt;footer&gt;</a:t>
             </a:r>
             <a:endParaRPr b="0" lang="en-US" sz="1400" spc="-1" strike="noStrike">
               <a:solidFill>
@@ -1231,14 +1231,14 @@
                 <a:tab algn="l" pos="0"/>
               </a:tabLst>
             </a:pPr>
-            <a:fld id="{7BC78425-1B59-4B85-BDDE-CDA99347A610}" type="slidenum">
+            <a:fld id="{EDA15DB3-01E8-47DB-81A5-BC097E041CB3}" type="slidenum">
               <a:rPr b="0" lang="en-US" sz="1800" spc="-1" strike="noStrike">
                 <a:solidFill>
                   <a:schemeClr val="dk1"/>
                 </a:solidFill>
                 <a:latin typeface="Calibri"/>
               </a:rPr>
-              <a:t>16</a:t>
+              <a:t>&lt;number&gt;</a:t>
             </a:fld>
             <a:endParaRPr b="0" lang="en-US" sz="1800" spc="-1" strike="noStrike">
               <a:solidFill>
@@ -1298,7 +1298,7 @@
                 </a:solidFill>
                 <a:latin typeface="Times New Roman"/>
               </a:rPr>
-              <a:t> </a:t>
+              <a:t>&lt;date/time&gt;</a:t>
             </a:r>
             <a:endParaRPr b="0" lang="en-US" sz="1400" spc="-1" strike="noStrike">
               <a:solidFill>
@@ -1347,7 +1347,25 @@
                 </a:solidFill>
                 <a:latin typeface="Arial"/>
               </a:rPr>
-              <a:t>Click to edit the title text format</a:t>
+              <a:t>Click to edit </a:t>
+            </a:r>
+            <a:r>
+              <a:rPr b="0" lang="en-US" sz="4400" spc="-1" strike="noStrike">
+                <a:solidFill>
+                  <a:srgbClr val="000000"/>
+                </a:solidFill>
+                <a:latin typeface="Arial"/>
+              </a:rPr>
+              <a:t>the title text </a:t>
+            </a:r>
+            <a:r>
+              <a:rPr b="0" lang="en-US" sz="4400" spc="-1" strike="noStrike">
+                <a:solidFill>
+                  <a:srgbClr val="000000"/>
+                </a:solidFill>
+                <a:latin typeface="Arial"/>
+              </a:rPr>
+              <a:t>format</a:t>
             </a:r>
             <a:endParaRPr b="0" lang="en-US" sz="4400" spc="-1" strike="noStrike">
               <a:solidFill>
@@ -2312,7 +2330,7 @@
                 <a:tab algn="l" pos="0"/>
               </a:tabLst>
             </a:pPr>
-            <a:fld id="{AA96B4B1-F9E8-49C7-8A60-F2B79D89E015}" type="slidenum">
+            <a:fld id="{1611805A-9257-46E2-BA23-DC3A346C8C68}" type="slidenum">
               <a:rPr b="0" lang="en-GB" sz="1800" spc="-1" strike="noStrike">
                 <a:solidFill>
                   <a:schemeClr val="dk1"/>
@@ -9554,7 +9572,7 @@
         <p:spPr>
           <a:xfrm>
             <a:off x="914400" y="1143000"/>
-            <a:ext cx="10359000" cy="854280"/>
+            <a:ext cx="10359000" cy="855000"/>
           </a:xfrm>
           <a:prstGeom prst="rect">
             <a:avLst/>
@@ -9936,7 +9954,7 @@
                 </a:solidFill>
                 <a:latin typeface="Calisto MT"/>
               </a:rPr>
-              <a:t>04.  Supervisory Brain Node</a:t>
+              <a:t>04.  Supervisory Node</a:t>
             </a:r>
             <a:endParaRPr b="0" lang="en-US" sz="1400" spc="-1" strike="noStrike">
               <a:solidFill>
@@ -11440,7 +11458,7 @@
                 </a:solidFill>
                 <a:latin typeface="Calisto MT"/>
               </a:rPr>
-              <a:t>Data Collection &amp; Setup</a:t>
+              <a:t>Data Collection</a:t>
             </a:r>
             <a:endParaRPr b="0" lang="en-US" sz="1400" spc="-1" strike="noStrike">
               <a:solidFill>

</xml_diff>